<commit_message>
Paginate Trumba feed (540 events) + add chamber action-items slide
NCAC scraper:
  Trumba caps each JSON response at ~200 events. The default call only
  returned the next 6 weeks (Apr 29 -> Jun 22). The actual calendar runs
  16 months out. Paginate by setting startdate=YYYYMMDD to the day after
  the last event in each batch; loop until empty or past horizon.
  Result: 176 -> 540 events.

Slides:
  New slide 12 ("What the chamber needs to do next") with three columns:
    - Data partnerships (NCAC Trumba, GoNevadaCounty Cloudflare, Union)
    - Member outreach (schema.org/Event, Trumba/Tribe adoption)
    - Operations (queue curator, AI run cadence, no-event alerts)
  Bottom callout cites the NCAC win as a concrete example.
  Total slides 14 -> 15.

Co-Authored-By: Claude Sonnet 4.6 <noreply@anthropic.com>
</commit_message>
<xml_diff>
--- a/demo_pitch.pptx
+++ b/demo_pitch.pptx
@@ -19,6 +19,7 @@
     <p:sldId id="267" r:id="rId18"/>
     <p:sldId id="268" r:id="rId19"/>
     <p:sldId id="269" r:id="rId20"/>
+    <p:sldId id="270" r:id="rId21"/>
   </p:sldIdLst>
   <p:sldSz cx="12191695" cy="6858000" type="screen4x3"/>
   <p:notesSz cx="6858000" cy="9144000"/>
@@ -4261,7 +4262,7 @@
                 </a:solidFill>
                 <a:latin typeface="Calibri"/>
               </a:rPr>
-              <a:t>10 / 14</a:t>
+              <a:t>10 / 15</a:t>
             </a:r>
           </a:p>
         </p:txBody>
@@ -5582,7 +5583,7 @@
                 </a:solidFill>
                 <a:latin typeface="Calibri"/>
               </a:rPr>
-              <a:t>11 / 14</a:t>
+              <a:t>11 / 15</a:t>
             </a:r>
           </a:p>
         </p:txBody>
@@ -5678,7 +5679,7 @@
                 </a:solidFill>
                 <a:latin typeface="Calibri"/>
               </a:rPr>
-              <a:t>The strategic insight</a:t>
+              <a:t>What the chamber needs to do next</a:t>
             </a:r>
           </a:p>
         </p:txBody>
@@ -5756,7 +5757,7 @@
                 </a:solidFill>
                 <a:latin typeface="Calibri"/>
               </a:rPr>
-              <a:t>What sets this apart from a generic tourism site.</a:t>
+              <a:t>Findings from building the scraper layer — items that need a person, not more code.</a:t>
             </a:r>
           </a:p>
         </p:txBody>
@@ -5770,7 +5771,7 @@
         <p:spPr>
           <a:xfrm>
             <a:off x="548640" y="1691640"/>
-            <a:ext cx="11064240" cy="914400"/>
+            <a:ext cx="3657600" cy="365760"/>
           </a:xfrm>
           <a:prstGeom prst="rect">
             <a:avLst/>
@@ -5785,13 +5786,13 @@
           <a:p>
             <a:pPr algn="l"/>
             <a:r>
-              <a:rPr sz="1500" b="0" i="0">
-                <a:solidFill>
-                  <a:srgbClr val="1E1508"/>
-                </a:solidFill>
-                <a:latin typeface="Calibri"/>
-              </a:rPr>
-              <a:t>Most tourism sites optimize for visits to the site. The right metric is lodging bookings driven by the site. Those are different optimization targets.</a:t>
+              <a:rPr sz="1200" b="1" i="0">
+                <a:solidFill>
+                  <a:srgbClr val="C9A84C"/>
+                </a:solidFill>
+                <a:latin typeface="Calibri"/>
+              </a:rPr>
+              <a:t>DATA PARTNERSHIPS</a:t>
             </a:r>
           </a:p>
         </p:txBody>
@@ -5804,8 +5805,8 @@
         </p:nvSpPr>
         <p:spPr>
           <a:xfrm>
-            <a:off x="548640" y="2697480"/>
-            <a:ext cx="11064240" cy="3200400"/>
+            <a:off x="548640" y="2057400"/>
+            <a:ext cx="3657600" cy="3840480"/>
           </a:xfrm>
           <a:prstGeom prst="rect">
             <a:avLst/>
@@ -5820,11 +5821,11 @@
           <a:p>
             <a:pPr algn="l">
               <a:lnSpc>
-                <a:spcPct val="140000"/>
+                <a:spcPct val="135000"/>
               </a:lnSpc>
             </a:pPr>
             <a:r>
-              <a:rPr sz="1400" b="1">
+              <a:rPr sz="1100" b="1">
                 <a:solidFill>
                   <a:srgbClr val="C9A84C"/>
                 </a:solidFill>
@@ -5833,26 +5834,26 @@
               <a:t>• </a:t>
             </a:r>
             <a:r>
-              <a:rPr sz="1200">
+              <a:rPr sz="900">
                 <a:solidFill>
                   <a:srgbClr val="1E1508"/>
                 </a:solidFill>
                 <a:latin typeface="Calibri"/>
               </a:rPr>
-              <a:t>Day-by-day itinerary view structurally surfaces the "where do I sleep?" question</a:t>
+              <a:t>Ask NCAC for read access to their Trumba master — its 540-event, 16-month window is the most comprehensive feed in the county</a:t>
             </a:r>
           </a:p>
           <a:p>
             <a:pPr algn="l">
               <a:lnSpc>
-                <a:spcPct val="140000"/>
+                <a:spcPct val="135000"/>
               </a:lnSpc>
               <a:spcBef>
                 <a:spcPts val="600"/>
               </a:spcBef>
             </a:pPr>
             <a:r>
-              <a:rPr sz="1400" b="1">
+              <a:rPr sz="1100" b="1">
                 <a:solidFill>
                   <a:srgbClr val="C9A84C"/>
                 </a:solidFill>
@@ -5861,26 +5862,26 @@
               <a:t>• </a:t>
             </a:r>
             <a:r>
-              <a:rPr sz="1200">
+              <a:rPr sz="900">
                 <a:solidFill>
                   <a:srgbClr val="1E1508"/>
                 </a:solidFill>
                 <a:latin typeface="Calibri"/>
               </a:rPr>
-              <a:t>"Find Lodging" CTA at the top of every itinerary — booking always one click away</a:t>
+              <a:t>Reach out to GoNevadaCounty (gonevadacounty.com) for a public events feed — Cloudflare blocks scrapers and we lose the 13 anchor festivals</a:t>
             </a:r>
           </a:p>
           <a:p>
             <a:pPr algn="l">
               <a:lnSpc>
-                <a:spcPct val="140000"/>
+                <a:spcPct val="135000"/>
               </a:lnSpc>
               <a:spcBef>
                 <a:spcPts val="600"/>
               </a:spcBef>
             </a:pPr>
             <a:r>
-              <a:rPr sz="1400" b="1">
+              <a:rPr sz="1100" b="1">
                 <a:solidFill>
                   <a:srgbClr val="C9A84C"/>
                 </a:solidFill>
@@ -5889,26 +5890,26 @@
               <a:t>• </a:t>
             </a:r>
             <a:r>
-              <a:rPr sz="1200">
+              <a:rPr sz="900">
                 <a:solidFill>
                   <a:srgbClr val="1E1508"/>
                 </a:solidFill>
                 <a:latin typeface="Calibri"/>
               </a:rPr>
-              <a:t>Empty lodging slots create a visual gap that drives the booking decision</a:t>
+              <a:t>Coordinate with The Union for a public events feed — articles are paywalled and the RSS often returns nothing scrape-able</a:t>
             </a:r>
           </a:p>
           <a:p>
             <a:pPr algn="l">
               <a:lnSpc>
-                <a:spcPct val="140000"/>
+                <a:spcPct val="135000"/>
               </a:lnSpc>
               <a:spcBef>
                 <a:spcPts val="600"/>
               </a:spcBef>
             </a:pPr>
             <a:r>
-              <a:rPr sz="1400" b="1">
+              <a:rPr sz="1100" b="1">
                 <a:solidFill>
                   <a:srgbClr val="C9A84C"/>
                 </a:solidFill>
@@ -5917,26 +5918,109 @@
               <a:t>• </a:t>
             </a:r>
             <a:r>
-              <a:rPr sz="1200">
+              <a:rPr sz="900">
                 <a:solidFill>
                   <a:srgbClr val="1E1508"/>
                 </a:solidFill>
                 <a:latin typeface="Calibri"/>
               </a:rPr>
-              <a:t>New items default to the latest day — no day-1 pile-up; trip naturally fills out</a:t>
-            </a:r>
-          </a:p>
+              <a:t>Confirm whether the County itself runs a Trumba master calendar — if so, federate from it instead of NCAC alone</a:t>
+            </a:r>
+          </a:p>
+        </p:txBody>
+      </p:sp>
+      <p:sp>
+        <p:nvSpPr>
+          <p:cNvPr id="7" name="TextBox 6"/>
+          <p:cNvSpPr txBox="1"/>
+          <p:nvPr/>
+        </p:nvSpPr>
+        <p:spPr>
+          <a:xfrm>
+            <a:off x="4297680" y="1691640"/>
+            <a:ext cx="3657600" cy="365760"/>
+          </a:xfrm>
+          <a:prstGeom prst="rect">
+            <a:avLst/>
+          </a:prstGeom>
+          <a:noFill/>
+        </p:spPr>
+        <p:txBody>
+          <a:bodyPr wrap="square" anchor="t" lIns="45720" rIns="45720" tIns="18288" bIns="18288">
+            <a:spAutoFit/>
+          </a:bodyPr>
+          <a:lstStyle/>
+          <a:p>
+            <a:pPr algn="l"/>
+            <a:r>
+              <a:rPr sz="1200" b="1" i="0">
+                <a:solidFill>
+                  <a:srgbClr val="C9A84C"/>
+                </a:solidFill>
+                <a:latin typeface="Calibri"/>
+              </a:rPr>
+              <a:t>MEMBER OUTREACH</a:t>
+            </a:r>
+          </a:p>
+        </p:txBody>
+      </p:sp>
+      <p:sp>
+        <p:nvSpPr>
+          <p:cNvPr id="8" name="TextBox 7"/>
+          <p:cNvSpPr txBox="1"/>
+          <p:nvPr/>
+        </p:nvSpPr>
+        <p:spPr>
+          <a:xfrm>
+            <a:off x="4297680" y="2057400"/>
+            <a:ext cx="3657600" cy="3840480"/>
+          </a:xfrm>
+          <a:prstGeom prst="rect">
+            <a:avLst/>
+          </a:prstGeom>
+          <a:noFill/>
+        </p:spPr>
+        <p:txBody>
+          <a:bodyPr wrap="square" lIns="45720" rIns="45720">
+            <a:spAutoFit/>
+          </a:bodyPr>
+          <a:lstStyle/>
           <a:p>
             <a:pPr algn="l">
               <a:lnSpc>
-                <a:spcPct val="140000"/>
+                <a:spcPct val="135000"/>
+              </a:lnSpc>
+            </a:pPr>
+            <a:r>
+              <a:rPr sz="1100" b="1">
+                <a:solidFill>
+                  <a:srgbClr val="C9A84C"/>
+                </a:solidFill>
+                <a:latin typeface="Calibri"/>
+              </a:rPr>
+              <a:t>• </a:t>
+            </a:r>
+            <a:r>
+              <a:rPr sz="900">
+                <a:solidFill>
+                  <a:srgbClr val="1E1508"/>
+                </a:solidFill>
+                <a:latin typeface="Calibri"/>
+              </a:rPr>
+              <a:t>Encourage venues to publish events on a platform with a public feed — Trumba, Tribe Events (WordPress), Eventbrite — not just static HTML pages</a:t>
+            </a:r>
+          </a:p>
+          <a:p>
+            <a:pPr algn="l">
+              <a:lnSpc>
+                <a:spcPct val="135000"/>
               </a:lnSpc>
               <a:spcBef>
                 <a:spcPts val="600"/>
               </a:spcBef>
             </a:pPr>
             <a:r>
-              <a:rPr sz="1400" b="1">
+              <a:rPr sz="1100" b="1">
                 <a:solidFill>
                   <a:srgbClr val="C9A84C"/>
                 </a:solidFill>
@@ -5945,26 +6029,26 @@
               <a:t>• </a:t>
             </a:r>
             <a:r>
-              <a:rPr sz="1200">
+              <a:rPr sz="900">
                 <a:solidFill>
                   <a:srgbClr val="1E1508"/>
                 </a:solidFill>
                 <a:latin typeface="Calibri"/>
               </a:rPr>
-              <a:t>Print view goes long-form per day — visitors who print, follow it</a:t>
+              <a:t>Push schema.org/Event JSON-LD adoption — one snippet on each event page makes scraping reliable without custom code per site</a:t>
             </a:r>
           </a:p>
           <a:p>
             <a:pPr algn="l">
               <a:lnSpc>
-                <a:spcPct val="140000"/>
+                <a:spcPct val="135000"/>
               </a:lnSpc>
               <a:spcBef>
                 <a:spcPts val="600"/>
               </a:spcBef>
             </a:pPr>
             <a:r>
-              <a:rPr sz="1400" b="1">
+              <a:rPr sz="1100" b="1">
                 <a:solidFill>
                   <a:srgbClr val="C9A84C"/>
                 </a:solidFill>
@@ -5973,27 +6057,222 @@
               <a:t>• </a:t>
             </a:r>
             <a:r>
-              <a:rPr sz="1200">
+              <a:rPr sz="900">
                 <a:solidFill>
                   <a:srgbClr val="1E1508"/>
                 </a:solidFill>
                 <a:latin typeface="Calibri"/>
               </a:rPr>
-              <a:t>Smart suggestions are tag + geography aware — clusters keep visitors close to lodging</a:t>
-            </a:r>
-          </a:p>
-        </p:txBody>
-      </p:sp>
-      <p:sp>
-        <p:nvSpPr>
-          <p:cNvPr id="7" name="Rectangle 6"/>
+              <a:t>Solicit "missing venue" submissions — a simple web form for member venues to flag events that didn't get auto-discovered</a:t>
+            </a:r>
+          </a:p>
+          <a:p>
+            <a:pPr algn="l">
+              <a:lnSpc>
+                <a:spcPct val="135000"/>
+              </a:lnSpc>
+              <a:spcBef>
+                <a:spcPts val="600"/>
+              </a:spcBef>
+            </a:pPr>
+            <a:r>
+              <a:rPr sz="1100" b="1">
+                <a:solidFill>
+                  <a:srgbClr val="C9A84C"/>
+                </a:solidFill>
+                <a:latin typeface="Calibri"/>
+              </a:rPr>
+              <a:t>• </a:t>
+            </a:r>
+            <a:r>
+              <a:rPr sz="900">
+                <a:solidFill>
+                  <a:srgbClr val="1E1508"/>
+                </a:solidFill>
+                <a:latin typeface="Calibri"/>
+              </a:rPr>
+              <a:t>Identify the 5-10 venues responsible for the bulk of visitor traffic and prioritize their data reliability over long-tail coverage</a:t>
+            </a:r>
+          </a:p>
+        </p:txBody>
+      </p:sp>
+      <p:sp>
+        <p:nvSpPr>
+          <p:cNvPr id="9" name="TextBox 8"/>
+          <p:cNvSpPr txBox="1"/>
+          <p:nvPr/>
+        </p:nvSpPr>
+        <p:spPr>
+          <a:xfrm>
+            <a:off x="8046720" y="1691640"/>
+            <a:ext cx="3657600" cy="365760"/>
+          </a:xfrm>
+          <a:prstGeom prst="rect">
+            <a:avLst/>
+          </a:prstGeom>
+          <a:noFill/>
+        </p:spPr>
+        <p:txBody>
+          <a:bodyPr wrap="square" anchor="t" lIns="45720" rIns="45720" tIns="18288" bIns="18288">
+            <a:spAutoFit/>
+          </a:bodyPr>
+          <a:lstStyle/>
+          <a:p>
+            <a:pPr algn="l"/>
+            <a:r>
+              <a:rPr sz="1200" b="1" i="0">
+                <a:solidFill>
+                  <a:srgbClr val="C9A84C"/>
+                </a:solidFill>
+                <a:latin typeface="Calibri"/>
+              </a:rPr>
+              <a:t>OPERATIONS</a:t>
+            </a:r>
+          </a:p>
+        </p:txBody>
+      </p:sp>
+      <p:sp>
+        <p:nvSpPr>
+          <p:cNvPr id="10" name="TextBox 9"/>
+          <p:cNvSpPr txBox="1"/>
+          <p:nvPr/>
+        </p:nvSpPr>
+        <p:spPr>
+          <a:xfrm>
+            <a:off x="8046720" y="2057400"/>
+            <a:ext cx="3657600" cy="3840480"/>
+          </a:xfrm>
+          <a:prstGeom prst="rect">
+            <a:avLst/>
+          </a:prstGeom>
+          <a:noFill/>
+        </p:spPr>
+        <p:txBody>
+          <a:bodyPr wrap="square" lIns="45720" rIns="45720">
+            <a:spAutoFit/>
+          </a:bodyPr>
+          <a:lstStyle/>
+          <a:p>
+            <a:pPr algn="l">
+              <a:lnSpc>
+                <a:spcPct val="135000"/>
+              </a:lnSpc>
+            </a:pPr>
+            <a:r>
+              <a:rPr sz="1100" b="1">
+                <a:solidFill>
+                  <a:srgbClr val="C9A84C"/>
+                </a:solidFill>
+                <a:latin typeface="Calibri"/>
+              </a:rPr>
+              <a:t>• </a:t>
+            </a:r>
+            <a:r>
+              <a:rPr sz="900">
+                <a:solidFill>
+                  <a:srgbClr val="1E1508"/>
+                </a:solidFill>
+                <a:latin typeface="Calibri"/>
+              </a:rPr>
+              <a:t>Designate a queue curator — someone clears the pending-events queue 1-2x per week (Approve / Dismiss takes ~5 minutes per session)</a:t>
+            </a:r>
+          </a:p>
+          <a:p>
+            <a:pPr algn="l">
+              <a:lnSpc>
+                <a:spcPct val="135000"/>
+              </a:lnSpc>
+              <a:spcBef>
+                <a:spcPts val="600"/>
+              </a:spcBef>
+            </a:pPr>
+            <a:r>
+              <a:rPr sz="1100" b="1">
+                <a:solidFill>
+                  <a:srgbClr val="C9A84C"/>
+                </a:solidFill>
+                <a:latin typeface="Calibri"/>
+              </a:rPr>
+              <a:t>• </a:t>
+            </a:r>
+            <a:r>
+              <a:rPr sz="900">
+                <a:solidFill>
+                  <a:srgbClr val="1E1508"/>
+                </a:solidFill>
+                <a:latin typeface="Calibri"/>
+              </a:rPr>
+              <a:t>Run AI Categorize after each scrape — fixes venue, area, tags on long-tail events ($0.50/mo)</a:t>
+            </a:r>
+          </a:p>
+          <a:p>
+            <a:pPr algn="l">
+              <a:lnSpc>
+                <a:spcPct val="135000"/>
+              </a:lnSpc>
+              <a:spcBef>
+                <a:spcPts val="600"/>
+              </a:spcBef>
+            </a:pPr>
+            <a:r>
+              <a:rPr sz="1100" b="1">
+                <a:solidFill>
+                  <a:srgbClr val="C9A84C"/>
+                </a:solidFill>
+                <a:latin typeface="Calibri"/>
+              </a:rPr>
+              <a:t>• </a:t>
+            </a:r>
+            <a:r>
+              <a:rPr sz="900">
+                <a:solidFill>
+                  <a:srgbClr val="1E1508"/>
+                </a:solidFill>
+                <a:latin typeface="Calibri"/>
+              </a:rPr>
+              <a:t>Validate "no event" alerts — when a scraper returns 0 events, the source has either gone down or restructured (NCAC was a false negative for months before we caught it)</a:t>
+            </a:r>
+          </a:p>
+          <a:p>
+            <a:pPr algn="l">
+              <a:lnSpc>
+                <a:spcPct val="135000"/>
+              </a:lnSpc>
+              <a:spcBef>
+                <a:spcPts val="600"/>
+              </a:spcBef>
+            </a:pPr>
+            <a:r>
+              <a:rPr sz="1100" b="1">
+                <a:solidFill>
+                  <a:srgbClr val="C9A84C"/>
+                </a:solidFill>
+                <a:latin typeface="Calibri"/>
+              </a:rPr>
+              <a:t>• </a:t>
+            </a:r>
+            <a:r>
+              <a:rPr sz="900">
+                <a:solidFill>
+                  <a:srgbClr val="1E1508"/>
+                </a:solidFill>
+                <a:latin typeface="Calibri"/>
+              </a:rPr>
+              <a:t>Quarterly review of disabled scrapers — vendors change platforms (e.g. NCAC moved to Trumba) and previously-blocked sources become reachable</a:t>
+            </a:r>
+          </a:p>
+        </p:txBody>
+      </p:sp>
+      <p:sp>
+        <p:nvSpPr>
+          <p:cNvPr id="11" name="Rectangle 10"/>
           <p:cNvSpPr/>
           <p:nvPr/>
         </p:nvSpPr>
         <p:spPr>
           <a:xfrm>
-            <a:off x="548640" y="5669280"/>
-            <a:ext cx="11064240" cy="640080"/>
+            <a:off x="548640" y="5943600"/>
+            <a:ext cx="11064240" cy="457200"/>
           </a:xfrm>
           <a:prstGeom prst="rect">
             <a:avLst/>
@@ -6032,14 +6311,14 @@
       </p:sp>
       <p:sp>
         <p:nvSpPr>
-          <p:cNvPr id="8" name="TextBox 7"/>
-          <p:cNvSpPr txBox="1"/>
-          <p:nvPr/>
-        </p:nvSpPr>
-        <p:spPr>
-          <a:xfrm>
-            <a:off x="640080" y="5715000"/>
-            <a:ext cx="10881360" cy="548640"/>
+          <p:cNvPr id="12" name="TextBox 11"/>
+          <p:cNvSpPr txBox="1"/>
+          <p:nvPr/>
+        </p:nvSpPr>
+        <p:spPr>
+          <a:xfrm>
+            <a:off x="640080" y="5989320"/>
+            <a:ext cx="10881360" cy="365760"/>
           </a:xfrm>
           <a:prstGeom prst="rect">
             <a:avLst/>
@@ -6054,20 +6333,20 @@
           <a:p>
             <a:pPr algn="ctr"/>
             <a:r>
-              <a:rPr sz="1300" b="0" i="1">
+              <a:rPr sz="1000" b="0" i="1">
                 <a:solidFill>
                   <a:srgbClr val="5C3A1F"/>
                 </a:solidFill>
                 <a:latin typeface="Calibri"/>
               </a:rPr>
-              <a:t>"Convince a visitor to add one more night and you double or triple local revenue."</a:t>
-            </a:r>
-          </a:p>
-        </p:txBody>
-      </p:sp>
-      <p:sp>
-        <p:nvSpPr>
-          <p:cNvPr id="9" name="TextBox 8"/>
+              <a:t>Concrete win from this work:  NCAC's calendar went from "0 events" (blocked by an iframe) to 540 events — by hitting Trumba's JSON feed directly.</a:t>
+            </a:r>
+          </a:p>
+        </p:txBody>
+      </p:sp>
+      <p:sp>
+        <p:nvSpPr>
+          <p:cNvPr id="13" name="TextBox 12"/>
           <p:cNvSpPr txBox="1"/>
           <p:nvPr/>
         </p:nvSpPr>
@@ -6102,7 +6381,7 @@
       </p:sp>
       <p:sp>
         <p:nvSpPr>
-          <p:cNvPr id="10" name="TextBox 9"/>
+          <p:cNvPr id="14" name="TextBox 13"/>
           <p:cNvSpPr txBox="1"/>
           <p:nvPr/>
         </p:nvSpPr>
@@ -6130,14 +6409,14 @@
                 </a:solidFill>
                 <a:latin typeface="Calibri"/>
               </a:rPr>
-              <a:t>12 / 14</a:t>
-            </a:r>
-          </a:p>
-        </p:txBody>
-      </p:sp>
-      <p:sp>
-        <p:nvSpPr>
-          <p:cNvPr id="11" name="Rectangle 10"/>
+              <a:t>12 / 15</a:t>
+            </a:r>
+          </a:p>
+        </p:txBody>
+      </p:sp>
+      <p:sp>
+        <p:nvSpPr>
+          <p:cNvPr id="15" name="Rectangle 14"/>
           <p:cNvSpPr/>
           <p:nvPr/>
         </p:nvSpPr>
@@ -6226,7 +6505,7 @@
                 </a:solidFill>
                 <a:latin typeface="Calibri"/>
               </a:rPr>
-              <a:t>The 8-minute demo flow</a:t>
+              <a:t>The strategic insight</a:t>
             </a:r>
           </a:p>
         </p:txBody>
@@ -6304,30 +6583,255 @@
                 </a:solidFill>
                 <a:latin typeface="Calibri"/>
               </a:rPr>
-              <a:t>A visitor planning a romantic November weekend in Western Nevada County.</a:t>
-            </a:r>
-          </a:p>
-        </p:txBody>
-      </p:sp>
-      <p:sp>
-        <p:nvSpPr>
-          <p:cNvPr id="5" name="Rectangle 4"/>
+              <a:t>What sets this apart from a generic tourism site.</a:t>
+            </a:r>
+          </a:p>
+        </p:txBody>
+      </p:sp>
+      <p:sp>
+        <p:nvSpPr>
+          <p:cNvPr id="5" name="TextBox 4"/>
+          <p:cNvSpPr txBox="1"/>
+          <p:nvPr/>
+        </p:nvSpPr>
+        <p:spPr>
+          <a:xfrm>
+            <a:off x="548640" y="1691640"/>
+            <a:ext cx="11064240" cy="914400"/>
+          </a:xfrm>
+          <a:prstGeom prst="rect">
+            <a:avLst/>
+          </a:prstGeom>
+          <a:noFill/>
+        </p:spPr>
+        <p:txBody>
+          <a:bodyPr wrap="square" anchor="t" lIns="45720" rIns="45720" tIns="18288" bIns="18288">
+            <a:spAutoFit/>
+          </a:bodyPr>
+          <a:lstStyle/>
+          <a:p>
+            <a:pPr algn="l"/>
+            <a:r>
+              <a:rPr sz="1500" b="0" i="0">
+                <a:solidFill>
+                  <a:srgbClr val="1E1508"/>
+                </a:solidFill>
+                <a:latin typeface="Calibri"/>
+              </a:rPr>
+              <a:t>Most tourism sites optimize for visits to the site. The right metric is lodging bookings driven by the site. Those are different optimization targets.</a:t>
+            </a:r>
+          </a:p>
+        </p:txBody>
+      </p:sp>
+      <p:sp>
+        <p:nvSpPr>
+          <p:cNvPr id="6" name="TextBox 5"/>
+          <p:cNvSpPr txBox="1"/>
+          <p:nvPr/>
+        </p:nvSpPr>
+        <p:spPr>
+          <a:xfrm>
+            <a:off x="548640" y="2697480"/>
+            <a:ext cx="11064240" cy="3200400"/>
+          </a:xfrm>
+          <a:prstGeom prst="rect">
+            <a:avLst/>
+          </a:prstGeom>
+          <a:noFill/>
+        </p:spPr>
+        <p:txBody>
+          <a:bodyPr wrap="square" lIns="45720" rIns="45720">
+            <a:spAutoFit/>
+          </a:bodyPr>
+          <a:lstStyle/>
+          <a:p>
+            <a:pPr algn="l">
+              <a:lnSpc>
+                <a:spcPct val="140000"/>
+              </a:lnSpc>
+            </a:pPr>
+            <a:r>
+              <a:rPr sz="1400" b="1">
+                <a:solidFill>
+                  <a:srgbClr val="C9A84C"/>
+                </a:solidFill>
+                <a:latin typeface="Calibri"/>
+              </a:rPr>
+              <a:t>• </a:t>
+            </a:r>
+            <a:r>
+              <a:rPr sz="1200">
+                <a:solidFill>
+                  <a:srgbClr val="1E1508"/>
+                </a:solidFill>
+                <a:latin typeface="Calibri"/>
+              </a:rPr>
+              <a:t>Day-by-day itinerary view structurally surfaces the "where do I sleep?" question</a:t>
+            </a:r>
+          </a:p>
+          <a:p>
+            <a:pPr algn="l">
+              <a:lnSpc>
+                <a:spcPct val="140000"/>
+              </a:lnSpc>
+              <a:spcBef>
+                <a:spcPts val="600"/>
+              </a:spcBef>
+            </a:pPr>
+            <a:r>
+              <a:rPr sz="1400" b="1">
+                <a:solidFill>
+                  <a:srgbClr val="C9A84C"/>
+                </a:solidFill>
+                <a:latin typeface="Calibri"/>
+              </a:rPr>
+              <a:t>• </a:t>
+            </a:r>
+            <a:r>
+              <a:rPr sz="1200">
+                <a:solidFill>
+                  <a:srgbClr val="1E1508"/>
+                </a:solidFill>
+                <a:latin typeface="Calibri"/>
+              </a:rPr>
+              <a:t>"Find Lodging" CTA at the top of every itinerary — booking always one click away</a:t>
+            </a:r>
+          </a:p>
+          <a:p>
+            <a:pPr algn="l">
+              <a:lnSpc>
+                <a:spcPct val="140000"/>
+              </a:lnSpc>
+              <a:spcBef>
+                <a:spcPts val="600"/>
+              </a:spcBef>
+            </a:pPr>
+            <a:r>
+              <a:rPr sz="1400" b="1">
+                <a:solidFill>
+                  <a:srgbClr val="C9A84C"/>
+                </a:solidFill>
+                <a:latin typeface="Calibri"/>
+              </a:rPr>
+              <a:t>• </a:t>
+            </a:r>
+            <a:r>
+              <a:rPr sz="1200">
+                <a:solidFill>
+                  <a:srgbClr val="1E1508"/>
+                </a:solidFill>
+                <a:latin typeface="Calibri"/>
+              </a:rPr>
+              <a:t>Empty lodging slots create a visual gap that drives the booking decision</a:t>
+            </a:r>
+          </a:p>
+          <a:p>
+            <a:pPr algn="l">
+              <a:lnSpc>
+                <a:spcPct val="140000"/>
+              </a:lnSpc>
+              <a:spcBef>
+                <a:spcPts val="600"/>
+              </a:spcBef>
+            </a:pPr>
+            <a:r>
+              <a:rPr sz="1400" b="1">
+                <a:solidFill>
+                  <a:srgbClr val="C9A84C"/>
+                </a:solidFill>
+                <a:latin typeface="Calibri"/>
+              </a:rPr>
+              <a:t>• </a:t>
+            </a:r>
+            <a:r>
+              <a:rPr sz="1200">
+                <a:solidFill>
+                  <a:srgbClr val="1E1508"/>
+                </a:solidFill>
+                <a:latin typeface="Calibri"/>
+              </a:rPr>
+              <a:t>New items default to the latest day — no day-1 pile-up; trip naturally fills out</a:t>
+            </a:r>
+          </a:p>
+          <a:p>
+            <a:pPr algn="l">
+              <a:lnSpc>
+                <a:spcPct val="140000"/>
+              </a:lnSpc>
+              <a:spcBef>
+                <a:spcPts val="600"/>
+              </a:spcBef>
+            </a:pPr>
+            <a:r>
+              <a:rPr sz="1400" b="1">
+                <a:solidFill>
+                  <a:srgbClr val="C9A84C"/>
+                </a:solidFill>
+                <a:latin typeface="Calibri"/>
+              </a:rPr>
+              <a:t>• </a:t>
+            </a:r>
+            <a:r>
+              <a:rPr sz="1200">
+                <a:solidFill>
+                  <a:srgbClr val="1E1508"/>
+                </a:solidFill>
+                <a:latin typeface="Calibri"/>
+              </a:rPr>
+              <a:t>Print view goes long-form per day — visitors who print, follow it</a:t>
+            </a:r>
+          </a:p>
+          <a:p>
+            <a:pPr algn="l">
+              <a:lnSpc>
+                <a:spcPct val="140000"/>
+              </a:lnSpc>
+              <a:spcBef>
+                <a:spcPts val="600"/>
+              </a:spcBef>
+            </a:pPr>
+            <a:r>
+              <a:rPr sz="1400" b="1">
+                <a:solidFill>
+                  <a:srgbClr val="C9A84C"/>
+                </a:solidFill>
+                <a:latin typeface="Calibri"/>
+              </a:rPr>
+              <a:t>• </a:t>
+            </a:r>
+            <a:r>
+              <a:rPr sz="1200">
+                <a:solidFill>
+                  <a:srgbClr val="1E1508"/>
+                </a:solidFill>
+                <a:latin typeface="Calibri"/>
+              </a:rPr>
+              <a:t>Smart suggestions are tag + geography aware — clusters keep visitors close to lodging</a:t>
+            </a:r>
+          </a:p>
+        </p:txBody>
+      </p:sp>
+      <p:sp>
+        <p:nvSpPr>
+          <p:cNvPr id="7" name="Rectangle 6"/>
           <p:cNvSpPr/>
           <p:nvPr/>
         </p:nvSpPr>
         <p:spPr>
           <a:xfrm>
-            <a:off x="548640" y="1691640"/>
-            <a:ext cx="11064240" cy="384048"/>
+            <a:off x="548640" y="5669280"/>
+            <a:ext cx="11064240" cy="640080"/>
           </a:xfrm>
           <a:prstGeom prst="rect">
             <a:avLst/>
           </a:prstGeom>
           <a:solidFill>
-            <a:srgbClr val="F5EFE2"/>
+            <a:srgbClr val="FBF7EE"/>
           </a:solidFill>
-          <a:ln>
-            <a:noFill/>
+          <a:ln w="6350">
+            <a:solidFill>
+              <a:srgbClr val="C9A84C"/>
+            </a:solidFill>
           </a:ln>
           <a:effectLst/>
         </p:spPr>
@@ -6355,602 +6859,42 @@
       </p:sp>
       <p:sp>
         <p:nvSpPr>
-          <p:cNvPr id="6" name="TextBox 5"/>
-          <p:cNvSpPr txBox="1"/>
-          <p:nvPr/>
-        </p:nvSpPr>
-        <p:spPr>
-          <a:xfrm>
-            <a:off x="640080" y="1737360"/>
-            <a:ext cx="1691640" cy="292608"/>
-          </a:xfrm>
-          <a:prstGeom prst="rect">
-            <a:avLst/>
-          </a:prstGeom>
-          <a:noFill/>
-        </p:spPr>
-        <p:txBody>
-          <a:bodyPr wrap="square" anchor="t" lIns="45720" rIns="45720" tIns="18288" bIns="18288">
-            <a:spAutoFit/>
-          </a:bodyPr>
-          <a:lstStyle/>
-          <a:p>
-            <a:pPr algn="l"/>
-            <a:r>
-              <a:rPr sz="1100" b="1" i="0">
+          <p:cNvPr id="8" name="TextBox 7"/>
+          <p:cNvSpPr txBox="1"/>
+          <p:nvPr/>
+        </p:nvSpPr>
+        <p:spPr>
+          <a:xfrm>
+            <a:off x="640080" y="5715000"/>
+            <a:ext cx="10881360" cy="548640"/>
+          </a:xfrm>
+          <a:prstGeom prst="rect">
+            <a:avLst/>
+          </a:prstGeom>
+          <a:noFill/>
+        </p:spPr>
+        <p:txBody>
+          <a:bodyPr wrap="square" anchor="ctr" lIns="45720" rIns="45720" tIns="18288" bIns="18288">
+            <a:spAutoFit/>
+          </a:bodyPr>
+          <a:lstStyle/>
+          <a:p>
+            <a:pPr algn="ctr"/>
+            <a:r>
+              <a:rPr sz="1300" b="0" i="1">
                 <a:solidFill>
                   <a:srgbClr val="5C3A1F"/>
                 </a:solidFill>
                 <a:latin typeface="Calibri"/>
               </a:rPr>
-              <a:t>Act</a:t>
-            </a:r>
-          </a:p>
-        </p:txBody>
-      </p:sp>
-      <p:sp>
-        <p:nvSpPr>
-          <p:cNvPr id="7" name="TextBox 6"/>
-          <p:cNvSpPr txBox="1"/>
-          <p:nvPr/>
-        </p:nvSpPr>
-        <p:spPr>
-          <a:xfrm>
-            <a:off x="2468880" y="1737360"/>
-            <a:ext cx="9098280" cy="292608"/>
-          </a:xfrm>
-          <a:prstGeom prst="rect">
-            <a:avLst/>
-          </a:prstGeom>
-          <a:noFill/>
-        </p:spPr>
-        <p:txBody>
-          <a:bodyPr wrap="square" anchor="t" lIns="45720" rIns="45720" tIns="18288" bIns="18288">
-            <a:spAutoFit/>
-          </a:bodyPr>
-          <a:lstStyle/>
-          <a:p>
-            <a:pPr algn="l"/>
-            <a:r>
-              <a:rPr sz="1100" b="1" i="0">
-                <a:solidFill>
-                  <a:srgbClr val="5C3A1F"/>
-                </a:solidFill>
-                <a:latin typeface="Calibri"/>
-              </a:rPr>
-              <a:t>What happens</a:t>
-            </a:r>
-          </a:p>
-        </p:txBody>
-      </p:sp>
-      <p:sp>
-        <p:nvSpPr>
-          <p:cNvPr id="8" name="Rectangle 7"/>
-          <p:cNvSpPr/>
-          <p:nvPr/>
-        </p:nvSpPr>
-        <p:spPr>
-          <a:xfrm>
-            <a:off x="548640" y="2075688"/>
-            <a:ext cx="11064240" cy="25400"/>
-          </a:xfrm>
-          <a:prstGeom prst="rect">
-            <a:avLst/>
-          </a:prstGeom>
-          <a:solidFill>
-            <a:srgbClr val="C9A84C"/>
-          </a:solidFill>
-          <a:ln>
-            <a:noFill/>
-          </a:ln>
-        </p:spPr>
-        <p:style>
-          <a:lnRef idx="1">
-            <a:schemeClr val="accent1"/>
-          </a:lnRef>
-          <a:fillRef idx="3">
-            <a:schemeClr val="accent1"/>
-          </a:fillRef>
-          <a:effectRef idx="2">
-            <a:schemeClr val="accent1"/>
-          </a:effectRef>
-          <a:fontRef idx="minor">
-            <a:schemeClr val="lt1"/>
-          </a:fontRef>
-        </p:style>
-        <p:txBody>
-          <a:bodyPr rtlCol="0" anchor="ctr"/>
-          <a:lstStyle/>
-          <a:p>
-            <a:pPr algn="ctr"/>
-          </a:p>
-        </p:txBody>
-      </p:sp>
-      <p:sp>
-        <p:nvSpPr>
-          <p:cNvPr id="9" name="Rectangle 8"/>
-          <p:cNvSpPr/>
-          <p:nvPr/>
-        </p:nvSpPr>
-        <p:spPr>
-          <a:xfrm>
-            <a:off x="548640" y="2112264"/>
-            <a:ext cx="11064240" cy="777240"/>
-          </a:xfrm>
-          <a:prstGeom prst="rect">
-            <a:avLst/>
-          </a:prstGeom>
-          <a:solidFill>
-            <a:srgbClr val="FBF7EE"/>
-          </a:solidFill>
-          <a:ln>
-            <a:noFill/>
-          </a:ln>
-          <a:effectLst/>
-        </p:spPr>
-        <p:style>
-          <a:lnRef idx="1">
-            <a:schemeClr val="accent1"/>
-          </a:lnRef>
-          <a:fillRef idx="3">
-            <a:schemeClr val="accent1"/>
-          </a:fillRef>
-          <a:effectRef idx="2">
-            <a:schemeClr val="accent1"/>
-          </a:effectRef>
-          <a:fontRef idx="minor">
-            <a:schemeClr val="lt1"/>
-          </a:fontRef>
-        </p:style>
-        <p:txBody>
-          <a:bodyPr rtlCol="0" anchor="ctr"/>
-          <a:lstStyle/>
-          <a:p>
-            <a:pPr algn="ctr"/>
-          </a:p>
-        </p:txBody>
-      </p:sp>
-      <p:sp>
-        <p:nvSpPr>
-          <p:cNvPr id="10" name="TextBox 9"/>
-          <p:cNvSpPr txBox="1"/>
-          <p:nvPr/>
-        </p:nvSpPr>
-        <p:spPr>
-          <a:xfrm>
-            <a:off x="640080" y="2157984"/>
-            <a:ext cx="1691640" cy="731519"/>
-          </a:xfrm>
-          <a:prstGeom prst="rect">
-            <a:avLst/>
-          </a:prstGeom>
-          <a:noFill/>
-        </p:spPr>
-        <p:txBody>
-          <a:bodyPr wrap="square" anchor="t" lIns="45720" rIns="45720" tIns="18288" bIns="18288">
-            <a:spAutoFit/>
-          </a:bodyPr>
-          <a:lstStyle/>
-          <a:p>
-            <a:pPr algn="l"/>
-            <a:r>
-              <a:rPr sz="1100" b="0" i="0">
-                <a:solidFill>
-                  <a:srgbClr val="1E1508"/>
-                </a:solidFill>
-                <a:latin typeface="Calibri"/>
-              </a:rPr>
-              <a:t>Act 1 · 2 min</a:t>
-            </a:r>
-          </a:p>
-        </p:txBody>
-      </p:sp>
-      <p:sp>
-        <p:nvSpPr>
-          <p:cNvPr id="11" name="TextBox 10"/>
-          <p:cNvSpPr txBox="1"/>
-          <p:nvPr/>
-        </p:nvSpPr>
-        <p:spPr>
-          <a:xfrm>
-            <a:off x="2468880" y="2157984"/>
-            <a:ext cx="9098280" cy="731519"/>
-          </a:xfrm>
-          <a:prstGeom prst="rect">
-            <a:avLst/>
-          </a:prstGeom>
-          <a:noFill/>
-        </p:spPr>
-        <p:txBody>
-          <a:bodyPr wrap="square" anchor="t" lIns="45720" rIns="45720" tIns="18288" bIns="18288">
-            <a:spAutoFit/>
-          </a:bodyPr>
-          <a:lstStyle/>
-          <a:p>
-            <a:pPr algn="l"/>
-            <a:r>
-              <a:rPr sz="1100" b="0" i="0">
-                <a:solidFill>
-                  <a:srgbClr val="1E1508"/>
-                </a:solidFill>
-                <a:latin typeface="Calibri"/>
-              </a:rPr>
-              <a:t>Set the scene — couple from Sacramento, click "This Weekend" + Festivals vibe</a:t>
-            </a:r>
-          </a:p>
-        </p:txBody>
-      </p:sp>
-      <p:sp>
-        <p:nvSpPr>
-          <p:cNvPr id="12" name="TextBox 11"/>
-          <p:cNvSpPr txBox="1"/>
-          <p:nvPr/>
-        </p:nvSpPr>
-        <p:spPr>
-          <a:xfrm>
-            <a:off x="640080" y="2935224"/>
-            <a:ext cx="1691640" cy="731519"/>
-          </a:xfrm>
-          <a:prstGeom prst="rect">
-            <a:avLst/>
-          </a:prstGeom>
-          <a:noFill/>
-        </p:spPr>
-        <p:txBody>
-          <a:bodyPr wrap="square" anchor="t" lIns="45720" rIns="45720" tIns="18288" bIns="18288">
-            <a:spAutoFit/>
-          </a:bodyPr>
-          <a:lstStyle/>
-          <a:p>
-            <a:pPr algn="l"/>
-            <a:r>
-              <a:rPr sz="1100" b="0" i="0">
-                <a:solidFill>
-                  <a:srgbClr val="1E1508"/>
-                </a:solidFill>
-                <a:latin typeface="Calibri"/>
-              </a:rPr>
-              <a:t>Act 2 · 90 sec</a:t>
-            </a:r>
-          </a:p>
-        </p:txBody>
-      </p:sp>
-      <p:sp>
-        <p:nvSpPr>
-          <p:cNvPr id="13" name="TextBox 12"/>
-          <p:cNvSpPr txBox="1"/>
-          <p:nvPr/>
-        </p:nvSpPr>
-        <p:spPr>
-          <a:xfrm>
-            <a:off x="2468880" y="2935224"/>
-            <a:ext cx="9098280" cy="731519"/>
-          </a:xfrm>
-          <a:prstGeom prst="rect">
-            <a:avLst/>
-          </a:prstGeom>
-          <a:noFill/>
-        </p:spPr>
-        <p:txBody>
-          <a:bodyPr wrap="square" anchor="t" lIns="45720" rIns="45720" tIns="18288" bIns="18288">
-            <a:spAutoFit/>
-          </a:bodyPr>
-          <a:lstStyle/>
-          <a:p>
-            <a:pPr algn="l"/>
-            <a:r>
-              <a:rPr sz="1100" b="0" i="0">
-                <a:solidFill>
-                  <a:srgbClr val="1E1508"/>
-                </a:solidFill>
-                <a:latin typeface="Calibri"/>
-              </a:rPr>
-              <a:t>Layer in Relaxed vibe + Lodging category + B&amp;B sub-pill — real Victorian B&amp;Bs surface</a:t>
-            </a:r>
-          </a:p>
-        </p:txBody>
-      </p:sp>
-      <p:sp>
-        <p:nvSpPr>
-          <p:cNvPr id="14" name="Rectangle 13"/>
-          <p:cNvSpPr/>
-          <p:nvPr/>
-        </p:nvSpPr>
-        <p:spPr>
-          <a:xfrm>
-            <a:off x="548640" y="3666744"/>
-            <a:ext cx="11064240" cy="777240"/>
-          </a:xfrm>
-          <a:prstGeom prst="rect">
-            <a:avLst/>
-          </a:prstGeom>
-          <a:solidFill>
-            <a:srgbClr val="FBF7EE"/>
-          </a:solidFill>
-          <a:ln>
-            <a:noFill/>
-          </a:ln>
-          <a:effectLst/>
-        </p:spPr>
-        <p:style>
-          <a:lnRef idx="1">
-            <a:schemeClr val="accent1"/>
-          </a:lnRef>
-          <a:fillRef idx="3">
-            <a:schemeClr val="accent1"/>
-          </a:fillRef>
-          <a:effectRef idx="2">
-            <a:schemeClr val="accent1"/>
-          </a:effectRef>
-          <a:fontRef idx="minor">
-            <a:schemeClr val="lt1"/>
-          </a:fontRef>
-        </p:style>
-        <p:txBody>
-          <a:bodyPr rtlCol="0" anchor="ctr"/>
-          <a:lstStyle/>
-          <a:p>
-            <a:pPr algn="ctr"/>
-          </a:p>
-        </p:txBody>
-      </p:sp>
-      <p:sp>
-        <p:nvSpPr>
-          <p:cNvPr id="15" name="TextBox 14"/>
-          <p:cNvSpPr txBox="1"/>
-          <p:nvPr/>
-        </p:nvSpPr>
-        <p:spPr>
-          <a:xfrm>
-            <a:off x="640080" y="3712464"/>
-            <a:ext cx="1691640" cy="731519"/>
-          </a:xfrm>
-          <a:prstGeom prst="rect">
-            <a:avLst/>
-          </a:prstGeom>
-          <a:noFill/>
-        </p:spPr>
-        <p:txBody>
-          <a:bodyPr wrap="square" anchor="t" lIns="45720" rIns="45720" tIns="18288" bIns="18288">
-            <a:spAutoFit/>
-          </a:bodyPr>
-          <a:lstStyle/>
-          <a:p>
-            <a:pPr algn="l"/>
-            <a:r>
-              <a:rPr sz="1100" b="0" i="0">
-                <a:solidFill>
-                  <a:srgbClr val="1E1508"/>
-                </a:solidFill>
-                <a:latin typeface="Calibri"/>
-              </a:rPr>
-              <a:t>Act 3 · 2 min</a:t>
-            </a:r>
-          </a:p>
-        </p:txBody>
-      </p:sp>
-      <p:sp>
-        <p:nvSpPr>
-          <p:cNvPr id="16" name="TextBox 15"/>
-          <p:cNvSpPr txBox="1"/>
-          <p:nvPr/>
-        </p:nvSpPr>
-        <p:spPr>
-          <a:xfrm>
-            <a:off x="2468880" y="3712464"/>
-            <a:ext cx="9098280" cy="731519"/>
-          </a:xfrm>
-          <a:prstGeom prst="rect">
-            <a:avLst/>
-          </a:prstGeom>
-          <a:noFill/>
-        </p:spPr>
-        <p:txBody>
-          <a:bodyPr wrap="square" anchor="t" lIns="45720" rIns="45720" tIns="18288" bIns="18288">
-            <a:spAutoFit/>
-          </a:bodyPr>
-          <a:lstStyle/>
-          <a:p>
-            <a:pPr algn="l"/>
-            <a:r>
-              <a:rPr sz="1100" b="0" i="0">
-                <a:solidFill>
-                  <a:srgbClr val="1E1508"/>
-                </a:solidFill>
-                <a:latin typeface="Calibri"/>
-              </a:rPr>
-              <a:t>Build the weekend — Cornish Christmas + Holbrooke Hotel + Empire Mine + Lola Restaurant. Open My Itinerary — Smart Suggestions appear with "0.4 mi away" labels. Map view + Print + Share link.</a:t>
-            </a:r>
-          </a:p>
-        </p:txBody>
-      </p:sp>
-      <p:sp>
-        <p:nvSpPr>
-          <p:cNvPr id="17" name="TextBox 16"/>
-          <p:cNvSpPr txBox="1"/>
-          <p:nvPr/>
-        </p:nvSpPr>
-        <p:spPr>
-          <a:xfrm>
-            <a:off x="640080" y="4489704"/>
-            <a:ext cx="1691640" cy="731519"/>
-          </a:xfrm>
-          <a:prstGeom prst="rect">
-            <a:avLst/>
-          </a:prstGeom>
-          <a:noFill/>
-        </p:spPr>
-        <p:txBody>
-          <a:bodyPr wrap="square" anchor="t" lIns="45720" rIns="45720" tIns="18288" bIns="18288">
-            <a:spAutoFit/>
-          </a:bodyPr>
-          <a:lstStyle/>
-          <a:p>
-            <a:pPr algn="l"/>
-            <a:r>
-              <a:rPr sz="1100" b="0" i="0">
-                <a:solidFill>
-                  <a:srgbClr val="1E1508"/>
-                </a:solidFill>
-                <a:latin typeface="Calibri"/>
-              </a:rPr>
-              <a:t>Act 4 · 90 sec</a:t>
-            </a:r>
-          </a:p>
-        </p:txBody>
-      </p:sp>
-      <p:sp>
-        <p:nvSpPr>
-          <p:cNvPr id="18" name="TextBox 17"/>
-          <p:cNvSpPr txBox="1"/>
-          <p:nvPr/>
-        </p:nvSpPr>
-        <p:spPr>
-          <a:xfrm>
-            <a:off x="2468880" y="4489704"/>
-            <a:ext cx="9098280" cy="731519"/>
-          </a:xfrm>
-          <a:prstGeom prst="rect">
-            <a:avLst/>
-          </a:prstGeom>
-          <a:noFill/>
-        </p:spPr>
-        <p:txBody>
-          <a:bodyPr wrap="square" anchor="t" lIns="45720" rIns="45720" tIns="18288" bIns="18288">
-            <a:spAutoFit/>
-          </a:bodyPr>
-          <a:lstStyle/>
-          <a:p>
-            <a:pPr algn="l"/>
-            <a:r>
-              <a:rPr sz="1100" b="0" i="0">
-                <a:solidFill>
-                  <a:srgbClr val="1E1508"/>
-                </a:solidFill>
-                <a:latin typeface="Calibri"/>
-              </a:rPr>
-              <a:t>Behind the scenes — admin Events Queue, Approve All, AI Categorize button, Scraper Sources tab</a:t>
-            </a:r>
-          </a:p>
-        </p:txBody>
-      </p:sp>
-      <p:sp>
-        <p:nvSpPr>
-          <p:cNvPr id="19" name="Rectangle 18"/>
-          <p:cNvSpPr/>
-          <p:nvPr/>
-        </p:nvSpPr>
-        <p:spPr>
-          <a:xfrm>
-            <a:off x="548640" y="5221224"/>
-            <a:ext cx="11064240" cy="777240"/>
-          </a:xfrm>
-          <a:prstGeom prst="rect">
-            <a:avLst/>
-          </a:prstGeom>
-          <a:solidFill>
-            <a:srgbClr val="FBF7EE"/>
-          </a:solidFill>
-          <a:ln>
-            <a:noFill/>
-          </a:ln>
-          <a:effectLst/>
-        </p:spPr>
-        <p:style>
-          <a:lnRef idx="1">
-            <a:schemeClr val="accent1"/>
-          </a:lnRef>
-          <a:fillRef idx="3">
-            <a:schemeClr val="accent1"/>
-          </a:fillRef>
-          <a:effectRef idx="2">
-            <a:schemeClr val="accent1"/>
-          </a:effectRef>
-          <a:fontRef idx="minor">
-            <a:schemeClr val="lt1"/>
-          </a:fontRef>
-        </p:style>
-        <p:txBody>
-          <a:bodyPr rtlCol="0" anchor="ctr"/>
-          <a:lstStyle/>
-          <a:p>
-            <a:pPr algn="ctr"/>
-          </a:p>
-        </p:txBody>
-      </p:sp>
-      <p:sp>
-        <p:nvSpPr>
-          <p:cNvPr id="20" name="TextBox 19"/>
-          <p:cNvSpPr txBox="1"/>
-          <p:nvPr/>
-        </p:nvSpPr>
-        <p:spPr>
-          <a:xfrm>
-            <a:off x="640080" y="5266944"/>
-            <a:ext cx="1691640" cy="731519"/>
-          </a:xfrm>
-          <a:prstGeom prst="rect">
-            <a:avLst/>
-          </a:prstGeom>
-          <a:noFill/>
-        </p:spPr>
-        <p:txBody>
-          <a:bodyPr wrap="square" anchor="t" lIns="45720" rIns="45720" tIns="18288" bIns="18288">
-            <a:spAutoFit/>
-          </a:bodyPr>
-          <a:lstStyle/>
-          <a:p>
-            <a:pPr algn="l"/>
-            <a:r>
-              <a:rPr sz="1100" b="0" i="0">
-                <a:solidFill>
-                  <a:srgbClr val="1E1508"/>
-                </a:solidFill>
-                <a:latin typeface="Calibri"/>
-              </a:rPr>
-              <a:t>Act 5 · 60 sec</a:t>
-            </a:r>
-          </a:p>
-        </p:txBody>
-      </p:sp>
-      <p:sp>
-        <p:nvSpPr>
-          <p:cNvPr id="21" name="TextBox 20"/>
-          <p:cNvSpPr txBox="1"/>
-          <p:nvPr/>
-        </p:nvSpPr>
-        <p:spPr>
-          <a:xfrm>
-            <a:off x="2468880" y="5266944"/>
-            <a:ext cx="9098280" cy="731519"/>
-          </a:xfrm>
-          <a:prstGeom prst="rect">
-            <a:avLst/>
-          </a:prstGeom>
-          <a:noFill/>
-        </p:spPr>
-        <p:txBody>
-          <a:bodyPr wrap="square" anchor="t" lIns="45720" rIns="45720" tIns="18288" bIns="18288">
-            <a:spAutoFit/>
-          </a:bodyPr>
-          <a:lstStyle/>
-          <a:p>
-            <a:pPr algn="l"/>
-            <a:r>
-              <a:rPr sz="1100" b="0" i="0">
-                <a:solidFill>
-                  <a:srgbClr val="1E1508"/>
-                </a:solidFill>
-                <a:latin typeface="Calibri"/>
-              </a:rPr>
-              <a:t>Close the value props — time saved, local visibility, privacy, no vendor lock-in, AI integration, low maintenance</a:t>
-            </a:r>
-          </a:p>
-        </p:txBody>
-      </p:sp>
-      <p:sp>
-        <p:nvSpPr>
-          <p:cNvPr id="22" name="TextBox 21"/>
+              <a:t>"Convince a visitor to add one more night and you double or triple local revenue."</a:t>
+            </a:r>
+          </a:p>
+        </p:txBody>
+      </p:sp>
+      <p:sp>
+        <p:nvSpPr>
+          <p:cNvPr id="9" name="TextBox 8"/>
           <p:cNvSpPr txBox="1"/>
           <p:nvPr/>
         </p:nvSpPr>
@@ -6985,7 +6929,7 @@
       </p:sp>
       <p:sp>
         <p:nvSpPr>
-          <p:cNvPr id="23" name="TextBox 22"/>
+          <p:cNvPr id="10" name="TextBox 9"/>
           <p:cNvSpPr txBox="1"/>
           <p:nvPr/>
         </p:nvSpPr>
@@ -7013,14 +6957,14 @@
                 </a:solidFill>
                 <a:latin typeface="Calibri"/>
               </a:rPr>
-              <a:t>13 / 14</a:t>
-            </a:r>
-          </a:p>
-        </p:txBody>
-      </p:sp>
-      <p:sp>
-        <p:nvSpPr>
-          <p:cNvPr id="24" name="Rectangle 23"/>
+              <a:t>13 / 15</a:t>
+            </a:r>
+          </a:p>
+        </p:txBody>
+      </p:sp>
+      <p:sp>
+        <p:nvSpPr>
+          <p:cNvPr id="11" name="Rectangle 10"/>
           <p:cNvSpPr/>
           <p:nvPr/>
         </p:nvSpPr>
@@ -7081,6 +7025,889 @@
       <p:grpSpPr/>
       <p:sp>
         <p:nvSpPr>
+          <p:cNvPr id="2" name="TextBox 1"/>
+          <p:cNvSpPr txBox="1"/>
+          <p:nvPr/>
+        </p:nvSpPr>
+        <p:spPr>
+          <a:xfrm>
+            <a:off x="548640" y="365760"/>
+            <a:ext cx="11064240" cy="640080"/>
+          </a:xfrm>
+          <a:prstGeom prst="rect">
+            <a:avLst/>
+          </a:prstGeom>
+          <a:noFill/>
+        </p:spPr>
+        <p:txBody>
+          <a:bodyPr wrap="square" anchor="t" lIns="45720" rIns="45720" tIns="18288" bIns="18288">
+            <a:spAutoFit/>
+          </a:bodyPr>
+          <a:lstStyle/>
+          <a:p>
+            <a:pPr algn="l"/>
+            <a:r>
+              <a:rPr sz="3200" b="1" i="0">
+                <a:solidFill>
+                  <a:srgbClr val="5C3A1F"/>
+                </a:solidFill>
+                <a:latin typeface="Calibri"/>
+              </a:rPr>
+              <a:t>The 8-minute demo flow</a:t>
+            </a:r>
+          </a:p>
+        </p:txBody>
+      </p:sp>
+      <p:sp>
+        <p:nvSpPr>
+          <p:cNvPr id="3" name="Rectangle 2"/>
+          <p:cNvSpPr/>
+          <p:nvPr/>
+        </p:nvSpPr>
+        <p:spPr>
+          <a:xfrm>
+            <a:off x="548640" y="1078992"/>
+            <a:ext cx="11064240" cy="25400"/>
+          </a:xfrm>
+          <a:prstGeom prst="rect">
+            <a:avLst/>
+          </a:prstGeom>
+          <a:solidFill>
+            <a:srgbClr val="C9A84C"/>
+          </a:solidFill>
+          <a:ln>
+            <a:noFill/>
+          </a:ln>
+        </p:spPr>
+        <p:style>
+          <a:lnRef idx="1">
+            <a:schemeClr val="accent1"/>
+          </a:lnRef>
+          <a:fillRef idx="3">
+            <a:schemeClr val="accent1"/>
+          </a:fillRef>
+          <a:effectRef idx="2">
+            <a:schemeClr val="accent1"/>
+          </a:effectRef>
+          <a:fontRef idx="minor">
+            <a:schemeClr val="lt1"/>
+          </a:fontRef>
+        </p:style>
+        <p:txBody>
+          <a:bodyPr rtlCol="0" anchor="ctr"/>
+          <a:lstStyle/>
+          <a:p>
+            <a:pPr algn="ctr"/>
+          </a:p>
+        </p:txBody>
+      </p:sp>
+      <p:sp>
+        <p:nvSpPr>
+          <p:cNvPr id="4" name="TextBox 3"/>
+          <p:cNvSpPr txBox="1"/>
+          <p:nvPr/>
+        </p:nvSpPr>
+        <p:spPr>
+          <a:xfrm>
+            <a:off x="548640" y="1207008"/>
+            <a:ext cx="11064240" cy="457200"/>
+          </a:xfrm>
+          <a:prstGeom prst="rect">
+            <a:avLst/>
+          </a:prstGeom>
+          <a:noFill/>
+        </p:spPr>
+        <p:txBody>
+          <a:bodyPr wrap="square" anchor="t" lIns="45720" rIns="45720" tIns="18288" bIns="18288">
+            <a:spAutoFit/>
+          </a:bodyPr>
+          <a:lstStyle/>
+          <a:p>
+            <a:pPr algn="l"/>
+            <a:r>
+              <a:rPr sz="1400" b="0" i="1">
+                <a:solidFill>
+                  <a:srgbClr val="4A5568"/>
+                </a:solidFill>
+                <a:latin typeface="Calibri"/>
+              </a:rPr>
+              <a:t>A visitor planning a romantic November weekend in Western Nevada County.</a:t>
+            </a:r>
+          </a:p>
+        </p:txBody>
+      </p:sp>
+      <p:sp>
+        <p:nvSpPr>
+          <p:cNvPr id="5" name="Rectangle 4"/>
+          <p:cNvSpPr/>
+          <p:nvPr/>
+        </p:nvSpPr>
+        <p:spPr>
+          <a:xfrm>
+            <a:off x="548640" y="1691640"/>
+            <a:ext cx="11064240" cy="384048"/>
+          </a:xfrm>
+          <a:prstGeom prst="rect">
+            <a:avLst/>
+          </a:prstGeom>
+          <a:solidFill>
+            <a:srgbClr val="F5EFE2"/>
+          </a:solidFill>
+          <a:ln>
+            <a:noFill/>
+          </a:ln>
+          <a:effectLst/>
+        </p:spPr>
+        <p:style>
+          <a:lnRef idx="1">
+            <a:schemeClr val="accent1"/>
+          </a:lnRef>
+          <a:fillRef idx="3">
+            <a:schemeClr val="accent1"/>
+          </a:fillRef>
+          <a:effectRef idx="2">
+            <a:schemeClr val="accent1"/>
+          </a:effectRef>
+          <a:fontRef idx="minor">
+            <a:schemeClr val="lt1"/>
+          </a:fontRef>
+        </p:style>
+        <p:txBody>
+          <a:bodyPr rtlCol="0" anchor="ctr"/>
+          <a:lstStyle/>
+          <a:p>
+            <a:pPr algn="ctr"/>
+          </a:p>
+        </p:txBody>
+      </p:sp>
+      <p:sp>
+        <p:nvSpPr>
+          <p:cNvPr id="6" name="TextBox 5"/>
+          <p:cNvSpPr txBox="1"/>
+          <p:nvPr/>
+        </p:nvSpPr>
+        <p:spPr>
+          <a:xfrm>
+            <a:off x="640080" y="1737360"/>
+            <a:ext cx="1691640" cy="292608"/>
+          </a:xfrm>
+          <a:prstGeom prst="rect">
+            <a:avLst/>
+          </a:prstGeom>
+          <a:noFill/>
+        </p:spPr>
+        <p:txBody>
+          <a:bodyPr wrap="square" anchor="t" lIns="45720" rIns="45720" tIns="18288" bIns="18288">
+            <a:spAutoFit/>
+          </a:bodyPr>
+          <a:lstStyle/>
+          <a:p>
+            <a:pPr algn="l"/>
+            <a:r>
+              <a:rPr sz="1100" b="1" i="0">
+                <a:solidFill>
+                  <a:srgbClr val="5C3A1F"/>
+                </a:solidFill>
+                <a:latin typeface="Calibri"/>
+              </a:rPr>
+              <a:t>Act</a:t>
+            </a:r>
+          </a:p>
+        </p:txBody>
+      </p:sp>
+      <p:sp>
+        <p:nvSpPr>
+          <p:cNvPr id="7" name="TextBox 6"/>
+          <p:cNvSpPr txBox="1"/>
+          <p:nvPr/>
+        </p:nvSpPr>
+        <p:spPr>
+          <a:xfrm>
+            <a:off x="2468880" y="1737360"/>
+            <a:ext cx="9098280" cy="292608"/>
+          </a:xfrm>
+          <a:prstGeom prst="rect">
+            <a:avLst/>
+          </a:prstGeom>
+          <a:noFill/>
+        </p:spPr>
+        <p:txBody>
+          <a:bodyPr wrap="square" anchor="t" lIns="45720" rIns="45720" tIns="18288" bIns="18288">
+            <a:spAutoFit/>
+          </a:bodyPr>
+          <a:lstStyle/>
+          <a:p>
+            <a:pPr algn="l"/>
+            <a:r>
+              <a:rPr sz="1100" b="1" i="0">
+                <a:solidFill>
+                  <a:srgbClr val="5C3A1F"/>
+                </a:solidFill>
+                <a:latin typeface="Calibri"/>
+              </a:rPr>
+              <a:t>What happens</a:t>
+            </a:r>
+          </a:p>
+        </p:txBody>
+      </p:sp>
+      <p:sp>
+        <p:nvSpPr>
+          <p:cNvPr id="8" name="Rectangle 7"/>
+          <p:cNvSpPr/>
+          <p:nvPr/>
+        </p:nvSpPr>
+        <p:spPr>
+          <a:xfrm>
+            <a:off x="548640" y="2075688"/>
+            <a:ext cx="11064240" cy="25400"/>
+          </a:xfrm>
+          <a:prstGeom prst="rect">
+            <a:avLst/>
+          </a:prstGeom>
+          <a:solidFill>
+            <a:srgbClr val="C9A84C"/>
+          </a:solidFill>
+          <a:ln>
+            <a:noFill/>
+          </a:ln>
+        </p:spPr>
+        <p:style>
+          <a:lnRef idx="1">
+            <a:schemeClr val="accent1"/>
+          </a:lnRef>
+          <a:fillRef idx="3">
+            <a:schemeClr val="accent1"/>
+          </a:fillRef>
+          <a:effectRef idx="2">
+            <a:schemeClr val="accent1"/>
+          </a:effectRef>
+          <a:fontRef idx="minor">
+            <a:schemeClr val="lt1"/>
+          </a:fontRef>
+        </p:style>
+        <p:txBody>
+          <a:bodyPr rtlCol="0" anchor="ctr"/>
+          <a:lstStyle/>
+          <a:p>
+            <a:pPr algn="ctr"/>
+          </a:p>
+        </p:txBody>
+      </p:sp>
+      <p:sp>
+        <p:nvSpPr>
+          <p:cNvPr id="9" name="Rectangle 8"/>
+          <p:cNvSpPr/>
+          <p:nvPr/>
+        </p:nvSpPr>
+        <p:spPr>
+          <a:xfrm>
+            <a:off x="548640" y="2112264"/>
+            <a:ext cx="11064240" cy="777240"/>
+          </a:xfrm>
+          <a:prstGeom prst="rect">
+            <a:avLst/>
+          </a:prstGeom>
+          <a:solidFill>
+            <a:srgbClr val="FBF7EE"/>
+          </a:solidFill>
+          <a:ln>
+            <a:noFill/>
+          </a:ln>
+          <a:effectLst/>
+        </p:spPr>
+        <p:style>
+          <a:lnRef idx="1">
+            <a:schemeClr val="accent1"/>
+          </a:lnRef>
+          <a:fillRef idx="3">
+            <a:schemeClr val="accent1"/>
+          </a:fillRef>
+          <a:effectRef idx="2">
+            <a:schemeClr val="accent1"/>
+          </a:effectRef>
+          <a:fontRef idx="minor">
+            <a:schemeClr val="lt1"/>
+          </a:fontRef>
+        </p:style>
+        <p:txBody>
+          <a:bodyPr rtlCol="0" anchor="ctr"/>
+          <a:lstStyle/>
+          <a:p>
+            <a:pPr algn="ctr"/>
+          </a:p>
+        </p:txBody>
+      </p:sp>
+      <p:sp>
+        <p:nvSpPr>
+          <p:cNvPr id="10" name="TextBox 9"/>
+          <p:cNvSpPr txBox="1"/>
+          <p:nvPr/>
+        </p:nvSpPr>
+        <p:spPr>
+          <a:xfrm>
+            <a:off x="640080" y="2157984"/>
+            <a:ext cx="1691640" cy="731519"/>
+          </a:xfrm>
+          <a:prstGeom prst="rect">
+            <a:avLst/>
+          </a:prstGeom>
+          <a:noFill/>
+        </p:spPr>
+        <p:txBody>
+          <a:bodyPr wrap="square" anchor="t" lIns="45720" rIns="45720" tIns="18288" bIns="18288">
+            <a:spAutoFit/>
+          </a:bodyPr>
+          <a:lstStyle/>
+          <a:p>
+            <a:pPr algn="l"/>
+            <a:r>
+              <a:rPr sz="1100" b="0" i="0">
+                <a:solidFill>
+                  <a:srgbClr val="1E1508"/>
+                </a:solidFill>
+                <a:latin typeface="Calibri"/>
+              </a:rPr>
+              <a:t>Act 1 · 2 min</a:t>
+            </a:r>
+          </a:p>
+        </p:txBody>
+      </p:sp>
+      <p:sp>
+        <p:nvSpPr>
+          <p:cNvPr id="11" name="TextBox 10"/>
+          <p:cNvSpPr txBox="1"/>
+          <p:nvPr/>
+        </p:nvSpPr>
+        <p:spPr>
+          <a:xfrm>
+            <a:off x="2468880" y="2157984"/>
+            <a:ext cx="9098280" cy="731519"/>
+          </a:xfrm>
+          <a:prstGeom prst="rect">
+            <a:avLst/>
+          </a:prstGeom>
+          <a:noFill/>
+        </p:spPr>
+        <p:txBody>
+          <a:bodyPr wrap="square" anchor="t" lIns="45720" rIns="45720" tIns="18288" bIns="18288">
+            <a:spAutoFit/>
+          </a:bodyPr>
+          <a:lstStyle/>
+          <a:p>
+            <a:pPr algn="l"/>
+            <a:r>
+              <a:rPr sz="1100" b="0" i="0">
+                <a:solidFill>
+                  <a:srgbClr val="1E1508"/>
+                </a:solidFill>
+                <a:latin typeface="Calibri"/>
+              </a:rPr>
+              <a:t>Set the scene — couple from Sacramento, click "This Weekend" + Festivals vibe</a:t>
+            </a:r>
+          </a:p>
+        </p:txBody>
+      </p:sp>
+      <p:sp>
+        <p:nvSpPr>
+          <p:cNvPr id="12" name="TextBox 11"/>
+          <p:cNvSpPr txBox="1"/>
+          <p:nvPr/>
+        </p:nvSpPr>
+        <p:spPr>
+          <a:xfrm>
+            <a:off x="640080" y="2935224"/>
+            <a:ext cx="1691640" cy="731519"/>
+          </a:xfrm>
+          <a:prstGeom prst="rect">
+            <a:avLst/>
+          </a:prstGeom>
+          <a:noFill/>
+        </p:spPr>
+        <p:txBody>
+          <a:bodyPr wrap="square" anchor="t" lIns="45720" rIns="45720" tIns="18288" bIns="18288">
+            <a:spAutoFit/>
+          </a:bodyPr>
+          <a:lstStyle/>
+          <a:p>
+            <a:pPr algn="l"/>
+            <a:r>
+              <a:rPr sz="1100" b="0" i="0">
+                <a:solidFill>
+                  <a:srgbClr val="1E1508"/>
+                </a:solidFill>
+                <a:latin typeface="Calibri"/>
+              </a:rPr>
+              <a:t>Act 2 · 90 sec</a:t>
+            </a:r>
+          </a:p>
+        </p:txBody>
+      </p:sp>
+      <p:sp>
+        <p:nvSpPr>
+          <p:cNvPr id="13" name="TextBox 12"/>
+          <p:cNvSpPr txBox="1"/>
+          <p:nvPr/>
+        </p:nvSpPr>
+        <p:spPr>
+          <a:xfrm>
+            <a:off x="2468880" y="2935224"/>
+            <a:ext cx="9098280" cy="731519"/>
+          </a:xfrm>
+          <a:prstGeom prst="rect">
+            <a:avLst/>
+          </a:prstGeom>
+          <a:noFill/>
+        </p:spPr>
+        <p:txBody>
+          <a:bodyPr wrap="square" anchor="t" lIns="45720" rIns="45720" tIns="18288" bIns="18288">
+            <a:spAutoFit/>
+          </a:bodyPr>
+          <a:lstStyle/>
+          <a:p>
+            <a:pPr algn="l"/>
+            <a:r>
+              <a:rPr sz="1100" b="0" i="0">
+                <a:solidFill>
+                  <a:srgbClr val="1E1508"/>
+                </a:solidFill>
+                <a:latin typeface="Calibri"/>
+              </a:rPr>
+              <a:t>Layer in Relaxed vibe + Lodging category + B&amp;B sub-pill — real Victorian B&amp;Bs surface</a:t>
+            </a:r>
+          </a:p>
+        </p:txBody>
+      </p:sp>
+      <p:sp>
+        <p:nvSpPr>
+          <p:cNvPr id="14" name="Rectangle 13"/>
+          <p:cNvSpPr/>
+          <p:nvPr/>
+        </p:nvSpPr>
+        <p:spPr>
+          <a:xfrm>
+            <a:off x="548640" y="3666744"/>
+            <a:ext cx="11064240" cy="777240"/>
+          </a:xfrm>
+          <a:prstGeom prst="rect">
+            <a:avLst/>
+          </a:prstGeom>
+          <a:solidFill>
+            <a:srgbClr val="FBF7EE"/>
+          </a:solidFill>
+          <a:ln>
+            <a:noFill/>
+          </a:ln>
+          <a:effectLst/>
+        </p:spPr>
+        <p:style>
+          <a:lnRef idx="1">
+            <a:schemeClr val="accent1"/>
+          </a:lnRef>
+          <a:fillRef idx="3">
+            <a:schemeClr val="accent1"/>
+          </a:fillRef>
+          <a:effectRef idx="2">
+            <a:schemeClr val="accent1"/>
+          </a:effectRef>
+          <a:fontRef idx="minor">
+            <a:schemeClr val="lt1"/>
+          </a:fontRef>
+        </p:style>
+        <p:txBody>
+          <a:bodyPr rtlCol="0" anchor="ctr"/>
+          <a:lstStyle/>
+          <a:p>
+            <a:pPr algn="ctr"/>
+          </a:p>
+        </p:txBody>
+      </p:sp>
+      <p:sp>
+        <p:nvSpPr>
+          <p:cNvPr id="15" name="TextBox 14"/>
+          <p:cNvSpPr txBox="1"/>
+          <p:nvPr/>
+        </p:nvSpPr>
+        <p:spPr>
+          <a:xfrm>
+            <a:off x="640080" y="3712464"/>
+            <a:ext cx="1691640" cy="731519"/>
+          </a:xfrm>
+          <a:prstGeom prst="rect">
+            <a:avLst/>
+          </a:prstGeom>
+          <a:noFill/>
+        </p:spPr>
+        <p:txBody>
+          <a:bodyPr wrap="square" anchor="t" lIns="45720" rIns="45720" tIns="18288" bIns="18288">
+            <a:spAutoFit/>
+          </a:bodyPr>
+          <a:lstStyle/>
+          <a:p>
+            <a:pPr algn="l"/>
+            <a:r>
+              <a:rPr sz="1100" b="0" i="0">
+                <a:solidFill>
+                  <a:srgbClr val="1E1508"/>
+                </a:solidFill>
+                <a:latin typeface="Calibri"/>
+              </a:rPr>
+              <a:t>Act 3 · 2 min</a:t>
+            </a:r>
+          </a:p>
+        </p:txBody>
+      </p:sp>
+      <p:sp>
+        <p:nvSpPr>
+          <p:cNvPr id="16" name="TextBox 15"/>
+          <p:cNvSpPr txBox="1"/>
+          <p:nvPr/>
+        </p:nvSpPr>
+        <p:spPr>
+          <a:xfrm>
+            <a:off x="2468880" y="3712464"/>
+            <a:ext cx="9098280" cy="731519"/>
+          </a:xfrm>
+          <a:prstGeom prst="rect">
+            <a:avLst/>
+          </a:prstGeom>
+          <a:noFill/>
+        </p:spPr>
+        <p:txBody>
+          <a:bodyPr wrap="square" anchor="t" lIns="45720" rIns="45720" tIns="18288" bIns="18288">
+            <a:spAutoFit/>
+          </a:bodyPr>
+          <a:lstStyle/>
+          <a:p>
+            <a:pPr algn="l"/>
+            <a:r>
+              <a:rPr sz="1100" b="0" i="0">
+                <a:solidFill>
+                  <a:srgbClr val="1E1508"/>
+                </a:solidFill>
+                <a:latin typeface="Calibri"/>
+              </a:rPr>
+              <a:t>Build the weekend — Cornish Christmas + Holbrooke Hotel + Empire Mine + Lola Restaurant. Open My Itinerary — Smart Suggestions appear with "0.4 mi away" labels. Map view + Print + Share link.</a:t>
+            </a:r>
+          </a:p>
+        </p:txBody>
+      </p:sp>
+      <p:sp>
+        <p:nvSpPr>
+          <p:cNvPr id="17" name="TextBox 16"/>
+          <p:cNvSpPr txBox="1"/>
+          <p:nvPr/>
+        </p:nvSpPr>
+        <p:spPr>
+          <a:xfrm>
+            <a:off x="640080" y="4489704"/>
+            <a:ext cx="1691640" cy="731519"/>
+          </a:xfrm>
+          <a:prstGeom prst="rect">
+            <a:avLst/>
+          </a:prstGeom>
+          <a:noFill/>
+        </p:spPr>
+        <p:txBody>
+          <a:bodyPr wrap="square" anchor="t" lIns="45720" rIns="45720" tIns="18288" bIns="18288">
+            <a:spAutoFit/>
+          </a:bodyPr>
+          <a:lstStyle/>
+          <a:p>
+            <a:pPr algn="l"/>
+            <a:r>
+              <a:rPr sz="1100" b="0" i="0">
+                <a:solidFill>
+                  <a:srgbClr val="1E1508"/>
+                </a:solidFill>
+                <a:latin typeface="Calibri"/>
+              </a:rPr>
+              <a:t>Act 4 · 90 sec</a:t>
+            </a:r>
+          </a:p>
+        </p:txBody>
+      </p:sp>
+      <p:sp>
+        <p:nvSpPr>
+          <p:cNvPr id="18" name="TextBox 17"/>
+          <p:cNvSpPr txBox="1"/>
+          <p:nvPr/>
+        </p:nvSpPr>
+        <p:spPr>
+          <a:xfrm>
+            <a:off x="2468880" y="4489704"/>
+            <a:ext cx="9098280" cy="731519"/>
+          </a:xfrm>
+          <a:prstGeom prst="rect">
+            <a:avLst/>
+          </a:prstGeom>
+          <a:noFill/>
+        </p:spPr>
+        <p:txBody>
+          <a:bodyPr wrap="square" anchor="t" lIns="45720" rIns="45720" tIns="18288" bIns="18288">
+            <a:spAutoFit/>
+          </a:bodyPr>
+          <a:lstStyle/>
+          <a:p>
+            <a:pPr algn="l"/>
+            <a:r>
+              <a:rPr sz="1100" b="0" i="0">
+                <a:solidFill>
+                  <a:srgbClr val="1E1508"/>
+                </a:solidFill>
+                <a:latin typeface="Calibri"/>
+              </a:rPr>
+              <a:t>Behind the scenes — admin Events Queue, Approve All, AI Categorize button, Scraper Sources tab</a:t>
+            </a:r>
+          </a:p>
+        </p:txBody>
+      </p:sp>
+      <p:sp>
+        <p:nvSpPr>
+          <p:cNvPr id="19" name="Rectangle 18"/>
+          <p:cNvSpPr/>
+          <p:nvPr/>
+        </p:nvSpPr>
+        <p:spPr>
+          <a:xfrm>
+            <a:off x="548640" y="5221224"/>
+            <a:ext cx="11064240" cy="777240"/>
+          </a:xfrm>
+          <a:prstGeom prst="rect">
+            <a:avLst/>
+          </a:prstGeom>
+          <a:solidFill>
+            <a:srgbClr val="FBF7EE"/>
+          </a:solidFill>
+          <a:ln>
+            <a:noFill/>
+          </a:ln>
+          <a:effectLst/>
+        </p:spPr>
+        <p:style>
+          <a:lnRef idx="1">
+            <a:schemeClr val="accent1"/>
+          </a:lnRef>
+          <a:fillRef idx="3">
+            <a:schemeClr val="accent1"/>
+          </a:fillRef>
+          <a:effectRef idx="2">
+            <a:schemeClr val="accent1"/>
+          </a:effectRef>
+          <a:fontRef idx="minor">
+            <a:schemeClr val="lt1"/>
+          </a:fontRef>
+        </p:style>
+        <p:txBody>
+          <a:bodyPr rtlCol="0" anchor="ctr"/>
+          <a:lstStyle/>
+          <a:p>
+            <a:pPr algn="ctr"/>
+          </a:p>
+        </p:txBody>
+      </p:sp>
+      <p:sp>
+        <p:nvSpPr>
+          <p:cNvPr id="20" name="TextBox 19"/>
+          <p:cNvSpPr txBox="1"/>
+          <p:nvPr/>
+        </p:nvSpPr>
+        <p:spPr>
+          <a:xfrm>
+            <a:off x="640080" y="5266944"/>
+            <a:ext cx="1691640" cy="731519"/>
+          </a:xfrm>
+          <a:prstGeom prst="rect">
+            <a:avLst/>
+          </a:prstGeom>
+          <a:noFill/>
+        </p:spPr>
+        <p:txBody>
+          <a:bodyPr wrap="square" anchor="t" lIns="45720" rIns="45720" tIns="18288" bIns="18288">
+            <a:spAutoFit/>
+          </a:bodyPr>
+          <a:lstStyle/>
+          <a:p>
+            <a:pPr algn="l"/>
+            <a:r>
+              <a:rPr sz="1100" b="0" i="0">
+                <a:solidFill>
+                  <a:srgbClr val="1E1508"/>
+                </a:solidFill>
+                <a:latin typeface="Calibri"/>
+              </a:rPr>
+              <a:t>Act 5 · 60 sec</a:t>
+            </a:r>
+          </a:p>
+        </p:txBody>
+      </p:sp>
+      <p:sp>
+        <p:nvSpPr>
+          <p:cNvPr id="21" name="TextBox 20"/>
+          <p:cNvSpPr txBox="1"/>
+          <p:nvPr/>
+        </p:nvSpPr>
+        <p:spPr>
+          <a:xfrm>
+            <a:off x="2468880" y="5266944"/>
+            <a:ext cx="9098280" cy="731519"/>
+          </a:xfrm>
+          <a:prstGeom prst="rect">
+            <a:avLst/>
+          </a:prstGeom>
+          <a:noFill/>
+        </p:spPr>
+        <p:txBody>
+          <a:bodyPr wrap="square" anchor="t" lIns="45720" rIns="45720" tIns="18288" bIns="18288">
+            <a:spAutoFit/>
+          </a:bodyPr>
+          <a:lstStyle/>
+          <a:p>
+            <a:pPr algn="l"/>
+            <a:r>
+              <a:rPr sz="1100" b="0" i="0">
+                <a:solidFill>
+                  <a:srgbClr val="1E1508"/>
+                </a:solidFill>
+                <a:latin typeface="Calibri"/>
+              </a:rPr>
+              <a:t>Close the value props — time saved, local visibility, privacy, no vendor lock-in, AI integration, low maintenance</a:t>
+            </a:r>
+          </a:p>
+        </p:txBody>
+      </p:sp>
+      <p:sp>
+        <p:nvSpPr>
+          <p:cNvPr id="22" name="TextBox 21"/>
+          <p:cNvSpPr txBox="1"/>
+          <p:nvPr/>
+        </p:nvSpPr>
+        <p:spPr>
+          <a:xfrm>
+            <a:off x="548640" y="6492240"/>
+            <a:ext cx="7315200" cy="274320"/>
+          </a:xfrm>
+          <a:prstGeom prst="rect">
+            <a:avLst/>
+          </a:prstGeom>
+          <a:noFill/>
+        </p:spPr>
+        <p:txBody>
+          <a:bodyPr wrap="square" anchor="t" lIns="45720" rIns="45720" tIns="18288" bIns="18288">
+            <a:spAutoFit/>
+          </a:bodyPr>
+          <a:lstStyle/>
+          <a:p>
+            <a:pPr algn="l"/>
+            <a:r>
+              <a:rPr sz="900" b="0" i="0">
+                <a:solidFill>
+                  <a:srgbClr val="4A5568"/>
+                </a:solidFill>
+                <a:latin typeface="Calibri"/>
+              </a:rPr>
+              <a:t>Western Nevada County Experience</a:t>
+            </a:r>
+          </a:p>
+        </p:txBody>
+      </p:sp>
+      <p:sp>
+        <p:nvSpPr>
+          <p:cNvPr id="23" name="TextBox 22"/>
+          <p:cNvSpPr txBox="1"/>
+          <p:nvPr/>
+        </p:nvSpPr>
+        <p:spPr>
+          <a:xfrm>
+            <a:off x="10515600" y="6492240"/>
+            <a:ext cx="1097280" cy="274320"/>
+          </a:xfrm>
+          <a:prstGeom prst="rect">
+            <a:avLst/>
+          </a:prstGeom>
+          <a:noFill/>
+        </p:spPr>
+        <p:txBody>
+          <a:bodyPr wrap="square" anchor="t" lIns="45720" rIns="45720" tIns="18288" bIns="18288">
+            <a:spAutoFit/>
+          </a:bodyPr>
+          <a:lstStyle/>
+          <a:p>
+            <a:pPr algn="r"/>
+            <a:r>
+              <a:rPr sz="900" b="0" i="0">
+                <a:solidFill>
+                  <a:srgbClr val="4A5568"/>
+                </a:solidFill>
+                <a:latin typeface="Calibri"/>
+              </a:rPr>
+              <a:t>14 / 15</a:t>
+            </a:r>
+          </a:p>
+        </p:txBody>
+      </p:sp>
+      <p:sp>
+        <p:nvSpPr>
+          <p:cNvPr id="24" name="Rectangle 23"/>
+          <p:cNvSpPr/>
+          <p:nvPr/>
+        </p:nvSpPr>
+        <p:spPr>
+          <a:xfrm>
+            <a:off x="548640" y="6455664"/>
+            <a:ext cx="11064240" cy="25400"/>
+          </a:xfrm>
+          <a:prstGeom prst="rect">
+            <a:avLst/>
+          </a:prstGeom>
+          <a:solidFill>
+            <a:srgbClr val="C9A84C"/>
+          </a:solidFill>
+          <a:ln>
+            <a:noFill/>
+          </a:ln>
+        </p:spPr>
+        <p:style>
+          <a:lnRef idx="1">
+            <a:schemeClr val="accent1"/>
+          </a:lnRef>
+          <a:fillRef idx="3">
+            <a:schemeClr val="accent1"/>
+          </a:fillRef>
+          <a:effectRef idx="2">
+            <a:schemeClr val="accent1"/>
+          </a:effectRef>
+          <a:fontRef idx="minor">
+            <a:schemeClr val="lt1"/>
+          </a:fontRef>
+        </p:style>
+        <p:txBody>
+          <a:bodyPr rtlCol="0" anchor="ctr"/>
+          <a:lstStyle/>
+          <a:p>
+            <a:pPr algn="ctr"/>
+          </a:p>
+        </p:txBody>
+      </p:sp>
+    </p:spTree>
+  </p:cSld>
+  <p:clrMapOvr>
+    <a:masterClrMapping/>
+  </p:clrMapOvr>
+</p:sld>
+</file>
+
+<file path=ppt/slides/slide15.xml><?xml version="1.0" encoding="utf-8"?>
+<p:sld xmlns:a="http://schemas.openxmlformats.org/drawingml/2006/main" xmlns:p="http://schemas.openxmlformats.org/presentationml/2006/main" xmlns:r="http://schemas.openxmlformats.org/officeDocument/2006/relationships">
+  <p:cSld>
+    <p:spTree>
+      <p:nvGrpSpPr>
+        <p:cNvPr id="1" name=""/>
+        <p:cNvGrpSpPr/>
+        <p:nvPr/>
+      </p:nvGrpSpPr>
+      <p:grpSpPr/>
+      <p:sp>
+        <p:nvSpPr>
           <p:cNvPr id="2" name="Rectangle 1"/>
           <p:cNvSpPr/>
           <p:nvPr/>
@@ -8122,7 +8949,7 @@
                 </a:solidFill>
                 <a:latin typeface="Calibri"/>
               </a:rPr>
-              <a:t>2 / 14</a:t>
+              <a:t>2 / 15</a:t>
             </a:r>
           </a:p>
         </p:txBody>
@@ -8719,7 +9546,7 @@
                 </a:solidFill>
                 <a:latin typeface="Calibri"/>
               </a:rPr>
-              <a:t>3 / 14</a:t>
+              <a:t>3 / 15</a:t>
             </a:r>
           </a:p>
         </p:txBody>
@@ -9786,7 +10613,7 @@
                 </a:solidFill>
                 <a:latin typeface="Calibri"/>
               </a:rPr>
-              <a:t>4 / 14</a:t>
+              <a:t>4 / 15</a:t>
             </a:r>
           </a:p>
         </p:txBody>
@@ -10659,7 +11486,7 @@
                 </a:solidFill>
                 <a:latin typeface="Calibri"/>
               </a:rPr>
-              <a:t>5 / 14</a:t>
+              <a:t>5 / 15</a:t>
             </a:r>
           </a:p>
         </p:txBody>
@@ -11980,7 +12807,7 @@
                 </a:solidFill>
                 <a:latin typeface="Calibri"/>
               </a:rPr>
-              <a:t>6 / 14</a:t>
+              <a:t>6 / 15</a:t>
             </a:r>
           </a:p>
         </p:txBody>
@@ -12549,7 +13376,7 @@
                 </a:solidFill>
                 <a:latin typeface="Calibri"/>
               </a:rPr>
-              <a:t>7 / 14</a:t>
+              <a:t>7 / 15</a:t>
             </a:r>
           </a:p>
         </p:txBody>
@@ -13037,7 +13864,7 @@
                 </a:solidFill>
                 <a:latin typeface="Calibri"/>
               </a:rPr>
-              <a:t>8 / 14</a:t>
+              <a:t>8 / 15</a:t>
             </a:r>
           </a:p>
         </p:txBody>
@@ -14145,7 +14972,7 @@
                 </a:solidFill>
                 <a:latin typeface="Calibri"/>
               </a:rPr>
-              <a:t>9 / 14</a:t>
+              <a:t>9 / 15</a:t>
             </a:r>
           </a:p>
         </p:txBody>

</xml_diff>

<commit_message>
Add a usage scenario beneath every feature in the deck
Each feature on slides 4, 5, 6, 7, 8, 9, and 13 now has an italic
sub-line "↳ scenario" describing how the feature is actually used —
e.g. "Spouse on phone moves Friday's hike to Saturday in two taps"
under "Drag-free move-between-days dropdown."

Helpers updated:
  add_bullets()    — accepts (text, scenario) tuples or plain strings
  two_col_table()  — accepts (a, b, scenario) 3-tuples or 2-tuples;
                     scenario renders as a second italic line in the
                     right column

Slide 6 trimmed from 10 to 8 UX decisions (dropped "Direct × on cards"
and "Type-emoji event placeholders") to fit two-line cells without
overflow. Other slides' fonts tightened from 12pt → 11pt with 9pt
scenarios to keep everything within 7.5" slide height.

Verified: every slide's max_y < 7.5" (no overflow).

Co-Authored-By: Claude Sonnet 4.6 <noreply@anthropic.com>
</commit_message>
<xml_diff>
--- a/demo_pitch.pptx
+++ b/demo_pitch.pptx
@@ -6631,7 +6631,7 @@
         </p:nvSpPr>
         <p:spPr>
           <a:xfrm>
-            <a:off x="548640" y="2697480"/>
+            <a:off x="548640" y="2606040"/>
             <a:ext cx="11064240" cy="3200400"/>
           </a:xfrm>
           <a:prstGeom prst="rect">
@@ -6647,11 +6647,11 @@
           <a:p>
             <a:pPr algn="l">
               <a:lnSpc>
-                <a:spcPct val="140000"/>
+                <a:spcPct val="120000"/>
               </a:lnSpc>
             </a:pPr>
             <a:r>
-              <a:rPr sz="1400" b="1">
+              <a:rPr sz="1300" b="1">
                 <a:solidFill>
                   <a:srgbClr val="C9A84C"/>
                 </a:solidFill>
@@ -6660,7 +6660,7 @@
               <a:t>• </a:t>
             </a:r>
             <a:r>
-              <a:rPr sz="1200">
+              <a:rPr sz="1100">
                 <a:solidFill>
                   <a:srgbClr val="1E1508"/>
                 </a:solidFill>
@@ -6672,42 +6672,33 @@
           <a:p>
             <a:pPr algn="l">
               <a:lnSpc>
-                <a:spcPct val="140000"/>
+                <a:spcPct val="110000"/>
               </a:lnSpc>
               <a:spcBef>
-                <a:spcPts val="600"/>
+                <a:spcPts val="0"/>
               </a:spcBef>
             </a:pPr>
             <a:r>
-              <a:rPr sz="1400" b="1">
-                <a:solidFill>
-                  <a:srgbClr val="C9A84C"/>
-                </a:solidFill>
-                <a:latin typeface="Calibri"/>
-              </a:rPr>
-              <a:t>• </a:t>
-            </a:r>
-            <a:r>
-              <a:rPr sz="1200">
-                <a:solidFill>
-                  <a:srgbClr val="1E1508"/>
-                </a:solidFill>
-                <a:latin typeface="Calibri"/>
-              </a:rPr>
-              <a:t>"Find Lodging" CTA at the top of every itinerary — booking always one click away</a:t>
+              <a:rPr sz="900" i="1">
+                <a:solidFill>
+                  <a:srgbClr val="5C3A1F"/>
+                </a:solidFill>
+                <a:latin typeface="Calibri"/>
+              </a:rPr>
+              <a:t>       ↳  Visitor sees Day 2 has no hotel and books one before leaving the page.</a:t>
             </a:r>
           </a:p>
           <a:p>
             <a:pPr algn="l">
               <a:lnSpc>
-                <a:spcPct val="140000"/>
+                <a:spcPct val="120000"/>
               </a:lnSpc>
               <a:spcBef>
-                <a:spcPts val="600"/>
+                <a:spcPts val="400"/>
               </a:spcBef>
             </a:pPr>
             <a:r>
-              <a:rPr sz="1400" b="1">
+              <a:rPr sz="1300" b="1">
                 <a:solidFill>
                   <a:srgbClr val="C9A84C"/>
                 </a:solidFill>
@@ -6716,54 +6707,45 @@
               <a:t>• </a:t>
             </a:r>
             <a:r>
-              <a:rPr sz="1200">
+              <a:rPr sz="1100">
                 <a:solidFill>
                   <a:srgbClr val="1E1508"/>
                 </a:solidFill>
                 <a:latin typeface="Calibri"/>
               </a:rPr>
-              <a:t>Empty lodging slots create a visual gap that drives the booking decision</a:t>
+              <a:t>"Find Lodging" CTA at the top of every itinerary — booking always one click away</a:t>
             </a:r>
           </a:p>
           <a:p>
             <a:pPr algn="l">
               <a:lnSpc>
-                <a:spcPct val="140000"/>
+                <a:spcPct val="110000"/>
               </a:lnSpc>
               <a:spcBef>
-                <a:spcPts val="600"/>
+                <a:spcPts val="0"/>
               </a:spcBef>
             </a:pPr>
             <a:r>
-              <a:rPr sz="1400" b="1">
-                <a:solidFill>
-                  <a:srgbClr val="C9A84C"/>
-                </a:solidFill>
-                <a:latin typeface="Calibri"/>
-              </a:rPr>
-              <a:t>• </a:t>
-            </a:r>
-            <a:r>
-              <a:rPr sz="1200">
-                <a:solidFill>
-                  <a:srgbClr val="1E1508"/>
-                </a:solidFill>
-                <a:latin typeface="Calibri"/>
-              </a:rPr>
-              <a:t>New items default to the latest day — no day-1 pile-up; trip naturally fills out</a:t>
+              <a:rPr sz="900" i="1">
+                <a:solidFill>
+                  <a:srgbClr val="5C3A1F"/>
+                </a:solidFill>
+                <a:latin typeface="Calibri"/>
+              </a:rPr>
+              <a:t>       ↳  No hunting for a button — booking decision is visible on every itinerary view.</a:t>
             </a:r>
           </a:p>
           <a:p>
             <a:pPr algn="l">
               <a:lnSpc>
-                <a:spcPct val="140000"/>
+                <a:spcPct val="120000"/>
               </a:lnSpc>
               <a:spcBef>
-                <a:spcPts val="600"/>
+                <a:spcPts val="400"/>
               </a:spcBef>
             </a:pPr>
             <a:r>
-              <a:rPr sz="1400" b="1">
+              <a:rPr sz="1300" b="1">
                 <a:solidFill>
                   <a:srgbClr val="C9A84C"/>
                 </a:solidFill>
@@ -6772,26 +6754,45 @@
               <a:t>• </a:t>
             </a:r>
             <a:r>
-              <a:rPr sz="1200">
+              <a:rPr sz="1100">
                 <a:solidFill>
                   <a:srgbClr val="1E1508"/>
                 </a:solidFill>
                 <a:latin typeface="Calibri"/>
               </a:rPr>
-              <a:t>Print view goes long-form per day — visitors who print, follow it</a:t>
+              <a:t>Empty lodging slots create a visual gap that drives the booking decision</a:t>
             </a:r>
           </a:p>
           <a:p>
             <a:pPr algn="l">
               <a:lnSpc>
-                <a:spcPct val="140000"/>
+                <a:spcPct val="110000"/>
               </a:lnSpc>
               <a:spcBef>
-                <a:spcPts val="600"/>
+                <a:spcPts val="0"/>
               </a:spcBef>
             </a:pPr>
             <a:r>
-              <a:rPr sz="1400" b="1">
+              <a:rPr sz="900" i="1">
+                <a:solidFill>
+                  <a:srgbClr val="5C3A1F"/>
+                </a:solidFill>
+                <a:latin typeface="Calibri"/>
+              </a:rPr>
+              <a:t>       ↳  That blank Day 2 stay tile is psychologically jarring; the visitor fills it.</a:t>
+            </a:r>
+          </a:p>
+          <a:p>
+            <a:pPr algn="l">
+              <a:lnSpc>
+                <a:spcPct val="120000"/>
+              </a:lnSpc>
+              <a:spcBef>
+                <a:spcPts val="400"/>
+              </a:spcBef>
+            </a:pPr>
+            <a:r>
+              <a:rPr sz="1300" b="1">
                 <a:solidFill>
                   <a:srgbClr val="C9A84C"/>
                 </a:solidFill>
@@ -6800,13 +6801,126 @@
               <a:t>• </a:t>
             </a:r>
             <a:r>
-              <a:rPr sz="1200">
+              <a:rPr sz="1100">
                 <a:solidFill>
                   <a:srgbClr val="1E1508"/>
                 </a:solidFill>
                 <a:latin typeface="Calibri"/>
               </a:rPr>
+              <a:t>New items default to the latest day — no day-1 pile-up; trip naturally fills out</a:t>
+            </a:r>
+          </a:p>
+          <a:p>
+            <a:pPr algn="l">
+              <a:lnSpc>
+                <a:spcPct val="110000"/>
+              </a:lnSpc>
+              <a:spcBef>
+                <a:spcPts val="0"/>
+              </a:spcBef>
+            </a:pPr>
+            <a:r>
+              <a:rPr sz="900" i="1">
+                <a:solidFill>
+                  <a:srgbClr val="5C3A1F"/>
+                </a:solidFill>
+                <a:latin typeface="Calibri"/>
+              </a:rPr>
+              <a:t>       ↳  Adding stops naturally extends the trip rather than cramming Day 1.</a:t>
+            </a:r>
+          </a:p>
+          <a:p>
+            <a:pPr algn="l">
+              <a:lnSpc>
+                <a:spcPct val="120000"/>
+              </a:lnSpc>
+              <a:spcBef>
+                <a:spcPts val="400"/>
+              </a:spcBef>
+            </a:pPr>
+            <a:r>
+              <a:rPr sz="1300" b="1">
+                <a:solidFill>
+                  <a:srgbClr val="C9A84C"/>
+                </a:solidFill>
+                <a:latin typeface="Calibri"/>
+              </a:rPr>
+              <a:t>• </a:t>
+            </a:r>
+            <a:r>
+              <a:rPr sz="1100">
+                <a:solidFill>
+                  <a:srgbClr val="1E1508"/>
+                </a:solidFill>
+                <a:latin typeface="Calibri"/>
+              </a:rPr>
+              <a:t>Print view goes long-form per day — visitors who print, follow it</a:t>
+            </a:r>
+          </a:p>
+          <a:p>
+            <a:pPr algn="l">
+              <a:lnSpc>
+                <a:spcPct val="110000"/>
+              </a:lnSpc>
+              <a:spcBef>
+                <a:spcPts val="0"/>
+              </a:spcBef>
+            </a:pPr>
+            <a:r>
+              <a:rPr sz="900" i="1">
+                <a:solidFill>
+                  <a:srgbClr val="5C3A1F"/>
+                </a:solidFill>
+                <a:latin typeface="Calibri"/>
+              </a:rPr>
+              <a:t>       ↳  Couple prints the itinerary; the same Day 1 / Day 2 structure follows on paper.</a:t>
+            </a:r>
+          </a:p>
+          <a:p>
+            <a:pPr algn="l">
+              <a:lnSpc>
+                <a:spcPct val="120000"/>
+              </a:lnSpc>
+              <a:spcBef>
+                <a:spcPts val="400"/>
+              </a:spcBef>
+            </a:pPr>
+            <a:r>
+              <a:rPr sz="1300" b="1">
+                <a:solidFill>
+                  <a:srgbClr val="C9A84C"/>
+                </a:solidFill>
+                <a:latin typeface="Calibri"/>
+              </a:rPr>
+              <a:t>• </a:t>
+            </a:r>
+            <a:r>
+              <a:rPr sz="1100">
+                <a:solidFill>
+                  <a:srgbClr val="1E1508"/>
+                </a:solidFill>
+                <a:latin typeface="Calibri"/>
+              </a:rPr>
               <a:t>Smart suggestions are tag + geography aware — clusters keep visitors close to lodging</a:t>
+            </a:r>
+          </a:p>
+          <a:p>
+            <a:pPr algn="l">
+              <a:lnSpc>
+                <a:spcPct val="110000"/>
+              </a:lnSpc>
+              <a:spcBef>
+                <a:spcPts val="0"/>
+              </a:spcBef>
+            </a:pPr>
+            <a:r>
+              <a:rPr sz="900" i="1">
+                <a:solidFill>
+                  <a:srgbClr val="5C3A1F"/>
+                </a:solidFill>
+                <a:latin typeface="Calibri"/>
+              </a:rPr>
+              <a:t>       ↳  After Holbrooke Hotel goes in, suggestions cluster around Mill Street.</a:t>
             </a:r>
           </a:p>
         </p:txBody>
@@ -9733,7 +9847,7 @@
         </p:nvSpPr>
         <p:spPr>
           <a:xfrm>
-            <a:off x="548640" y="1691640"/>
+            <a:off x="548640" y="1600200"/>
             <a:ext cx="11064240" cy="384048"/>
           </a:xfrm>
           <a:prstGeom prst="rect">
@@ -9777,7 +9891,7 @@
         </p:nvSpPr>
         <p:spPr>
           <a:xfrm>
-            <a:off x="640080" y="1737360"/>
+            <a:off x="640080" y="1645920"/>
             <a:ext cx="2971800" cy="292608"/>
           </a:xfrm>
           <a:prstGeom prst="rect">
@@ -9812,7 +9926,7 @@
         </p:nvSpPr>
         <p:spPr>
           <a:xfrm>
-            <a:off x="3749040" y="1737360"/>
+            <a:off x="3749040" y="1645920"/>
             <a:ext cx="7818119" cy="292608"/>
           </a:xfrm>
           <a:prstGeom prst="rect">
@@ -9847,7 +9961,7 @@
         </p:nvSpPr>
         <p:spPr>
           <a:xfrm>
-            <a:off x="548640" y="2075688"/>
+            <a:off x="548640" y="1984248"/>
             <a:ext cx="11064240" cy="25400"/>
           </a:xfrm>
           <a:prstGeom prst="rect">
@@ -9890,8 +10004,8 @@
         </p:nvSpPr>
         <p:spPr>
           <a:xfrm>
-            <a:off x="548640" y="2112264"/>
-            <a:ext cx="11064240" cy="502920"/>
+            <a:off x="548640" y="2020824"/>
+            <a:ext cx="11064240" cy="594360"/>
           </a:xfrm>
           <a:prstGeom prst="rect">
             <a:avLst/>
@@ -9934,16 +10048,16 @@
         </p:nvSpPr>
         <p:spPr>
           <a:xfrm>
-            <a:off x="640080" y="2157984"/>
-            <a:ext cx="2971800" cy="457200"/>
-          </a:xfrm>
-          <a:prstGeom prst="rect">
-            <a:avLst/>
-          </a:prstGeom>
-          <a:noFill/>
-        </p:spPr>
-        <p:txBody>
-          <a:bodyPr wrap="square" anchor="t" lIns="45720" rIns="45720" tIns="18288" bIns="18288">
+            <a:off x="640080" y="2066544"/>
+            <a:ext cx="2971800" cy="548640"/>
+          </a:xfrm>
+          <a:prstGeom prst="rect">
+            <a:avLst/>
+          </a:prstGeom>
+          <a:noFill/>
+        </p:spPr>
+        <p:txBody>
+          <a:bodyPr wrap="square" anchor="ctr" lIns="45720" rIns="45720" tIns="18288" bIns="18288">
             <a:spAutoFit/>
           </a:bodyPr>
           <a:lstStyle/>
@@ -9969,8 +10083,8 @@
         </p:nvSpPr>
         <p:spPr>
           <a:xfrm>
-            <a:off x="3749040" y="2157984"/>
-            <a:ext cx="7818119" cy="457200"/>
+            <a:off x="3749040" y="2057400"/>
+            <a:ext cx="7818119" cy="274320"/>
           </a:xfrm>
           <a:prstGeom prst="rect">
             <a:avLst/>
@@ -10004,16 +10118,51 @@
         </p:nvSpPr>
         <p:spPr>
           <a:xfrm>
+            <a:off x="3749040" y="2331720"/>
+            <a:ext cx="7818119" cy="274320"/>
+          </a:xfrm>
+          <a:prstGeom prst="rect">
+            <a:avLst/>
+          </a:prstGeom>
+          <a:noFill/>
+        </p:spPr>
+        <p:txBody>
+          <a:bodyPr wrap="square" anchor="t" lIns="45720" rIns="45720" tIns="18288" bIns="18288">
+            <a:spAutoFit/>
+          </a:bodyPr>
+          <a:lstStyle/>
+          <a:p>
+            <a:pPr algn="l"/>
+            <a:r>
+              <a:rPr sz="800" b="0" i="1">
+                <a:solidFill>
+                  <a:srgbClr val="5C3A1F"/>
+                </a:solidFill>
+                <a:latin typeface="Calibri"/>
+              </a:rPr>
+              <a:t>↳  No-plan visitor taps "Foodie" — relevant cards instantly filter in.</a:t>
+            </a:r>
+          </a:p>
+        </p:txBody>
+      </p:sp>
+      <p:sp>
+        <p:nvSpPr>
+          <p:cNvPr id="13" name="TextBox 12"/>
+          <p:cNvSpPr txBox="1"/>
+          <p:nvPr/>
+        </p:nvSpPr>
+        <p:spPr>
+          <a:xfrm>
             <a:off x="640080" y="2660904"/>
-            <a:ext cx="2971800" cy="457200"/>
-          </a:xfrm>
-          <a:prstGeom prst="rect">
-            <a:avLst/>
-          </a:prstGeom>
-          <a:noFill/>
-        </p:spPr>
-        <p:txBody>
-          <a:bodyPr wrap="square" anchor="t" lIns="45720" rIns="45720" tIns="18288" bIns="18288">
+            <a:ext cx="2971800" cy="548640"/>
+          </a:xfrm>
+          <a:prstGeom prst="rect">
+            <a:avLst/>
+          </a:prstGeom>
+          <a:noFill/>
+        </p:spPr>
+        <p:txBody>
+          <a:bodyPr wrap="square" anchor="ctr" lIns="45720" rIns="45720" tIns="18288" bIns="18288">
             <a:spAutoFit/>
           </a:bodyPr>
           <a:lstStyle/>
@@ -10033,14 +10182,14 @@
       </p:sp>
       <p:sp>
         <p:nvSpPr>
-          <p:cNvPr id="13" name="TextBox 12"/>
-          <p:cNvSpPr txBox="1"/>
-          <p:nvPr/>
-        </p:nvSpPr>
-        <p:spPr>
-          <a:xfrm>
-            <a:off x="3749040" y="2660904"/>
-            <a:ext cx="7818119" cy="457200"/>
+          <p:cNvPr id="14" name="TextBox 13"/>
+          <p:cNvSpPr txBox="1"/>
+          <p:nvPr/>
+        </p:nvSpPr>
+        <p:spPr>
+          <a:xfrm>
+            <a:off x="3749040" y="2651760"/>
+            <a:ext cx="7818119" cy="274320"/>
           </a:xfrm>
           <a:prstGeom prst="rect">
             <a:avLst/>
@@ -10068,14 +10217,49 @@
       </p:sp>
       <p:sp>
         <p:nvSpPr>
-          <p:cNvPr id="14" name="Rectangle 13"/>
+          <p:cNvPr id="15" name="TextBox 14"/>
+          <p:cNvSpPr txBox="1"/>
+          <p:nvPr/>
+        </p:nvSpPr>
+        <p:spPr>
+          <a:xfrm>
+            <a:off x="3749040" y="2926080"/>
+            <a:ext cx="7818119" cy="274320"/>
+          </a:xfrm>
+          <a:prstGeom prst="rect">
+            <a:avLst/>
+          </a:prstGeom>
+          <a:noFill/>
+        </p:spPr>
+        <p:txBody>
+          <a:bodyPr wrap="square" anchor="t" lIns="45720" rIns="45720" tIns="18288" bIns="18288">
+            <a:spAutoFit/>
+          </a:bodyPr>
+          <a:lstStyle/>
+          <a:p>
+            <a:pPr algn="l"/>
+            <a:r>
+              <a:rPr sz="800" b="0" i="1">
+                <a:solidFill>
+                  <a:srgbClr val="5C3A1F"/>
+                </a:solidFill>
+                <a:latin typeface="Calibri"/>
+              </a:rPr>
+              <a:t>↳  Foodie visitor switches to "Wineries only" without leaving the vibe.</a:t>
+            </a:r>
+          </a:p>
+        </p:txBody>
+      </p:sp>
+      <p:sp>
+        <p:nvSpPr>
+          <p:cNvPr id="16" name="Rectangle 15"/>
           <p:cNvSpPr/>
           <p:nvPr/>
         </p:nvSpPr>
         <p:spPr>
           <a:xfrm>
-            <a:off x="548640" y="3118104"/>
-            <a:ext cx="11064240" cy="502920"/>
+            <a:off x="548640" y="3209544"/>
+            <a:ext cx="11064240" cy="594360"/>
           </a:xfrm>
           <a:prstGeom prst="rect">
             <a:avLst/>
@@ -10112,22 +10296,22 @@
       </p:sp>
       <p:sp>
         <p:nvSpPr>
-          <p:cNvPr id="15" name="TextBox 14"/>
-          <p:cNvSpPr txBox="1"/>
-          <p:nvPr/>
-        </p:nvSpPr>
-        <p:spPr>
-          <a:xfrm>
-            <a:off x="640080" y="3163824"/>
-            <a:ext cx="2971800" cy="457200"/>
-          </a:xfrm>
-          <a:prstGeom prst="rect">
-            <a:avLst/>
-          </a:prstGeom>
-          <a:noFill/>
-        </p:spPr>
-        <p:txBody>
-          <a:bodyPr wrap="square" anchor="t" lIns="45720" rIns="45720" tIns="18288" bIns="18288">
+          <p:cNvPr id="17" name="TextBox 16"/>
+          <p:cNvSpPr txBox="1"/>
+          <p:nvPr/>
+        </p:nvSpPr>
+        <p:spPr>
+          <a:xfrm>
+            <a:off x="640080" y="3255264"/>
+            <a:ext cx="2971800" cy="548640"/>
+          </a:xfrm>
+          <a:prstGeom prst="rect">
+            <a:avLst/>
+          </a:prstGeom>
+          <a:noFill/>
+        </p:spPr>
+        <p:txBody>
+          <a:bodyPr wrap="square" anchor="ctr" lIns="45720" rIns="45720" tIns="18288" bIns="18288">
             <a:spAutoFit/>
           </a:bodyPr>
           <a:lstStyle/>
@@ -10147,14 +10331,14 @@
       </p:sp>
       <p:sp>
         <p:nvSpPr>
-          <p:cNvPr id="16" name="TextBox 15"/>
-          <p:cNvSpPr txBox="1"/>
-          <p:nvPr/>
-        </p:nvSpPr>
-        <p:spPr>
-          <a:xfrm>
-            <a:off x="3749040" y="3163824"/>
-            <a:ext cx="7818119" cy="457200"/>
+          <p:cNvPr id="18" name="TextBox 17"/>
+          <p:cNvSpPr txBox="1"/>
+          <p:nvPr/>
+        </p:nvSpPr>
+        <p:spPr>
+          <a:xfrm>
+            <a:off x="3749040" y="3246120"/>
+            <a:ext cx="7818119" cy="274320"/>
           </a:xfrm>
           <a:prstGeom prst="rect">
             <a:avLst/>
@@ -10182,14 +10366,14 @@
       </p:sp>
       <p:sp>
         <p:nvSpPr>
-          <p:cNvPr id="17" name="TextBox 16"/>
-          <p:cNvSpPr txBox="1"/>
-          <p:nvPr/>
-        </p:nvSpPr>
-        <p:spPr>
-          <a:xfrm>
-            <a:off x="640080" y="3666744"/>
-            <a:ext cx="2971800" cy="457200"/>
+          <p:cNvPr id="19" name="TextBox 18"/>
+          <p:cNvSpPr txBox="1"/>
+          <p:nvPr/>
+        </p:nvSpPr>
+        <p:spPr>
+          <a:xfrm>
+            <a:off x="3749040" y="3520440"/>
+            <a:ext cx="7818119" cy="274320"/>
           </a:xfrm>
           <a:prstGeom prst="rect">
             <a:avLst/>
@@ -10204,6 +10388,41 @@
           <a:p>
             <a:pPr algn="l"/>
             <a:r>
+              <a:rPr sz="800" b="0" i="1">
+                <a:solidFill>
+                  <a:srgbClr val="5C3A1F"/>
+                </a:solidFill>
+                <a:latin typeface="Calibri"/>
+              </a:rPr>
+              <a:t>↳  Family of four picks Lodging → B&amp;Bs to find character stays over chains.</a:t>
+            </a:r>
+          </a:p>
+        </p:txBody>
+      </p:sp>
+      <p:sp>
+        <p:nvSpPr>
+          <p:cNvPr id="20" name="TextBox 19"/>
+          <p:cNvSpPr txBox="1"/>
+          <p:nvPr/>
+        </p:nvSpPr>
+        <p:spPr>
+          <a:xfrm>
+            <a:off x="640080" y="3849624"/>
+            <a:ext cx="2971800" cy="548640"/>
+          </a:xfrm>
+          <a:prstGeom prst="rect">
+            <a:avLst/>
+          </a:prstGeom>
+          <a:noFill/>
+        </p:spPr>
+        <p:txBody>
+          <a:bodyPr wrap="square" anchor="ctr" lIns="45720" rIns="45720" tIns="18288" bIns="18288">
+            <a:spAutoFit/>
+          </a:bodyPr>
+          <a:lstStyle/>
+          <a:p>
+            <a:pPr algn="l"/>
+            <a:r>
               <a:rPr sz="1000" b="0" i="0">
                 <a:solidFill>
                   <a:srgbClr val="1E1508"/>
@@ -10217,14 +10436,14 @@
       </p:sp>
       <p:sp>
         <p:nvSpPr>
-          <p:cNvPr id="18" name="TextBox 17"/>
-          <p:cNvSpPr txBox="1"/>
-          <p:nvPr/>
-        </p:nvSpPr>
-        <p:spPr>
-          <a:xfrm>
-            <a:off x="3749040" y="3666744"/>
-            <a:ext cx="7818119" cy="457200"/>
+          <p:cNvPr id="21" name="TextBox 20"/>
+          <p:cNvSpPr txBox="1"/>
+          <p:nvPr/>
+        </p:nvSpPr>
+        <p:spPr>
+          <a:xfrm>
+            <a:off x="3749040" y="3840480"/>
+            <a:ext cx="7818119" cy="274320"/>
           </a:xfrm>
           <a:prstGeom prst="rect">
             <a:avLst/>
@@ -10252,14 +10471,49 @@
       </p:sp>
       <p:sp>
         <p:nvSpPr>
-          <p:cNvPr id="19" name="Rectangle 18"/>
+          <p:cNvPr id="22" name="TextBox 21"/>
+          <p:cNvSpPr txBox="1"/>
+          <p:nvPr/>
+        </p:nvSpPr>
+        <p:spPr>
+          <a:xfrm>
+            <a:off x="3749040" y="4114800"/>
+            <a:ext cx="7818119" cy="274320"/>
+          </a:xfrm>
+          <a:prstGeom prst="rect">
+            <a:avLst/>
+          </a:prstGeom>
+          <a:noFill/>
+        </p:spPr>
+        <p:txBody>
+          <a:bodyPr wrap="square" anchor="t" lIns="45720" rIns="45720" tIns="18288" bIns="18288">
+            <a:spAutoFit/>
+          </a:bodyPr>
+          <a:lstStyle/>
+          <a:p>
+            <a:pPr algn="l"/>
+            <a:r>
+              <a:rPr sz="800" b="0" i="1">
+                <a:solidFill>
+                  <a:srgbClr val="5C3A1F"/>
+                </a:solidFill>
+                <a:latin typeface="Calibri"/>
+              </a:rPr>
+              <a:t>↳  Mountain biker scrolls and immediately spots cards tagged "Biking".</a:t>
+            </a:r>
+          </a:p>
+        </p:txBody>
+      </p:sp>
+      <p:sp>
+        <p:nvSpPr>
+          <p:cNvPr id="23" name="Rectangle 22"/>
           <p:cNvSpPr/>
           <p:nvPr/>
         </p:nvSpPr>
         <p:spPr>
           <a:xfrm>
-            <a:off x="548640" y="4123944"/>
-            <a:ext cx="11064240" cy="502920"/>
+            <a:off x="548640" y="4398264"/>
+            <a:ext cx="11064240" cy="594360"/>
           </a:xfrm>
           <a:prstGeom prst="rect">
             <a:avLst/>
@@ -10296,22 +10550,22 @@
       </p:sp>
       <p:sp>
         <p:nvSpPr>
-          <p:cNvPr id="20" name="TextBox 19"/>
-          <p:cNvSpPr txBox="1"/>
-          <p:nvPr/>
-        </p:nvSpPr>
-        <p:spPr>
-          <a:xfrm>
-            <a:off x="640080" y="4169664"/>
-            <a:ext cx="2971800" cy="457200"/>
-          </a:xfrm>
-          <a:prstGeom prst="rect">
-            <a:avLst/>
-          </a:prstGeom>
-          <a:noFill/>
-        </p:spPr>
-        <p:txBody>
-          <a:bodyPr wrap="square" anchor="t" lIns="45720" rIns="45720" tIns="18288" bIns="18288">
+          <p:cNvPr id="24" name="TextBox 23"/>
+          <p:cNvSpPr txBox="1"/>
+          <p:nvPr/>
+        </p:nvSpPr>
+        <p:spPr>
+          <a:xfrm>
+            <a:off x="640080" y="4443984"/>
+            <a:ext cx="2971800" cy="548640"/>
+          </a:xfrm>
+          <a:prstGeom prst="rect">
+            <a:avLst/>
+          </a:prstGeom>
+          <a:noFill/>
+        </p:spPr>
+        <p:txBody>
+          <a:bodyPr wrap="square" anchor="ctr" lIns="45720" rIns="45720" tIns="18288" bIns="18288">
             <a:spAutoFit/>
           </a:bodyPr>
           <a:lstStyle/>
@@ -10331,14 +10585,14 @@
       </p:sp>
       <p:sp>
         <p:nvSpPr>
-          <p:cNvPr id="21" name="TextBox 20"/>
-          <p:cNvSpPr txBox="1"/>
-          <p:nvPr/>
-        </p:nvSpPr>
-        <p:spPr>
-          <a:xfrm>
-            <a:off x="3749040" y="4169664"/>
-            <a:ext cx="7818119" cy="457200"/>
+          <p:cNvPr id="25" name="TextBox 24"/>
+          <p:cNvSpPr txBox="1"/>
+          <p:nvPr/>
+        </p:nvSpPr>
+        <p:spPr>
+          <a:xfrm>
+            <a:off x="3749040" y="4434840"/>
+            <a:ext cx="7818119" cy="274320"/>
           </a:xfrm>
           <a:prstGeom prst="rect">
             <a:avLst/>
@@ -10366,14 +10620,14 @@
       </p:sp>
       <p:sp>
         <p:nvSpPr>
-          <p:cNvPr id="22" name="TextBox 21"/>
-          <p:cNvSpPr txBox="1"/>
-          <p:nvPr/>
-        </p:nvSpPr>
-        <p:spPr>
-          <a:xfrm>
-            <a:off x="640080" y="4672584"/>
-            <a:ext cx="2971800" cy="457200"/>
+          <p:cNvPr id="26" name="TextBox 25"/>
+          <p:cNvSpPr txBox="1"/>
+          <p:nvPr/>
+        </p:nvSpPr>
+        <p:spPr>
+          <a:xfrm>
+            <a:off x="3749040" y="4709160"/>
+            <a:ext cx="7818119" cy="274320"/>
           </a:xfrm>
           <a:prstGeom prst="rect">
             <a:avLst/>
@@ -10388,6 +10642,41 @@
           <a:p>
             <a:pPr algn="l"/>
             <a:r>
+              <a:rPr sz="800" b="0" i="1">
+                <a:solidFill>
+                  <a:srgbClr val="5C3A1F"/>
+                </a:solidFill>
+                <a:latin typeface="Calibri"/>
+              </a:rPr>
+              <a:t>↳  One-tap "Weekend" — only Sat/Sun events remain across every vibe.</a:t>
+            </a:r>
+          </a:p>
+        </p:txBody>
+      </p:sp>
+      <p:sp>
+        <p:nvSpPr>
+          <p:cNvPr id="27" name="TextBox 26"/>
+          <p:cNvSpPr txBox="1"/>
+          <p:nvPr/>
+        </p:nvSpPr>
+        <p:spPr>
+          <a:xfrm>
+            <a:off x="640080" y="5038344"/>
+            <a:ext cx="2971800" cy="548640"/>
+          </a:xfrm>
+          <a:prstGeom prst="rect">
+            <a:avLst/>
+          </a:prstGeom>
+          <a:noFill/>
+        </p:spPr>
+        <p:txBody>
+          <a:bodyPr wrap="square" anchor="ctr" lIns="45720" rIns="45720" tIns="18288" bIns="18288">
+            <a:spAutoFit/>
+          </a:bodyPr>
+          <a:lstStyle/>
+          <a:p>
+            <a:pPr algn="l"/>
+            <a:r>
               <a:rPr sz="1000" b="0" i="0">
                 <a:solidFill>
                   <a:srgbClr val="1E1508"/>
@@ -10401,14 +10690,14 @@
       </p:sp>
       <p:sp>
         <p:nvSpPr>
-          <p:cNvPr id="23" name="TextBox 22"/>
-          <p:cNvSpPr txBox="1"/>
-          <p:nvPr/>
-        </p:nvSpPr>
-        <p:spPr>
-          <a:xfrm>
-            <a:off x="3749040" y="4672584"/>
-            <a:ext cx="7818119" cy="457200"/>
+          <p:cNvPr id="28" name="TextBox 27"/>
+          <p:cNvSpPr txBox="1"/>
+          <p:nvPr/>
+        </p:nvSpPr>
+        <p:spPr>
+          <a:xfrm>
+            <a:off x="3749040" y="5029200"/>
+            <a:ext cx="7818119" cy="274320"/>
           </a:xfrm>
           <a:prstGeom prst="rect">
             <a:avLst/>
@@ -10436,14 +10725,49 @@
       </p:sp>
       <p:sp>
         <p:nvSpPr>
-          <p:cNvPr id="24" name="Rectangle 23"/>
+          <p:cNvPr id="29" name="TextBox 28"/>
+          <p:cNvSpPr txBox="1"/>
+          <p:nvPr/>
+        </p:nvSpPr>
+        <p:spPr>
+          <a:xfrm>
+            <a:off x="3749040" y="5303520"/>
+            <a:ext cx="7818119" cy="274320"/>
+          </a:xfrm>
+          <a:prstGeom prst="rect">
+            <a:avLst/>
+          </a:prstGeom>
+          <a:noFill/>
+        </p:spPr>
+        <p:txBody>
+          <a:bodyPr wrap="square" anchor="t" lIns="45720" rIns="45720" tIns="18288" bIns="18288">
+            <a:spAutoFit/>
+          </a:bodyPr>
+          <a:lstStyle/>
+          <a:p>
+            <a:pPr algn="l"/>
+            <a:r>
+              <a:rPr sz="800" b="0" i="1">
+                <a:solidFill>
+                  <a:srgbClr val="5C3A1F"/>
+                </a:solidFill>
+                <a:latin typeface="Calibri"/>
+              </a:rPr>
+              <a:t>↳  Penn Valley resident filters out Nevada City clutter for a local night out.</a:t>
+            </a:r>
+          </a:p>
+        </p:txBody>
+      </p:sp>
+      <p:sp>
+        <p:nvSpPr>
+          <p:cNvPr id="30" name="Rectangle 29"/>
           <p:cNvSpPr/>
           <p:nvPr/>
         </p:nvSpPr>
         <p:spPr>
           <a:xfrm>
-            <a:off x="548640" y="5129784"/>
-            <a:ext cx="11064240" cy="502920"/>
+            <a:off x="548640" y="5586984"/>
+            <a:ext cx="11064240" cy="594360"/>
           </a:xfrm>
           <a:prstGeom prst="rect">
             <a:avLst/>
@@ -10480,22 +10804,22 @@
       </p:sp>
       <p:sp>
         <p:nvSpPr>
-          <p:cNvPr id="25" name="TextBox 24"/>
-          <p:cNvSpPr txBox="1"/>
-          <p:nvPr/>
-        </p:nvSpPr>
-        <p:spPr>
-          <a:xfrm>
-            <a:off x="640080" y="5175504"/>
-            <a:ext cx="2971800" cy="457200"/>
-          </a:xfrm>
-          <a:prstGeom prst="rect">
-            <a:avLst/>
-          </a:prstGeom>
-          <a:noFill/>
-        </p:spPr>
-        <p:txBody>
-          <a:bodyPr wrap="square" anchor="t" lIns="45720" rIns="45720" tIns="18288" bIns="18288">
+          <p:cNvPr id="31" name="TextBox 30"/>
+          <p:cNvSpPr txBox="1"/>
+          <p:nvPr/>
+        </p:nvSpPr>
+        <p:spPr>
+          <a:xfrm>
+            <a:off x="640080" y="5632704"/>
+            <a:ext cx="2971800" cy="548640"/>
+          </a:xfrm>
+          <a:prstGeom prst="rect">
+            <a:avLst/>
+          </a:prstGeom>
+          <a:noFill/>
+        </p:spPr>
+        <p:txBody>
+          <a:bodyPr wrap="square" anchor="ctr" lIns="45720" rIns="45720" tIns="18288" bIns="18288">
             <a:spAutoFit/>
           </a:bodyPr>
           <a:lstStyle/>
@@ -10515,14 +10839,14 @@
       </p:sp>
       <p:sp>
         <p:nvSpPr>
-          <p:cNvPr id="26" name="TextBox 25"/>
-          <p:cNvSpPr txBox="1"/>
-          <p:nvPr/>
-        </p:nvSpPr>
-        <p:spPr>
-          <a:xfrm>
-            <a:off x="3749040" y="5175504"/>
-            <a:ext cx="7818119" cy="457200"/>
+          <p:cNvPr id="32" name="TextBox 31"/>
+          <p:cNvSpPr txBox="1"/>
+          <p:nvPr/>
+        </p:nvSpPr>
+        <p:spPr>
+          <a:xfrm>
+            <a:off x="3749040" y="5623560"/>
+            <a:ext cx="7818119" cy="274320"/>
           </a:xfrm>
           <a:prstGeom prst="rect">
             <a:avLst/>
@@ -10550,7 +10874,42 @@
       </p:sp>
       <p:sp>
         <p:nvSpPr>
-          <p:cNvPr id="27" name="TextBox 26"/>
+          <p:cNvPr id="33" name="TextBox 32"/>
+          <p:cNvSpPr txBox="1"/>
+          <p:nvPr/>
+        </p:nvSpPr>
+        <p:spPr>
+          <a:xfrm>
+            <a:off x="3749040" y="5897880"/>
+            <a:ext cx="7818119" cy="274320"/>
+          </a:xfrm>
+          <a:prstGeom prst="rect">
+            <a:avLst/>
+          </a:prstGeom>
+          <a:noFill/>
+        </p:spPr>
+        <p:txBody>
+          <a:bodyPr wrap="square" anchor="t" lIns="45720" rIns="45720" tIns="18288" bIns="18288">
+            <a:spAutoFit/>
+          </a:bodyPr>
+          <a:lstStyle/>
+          <a:p>
+            <a:pPr algn="l"/>
+            <a:r>
+              <a:rPr sz="800" b="0" i="1">
+                <a:solidFill>
+                  <a:srgbClr val="5C3A1F"/>
+                </a:solidFill>
+                <a:latin typeface="Calibri"/>
+              </a:rPr>
+              <a:t>↳  After Empire Mine goes in, the panel surfaces Holbrooke Hotel 0.4 mi away.</a:t>
+            </a:r>
+          </a:p>
+        </p:txBody>
+      </p:sp>
+      <p:sp>
+        <p:nvSpPr>
+          <p:cNvPr id="34" name="TextBox 33"/>
           <p:cNvSpPr txBox="1"/>
           <p:nvPr/>
         </p:nvSpPr>
@@ -10585,7 +10944,7 @@
       </p:sp>
       <p:sp>
         <p:nvSpPr>
-          <p:cNvPr id="28" name="TextBox 27"/>
+          <p:cNvPr id="35" name="TextBox 34"/>
           <p:cNvSpPr txBox="1"/>
           <p:nvPr/>
         </p:nvSpPr>
@@ -10620,7 +10979,7 @@
       </p:sp>
       <p:sp>
         <p:nvSpPr>
-          <p:cNvPr id="29" name="Rectangle 28"/>
+          <p:cNvPr id="36" name="Rectangle 35"/>
           <p:cNvSpPr/>
           <p:nvPr/>
         </p:nvSpPr>
@@ -10800,8 +11159,8 @@
         </p:nvSpPr>
         <p:spPr>
           <a:xfrm>
-            <a:off x="548640" y="1691640"/>
-            <a:ext cx="6400800" cy="4572000"/>
+            <a:off x="548640" y="1600200"/>
+            <a:ext cx="6400800" cy="4846320"/>
           </a:xfrm>
           <a:prstGeom prst="rect">
             <a:avLst/>
@@ -10816,11 +11175,11 @@
           <a:p>
             <a:pPr algn="l">
               <a:lnSpc>
-                <a:spcPct val="145000"/>
+                <a:spcPct val="120000"/>
               </a:lnSpc>
             </a:pPr>
             <a:r>
-              <a:rPr sz="1400" b="1">
+              <a:rPr sz="1300" b="1">
                 <a:solidFill>
                   <a:srgbClr val="C9A84C"/>
                 </a:solidFill>
@@ -10829,7 +11188,7 @@
               <a:t>• </a:t>
             </a:r>
             <a:r>
-              <a:rPr sz="1200">
+              <a:rPr sz="1100">
                 <a:solidFill>
                   <a:srgbClr val="1E1508"/>
                 </a:solidFill>
@@ -10841,42 +11200,33 @@
           <a:p>
             <a:pPr algn="l">
               <a:lnSpc>
-                <a:spcPct val="145000"/>
+                <a:spcPct val="110000"/>
               </a:lnSpc>
               <a:spcBef>
-                <a:spcPts val="600"/>
+                <a:spcPts val="0"/>
               </a:spcBef>
             </a:pPr>
             <a:r>
-              <a:rPr sz="1400" b="1">
-                <a:solidFill>
-                  <a:srgbClr val="C9A84C"/>
-                </a:solidFill>
-                <a:latin typeface="Calibri"/>
-              </a:rPr>
-              <a:t>• </a:t>
-            </a:r>
-            <a:r>
-              <a:rPr sz="1200">
-                <a:solidFill>
-                  <a:srgbClr val="1E1508"/>
-                </a:solidFill>
-                <a:latin typeface="Calibri"/>
-              </a:rPr>
-              <a:t>Per-day "Tonight's Stay" lodging slot — empty slots prompt for booking</a:t>
+              <a:rPr sz="900" i="1">
+                <a:solidFill>
+                  <a:srgbClr val="5C3A1F"/>
+                </a:solidFill>
+                <a:latin typeface="Calibri"/>
+              </a:rPr>
+              <a:t>       ↳  Visitor sees "Day 1: Sat May 17" instead of an undifferentiated stop list.</a:t>
             </a:r>
           </a:p>
           <a:p>
             <a:pPr algn="l">
               <a:lnSpc>
-                <a:spcPct val="145000"/>
+                <a:spcPct val="120000"/>
               </a:lnSpc>
               <a:spcBef>
-                <a:spcPts val="600"/>
+                <a:spcPts val="400"/>
               </a:spcBef>
             </a:pPr>
             <a:r>
-              <a:rPr sz="1400" b="1">
+              <a:rPr sz="1300" b="1">
                 <a:solidFill>
                   <a:srgbClr val="C9A84C"/>
                 </a:solidFill>
@@ -10885,54 +11235,45 @@
               <a:t>• </a:t>
             </a:r>
             <a:r>
-              <a:rPr sz="1200">
+              <a:rPr sz="1100">
                 <a:solidFill>
                   <a:srgbClr val="1E1508"/>
                 </a:solidFill>
                 <a:latin typeface="Calibri"/>
               </a:rPr>
-              <a:t>Drag-free move-between-days dropdown on every item</a:t>
+              <a:t>Per-day "Tonight's Stay" lodging slot — empty slots prompt for booking</a:t>
             </a:r>
           </a:p>
           <a:p>
             <a:pPr algn="l">
               <a:lnSpc>
-                <a:spcPct val="145000"/>
+                <a:spcPct val="110000"/>
               </a:lnSpc>
               <a:spcBef>
-                <a:spcPts val="600"/>
+                <a:spcPts val="0"/>
               </a:spcBef>
             </a:pPr>
             <a:r>
-              <a:rPr sz="1400" b="1">
-                <a:solidFill>
-                  <a:srgbClr val="C9A84C"/>
-                </a:solidFill>
-                <a:latin typeface="Calibri"/>
-              </a:rPr>
-              <a:t>• </a:t>
-            </a:r>
-            <a:r>
-              <a:rPr sz="1200">
-                <a:solidFill>
-                  <a:srgbClr val="1E1508"/>
-                </a:solidFill>
-                <a:latin typeface="Calibri"/>
-              </a:rPr>
-              <a:t>Add Day → returns visitor to browse mode for the new day</a:t>
+              <a:rPr sz="900" i="1">
+                <a:solidFill>
+                  <a:srgbClr val="5C3A1F"/>
+                </a:solidFill>
+                <a:latin typeface="Calibri"/>
+              </a:rPr>
+              <a:t>       ↳  Empty Day 2 stay tile reminds the visitor they haven't booked Sunday yet.</a:t>
             </a:r>
           </a:p>
           <a:p>
             <a:pPr algn="l">
               <a:lnSpc>
-                <a:spcPct val="145000"/>
+                <a:spcPct val="120000"/>
               </a:lnSpc>
               <a:spcBef>
-                <a:spcPts val="600"/>
+                <a:spcPts val="400"/>
               </a:spcBef>
             </a:pPr>
             <a:r>
-              <a:rPr sz="1400" b="1">
+              <a:rPr sz="1300" b="1">
                 <a:solidFill>
                   <a:srgbClr val="C9A84C"/>
                 </a:solidFill>
@@ -10941,54 +11282,45 @@
               <a:t>• </a:t>
             </a:r>
             <a:r>
-              <a:rPr sz="1200">
+              <a:rPr sz="1100">
                 <a:solidFill>
                   <a:srgbClr val="1E1508"/>
                 </a:solidFill>
                 <a:latin typeface="Calibri"/>
               </a:rPr>
-              <a:t>Find Lodging button at top of itinerary jumps directly to lodging filter</a:t>
+              <a:t>Drag-free move-between-days dropdown on every item</a:t>
             </a:r>
           </a:p>
           <a:p>
             <a:pPr algn="l">
               <a:lnSpc>
-                <a:spcPct val="145000"/>
+                <a:spcPct val="110000"/>
               </a:lnSpc>
               <a:spcBef>
-                <a:spcPts val="600"/>
+                <a:spcPts val="0"/>
               </a:spcBef>
             </a:pPr>
             <a:r>
-              <a:rPr sz="1400" b="1">
-                <a:solidFill>
-                  <a:srgbClr val="C9A84C"/>
-                </a:solidFill>
-                <a:latin typeface="Calibri"/>
-              </a:rPr>
-              <a:t>• </a:t>
-            </a:r>
-            <a:r>
-              <a:rPr sz="1200">
-                <a:solidFill>
-                  <a:srgbClr val="1E1508"/>
-                </a:solidFill>
-                <a:latin typeface="Calibri"/>
-              </a:rPr>
-              <a:t>Events go INTO the itinerary first; the visitor decides what to commit to</a:t>
+              <a:rPr sz="900" i="1">
+                <a:solidFill>
+                  <a:srgbClr val="5C3A1F"/>
+                </a:solidFill>
+                <a:latin typeface="Calibri"/>
+              </a:rPr>
+              <a:t>       ↳  Spouse on phone moves Friday's hike to Saturday in two taps.</a:t>
             </a:r>
           </a:p>
           <a:p>
             <a:pPr algn="l">
               <a:lnSpc>
-                <a:spcPct val="145000"/>
+                <a:spcPct val="120000"/>
               </a:lnSpc>
               <a:spcBef>
-                <a:spcPts val="600"/>
+                <a:spcPts val="400"/>
               </a:spcBef>
             </a:pPr>
             <a:r>
-              <a:rPr sz="1400" b="1">
+              <a:rPr sz="1300" b="1">
                 <a:solidFill>
                   <a:srgbClr val="C9A84C"/>
                 </a:solidFill>
@@ -10997,26 +11329,45 @@
               <a:t>• </a:t>
             </a:r>
             <a:r>
-              <a:rPr sz="1200">
+              <a:rPr sz="1100">
                 <a:solidFill>
                   <a:srgbClr val="1E1508"/>
                 </a:solidFill>
                 <a:latin typeface="Calibri"/>
               </a:rPr>
-              <a:t>15-min add → opt-in save → survives tab close + browser restart</a:t>
+              <a:t>Add Day → returns visitor to browse mode for the new day</a:t>
             </a:r>
           </a:p>
           <a:p>
             <a:pPr algn="l">
               <a:lnSpc>
-                <a:spcPct val="145000"/>
+                <a:spcPct val="110000"/>
               </a:lnSpc>
               <a:spcBef>
-                <a:spcPts val="600"/>
+                <a:spcPts val="0"/>
               </a:spcBef>
             </a:pPr>
             <a:r>
-              <a:rPr sz="1400" b="1">
+              <a:rPr sz="900" i="1">
+                <a:solidFill>
+                  <a:srgbClr val="5C3A1F"/>
+                </a:solidFill>
+                <a:latin typeface="Calibri"/>
+              </a:rPr>
+              <a:t>       ↳  Tap "Add Day," land on cards to pick Day 3 activities — flow continues.</a:t>
+            </a:r>
+          </a:p>
+          <a:p>
+            <a:pPr algn="l">
+              <a:lnSpc>
+                <a:spcPct val="120000"/>
+              </a:lnSpc>
+              <a:spcBef>
+                <a:spcPts val="400"/>
+              </a:spcBef>
+            </a:pPr>
+            <a:r>
+              <a:rPr sz="1300" b="1">
                 <a:solidFill>
                   <a:srgbClr val="C9A84C"/>
                 </a:solidFill>
@@ -11025,13 +11376,173 @@
               <a:t>• </a:t>
             </a:r>
             <a:r>
-              <a:rPr sz="1200">
+              <a:rPr sz="1100">
                 <a:solidFill>
                   <a:srgbClr val="1E1508"/>
                 </a:solidFill>
                 <a:latin typeface="Calibri"/>
               </a:rPr>
+              <a:t>Find Lodging button at top of itinerary jumps directly to lodging filter</a:t>
+            </a:r>
+          </a:p>
+          <a:p>
+            <a:pPr algn="l">
+              <a:lnSpc>
+                <a:spcPct val="110000"/>
+              </a:lnSpc>
+              <a:spcBef>
+                <a:spcPts val="0"/>
+              </a:spcBef>
+            </a:pPr>
+            <a:r>
+              <a:rPr sz="900" i="1">
+                <a:solidFill>
+                  <a:srgbClr val="5C3A1F"/>
+                </a:solidFill>
+                <a:latin typeface="Calibri"/>
+              </a:rPr>
+              <a:t>       ↳  Six stops in but no hotel — one tap surfaces every nearby B&amp;B.</a:t>
+            </a:r>
+          </a:p>
+          <a:p>
+            <a:pPr algn="l">
+              <a:lnSpc>
+                <a:spcPct val="120000"/>
+              </a:lnSpc>
+              <a:spcBef>
+                <a:spcPts val="400"/>
+              </a:spcBef>
+            </a:pPr>
+            <a:r>
+              <a:rPr sz="1300" b="1">
+                <a:solidFill>
+                  <a:srgbClr val="C9A84C"/>
+                </a:solidFill>
+                <a:latin typeface="Calibri"/>
+              </a:rPr>
+              <a:t>• </a:t>
+            </a:r>
+            <a:r>
+              <a:rPr sz="1100">
+                <a:solidFill>
+                  <a:srgbClr val="1E1508"/>
+                </a:solidFill>
+                <a:latin typeface="Calibri"/>
+              </a:rPr>
+              <a:t>Events go INTO the itinerary first; the visitor decides what to commit to</a:t>
+            </a:r>
+          </a:p>
+          <a:p>
+            <a:pPr algn="l">
+              <a:lnSpc>
+                <a:spcPct val="110000"/>
+              </a:lnSpc>
+              <a:spcBef>
+                <a:spcPts val="0"/>
+              </a:spcBef>
+            </a:pPr>
+            <a:r>
+              <a:rPr sz="900" i="1">
+                <a:solidFill>
+                  <a:srgbClr val="5C3A1F"/>
+                </a:solidFill>
+                <a:latin typeface="Calibri"/>
+              </a:rPr>
+              <a:t>       ↳  Bluegrass concert tile lands in My Itinerary, not on KVMR's site.</a:t>
+            </a:r>
+          </a:p>
+          <a:p>
+            <a:pPr algn="l">
+              <a:lnSpc>
+                <a:spcPct val="120000"/>
+              </a:lnSpc>
+              <a:spcBef>
+                <a:spcPts val="400"/>
+              </a:spcBef>
+            </a:pPr>
+            <a:r>
+              <a:rPr sz="1300" b="1">
+                <a:solidFill>
+                  <a:srgbClr val="C9A84C"/>
+                </a:solidFill>
+                <a:latin typeface="Calibri"/>
+              </a:rPr>
+              <a:t>• </a:t>
+            </a:r>
+            <a:r>
+              <a:rPr sz="1100">
+                <a:solidFill>
+                  <a:srgbClr val="1E1508"/>
+                </a:solidFill>
+                <a:latin typeface="Calibri"/>
+              </a:rPr>
+              <a:t>15-min add → opt-in save → survives tab close + browser restart</a:t>
+            </a:r>
+          </a:p>
+          <a:p>
+            <a:pPr algn="l">
+              <a:lnSpc>
+                <a:spcPct val="110000"/>
+              </a:lnSpc>
+              <a:spcBef>
+                <a:spcPts val="0"/>
+              </a:spcBef>
+            </a:pPr>
+            <a:r>
+              <a:rPr sz="900" i="1">
+                <a:solidFill>
+                  <a:srgbClr val="5C3A1F"/>
+                </a:solidFill>
+                <a:latin typeface="Calibri"/>
+              </a:rPr>
+              <a:t>       ↳  Browser closes, phone reboots — itinerary still there next morning.</a:t>
+            </a:r>
+          </a:p>
+          <a:p>
+            <a:pPr algn="l">
+              <a:lnSpc>
+                <a:spcPct val="120000"/>
+              </a:lnSpc>
+              <a:spcBef>
+                <a:spcPts val="400"/>
+              </a:spcBef>
+            </a:pPr>
+            <a:r>
+              <a:rPr sz="1300" b="1">
+                <a:solidFill>
+                  <a:srgbClr val="C9A84C"/>
+                </a:solidFill>
+                <a:latin typeface="Calibri"/>
+              </a:rPr>
+              <a:t>• </a:t>
+            </a:r>
+            <a:r>
+              <a:rPr sz="1100">
+                <a:solidFill>
+                  <a:srgbClr val="1E1508"/>
+                </a:solidFill>
+                <a:latin typeface="Calibri"/>
+              </a:rPr>
               <a:t>Share link via native phone share sheet, email, text, or copy URL</a:t>
+            </a:r>
+          </a:p>
+          <a:p>
+            <a:pPr algn="l">
+              <a:lnSpc>
+                <a:spcPct val="110000"/>
+              </a:lnSpc>
+              <a:spcBef>
+                <a:spcPts val="0"/>
+              </a:spcBef>
+            </a:pPr>
+            <a:r>
+              <a:rPr sz="900" i="1">
+                <a:solidFill>
+                  <a:srgbClr val="5C3A1F"/>
+                </a:solidFill>
+                <a:latin typeface="Calibri"/>
+              </a:rPr>
+              <a:t>       ↳  Visitor texts the URL to spouse: "this is what I'm thinking."</a:t>
             </a:r>
           </a:p>
         </p:txBody>
@@ -11673,7 +12184,7 @@
         </p:nvSpPr>
         <p:spPr>
           <a:xfrm>
-            <a:off x="548640" y="1691640"/>
+            <a:off x="548640" y="1508760"/>
             <a:ext cx="11064240" cy="384048"/>
           </a:xfrm>
           <a:prstGeom prst="rect">
@@ -11717,7 +12228,7 @@
         </p:nvSpPr>
         <p:spPr>
           <a:xfrm>
-            <a:off x="640080" y="1737360"/>
+            <a:off x="640080" y="1554480"/>
             <a:ext cx="3520440" cy="292608"/>
           </a:xfrm>
           <a:prstGeom prst="rect">
@@ -11752,7 +12263,7 @@
         </p:nvSpPr>
         <p:spPr>
           <a:xfrm>
-            <a:off x="4297680" y="1737360"/>
+            <a:off x="4297680" y="1554480"/>
             <a:ext cx="7269479" cy="292608"/>
           </a:xfrm>
           <a:prstGeom prst="rect">
@@ -11787,7 +12298,7 @@
         </p:nvSpPr>
         <p:spPr>
           <a:xfrm>
-            <a:off x="548640" y="2075688"/>
+            <a:off x="548640" y="1892808"/>
             <a:ext cx="11064240" cy="25400"/>
           </a:xfrm>
           <a:prstGeom prst="rect">
@@ -11830,8 +12341,8 @@
         </p:nvSpPr>
         <p:spPr>
           <a:xfrm>
-            <a:off x="548640" y="2112264"/>
-            <a:ext cx="11064240" cy="384048"/>
+            <a:off x="548640" y="1929384"/>
+            <a:ext cx="11064240" cy="548640"/>
           </a:xfrm>
           <a:prstGeom prst="rect">
             <a:avLst/>
@@ -11874,23 +12385,23 @@
         </p:nvSpPr>
         <p:spPr>
           <a:xfrm>
-            <a:off x="640080" y="2157984"/>
-            <a:ext cx="3520440" cy="338328"/>
-          </a:xfrm>
-          <a:prstGeom prst="rect">
-            <a:avLst/>
-          </a:prstGeom>
-          <a:noFill/>
-        </p:spPr>
-        <p:txBody>
-          <a:bodyPr wrap="square" anchor="t" lIns="45720" rIns="45720" tIns="18288" bIns="18288">
+            <a:off x="640080" y="1975104"/>
+            <a:ext cx="3520440" cy="502919"/>
+          </a:xfrm>
+          <a:prstGeom prst="rect">
+            <a:avLst/>
+          </a:prstGeom>
+          <a:noFill/>
+        </p:spPr>
+        <p:txBody>
+          <a:bodyPr wrap="square" anchor="ctr" lIns="45720" rIns="45720" tIns="18288" bIns="18288">
             <a:spAutoFit/>
           </a:bodyPr>
           <a:lstStyle/>
           <a:p>
             <a:pPr algn="l"/>
             <a:r>
-              <a:rPr sz="1000" b="0" i="0">
+              <a:rPr sz="900" b="0" i="0">
                 <a:solidFill>
                   <a:srgbClr val="1E1508"/>
                 </a:solidFill>
@@ -11909,8 +12420,8 @@
         </p:nvSpPr>
         <p:spPr>
           <a:xfrm>
-            <a:off x="4297680" y="2157984"/>
-            <a:ext cx="7269479" cy="338328"/>
+            <a:off x="4297680" y="1965960"/>
+            <a:ext cx="7269479" cy="251459"/>
           </a:xfrm>
           <a:prstGeom prst="rect">
             <a:avLst/>
@@ -11925,7 +12436,7 @@
           <a:p>
             <a:pPr algn="l"/>
             <a:r>
-              <a:rPr sz="1000" b="0" i="0">
+              <a:rPr sz="900" b="0" i="0">
                 <a:solidFill>
                   <a:srgbClr val="1E1508"/>
                 </a:solidFill>
@@ -11944,8 +12455,8 @@
         </p:nvSpPr>
         <p:spPr>
           <a:xfrm>
-            <a:off x="640080" y="2542032"/>
-            <a:ext cx="3520440" cy="338328"/>
+            <a:off x="4297680" y="2217419"/>
+            <a:ext cx="7269479" cy="251459"/>
           </a:xfrm>
           <a:prstGeom prst="rect">
             <a:avLst/>
@@ -11960,7 +12471,42 @@
           <a:p>
             <a:pPr algn="l"/>
             <a:r>
-              <a:rPr sz="1000" b="0" i="0">
+              <a:rPr sz="800" b="0" i="1">
+                <a:solidFill>
+                  <a:srgbClr val="5C3A1F"/>
+                </a:solidFill>
+                <a:latin typeface="Calibri"/>
+              </a:rPr>
+              <a:t>↳  Visitor sees Day 2 has no stay tile, books before leaving the page.</a:t>
+            </a:r>
+          </a:p>
+        </p:txBody>
+      </p:sp>
+      <p:sp>
+        <p:nvSpPr>
+          <p:cNvPr id="13" name="TextBox 12"/>
+          <p:cNvSpPr txBox="1"/>
+          <p:nvPr/>
+        </p:nvSpPr>
+        <p:spPr>
+          <a:xfrm>
+            <a:off x="640080" y="2523744"/>
+            <a:ext cx="3520440" cy="502919"/>
+          </a:xfrm>
+          <a:prstGeom prst="rect">
+            <a:avLst/>
+          </a:prstGeom>
+          <a:noFill/>
+        </p:spPr>
+        <p:txBody>
+          <a:bodyPr wrap="square" anchor="ctr" lIns="45720" rIns="45720" tIns="18288" bIns="18288">
+            <a:spAutoFit/>
+          </a:bodyPr>
+          <a:lstStyle/>
+          <a:p>
+            <a:pPr algn="l"/>
+            <a:r>
+              <a:rPr sz="900" b="0" i="0">
                 <a:solidFill>
                   <a:srgbClr val="1E1508"/>
                 </a:solidFill>
@@ -11973,14 +12519,14 @@
       </p:sp>
       <p:sp>
         <p:nvSpPr>
-          <p:cNvPr id="13" name="TextBox 12"/>
-          <p:cNvSpPr txBox="1"/>
-          <p:nvPr/>
-        </p:nvSpPr>
-        <p:spPr>
-          <a:xfrm>
-            <a:off x="4297680" y="2542032"/>
-            <a:ext cx="7269479" cy="338328"/>
+          <p:cNvPr id="14" name="TextBox 13"/>
+          <p:cNvSpPr txBox="1"/>
+          <p:nvPr/>
+        </p:nvSpPr>
+        <p:spPr>
+          <a:xfrm>
+            <a:off x="4297680" y="2514600"/>
+            <a:ext cx="7269479" cy="251459"/>
           </a:xfrm>
           <a:prstGeom prst="rect">
             <a:avLst/>
@@ -11995,7 +12541,7 @@
           <a:p>
             <a:pPr algn="l"/>
             <a:r>
-              <a:rPr sz="1000" b="0" i="0">
+              <a:rPr sz="900" b="0" i="0">
                 <a:solidFill>
                   <a:srgbClr val="1E1508"/>
                 </a:solidFill>
@@ -12008,14 +12554,49 @@
       </p:sp>
       <p:sp>
         <p:nvSpPr>
-          <p:cNvPr id="14" name="Rectangle 13"/>
+          <p:cNvPr id="15" name="TextBox 14"/>
+          <p:cNvSpPr txBox="1"/>
+          <p:nvPr/>
+        </p:nvSpPr>
+        <p:spPr>
+          <a:xfrm>
+            <a:off x="4297680" y="2766059"/>
+            <a:ext cx="7269479" cy="251459"/>
+          </a:xfrm>
+          <a:prstGeom prst="rect">
+            <a:avLst/>
+          </a:prstGeom>
+          <a:noFill/>
+        </p:spPr>
+        <p:txBody>
+          <a:bodyPr wrap="square" anchor="t" lIns="45720" rIns="45720" tIns="18288" bIns="18288">
+            <a:spAutoFit/>
+          </a:bodyPr>
+          <a:lstStyle/>
+          <a:p>
+            <a:pPr algn="l"/>
+            <a:r>
+              <a:rPr sz="800" b="0" i="1">
+                <a:solidFill>
+                  <a:srgbClr val="5C3A1F"/>
+                </a:solidFill>
+                <a:latin typeface="Calibri"/>
+              </a:rPr>
+              <a:t>↳  Foodie-vibe visitor taps Find Lodging; vibes clear so all stays show.</a:t>
+            </a:r>
+          </a:p>
+        </p:txBody>
+      </p:sp>
+      <p:sp>
+        <p:nvSpPr>
+          <p:cNvPr id="16" name="Rectangle 15"/>
           <p:cNvSpPr/>
           <p:nvPr/>
         </p:nvSpPr>
         <p:spPr>
           <a:xfrm>
-            <a:off x="548640" y="2880360"/>
-            <a:ext cx="11064240" cy="384048"/>
+            <a:off x="548640" y="3026664"/>
+            <a:ext cx="11064240" cy="548640"/>
           </a:xfrm>
           <a:prstGeom prst="rect">
             <a:avLst/>
@@ -12052,29 +12633,29 @@
       </p:sp>
       <p:sp>
         <p:nvSpPr>
-          <p:cNvPr id="15" name="TextBox 14"/>
-          <p:cNvSpPr txBox="1"/>
-          <p:nvPr/>
-        </p:nvSpPr>
-        <p:spPr>
-          <a:xfrm>
-            <a:off x="640080" y="2926080"/>
-            <a:ext cx="3520440" cy="338328"/>
-          </a:xfrm>
-          <a:prstGeom prst="rect">
-            <a:avLst/>
-          </a:prstGeom>
-          <a:noFill/>
-        </p:spPr>
-        <p:txBody>
-          <a:bodyPr wrap="square" anchor="t" lIns="45720" rIns="45720" tIns="18288" bIns="18288">
+          <p:cNvPr id="17" name="TextBox 16"/>
+          <p:cNvSpPr txBox="1"/>
+          <p:nvPr/>
+        </p:nvSpPr>
+        <p:spPr>
+          <a:xfrm>
+            <a:off x="640080" y="3072384"/>
+            <a:ext cx="3520440" cy="502919"/>
+          </a:xfrm>
+          <a:prstGeom prst="rect">
+            <a:avLst/>
+          </a:prstGeom>
+          <a:noFill/>
+        </p:spPr>
+        <p:txBody>
+          <a:bodyPr wrap="square" anchor="ctr" lIns="45720" rIns="45720" tIns="18288" bIns="18288">
             <a:spAutoFit/>
           </a:bodyPr>
           <a:lstStyle/>
           <a:p>
             <a:pPr algn="l"/>
             <a:r>
-              <a:rPr sz="1000" b="0" i="0">
+              <a:rPr sz="900" b="0" i="0">
                 <a:solidFill>
                   <a:srgbClr val="1E1508"/>
                 </a:solidFill>
@@ -12087,14 +12668,14 @@
       </p:sp>
       <p:sp>
         <p:nvSpPr>
-          <p:cNvPr id="16" name="TextBox 15"/>
-          <p:cNvSpPr txBox="1"/>
-          <p:nvPr/>
-        </p:nvSpPr>
-        <p:spPr>
-          <a:xfrm>
-            <a:off x="4297680" y="2926080"/>
-            <a:ext cx="7269479" cy="338328"/>
+          <p:cNvPr id="18" name="TextBox 17"/>
+          <p:cNvSpPr txBox="1"/>
+          <p:nvPr/>
+        </p:nvSpPr>
+        <p:spPr>
+          <a:xfrm>
+            <a:off x="4297680" y="3063240"/>
+            <a:ext cx="7269479" cy="251459"/>
           </a:xfrm>
           <a:prstGeom prst="rect">
             <a:avLst/>
@@ -12109,7 +12690,7 @@
           <a:p>
             <a:pPr algn="l"/>
             <a:r>
-              <a:rPr sz="1000" b="0" i="0">
+              <a:rPr sz="900" b="0" i="0">
                 <a:solidFill>
                   <a:srgbClr val="1E1508"/>
                 </a:solidFill>
@@ -12122,14 +12703,14 @@
       </p:sp>
       <p:sp>
         <p:nvSpPr>
-          <p:cNvPr id="17" name="TextBox 16"/>
-          <p:cNvSpPr txBox="1"/>
-          <p:nvPr/>
-        </p:nvSpPr>
-        <p:spPr>
-          <a:xfrm>
-            <a:off x="640080" y="3310128"/>
-            <a:ext cx="3520440" cy="338328"/>
+          <p:cNvPr id="19" name="TextBox 18"/>
+          <p:cNvSpPr txBox="1"/>
+          <p:nvPr/>
+        </p:nvSpPr>
+        <p:spPr>
+          <a:xfrm>
+            <a:off x="4297680" y="3314699"/>
+            <a:ext cx="7269479" cy="251459"/>
           </a:xfrm>
           <a:prstGeom prst="rect">
             <a:avLst/>
@@ -12144,7 +12725,42 @@
           <a:p>
             <a:pPr algn="l"/>
             <a:r>
-              <a:rPr sz="1000" b="0" i="0">
+              <a:rPr sz="800" b="0" i="1">
+                <a:solidFill>
+                  <a:srgbClr val="5C3A1F"/>
+                </a:solidFill>
+                <a:latin typeface="Calibri"/>
+              </a:rPr>
+              <a:t>↳  Day 2 isn't an empty container — visitor lands somewhere productive.</a:t>
+            </a:r>
+          </a:p>
+        </p:txBody>
+      </p:sp>
+      <p:sp>
+        <p:nvSpPr>
+          <p:cNvPr id="20" name="TextBox 19"/>
+          <p:cNvSpPr txBox="1"/>
+          <p:nvPr/>
+        </p:nvSpPr>
+        <p:spPr>
+          <a:xfrm>
+            <a:off x="640080" y="3621024"/>
+            <a:ext cx="3520440" cy="502919"/>
+          </a:xfrm>
+          <a:prstGeom prst="rect">
+            <a:avLst/>
+          </a:prstGeom>
+          <a:noFill/>
+        </p:spPr>
+        <p:txBody>
+          <a:bodyPr wrap="square" anchor="ctr" lIns="45720" rIns="45720" tIns="18288" bIns="18288">
+            <a:spAutoFit/>
+          </a:bodyPr>
+          <a:lstStyle/>
+          <a:p>
+            <a:pPr algn="l"/>
+            <a:r>
+              <a:rPr sz="900" b="0" i="0">
                 <a:solidFill>
                   <a:srgbClr val="1E1508"/>
                 </a:solidFill>
@@ -12157,14 +12773,14 @@
       </p:sp>
       <p:sp>
         <p:nvSpPr>
-          <p:cNvPr id="18" name="TextBox 17"/>
-          <p:cNvSpPr txBox="1"/>
-          <p:nvPr/>
-        </p:nvSpPr>
-        <p:spPr>
-          <a:xfrm>
-            <a:off x="4297680" y="3310128"/>
-            <a:ext cx="7269479" cy="338328"/>
+          <p:cNvPr id="21" name="TextBox 20"/>
+          <p:cNvSpPr txBox="1"/>
+          <p:nvPr/>
+        </p:nvSpPr>
+        <p:spPr>
+          <a:xfrm>
+            <a:off x="4297680" y="3611880"/>
+            <a:ext cx="7269479" cy="251459"/>
           </a:xfrm>
           <a:prstGeom prst="rect">
             <a:avLst/>
@@ -12179,7 +12795,7 @@
           <a:p>
             <a:pPr algn="l"/>
             <a:r>
-              <a:rPr sz="1000" b="0" i="0">
+              <a:rPr sz="900" b="0" i="0">
                 <a:solidFill>
                   <a:srgbClr val="1E1508"/>
                 </a:solidFill>
@@ -12192,14 +12808,49 @@
       </p:sp>
       <p:sp>
         <p:nvSpPr>
-          <p:cNvPr id="19" name="Rectangle 18"/>
+          <p:cNvPr id="22" name="TextBox 21"/>
+          <p:cNvSpPr txBox="1"/>
+          <p:nvPr/>
+        </p:nvSpPr>
+        <p:spPr>
+          <a:xfrm>
+            <a:off x="4297680" y="3863339"/>
+            <a:ext cx="7269479" cy="251459"/>
+          </a:xfrm>
+          <a:prstGeom prst="rect">
+            <a:avLst/>
+          </a:prstGeom>
+          <a:noFill/>
+        </p:spPr>
+        <p:txBody>
+          <a:bodyPr wrap="square" anchor="t" lIns="45720" rIns="45720" tIns="18288" bIns="18288">
+            <a:spAutoFit/>
+          </a:bodyPr>
+          <a:lstStyle/>
+          <a:p>
+            <a:pPr algn="l"/>
+            <a:r>
+              <a:rPr sz="800" b="0" i="1">
+                <a:solidFill>
+                  <a:srgbClr val="5C3A1F"/>
+                </a:solidFill>
+                <a:latin typeface="Calibri"/>
+              </a:rPr>
+              <a:t>↳  Three concerts compared side-by-side before committing to one.</a:t>
+            </a:r>
+          </a:p>
+        </p:txBody>
+      </p:sp>
+      <p:sp>
+        <p:nvSpPr>
+          <p:cNvPr id="23" name="Rectangle 22"/>
           <p:cNvSpPr/>
           <p:nvPr/>
         </p:nvSpPr>
         <p:spPr>
           <a:xfrm>
-            <a:off x="548640" y="3648456"/>
-            <a:ext cx="11064240" cy="384048"/>
+            <a:off x="548640" y="4123944"/>
+            <a:ext cx="11064240" cy="548640"/>
           </a:xfrm>
           <a:prstGeom prst="rect">
             <a:avLst/>
@@ -12236,49 +12887,49 @@
       </p:sp>
       <p:sp>
         <p:nvSpPr>
-          <p:cNvPr id="20" name="TextBox 19"/>
-          <p:cNvSpPr txBox="1"/>
-          <p:nvPr/>
-        </p:nvSpPr>
-        <p:spPr>
-          <a:xfrm>
-            <a:off x="640080" y="3694176"/>
-            <a:ext cx="3520440" cy="338328"/>
-          </a:xfrm>
-          <a:prstGeom prst="rect">
-            <a:avLst/>
-          </a:prstGeom>
-          <a:noFill/>
-        </p:spPr>
-        <p:txBody>
-          <a:bodyPr wrap="square" anchor="t" lIns="45720" rIns="45720" tIns="18288" bIns="18288">
+          <p:cNvPr id="24" name="TextBox 23"/>
+          <p:cNvSpPr txBox="1"/>
+          <p:nvPr/>
+        </p:nvSpPr>
+        <p:spPr>
+          <a:xfrm>
+            <a:off x="640080" y="4169664"/>
+            <a:ext cx="3520440" cy="502919"/>
+          </a:xfrm>
+          <a:prstGeom prst="rect">
+            <a:avLst/>
+          </a:prstGeom>
+          <a:noFill/>
+        </p:spPr>
+        <p:txBody>
+          <a:bodyPr wrap="square" anchor="ctr" lIns="45720" rIns="45720" tIns="18288" bIns="18288">
             <a:spAutoFit/>
           </a:bodyPr>
           <a:lstStyle/>
           <a:p>
             <a:pPr algn="l"/>
             <a:r>
-              <a:rPr sz="1000" b="0" i="0">
+              <a:rPr sz="900" b="0" i="0">
                 <a:solidFill>
                   <a:srgbClr val="1E1508"/>
                 </a:solidFill>
                 <a:latin typeface="Calibri"/>
               </a:rPr>
-              <a:t>Direct × on cards</a:t>
-            </a:r>
-          </a:p>
-        </p:txBody>
-      </p:sp>
-      <p:sp>
-        <p:nvSpPr>
-          <p:cNvPr id="21" name="TextBox 20"/>
-          <p:cNvSpPr txBox="1"/>
-          <p:nvPr/>
-        </p:nvSpPr>
-        <p:spPr>
-          <a:xfrm>
-            <a:off x="4297680" y="3694176"/>
-            <a:ext cx="7269479" cy="338328"/>
+              <a:t>Vibe sub-pills</a:t>
+            </a:r>
+          </a:p>
+        </p:txBody>
+      </p:sp>
+      <p:sp>
+        <p:nvSpPr>
+          <p:cNvPr id="25" name="TextBox 24"/>
+          <p:cNvSpPr txBox="1"/>
+          <p:nvPr/>
+        </p:nvSpPr>
+        <p:spPr>
+          <a:xfrm>
+            <a:off x="4297680" y="4160520"/>
+            <a:ext cx="7269479" cy="251459"/>
           </a:xfrm>
           <a:prstGeom prst="rect">
             <a:avLst/>
@@ -12293,27 +12944,27 @@
           <a:p>
             <a:pPr algn="l"/>
             <a:r>
-              <a:rPr sz="1000" b="0" i="0">
+              <a:rPr sz="900" b="0" i="0">
                 <a:solidFill>
                   <a:srgbClr val="1E1508"/>
                 </a:solidFill>
                 <a:latin typeface="Calibri"/>
               </a:rPr>
-              <a:t>No "Manage Mode" toggle; remove buttons always visible</a:t>
-            </a:r>
-          </a:p>
-        </p:txBody>
-      </p:sp>
-      <p:sp>
-        <p:nvSpPr>
-          <p:cNvPr id="22" name="TextBox 21"/>
-          <p:cNvSpPr txBox="1"/>
-          <p:nvPr/>
-        </p:nvSpPr>
-        <p:spPr>
-          <a:xfrm>
-            <a:off x="640080" y="4078224"/>
-            <a:ext cx="3520440" cy="338328"/>
+              <a:t>Foodie → Restaurants/Markets/Wineries — granular without leaving the vibe</a:t>
+            </a:r>
+          </a:p>
+        </p:txBody>
+      </p:sp>
+      <p:sp>
+        <p:nvSpPr>
+          <p:cNvPr id="26" name="TextBox 25"/>
+          <p:cNvSpPr txBox="1"/>
+          <p:nvPr/>
+        </p:nvSpPr>
+        <p:spPr>
+          <a:xfrm>
+            <a:off x="4297680" y="4411979"/>
+            <a:ext cx="7269479" cy="251459"/>
           </a:xfrm>
           <a:prstGeom prst="rect">
             <a:avLst/>
@@ -12328,27 +12979,62 @@
           <a:p>
             <a:pPr algn="l"/>
             <a:r>
-              <a:rPr sz="1000" b="0" i="0">
+              <a:rPr sz="800" b="0" i="1">
+                <a:solidFill>
+                  <a:srgbClr val="5C3A1F"/>
+                </a:solidFill>
+                <a:latin typeface="Calibri"/>
+              </a:rPr>
+              <a:t>↳  Foodie → Wineries narrows without switching mental contexts.</a:t>
+            </a:r>
+          </a:p>
+        </p:txBody>
+      </p:sp>
+      <p:sp>
+        <p:nvSpPr>
+          <p:cNvPr id="27" name="TextBox 26"/>
+          <p:cNvSpPr txBox="1"/>
+          <p:nvPr/>
+        </p:nvSpPr>
+        <p:spPr>
+          <a:xfrm>
+            <a:off x="640080" y="4718304"/>
+            <a:ext cx="3520440" cy="502919"/>
+          </a:xfrm>
+          <a:prstGeom prst="rect">
+            <a:avLst/>
+          </a:prstGeom>
+          <a:noFill/>
+        </p:spPr>
+        <p:txBody>
+          <a:bodyPr wrap="square" anchor="ctr" lIns="45720" rIns="45720" tIns="18288" bIns="18288">
+            <a:spAutoFit/>
+          </a:bodyPr>
+          <a:lstStyle/>
+          <a:p>
+            <a:pPr algn="l"/>
+            <a:r>
+              <a:rPr sz="900" b="0" i="0">
                 <a:solidFill>
                   <a:srgbClr val="1E1508"/>
                 </a:solidFill>
                 <a:latin typeface="Calibri"/>
               </a:rPr>
-              <a:t>Vibe sub-pills</a:t>
-            </a:r>
-          </a:p>
-        </p:txBody>
-      </p:sp>
-      <p:sp>
-        <p:nvSpPr>
-          <p:cNvPr id="23" name="TextBox 22"/>
-          <p:cNvSpPr txBox="1"/>
-          <p:nvPr/>
-        </p:nvSpPr>
-        <p:spPr>
-          <a:xfrm>
-            <a:off x="4297680" y="4078224"/>
-            <a:ext cx="7269479" cy="338328"/>
+              <a:t>Calendar dates on day headers</a:t>
+            </a:r>
+          </a:p>
+        </p:txBody>
+      </p:sp>
+      <p:sp>
+        <p:nvSpPr>
+          <p:cNvPr id="28" name="TextBox 27"/>
+          <p:cNvSpPr txBox="1"/>
+          <p:nvPr/>
+        </p:nvSpPr>
+        <p:spPr>
+          <a:xfrm>
+            <a:off x="4297680" y="4709160"/>
+            <a:ext cx="7269479" cy="251459"/>
           </a:xfrm>
           <a:prstGeom prst="rect">
             <a:avLst/>
@@ -12363,27 +13049,62 @@
           <a:p>
             <a:pPr algn="l"/>
             <a:r>
-              <a:rPr sz="1000" b="0" i="0">
+              <a:rPr sz="900" b="0" i="0">
                 <a:solidFill>
                   <a:srgbClr val="1E1508"/>
                 </a:solidFill>
                 <a:latin typeface="Calibri"/>
               </a:rPr>
-              <a:t>Foodie → Restaurants/Markets/Wineries — granular without leaving the vibe</a:t>
-            </a:r>
-          </a:p>
-        </p:txBody>
-      </p:sp>
-      <p:sp>
-        <p:nvSpPr>
-          <p:cNvPr id="24" name="Rectangle 23"/>
+              <a:t>"DAY 1 · Sat, May 17" instead of abstract numbers</a:t>
+            </a:r>
+          </a:p>
+        </p:txBody>
+      </p:sp>
+      <p:sp>
+        <p:nvSpPr>
+          <p:cNvPr id="29" name="TextBox 28"/>
+          <p:cNvSpPr txBox="1"/>
+          <p:nvPr/>
+        </p:nvSpPr>
+        <p:spPr>
+          <a:xfrm>
+            <a:off x="4297680" y="4960619"/>
+            <a:ext cx="7269479" cy="251459"/>
+          </a:xfrm>
+          <a:prstGeom prst="rect">
+            <a:avLst/>
+          </a:prstGeom>
+          <a:noFill/>
+        </p:spPr>
+        <p:txBody>
+          <a:bodyPr wrap="square" anchor="t" lIns="45720" rIns="45720" tIns="18288" bIns="18288">
+            <a:spAutoFit/>
+          </a:bodyPr>
+          <a:lstStyle/>
+          <a:p>
+            <a:pPr algn="l"/>
+            <a:r>
+              <a:rPr sz="800" b="0" i="1">
+                <a:solidFill>
+                  <a:srgbClr val="5C3A1F"/>
+                </a:solidFill>
+                <a:latin typeface="Calibri"/>
+              </a:rPr>
+              <a:t>↳  "Sat, May 17" grounds the trip in real-world weekend planning.</a:t>
+            </a:r>
+          </a:p>
+        </p:txBody>
+      </p:sp>
+      <p:sp>
+        <p:nvSpPr>
+          <p:cNvPr id="30" name="Rectangle 29"/>
           <p:cNvSpPr/>
           <p:nvPr/>
         </p:nvSpPr>
         <p:spPr>
           <a:xfrm>
-            <a:off x="548640" y="4416552"/>
-            <a:ext cx="11064240" cy="384048"/>
+            <a:off x="548640" y="5221224"/>
+            <a:ext cx="11064240" cy="548640"/>
           </a:xfrm>
           <a:prstGeom prst="rect">
             <a:avLst/>
@@ -12420,49 +13141,49 @@
       </p:sp>
       <p:sp>
         <p:nvSpPr>
-          <p:cNvPr id="25" name="TextBox 24"/>
-          <p:cNvSpPr txBox="1"/>
-          <p:nvPr/>
-        </p:nvSpPr>
-        <p:spPr>
-          <a:xfrm>
-            <a:off x="640080" y="4462272"/>
-            <a:ext cx="3520440" cy="338328"/>
-          </a:xfrm>
-          <a:prstGeom prst="rect">
-            <a:avLst/>
-          </a:prstGeom>
-          <a:noFill/>
-        </p:spPr>
-        <p:txBody>
-          <a:bodyPr wrap="square" anchor="t" lIns="45720" rIns="45720" tIns="18288" bIns="18288">
+          <p:cNvPr id="31" name="TextBox 30"/>
+          <p:cNvSpPr txBox="1"/>
+          <p:nvPr/>
+        </p:nvSpPr>
+        <p:spPr>
+          <a:xfrm>
+            <a:off x="640080" y="5266944"/>
+            <a:ext cx="3520440" cy="502919"/>
+          </a:xfrm>
+          <a:prstGeom prst="rect">
+            <a:avLst/>
+          </a:prstGeom>
+          <a:noFill/>
+        </p:spPr>
+        <p:txBody>
+          <a:bodyPr wrap="square" anchor="ctr" lIns="45720" rIns="45720" tIns="18288" bIns="18288">
             <a:spAutoFit/>
           </a:bodyPr>
           <a:lstStyle/>
           <a:p>
             <a:pPr algn="l"/>
             <a:r>
-              <a:rPr sz="1000" b="0" i="0">
+              <a:rPr sz="900" b="0" i="0">
                 <a:solidFill>
                   <a:srgbClr val="1E1508"/>
                 </a:solidFill>
                 <a:latin typeface="Calibri"/>
               </a:rPr>
-              <a:t>Calendar dates on day headers</a:t>
-            </a:r>
-          </a:p>
-        </p:txBody>
-      </p:sp>
-      <p:sp>
-        <p:nvSpPr>
-          <p:cNvPr id="26" name="TextBox 25"/>
-          <p:cNvSpPr txBox="1"/>
-          <p:nvPr/>
-        </p:nvSpPr>
-        <p:spPr>
-          <a:xfrm>
-            <a:off x="4297680" y="4462272"/>
-            <a:ext cx="7269479" cy="338328"/>
+              <a:t>Opt-in itinerary save</a:t>
+            </a:r>
+          </a:p>
+        </p:txBody>
+      </p:sp>
+      <p:sp>
+        <p:nvSpPr>
+          <p:cNvPr id="32" name="TextBox 31"/>
+          <p:cNvSpPr txBox="1"/>
+          <p:nvPr/>
+        </p:nvSpPr>
+        <p:spPr>
+          <a:xfrm>
+            <a:off x="4297680" y="5257800"/>
+            <a:ext cx="7269479" cy="251459"/>
           </a:xfrm>
           <a:prstGeom prst="rect">
             <a:avLst/>
@@ -12477,27 +13198,27 @@
           <a:p>
             <a:pPr algn="l"/>
             <a:r>
-              <a:rPr sz="1000" b="0" i="0">
+              <a:rPr sz="900" b="0" i="0">
                 <a:solidFill>
                   <a:srgbClr val="1E1508"/>
                 </a:solidFill>
                 <a:latin typeface="Calibri"/>
               </a:rPr>
-              <a:t>"DAY 1 · Sat, May 17" instead of abstract numbers</a:t>
-            </a:r>
-          </a:p>
-        </p:txBody>
-      </p:sp>
-      <p:sp>
-        <p:nvSpPr>
-          <p:cNvPr id="27" name="TextBox 26"/>
-          <p:cNvSpPr txBox="1"/>
-          <p:nvPr/>
-        </p:nvSpPr>
-        <p:spPr>
-          <a:xfrm>
-            <a:off x="640080" y="4846320"/>
-            <a:ext cx="3520440" cy="338328"/>
+              <a:t>Survives tab close + restart — no account, no email, explicit consent</a:t>
+            </a:r>
+          </a:p>
+        </p:txBody>
+      </p:sp>
+      <p:sp>
+        <p:nvSpPr>
+          <p:cNvPr id="33" name="TextBox 32"/>
+          <p:cNvSpPr txBox="1"/>
+          <p:nvPr/>
+        </p:nvSpPr>
+        <p:spPr>
+          <a:xfrm>
+            <a:off x="4297680" y="5509259"/>
+            <a:ext cx="7269479" cy="251459"/>
           </a:xfrm>
           <a:prstGeom prst="rect">
             <a:avLst/>
@@ -12512,27 +13233,62 @@
           <a:p>
             <a:pPr algn="l"/>
             <a:r>
-              <a:rPr sz="1000" b="0" i="0">
+              <a:rPr sz="800" b="0" i="1">
+                <a:solidFill>
+                  <a:srgbClr val="5C3A1F"/>
+                </a:solidFill>
+                <a:latin typeface="Calibri"/>
+              </a:rPr>
+              <a:t>↳  Banner appears only after first add — visitor consents knowingly.</a:t>
+            </a:r>
+          </a:p>
+        </p:txBody>
+      </p:sp>
+      <p:sp>
+        <p:nvSpPr>
+          <p:cNvPr id="34" name="TextBox 33"/>
+          <p:cNvSpPr txBox="1"/>
+          <p:nvPr/>
+        </p:nvSpPr>
+        <p:spPr>
+          <a:xfrm>
+            <a:off x="640080" y="5815584"/>
+            <a:ext cx="3520440" cy="502919"/>
+          </a:xfrm>
+          <a:prstGeom prst="rect">
+            <a:avLst/>
+          </a:prstGeom>
+          <a:noFill/>
+        </p:spPr>
+        <p:txBody>
+          <a:bodyPr wrap="square" anchor="ctr" lIns="45720" rIns="45720" tIns="18288" bIns="18288">
+            <a:spAutoFit/>
+          </a:bodyPr>
+          <a:lstStyle/>
+          <a:p>
+            <a:pPr algn="l"/>
+            <a:r>
+              <a:rPr sz="900" b="0" i="0">
                 <a:solidFill>
                   <a:srgbClr val="1E1508"/>
                 </a:solidFill>
                 <a:latin typeface="Calibri"/>
               </a:rPr>
-              <a:t>Opt-in itinerary save</a:t>
-            </a:r>
-          </a:p>
-        </p:txBody>
-      </p:sp>
-      <p:sp>
-        <p:nvSpPr>
-          <p:cNvPr id="28" name="TextBox 27"/>
-          <p:cNvSpPr txBox="1"/>
-          <p:nvPr/>
-        </p:nvSpPr>
-        <p:spPr>
-          <a:xfrm>
-            <a:off x="4297680" y="4846320"/>
-            <a:ext cx="7269479" cy="338328"/>
+              <a:t>Auto-season filtering</a:t>
+            </a:r>
+          </a:p>
+        </p:txBody>
+      </p:sp>
+      <p:sp>
+        <p:nvSpPr>
+          <p:cNvPr id="35" name="TextBox 34"/>
+          <p:cNvSpPr txBox="1"/>
+          <p:nvPr/>
+        </p:nvSpPr>
+        <p:spPr>
+          <a:xfrm>
+            <a:off x="4297680" y="5806440"/>
+            <a:ext cx="7269479" cy="251459"/>
           </a:xfrm>
           <a:prstGeom prst="rect">
             <a:avLst/>
@@ -12547,71 +13303,27 @@
           <a:p>
             <a:pPr algn="l"/>
             <a:r>
-              <a:rPr sz="1000" b="0" i="0">
+              <a:rPr sz="900" b="0" i="0">
                 <a:solidFill>
                   <a:srgbClr val="1E1508"/>
                 </a:solidFill>
                 <a:latin typeface="Calibri"/>
               </a:rPr>
-              <a:t>Survives tab close + restart — no account, no email, explicit consent</a:t>
-            </a:r>
-          </a:p>
-        </p:txBody>
-      </p:sp>
-      <p:sp>
-        <p:nvSpPr>
-          <p:cNvPr id="29" name="Rectangle 28"/>
-          <p:cNvSpPr/>
-          <p:nvPr/>
-        </p:nvSpPr>
-        <p:spPr>
-          <a:xfrm>
-            <a:off x="548640" y="5184648"/>
-            <a:ext cx="11064240" cy="384048"/>
-          </a:xfrm>
-          <a:prstGeom prst="rect">
-            <a:avLst/>
-          </a:prstGeom>
-          <a:solidFill>
-            <a:srgbClr val="FBF7EE"/>
-          </a:solidFill>
-          <a:ln>
-            <a:noFill/>
-          </a:ln>
-          <a:effectLst/>
-        </p:spPr>
-        <p:style>
-          <a:lnRef idx="1">
-            <a:schemeClr val="accent1"/>
-          </a:lnRef>
-          <a:fillRef idx="3">
-            <a:schemeClr val="accent1"/>
-          </a:fillRef>
-          <a:effectRef idx="2">
-            <a:schemeClr val="accent1"/>
-          </a:effectRef>
-          <a:fontRef idx="minor">
-            <a:schemeClr val="lt1"/>
-          </a:fontRef>
-        </p:style>
-        <p:txBody>
-          <a:bodyPr rtlCol="0" anchor="ctr"/>
-          <a:lstStyle/>
-          <a:p>
-            <a:pPr algn="ctr"/>
-          </a:p>
-        </p:txBody>
-      </p:sp>
-      <p:sp>
-        <p:nvSpPr>
-          <p:cNvPr id="30" name="TextBox 29"/>
-          <p:cNvSpPr txBox="1"/>
-          <p:nvPr/>
-        </p:nvSpPr>
-        <p:spPr>
-          <a:xfrm>
-            <a:off x="640080" y="5230368"/>
-            <a:ext cx="3520440" cy="338328"/>
+              <a:t>November visit hides summer-only experiences automatically</a:t>
+            </a:r>
+          </a:p>
+        </p:txBody>
+      </p:sp>
+      <p:sp>
+        <p:nvSpPr>
+          <p:cNvPr id="36" name="TextBox 35"/>
+          <p:cNvSpPr txBox="1"/>
+          <p:nvPr/>
+        </p:nvSpPr>
+        <p:spPr>
+          <a:xfrm>
+            <a:off x="4297680" y="6057899"/>
+            <a:ext cx="7269479" cy="251459"/>
           </a:xfrm>
           <a:prstGeom prst="rect">
             <a:avLst/>
@@ -12626,125 +13338,20 @@
           <a:p>
             <a:pPr algn="l"/>
             <a:r>
-              <a:rPr sz="1000" b="0" i="0">
-                <a:solidFill>
-                  <a:srgbClr val="1E1508"/>
-                </a:solidFill>
-                <a:latin typeface="Calibri"/>
-              </a:rPr>
-              <a:t>Auto-season filtering</a:t>
-            </a:r>
-          </a:p>
-        </p:txBody>
-      </p:sp>
-      <p:sp>
-        <p:nvSpPr>
-          <p:cNvPr id="31" name="TextBox 30"/>
-          <p:cNvSpPr txBox="1"/>
-          <p:nvPr/>
-        </p:nvSpPr>
-        <p:spPr>
-          <a:xfrm>
-            <a:off x="4297680" y="5230368"/>
-            <a:ext cx="7269479" cy="338328"/>
-          </a:xfrm>
-          <a:prstGeom prst="rect">
-            <a:avLst/>
-          </a:prstGeom>
-          <a:noFill/>
-        </p:spPr>
-        <p:txBody>
-          <a:bodyPr wrap="square" anchor="t" lIns="45720" rIns="45720" tIns="18288" bIns="18288">
-            <a:spAutoFit/>
-          </a:bodyPr>
-          <a:lstStyle/>
-          <a:p>
-            <a:pPr algn="l"/>
-            <a:r>
-              <a:rPr sz="1000" b="0" i="0">
-                <a:solidFill>
-                  <a:srgbClr val="1E1508"/>
-                </a:solidFill>
-                <a:latin typeface="Calibri"/>
-              </a:rPr>
-              <a:t>November visit hides summer-only experiences automatically</a:t>
-            </a:r>
-          </a:p>
-        </p:txBody>
-      </p:sp>
-      <p:sp>
-        <p:nvSpPr>
-          <p:cNvPr id="32" name="TextBox 31"/>
-          <p:cNvSpPr txBox="1"/>
-          <p:nvPr/>
-        </p:nvSpPr>
-        <p:spPr>
-          <a:xfrm>
-            <a:off x="640080" y="5614416"/>
-            <a:ext cx="3520440" cy="338328"/>
-          </a:xfrm>
-          <a:prstGeom prst="rect">
-            <a:avLst/>
-          </a:prstGeom>
-          <a:noFill/>
-        </p:spPr>
-        <p:txBody>
-          <a:bodyPr wrap="square" anchor="t" lIns="45720" rIns="45720" tIns="18288" bIns="18288">
-            <a:spAutoFit/>
-          </a:bodyPr>
-          <a:lstStyle/>
-          <a:p>
-            <a:pPr algn="l"/>
-            <a:r>
-              <a:rPr sz="1000" b="0" i="0">
-                <a:solidFill>
-                  <a:srgbClr val="1E1508"/>
-                </a:solidFill>
-                <a:latin typeface="Calibri"/>
-              </a:rPr>
-              <a:t>Type-emoji event placeholders</a:t>
-            </a:r>
-          </a:p>
-        </p:txBody>
-      </p:sp>
-      <p:sp>
-        <p:nvSpPr>
-          <p:cNvPr id="33" name="TextBox 32"/>
-          <p:cNvSpPr txBox="1"/>
-          <p:nvPr/>
-        </p:nvSpPr>
-        <p:spPr>
-          <a:xfrm>
-            <a:off x="4297680" y="5614416"/>
-            <a:ext cx="7269479" cy="338328"/>
-          </a:xfrm>
-          <a:prstGeom prst="rect">
-            <a:avLst/>
-          </a:prstGeom>
-          <a:noFill/>
-        </p:spPr>
-        <p:txBody>
-          <a:bodyPr wrap="square" anchor="t" lIns="45720" rIns="45720" tIns="18288" bIns="18288">
-            <a:spAutoFit/>
-          </a:bodyPr>
-          <a:lstStyle/>
-          <a:p>
-            <a:pPr algn="l"/>
-            <a:r>
-              <a:rPr sz="1000" b="0" i="0">
-                <a:solidFill>
-                  <a:srgbClr val="1E1508"/>
-                </a:solidFill>
-                <a:latin typeface="Calibri"/>
-              </a:rPr>
-              <a:t>126 events without posters now visually distinct by type</a:t>
-            </a:r>
-          </a:p>
-        </p:txBody>
-      </p:sp>
-      <p:sp>
-        <p:nvSpPr>
-          <p:cNvPr id="34" name="TextBox 33"/>
+              <a:rPr sz="800" b="0" i="1">
+                <a:solidFill>
+                  <a:srgbClr val="5C3A1F"/>
+                </a:solidFill>
+                <a:latin typeface="Calibri"/>
+              </a:rPr>
+              <a:t>↳  December visitor never sees "summer concert series" as a dead lead.</a:t>
+            </a:r>
+          </a:p>
+        </p:txBody>
+      </p:sp>
+      <p:sp>
+        <p:nvSpPr>
+          <p:cNvPr id="37" name="TextBox 36"/>
           <p:cNvSpPr txBox="1"/>
           <p:nvPr/>
         </p:nvSpPr>
@@ -12779,7 +13386,7 @@
       </p:sp>
       <p:sp>
         <p:nvSpPr>
-          <p:cNvPr id="35" name="TextBox 34"/>
+          <p:cNvPr id="38" name="TextBox 37"/>
           <p:cNvSpPr txBox="1"/>
           <p:nvPr/>
         </p:nvSpPr>
@@ -12814,7 +13421,7 @@
       </p:sp>
       <p:sp>
         <p:nvSpPr>
-          <p:cNvPr id="36" name="Rectangle 35"/>
+          <p:cNvPr id="39" name="Rectangle 38"/>
           <p:cNvSpPr/>
           <p:nvPr/>
         </p:nvSpPr>
@@ -12994,7 +13601,7 @@
         </p:nvSpPr>
         <p:spPr>
           <a:xfrm>
-            <a:off x="548640" y="1691640"/>
+            <a:off x="548640" y="1554480"/>
             <a:ext cx="11064240" cy="4114800"/>
           </a:xfrm>
           <a:prstGeom prst="rect">
@@ -13010,11 +13617,11 @@
           <a:p>
             <a:pPr algn="l">
               <a:lnSpc>
-                <a:spcPct val="150000"/>
+                <a:spcPct val="120000"/>
               </a:lnSpc>
             </a:pPr>
             <a:r>
-              <a:rPr sz="1500" b="1">
+              <a:rPr sz="1300" b="1">
                 <a:solidFill>
                   <a:srgbClr val="C9A84C"/>
                 </a:solidFill>
@@ -13023,7 +13630,7 @@
               <a:t>• </a:t>
             </a:r>
             <a:r>
-              <a:rPr sz="1300">
+              <a:rPr sz="1100">
                 <a:solidFill>
                   <a:srgbClr val="1E1508"/>
                 </a:solidFill>
@@ -13035,42 +13642,33 @@
           <a:p>
             <a:pPr algn="l">
               <a:lnSpc>
-                <a:spcPct val="150000"/>
+                <a:spcPct val="110000"/>
               </a:lnSpc>
               <a:spcBef>
-                <a:spcPts val="600"/>
+                <a:spcPts val="0"/>
               </a:spcBef>
             </a:pPr>
             <a:r>
-              <a:rPr sz="1500" b="1">
-                <a:solidFill>
-                  <a:srgbClr val="C9A84C"/>
-                </a:solidFill>
-                <a:latin typeface="Calibri"/>
-              </a:rPr>
-              <a:t>• </a:t>
-            </a:r>
-            <a:r>
-              <a:rPr sz="1300">
-                <a:solidFill>
-                  <a:srgbClr val="1E1508"/>
-                </a:solidFill>
-                <a:latin typeface="Calibri"/>
-              </a:rPr>
-              <a:t>Itinerary save is opt-in only — explicit consent banner on first add</a:t>
+              <a:rPr sz="900" i="1">
+                <a:solidFill>
+                  <a:srgbClr val="5C3A1F"/>
+                </a:solidFill>
+                <a:latin typeface="Calibri"/>
+              </a:rPr>
+              <a:t>       ↳  Site loads instantly — no cookie modal between visitor and content.</a:t>
             </a:r>
           </a:p>
           <a:p>
             <a:pPr algn="l">
               <a:lnSpc>
-                <a:spcPct val="150000"/>
+                <a:spcPct val="120000"/>
               </a:lnSpc>
               <a:spcBef>
-                <a:spcPts val="600"/>
+                <a:spcPts val="400"/>
               </a:spcBef>
             </a:pPr>
             <a:r>
-              <a:rPr sz="1500" b="1">
+              <a:rPr sz="1300" b="1">
                 <a:solidFill>
                   <a:srgbClr val="C9A84C"/>
                 </a:solidFill>
@@ -13079,54 +13677,45 @@
               <a:t>• </a:t>
             </a:r>
             <a:r>
-              <a:rPr sz="1300">
+              <a:rPr sz="1100">
                 <a:solidFill>
                   <a:srgbClr val="1E1508"/>
                 </a:solidFill>
                 <a:latin typeface="Calibri"/>
               </a:rPr>
-              <a:t>"Forget on this device" link revokes consent and wipes saved data anytime</a:t>
+              <a:t>Itinerary save is opt-in only — explicit consent banner on first add</a:t>
             </a:r>
           </a:p>
           <a:p>
             <a:pPr algn="l">
               <a:lnSpc>
-                <a:spcPct val="150000"/>
+                <a:spcPct val="110000"/>
               </a:lnSpc>
               <a:spcBef>
-                <a:spcPts val="600"/>
+                <a:spcPts val="0"/>
               </a:spcBef>
             </a:pPr>
             <a:r>
-              <a:rPr sz="1500" b="1">
-                <a:solidFill>
-                  <a:srgbClr val="C9A84C"/>
-                </a:solidFill>
-                <a:latin typeface="Calibri"/>
-              </a:rPr>
-              <a:t>• </a:t>
-            </a:r>
-            <a:r>
-              <a:rPr sz="1300">
-                <a:solidFill>
-                  <a:srgbClr val="1E1508"/>
-                </a:solidFill>
-                <a:latin typeface="Calibri"/>
-              </a:rPr>
-              <a:t>Share-link URL works without any consent — purely a URL fragment</a:t>
+              <a:rPr sz="900" i="1">
+                <a:solidFill>
+                  <a:srgbClr val="5C3A1F"/>
+                </a:solidFill>
+                <a:latin typeface="Calibri"/>
+              </a:rPr>
+              <a:t>       ↳  Banner appears only after first card added; visitor knows what they're consenting to.</a:t>
             </a:r>
           </a:p>
           <a:p>
             <a:pPr algn="l">
               <a:lnSpc>
-                <a:spcPct val="150000"/>
+                <a:spcPct val="120000"/>
               </a:lnSpc>
               <a:spcBef>
-                <a:spcPts val="600"/>
+                <a:spcPts val="400"/>
               </a:spcBef>
             </a:pPr>
             <a:r>
-              <a:rPr sz="1500" b="1">
+              <a:rPr sz="1300" b="1">
                 <a:solidFill>
                   <a:srgbClr val="C9A84C"/>
                 </a:solidFill>
@@ -13135,54 +13724,45 @@
               <a:t>• </a:t>
             </a:r>
             <a:r>
-              <a:rPr sz="1300">
+              <a:rPr sz="1100">
                 <a:solidFill>
                   <a:srgbClr val="1E1508"/>
                 </a:solidFill>
                 <a:latin typeface="Calibri"/>
               </a:rPr>
-              <a:t>No account / sign-up / email required to plan a full trip</a:t>
+              <a:t>"Forget on this device" link revokes consent and wipes saved data anytime</a:t>
             </a:r>
           </a:p>
           <a:p>
             <a:pPr algn="l">
               <a:lnSpc>
-                <a:spcPct val="150000"/>
+                <a:spcPct val="110000"/>
               </a:lnSpc>
               <a:spcBef>
-                <a:spcPts val="600"/>
+                <a:spcPts val="0"/>
               </a:spcBef>
             </a:pPr>
             <a:r>
-              <a:rPr sz="1500" b="1">
-                <a:solidFill>
-                  <a:srgbClr val="C9A84C"/>
-                </a:solidFill>
-                <a:latin typeface="Calibri"/>
-              </a:rPr>
-              <a:t>• </a:t>
-            </a:r>
-            <a:r>
-              <a:rPr sz="1300">
-                <a:solidFill>
-                  <a:srgbClr val="1E1508"/>
-                </a:solidFill>
-                <a:latin typeface="Calibri"/>
-              </a:rPr>
-              <a:t>Chamber sees zero personal information about visitors</a:t>
+              <a:rPr sz="900" i="1">
+                <a:solidFill>
+                  <a:srgbClr val="5C3A1F"/>
+                </a:solidFill>
+                <a:latin typeface="Calibri"/>
+              </a:rPr>
+              <a:t>       ↳  Trip ends — visitor wipes the itinerary in two taps, takes nothing back home.</a:t>
             </a:r>
           </a:p>
           <a:p>
             <a:pPr algn="l">
               <a:lnSpc>
-                <a:spcPct val="150000"/>
+                <a:spcPct val="120000"/>
               </a:lnSpc>
               <a:spcBef>
-                <a:spcPts val="600"/>
+                <a:spcPts val="400"/>
               </a:spcBef>
             </a:pPr>
             <a:r>
-              <a:rPr sz="1500" b="1">
+              <a:rPr sz="1300" b="1">
                 <a:solidFill>
                   <a:srgbClr val="C9A84C"/>
                 </a:solidFill>
@@ -13191,26 +13771,45 @@
               <a:t>• </a:t>
             </a:r>
             <a:r>
-              <a:rPr sz="1300">
+              <a:rPr sz="1100">
                 <a:solidFill>
                   <a:srgbClr val="1E1508"/>
                 </a:solidFill>
                 <a:latin typeface="Calibri"/>
               </a:rPr>
-              <a:t>No GDPR / CCPA banners required (because nothing is collected)</a:t>
+              <a:t>Share-link URL works without any consent — purely a URL fragment</a:t>
             </a:r>
           </a:p>
           <a:p>
             <a:pPr algn="l">
               <a:lnSpc>
-                <a:spcPct val="150000"/>
+                <a:spcPct val="110000"/>
               </a:lnSpc>
               <a:spcBef>
-                <a:spcPts val="600"/>
+                <a:spcPts val="0"/>
               </a:spcBef>
             </a:pPr>
             <a:r>
-              <a:rPr sz="1500" b="1">
+              <a:rPr sz="900" i="1">
+                <a:solidFill>
+                  <a:srgbClr val="5C3A1F"/>
+                </a:solidFill>
+                <a:latin typeface="Calibri"/>
+              </a:rPr>
+              <a:t>       ↳  Two friends compare itineraries via shared URLs, neither registered for anything.</a:t>
+            </a:r>
+          </a:p>
+          <a:p>
+            <a:pPr algn="l">
+              <a:lnSpc>
+                <a:spcPct val="120000"/>
+              </a:lnSpc>
+              <a:spcBef>
+                <a:spcPts val="400"/>
+              </a:spcBef>
+            </a:pPr>
+            <a:r>
+              <a:rPr sz="1300" b="1">
                 <a:solidFill>
                   <a:srgbClr val="C9A84C"/>
                 </a:solidFill>
@@ -13219,13 +13818,173 @@
               <a:t>• </a:t>
             </a:r>
             <a:r>
-              <a:rPr sz="1300">
+              <a:rPr sz="1100">
                 <a:solidFill>
                   <a:srgbClr val="1E1508"/>
                 </a:solidFill>
                 <a:latin typeface="Calibri"/>
               </a:rPr>
+              <a:t>No account / sign-up / email required to plan a full trip</a:t>
+            </a:r>
+          </a:p>
+          <a:p>
+            <a:pPr algn="l">
+              <a:lnSpc>
+                <a:spcPct val="110000"/>
+              </a:lnSpc>
+              <a:spcBef>
+                <a:spcPts val="0"/>
+              </a:spcBef>
+            </a:pPr>
+            <a:r>
+              <a:rPr sz="900" i="1">
+                <a:solidFill>
+                  <a:srgbClr val="5C3A1F"/>
+                </a:solidFill>
+                <a:latin typeface="Calibri"/>
+              </a:rPr>
+              <a:t>       ↳  30 seconds from landing → planning, no email-collection wall.</a:t>
+            </a:r>
+          </a:p>
+          <a:p>
+            <a:pPr algn="l">
+              <a:lnSpc>
+                <a:spcPct val="120000"/>
+              </a:lnSpc>
+              <a:spcBef>
+                <a:spcPts val="400"/>
+              </a:spcBef>
+            </a:pPr>
+            <a:r>
+              <a:rPr sz="1300" b="1">
+                <a:solidFill>
+                  <a:srgbClr val="C9A84C"/>
+                </a:solidFill>
+                <a:latin typeface="Calibri"/>
+              </a:rPr>
+              <a:t>• </a:t>
+            </a:r>
+            <a:r>
+              <a:rPr sz="1100">
+                <a:solidFill>
+                  <a:srgbClr val="1E1508"/>
+                </a:solidFill>
+                <a:latin typeface="Calibri"/>
+              </a:rPr>
+              <a:t>Chamber sees zero personal information about visitors</a:t>
+            </a:r>
+          </a:p>
+          <a:p>
+            <a:pPr algn="l">
+              <a:lnSpc>
+                <a:spcPct val="110000"/>
+              </a:lnSpc>
+              <a:spcBef>
+                <a:spcPts val="0"/>
+              </a:spcBef>
+            </a:pPr>
+            <a:r>
+              <a:rPr sz="900" i="1">
+                <a:solidFill>
+                  <a:srgbClr val="5C3A1F"/>
+                </a:solidFill>
+                <a:latin typeface="Calibri"/>
+              </a:rPr>
+              <a:t>       ↳  Aggregate scraper queue tells the chamber what's hot; visitor identity stays local.</a:t>
+            </a:r>
+          </a:p>
+          <a:p>
+            <a:pPr algn="l">
+              <a:lnSpc>
+                <a:spcPct val="120000"/>
+              </a:lnSpc>
+              <a:spcBef>
+                <a:spcPts val="400"/>
+              </a:spcBef>
+            </a:pPr>
+            <a:r>
+              <a:rPr sz="1300" b="1">
+                <a:solidFill>
+                  <a:srgbClr val="C9A84C"/>
+                </a:solidFill>
+                <a:latin typeface="Calibri"/>
+              </a:rPr>
+              <a:t>• </a:t>
+            </a:r>
+            <a:r>
+              <a:rPr sz="1100">
+                <a:solidFill>
+                  <a:srgbClr val="1E1508"/>
+                </a:solidFill>
+                <a:latin typeface="Calibri"/>
+              </a:rPr>
+              <a:t>No GDPR / CCPA banners required (because nothing is collected)</a:t>
+            </a:r>
+          </a:p>
+          <a:p>
+            <a:pPr algn="l">
+              <a:lnSpc>
+                <a:spcPct val="110000"/>
+              </a:lnSpc>
+              <a:spcBef>
+                <a:spcPts val="0"/>
+              </a:spcBef>
+            </a:pPr>
+            <a:r>
+              <a:rPr sz="900" i="1">
+                <a:solidFill>
+                  <a:srgbClr val="5C3A1F"/>
+                </a:solidFill>
+                <a:latin typeface="Calibri"/>
+              </a:rPr>
+              <a:t>       ↳  EU visitor on holiday gets the site without a banner ambush.</a:t>
+            </a:r>
+          </a:p>
+          <a:p>
+            <a:pPr algn="l">
+              <a:lnSpc>
+                <a:spcPct val="120000"/>
+              </a:lnSpc>
+              <a:spcBef>
+                <a:spcPts val="400"/>
+              </a:spcBef>
+            </a:pPr>
+            <a:r>
+              <a:rPr sz="1300" b="1">
+                <a:solidFill>
+                  <a:srgbClr val="C9A84C"/>
+                </a:solidFill>
+                <a:latin typeface="Calibri"/>
+              </a:rPr>
+              <a:t>• </a:t>
+            </a:r>
+            <a:r>
+              <a:rPr sz="1100">
+                <a:solidFill>
+                  <a:srgbClr val="1E1508"/>
+                </a:solidFill>
+                <a:latin typeface="Calibri"/>
+              </a:rPr>
               <a:t>No privacy review, no consent-platform fees, no compliance overhead</a:t>
+            </a:r>
+          </a:p>
+          <a:p>
+            <a:pPr algn="l">
+              <a:lnSpc>
+                <a:spcPct val="110000"/>
+              </a:lnSpc>
+              <a:spcBef>
+                <a:spcPts val="0"/>
+              </a:spcBef>
+            </a:pPr>
+            <a:r>
+              <a:rPr sz="900" i="1">
+                <a:solidFill>
+                  <a:srgbClr val="5C3A1F"/>
+                </a:solidFill>
+                <a:latin typeface="Calibri"/>
+              </a:rPr>
+              <a:t>       ↳  Annual compliance budget for the platform: $0 — nothing to review.</a:t>
             </a:r>
           </a:p>
         </p:txBody>
@@ -13563,8 +14322,8 @@
         </p:nvSpPr>
         <p:spPr>
           <a:xfrm>
-            <a:off x="548640" y="1691640"/>
-            <a:ext cx="11064240" cy="4572000"/>
+            <a:off x="548640" y="1554480"/>
+            <a:ext cx="11064240" cy="4754880"/>
           </a:xfrm>
           <a:prstGeom prst="rect">
             <a:avLst/>
@@ -13579,11 +14338,11 @@
           <a:p>
             <a:pPr algn="l">
               <a:lnSpc>
-                <a:spcPct val="150000"/>
+                <a:spcPct val="120000"/>
               </a:lnSpc>
             </a:pPr>
             <a:r>
-              <a:rPr sz="1500" b="1">
+              <a:rPr sz="1300" b="1">
                 <a:solidFill>
                   <a:srgbClr val="C9A84C"/>
                 </a:solidFill>
@@ -13592,7 +14351,7 @@
               <a:t>• </a:t>
             </a:r>
             <a:r>
-              <a:rPr sz="1300">
+              <a:rPr sz="1100">
                 <a:solidFill>
                   <a:srgbClr val="1E1508"/>
                 </a:solidFill>
@@ -13604,42 +14363,33 @@
           <a:p>
             <a:pPr algn="l">
               <a:lnSpc>
-                <a:spcPct val="150000"/>
+                <a:spcPct val="110000"/>
               </a:lnSpc>
               <a:spcBef>
-                <a:spcPts val="600"/>
+                <a:spcPts val="0"/>
               </a:spcBef>
             </a:pPr>
             <a:r>
-              <a:rPr sz="1500" b="1">
-                <a:solidFill>
-                  <a:srgbClr val="C9A84C"/>
-                </a:solidFill>
-                <a:latin typeface="Calibri"/>
-              </a:rPr>
-              <a:t>• </a:t>
-            </a:r>
-            <a:r>
-              <a:rPr sz="1300">
-                <a:solidFill>
-                  <a:srgbClr val="1E1508"/>
-                </a:solidFill>
-                <a:latin typeface="Calibri"/>
-              </a:rPr>
-              <a:t>✅ Approve / dismiss events in a queue; bulk-approve is one click</a:t>
+              <a:rPr sz="900" i="1">
+                <a:solidFill>
+                  <a:srgbClr val="5C3A1F"/>
+                </a:solidFill>
+                <a:latin typeface="Calibri"/>
+              </a:rPr>
+              <a:t>       ↳  Chamber staffer clicks "Run Scrapers" Monday morning; ~50 new events appear.</a:t>
             </a:r>
           </a:p>
           <a:p>
             <a:pPr algn="l">
               <a:lnSpc>
-                <a:spcPct val="150000"/>
+                <a:spcPct val="120000"/>
               </a:lnSpc>
               <a:spcBef>
-                <a:spcPts val="600"/>
+                <a:spcPts val="400"/>
               </a:spcBef>
             </a:pPr>
             <a:r>
-              <a:rPr sz="1500" b="1">
+              <a:rPr sz="1300" b="1">
                 <a:solidFill>
                   <a:srgbClr val="C9A84C"/>
                 </a:solidFill>
@@ -13648,54 +14398,45 @@
               <a:t>• </a:t>
             </a:r>
             <a:r>
-              <a:rPr sz="1300">
+              <a:rPr sz="1100">
                 <a:solidFill>
                   <a:srgbClr val="1E1508"/>
                 </a:solidFill>
                 <a:latin typeface="Calibri"/>
               </a:rPr>
-              <a:t>🤖 AI Categorize button (Claude Haiku) — refines area, venue, tags, quality (~$0.20 per full run)</a:t>
+              <a:t>✅ Approve / dismiss events in a queue; bulk-approve is one click</a:t>
             </a:r>
           </a:p>
           <a:p>
             <a:pPr algn="l">
               <a:lnSpc>
-                <a:spcPct val="150000"/>
+                <a:spcPct val="110000"/>
               </a:lnSpc>
               <a:spcBef>
-                <a:spcPts val="600"/>
+                <a:spcPts val="0"/>
               </a:spcBef>
             </a:pPr>
             <a:r>
-              <a:rPr sz="1500" b="1">
-                <a:solidFill>
-                  <a:srgbClr val="C9A84C"/>
-                </a:solidFill>
-                <a:latin typeface="Calibri"/>
-              </a:rPr>
-              <a:t>• </a:t>
-            </a:r>
-            <a:r>
-              <a:rPr sz="1300">
-                <a:solidFill>
-                  <a:srgbClr val="1E1508"/>
-                </a:solidFill>
-                <a:latin typeface="Calibri"/>
-              </a:rPr>
-              <a:t>✏️ Inline-editable experience table — anyone who can edit a spreadsheet can maintain it</a:t>
+              <a:rPr sz="900" i="1">
+                <a:solidFill>
+                  <a:srgbClr val="5C3A1F"/>
+                </a:solidFill>
+                <a:latin typeface="Calibri"/>
+              </a:rPr>
+              <a:t>       ↳  Bulk-approve all KVMR events; dismiss the suspect ones individually.</a:t>
             </a:r>
           </a:p>
           <a:p>
             <a:pPr algn="l">
               <a:lnSpc>
-                <a:spcPct val="150000"/>
+                <a:spcPct val="120000"/>
               </a:lnSpc>
               <a:spcBef>
-                <a:spcPts val="600"/>
+                <a:spcPts val="400"/>
               </a:spcBef>
             </a:pPr>
             <a:r>
-              <a:rPr sz="1500" b="1">
+              <a:rPr sz="1300" b="1">
                 <a:solidFill>
                   <a:srgbClr val="C9A84C"/>
                 </a:solidFill>
@@ -13704,54 +14445,45 @@
               <a:t>• </a:t>
             </a:r>
             <a:r>
-              <a:rPr sz="1300">
+              <a:rPr sz="1100">
                 <a:solidFill>
                   <a:srgbClr val="1E1508"/>
                 </a:solidFill>
                 <a:latin typeface="Calibri"/>
               </a:rPr>
-              <a:t>🏷 Tag taxonomy editor — add/rename/delete tags without code</a:t>
+              <a:t>🤖 AI Categorize button (Claude Haiku) — refines area, venue, tags, quality (~$0.20 per full run)</a:t>
             </a:r>
           </a:p>
           <a:p>
             <a:pPr algn="l">
               <a:lnSpc>
-                <a:spcPct val="150000"/>
+                <a:spcPct val="110000"/>
               </a:lnSpc>
               <a:spcBef>
-                <a:spcPts val="600"/>
+                <a:spcPts val="0"/>
               </a:spcBef>
             </a:pPr>
             <a:r>
-              <a:rPr sz="1500" b="1">
-                <a:solidFill>
-                  <a:srgbClr val="C9A84C"/>
-                </a:solidFill>
-                <a:latin typeface="Calibri"/>
-              </a:rPr>
-              <a:t>• </a:t>
-            </a:r>
-            <a:r>
-              <a:rPr sz="1300">
-                <a:solidFill>
-                  <a:srgbClr val="1E1508"/>
-                </a:solidFill>
-                <a:latin typeface="Calibri"/>
-              </a:rPr>
-              <a:t>🔗 Source URL management — add a new scraper feed by pasting a URL</a:t>
+              <a:rPr sz="900" i="1">
+                <a:solidFill>
+                  <a:srgbClr val="5C3A1F"/>
+                </a:solidFill>
+                <a:latin typeface="Calibri"/>
+              </a:rPr>
+              <a:t>       ↳  One click after a scrape; 460 events get area + venue + tags fixed for ~20¢.</a:t>
             </a:r>
           </a:p>
           <a:p>
             <a:pPr algn="l">
               <a:lnSpc>
-                <a:spcPct val="150000"/>
+                <a:spcPct val="120000"/>
               </a:lnSpc>
               <a:spcBef>
-                <a:spcPts val="600"/>
+                <a:spcPts val="400"/>
               </a:spcBef>
             </a:pPr>
             <a:r>
-              <a:rPr sz="1500" b="1">
+              <a:rPr sz="1300" b="1">
                 <a:solidFill>
                   <a:srgbClr val="C9A84C"/>
                 </a:solidFill>
@@ -13760,26 +14492,45 @@
               <a:t>• </a:t>
             </a:r>
             <a:r>
-              <a:rPr sz="1300">
+              <a:rPr sz="1100">
                 <a:solidFill>
                   <a:srgbClr val="1E1508"/>
                 </a:solidFill>
                 <a:latin typeface="Calibri"/>
               </a:rPr>
-              <a:t>📅 Auto-prune past events; auto-dismiss internal admin meetings</a:t>
+              <a:t>✏️ Inline-editable experience table — anyone who can edit a spreadsheet can maintain it</a:t>
             </a:r>
           </a:p>
           <a:p>
             <a:pPr algn="l">
               <a:lnSpc>
-                <a:spcPct val="150000"/>
+                <a:spcPct val="110000"/>
               </a:lnSpc>
               <a:spcBef>
-                <a:spcPts val="600"/>
+                <a:spcPts val="0"/>
               </a:spcBef>
             </a:pPr>
             <a:r>
-              <a:rPr sz="1500" b="1">
+              <a:rPr sz="900" i="1">
+                <a:solidFill>
+                  <a:srgbClr val="5C3A1F"/>
+                </a:solidFill>
+                <a:latin typeface="Calibri"/>
+              </a:rPr>
+              <a:t>       ↳  New cidery opens — staff types one row, hits save, it's live on the public site.</a:t>
+            </a:r>
+          </a:p>
+          <a:p>
+            <a:pPr algn="l">
+              <a:lnSpc>
+                <a:spcPct val="120000"/>
+              </a:lnSpc>
+              <a:spcBef>
+                <a:spcPts val="400"/>
+              </a:spcBef>
+            </a:pPr>
+            <a:r>
+              <a:rPr sz="1300" b="1">
                 <a:solidFill>
                   <a:srgbClr val="C9A84C"/>
                 </a:solidFill>
@@ -13788,13 +14539,173 @@
               <a:t>• </a:t>
             </a:r>
             <a:r>
-              <a:rPr sz="1300">
+              <a:rPr sz="1100">
                 <a:solidFill>
                   <a:srgbClr val="1E1508"/>
                 </a:solidFill>
                 <a:latin typeface="Calibri"/>
               </a:rPr>
+              <a:t>🏷 Tag taxonomy editor — add/rename/delete tags without code</a:t>
+            </a:r>
+          </a:p>
+          <a:p>
+            <a:pPr algn="l">
+              <a:lnSpc>
+                <a:spcPct val="110000"/>
+              </a:lnSpc>
+              <a:spcBef>
+                <a:spcPts val="0"/>
+              </a:spcBef>
+            </a:pPr>
+            <a:r>
+              <a:rPr sz="900" i="1">
+                <a:solidFill>
+                  <a:srgbClr val="5C3A1F"/>
+                </a:solidFill>
+                <a:latin typeface="Calibri"/>
+              </a:rPr>
+              <a:t>       ↳  "Music" splits into "Live Music" and "Open Mic" without a developer.</a:t>
+            </a:r>
+          </a:p>
+          <a:p>
+            <a:pPr algn="l">
+              <a:lnSpc>
+                <a:spcPct val="120000"/>
+              </a:lnSpc>
+              <a:spcBef>
+                <a:spcPts val="400"/>
+              </a:spcBef>
+            </a:pPr>
+            <a:r>
+              <a:rPr sz="1300" b="1">
+                <a:solidFill>
+                  <a:srgbClr val="C9A84C"/>
+                </a:solidFill>
+                <a:latin typeface="Calibri"/>
+              </a:rPr>
+              <a:t>• </a:t>
+            </a:r>
+            <a:r>
+              <a:rPr sz="1100">
+                <a:solidFill>
+                  <a:srgbClr val="1E1508"/>
+                </a:solidFill>
+                <a:latin typeface="Calibri"/>
+              </a:rPr>
+              <a:t>🔗 Source URL management — add a new scraper feed by pasting a URL</a:t>
+            </a:r>
+          </a:p>
+          <a:p>
+            <a:pPr algn="l">
+              <a:lnSpc>
+                <a:spcPct val="110000"/>
+              </a:lnSpc>
+              <a:spcBef>
+                <a:spcPts val="0"/>
+              </a:spcBef>
+            </a:pPr>
+            <a:r>
+              <a:rPr sz="900" i="1">
+                <a:solidFill>
+                  <a:srgbClr val="5C3A1F"/>
+                </a:solidFill>
+                <a:latin typeface="Calibri"/>
+              </a:rPr>
+              <a:t>       ↳  New venue website? Paste the URL, pick a parser pattern, done.</a:t>
+            </a:r>
+          </a:p>
+          <a:p>
+            <a:pPr algn="l">
+              <a:lnSpc>
+                <a:spcPct val="120000"/>
+              </a:lnSpc>
+              <a:spcBef>
+                <a:spcPts val="400"/>
+              </a:spcBef>
+            </a:pPr>
+            <a:r>
+              <a:rPr sz="1300" b="1">
+                <a:solidFill>
+                  <a:srgbClr val="C9A84C"/>
+                </a:solidFill>
+                <a:latin typeface="Calibri"/>
+              </a:rPr>
+              <a:t>• </a:t>
+            </a:r>
+            <a:r>
+              <a:rPr sz="1100">
+                <a:solidFill>
+                  <a:srgbClr val="1E1508"/>
+                </a:solidFill>
+                <a:latin typeface="Calibri"/>
+              </a:rPr>
+              <a:t>📅 Auto-prune past events; auto-dismiss internal admin meetings</a:t>
+            </a:r>
+          </a:p>
+          <a:p>
+            <a:pPr algn="l">
+              <a:lnSpc>
+                <a:spcPct val="110000"/>
+              </a:lnSpc>
+              <a:spcBef>
+                <a:spcPts val="0"/>
+              </a:spcBef>
+            </a:pPr>
+            <a:r>
+              <a:rPr sz="900" i="1">
+                <a:solidFill>
+                  <a:srgbClr val="5C3A1F"/>
+                </a:solidFill>
+                <a:latin typeface="Calibri"/>
+              </a:rPr>
+              <a:t>       ↳  Saturday's farmers market vanishes from the queue Sunday morning.</a:t>
+            </a:r>
+          </a:p>
+          <a:p>
+            <a:pPr algn="l">
+              <a:lnSpc>
+                <a:spcPct val="120000"/>
+              </a:lnSpc>
+              <a:spcBef>
+                <a:spcPts val="400"/>
+              </a:spcBef>
+            </a:pPr>
+            <a:r>
+              <a:rPr sz="1300" b="1">
+                <a:solidFill>
+                  <a:srgbClr val="C9A84C"/>
+                </a:solidFill>
+                <a:latin typeface="Calibri"/>
+              </a:rPr>
+              <a:t>• </a:t>
+            </a:r>
+            <a:r>
+              <a:rPr sz="1100">
+                <a:solidFill>
+                  <a:srgbClr val="1E1508"/>
+                </a:solidFill>
+                <a:latin typeface="Calibri"/>
+              </a:rPr>
               <a:t>🌐 Public RSS feed at /feed.rss — partners republish without integration work</a:t>
+            </a:r>
+          </a:p>
+          <a:p>
+            <a:pPr algn="l">
+              <a:lnSpc>
+                <a:spcPct val="110000"/>
+              </a:lnSpc>
+              <a:spcBef>
+                <a:spcPts val="0"/>
+              </a:spcBef>
+            </a:pPr>
+            <a:r>
+              <a:rPr sz="900" i="1">
+                <a:solidFill>
+                  <a:srgbClr val="5C3A1F"/>
+                </a:solidFill>
+                <a:latin typeface="Calibri"/>
+              </a:rPr>
+              <a:t>       ↳  Local newspaper's "this weekend" widget pulls straight from /feed.rss.</a:t>
             </a:r>
           </a:p>
         </p:txBody>
@@ -14087,7 +14998,7 @@
         <p:spPr>
           <a:xfrm>
             <a:off x="548640" y="2103120"/>
-            <a:ext cx="5486400" cy="4114800"/>
+            <a:ext cx="5486400" cy="3840480"/>
           </a:xfrm>
           <a:prstGeom prst="rect">
             <a:avLst/>
@@ -14102,11 +15013,11 @@
           <a:p>
             <a:pPr algn="l">
               <a:lnSpc>
-                <a:spcPct val="140000"/>
+                <a:spcPct val="115000"/>
               </a:lnSpc>
             </a:pPr>
             <a:r>
-              <a:rPr sz="1300" b="1">
+              <a:rPr sz="1200" b="1">
                 <a:solidFill>
                   <a:srgbClr val="C9A84C"/>
                 </a:solidFill>
@@ -14115,7 +15026,7 @@
               <a:t>• </a:t>
             </a:r>
             <a:r>
-              <a:rPr sz="1100">
+              <a:rPr sz="1000">
                 <a:solidFill>
                   <a:srgbClr val="1E1508"/>
                 </a:solidFill>
@@ -14127,42 +15038,33 @@
           <a:p>
             <a:pPr algn="l">
               <a:lnSpc>
-                <a:spcPct val="140000"/>
+                <a:spcPct val="110000"/>
               </a:lnSpc>
               <a:spcBef>
-                <a:spcPts val="600"/>
+                <a:spcPts val="0"/>
               </a:spcBef>
             </a:pPr>
             <a:r>
-              <a:rPr sz="1300" b="1">
-                <a:solidFill>
-                  <a:srgbClr val="C9A84C"/>
-                </a:solidFill>
-                <a:latin typeface="Calibri"/>
-              </a:rPr>
-              <a:t>• </a:t>
-            </a:r>
-            <a:r>
-              <a:rPr sz="1100">
-                <a:solidFill>
-                  <a:srgbClr val="1E1508"/>
-                </a:solidFill>
-                <a:latin typeface="Calibri"/>
-              </a:rPr>
-              <a:t>Empty location field on most KVMR events → extracts venue name</a:t>
+              <a:rPr sz="800" i="1">
+                <a:solidFill>
+                  <a:srgbClr val="5C3A1F"/>
+                </a:solidFill>
+                <a:latin typeface="Calibri"/>
+              </a:rPr>
+              <a:t>       ↳  "KVMR Storytelling Night" gets "Nevada City" instead of vague "Nevada County".</a:t>
             </a:r>
           </a:p>
           <a:p>
             <a:pPr algn="l">
               <a:lnSpc>
-                <a:spcPct val="140000"/>
+                <a:spcPct val="115000"/>
               </a:lnSpc>
               <a:spcBef>
-                <a:spcPts val="600"/>
+                <a:spcPts val="400"/>
               </a:spcBef>
             </a:pPr>
             <a:r>
-              <a:rPr sz="1300" b="1">
+              <a:rPr sz="1200" b="1">
                 <a:solidFill>
                   <a:srgbClr val="C9A84C"/>
                 </a:solidFill>
@@ -14171,54 +15073,45 @@
               <a:t>• </a:t>
             </a:r>
             <a:r>
-              <a:rPr sz="1100">
+              <a:rPr sz="1000">
                 <a:solidFill>
                   <a:srgbClr val="1E1508"/>
                 </a:solidFill>
                 <a:latin typeface="Calibri"/>
               </a:rPr>
-              <a:t>"Center for the Arts" → Grass Valley; "Miners Foundry" → Nevada City</a:t>
+              <a:t>Empty location field on most KVMR events → extracts venue name</a:t>
             </a:r>
           </a:p>
           <a:p>
             <a:pPr algn="l">
               <a:lnSpc>
-                <a:spcPct val="140000"/>
+                <a:spcPct val="110000"/>
               </a:lnSpc>
               <a:spcBef>
-                <a:spcPts val="600"/>
+                <a:spcPts val="0"/>
               </a:spcBef>
             </a:pPr>
             <a:r>
-              <a:rPr sz="1300" b="1">
-                <a:solidFill>
-                  <a:srgbClr val="C9A84C"/>
-                </a:solidFill>
-                <a:latin typeface="Calibri"/>
-              </a:rPr>
-              <a:t>• </a:t>
-            </a:r>
-            <a:r>
-              <a:rPr sz="1100">
-                <a:solidFill>
-                  <a:srgbClr val="1E1508"/>
-                </a:solidFill>
-                <a:latin typeface="Calibri"/>
-              </a:rPr>
-              <a:t>Cluttered descriptions → clean one-line summaries</a:t>
+              <a:rPr sz="800" i="1">
+                <a:solidFill>
+                  <a:srgbClr val="5C3A1F"/>
+                </a:solidFill>
+                <a:latin typeface="Calibri"/>
+              </a:rPr>
+              <a:t>       ↳  "Center for the Arts" surfaces as the venue from a description-only event.</a:t>
             </a:r>
           </a:p>
           <a:p>
             <a:pPr algn="l">
               <a:lnSpc>
-                <a:spcPct val="140000"/>
+                <a:spcPct val="115000"/>
               </a:lnSpc>
               <a:spcBef>
-                <a:spcPts val="600"/>
+                <a:spcPts val="400"/>
               </a:spcBef>
             </a:pPr>
             <a:r>
-              <a:rPr sz="1300" b="1">
+              <a:rPr sz="1200" b="1">
                 <a:solidFill>
                   <a:srgbClr val="C9A84C"/>
                 </a:solidFill>
@@ -14227,26 +15120,45 @@
               <a:t>• </a:t>
             </a:r>
             <a:r>
-              <a:rPr sz="1100">
+              <a:rPr sz="1000">
                 <a:solidFill>
                   <a:srgbClr val="1E1508"/>
                 </a:solidFill>
                 <a:latin typeface="Calibri"/>
               </a:rPr>
-              <a:t>Truckee / Sierra-side events flagged "low quality" → auto-hidden</a:t>
+              <a:t>"Center for the Arts" → Grass Valley; "Miners Foundry" → Nevada City</a:t>
             </a:r>
           </a:p>
           <a:p>
             <a:pPr algn="l">
               <a:lnSpc>
-                <a:spcPct val="140000"/>
+                <a:spcPct val="110000"/>
               </a:lnSpc>
               <a:spcBef>
-                <a:spcPts val="600"/>
+                <a:spcPts val="0"/>
               </a:spcBef>
             </a:pPr>
             <a:r>
-              <a:rPr sz="1300" b="1">
+              <a:rPr sz="800" i="1">
+                <a:solidFill>
+                  <a:srgbClr val="5C3A1F"/>
+                </a:solidFill>
+                <a:latin typeface="Calibri"/>
+              </a:rPr>
+              <a:t>       ↳  Visitor filtering by Grass Valley gets concerts without manual tagging.</a:t>
+            </a:r>
+          </a:p>
+          <a:p>
+            <a:pPr algn="l">
+              <a:lnSpc>
+                <a:spcPct val="115000"/>
+              </a:lnSpc>
+              <a:spcBef>
+                <a:spcPts val="400"/>
+              </a:spcBef>
+            </a:pPr>
+            <a:r>
+              <a:rPr sz="1200" b="1">
                 <a:solidFill>
                   <a:srgbClr val="C9A84C"/>
                 </a:solidFill>
@@ -14255,13 +15167,126 @@
               <a:t>• </a:t>
             </a:r>
             <a:r>
-              <a:rPr sz="1100">
+              <a:rPr sz="1000">
                 <a:solidFill>
                   <a:srgbClr val="1E1508"/>
                 </a:solidFill>
                 <a:latin typeface="Calibri"/>
               </a:rPr>
+              <a:t>Cluttered descriptions → clean one-line summaries</a:t>
+            </a:r>
+          </a:p>
+          <a:p>
+            <a:pPr algn="l">
+              <a:lnSpc>
+                <a:spcPct val="110000"/>
+              </a:lnSpc>
+              <a:spcBef>
+                <a:spcPts val="0"/>
+              </a:spcBef>
+            </a:pPr>
+            <a:r>
+              <a:rPr sz="800" i="1">
+                <a:solidFill>
+                  <a:srgbClr val="5C3A1F"/>
+                </a:solidFill>
+                <a:latin typeface="Calibri"/>
+              </a:rPr>
+              <a:t>       ↳  Long press-release blob shrinks to a clean teaser the visitor will actually read.</a:t>
+            </a:r>
+          </a:p>
+          <a:p>
+            <a:pPr algn="l">
+              <a:lnSpc>
+                <a:spcPct val="115000"/>
+              </a:lnSpc>
+              <a:spcBef>
+                <a:spcPts val="400"/>
+              </a:spcBef>
+            </a:pPr>
+            <a:r>
+              <a:rPr sz="1200" b="1">
+                <a:solidFill>
+                  <a:srgbClr val="C9A84C"/>
+                </a:solidFill>
+                <a:latin typeface="Calibri"/>
+              </a:rPr>
+              <a:t>• </a:t>
+            </a:r>
+            <a:r>
+              <a:rPr sz="1000">
+                <a:solidFill>
+                  <a:srgbClr val="1E1508"/>
+                </a:solidFill>
+                <a:latin typeface="Calibri"/>
+              </a:rPr>
+              <a:t>Truckee / Sierra-side events flagged "low quality" → auto-hidden</a:t>
+            </a:r>
+          </a:p>
+          <a:p>
+            <a:pPr algn="l">
+              <a:lnSpc>
+                <a:spcPct val="110000"/>
+              </a:lnSpc>
+              <a:spcBef>
+                <a:spcPts val="0"/>
+              </a:spcBef>
+            </a:pPr>
+            <a:r>
+              <a:rPr sz="800" i="1">
+                <a:solidFill>
+                  <a:srgbClr val="5C3A1F"/>
+                </a:solidFill>
+                <a:latin typeface="Calibri"/>
+              </a:rPr>
+              <a:t>       ↳  Tahoe events tagged "low quality" auto-hide on the public site, no manual cleanup.</a:t>
+            </a:r>
+          </a:p>
+          <a:p>
+            <a:pPr algn="l">
+              <a:lnSpc>
+                <a:spcPct val="115000"/>
+              </a:lnSpc>
+              <a:spcBef>
+                <a:spcPts val="400"/>
+              </a:spcBef>
+            </a:pPr>
+            <a:r>
+              <a:rPr sz="1200" b="1">
+                <a:solidFill>
+                  <a:srgbClr val="C9A84C"/>
+                </a:solidFill>
+                <a:latin typeface="Calibri"/>
+              </a:rPr>
+              <a:t>• </a:t>
+            </a:r>
+            <a:r>
+              <a:rPr sz="1000">
+                <a:solidFill>
+                  <a:srgbClr val="1E1508"/>
+                </a:solidFill>
+                <a:latin typeface="Calibri"/>
+              </a:rPr>
               <a:t>Future scrapes auto-categorize new events with the same logic</a:t>
+            </a:r>
+          </a:p>
+          <a:p>
+            <a:pPr algn="l">
+              <a:lnSpc>
+                <a:spcPct val="110000"/>
+              </a:lnSpc>
+              <a:spcBef>
+                <a:spcPts val="0"/>
+              </a:spcBef>
+            </a:pPr>
+            <a:r>
+              <a:rPr sz="800" i="1">
+                <a:solidFill>
+                  <a:srgbClr val="5C3A1F"/>
+                </a:solidFill>
+                <a:latin typeface="Calibri"/>
+              </a:rPr>
+              <a:t>       ↳  Tuesday's new event gets correct area + venue + tags without human touch.</a:t>
             </a:r>
           </a:p>
         </p:txBody>

</xml_diff>

<commit_message>
Feature the Suggest-a-venue/event form in the deck
The form was just built but not surfaced anywhere in the slides.

Slide 10 (Behind the scenes / Admin):
  Added a 9th bullet — '💡 Public "Suggest a venue or event" form —
  submissions queue for chamber review' with scenario about how the
  flow plays out (chamber emails URL → member fills form → admin
  Suggestions tab).

  Tightened body font from 11pt -> 10pt and shifted top from 1.7
  -> 1.65 to keep all 9 bullets within the slide.

Slide 13 (Where the group can take this):
  Pivoted the member-outreach bullet from aspirational ('Solicit
  missing-venue submissions — a simple web form...') to actionable
  ('Promote the existing form to members — already wired; lift is
  socialization, not engineering'). Reflects that this work is done.

deck_outline.md mirrored to match.

Co-Authored-By: Claude Sonnet 4.6 <noreply@anthropic.com>
</commit_message>
<xml_diff>
--- a/demo_pitch.pptx
+++ b/demo_pitch.pptx
@@ -3514,8 +3514,8 @@
         </p:nvSpPr>
         <p:spPr>
           <a:xfrm>
-            <a:off x="548640" y="1554480"/>
-            <a:ext cx="11064240" cy="4754880"/>
+            <a:off x="548640" y="1508760"/>
+            <a:ext cx="11064240" cy="4937760"/>
           </a:xfrm>
           <a:prstGeom prst="rect">
             <a:avLst/>
@@ -3530,11 +3530,11 @@
           <a:p>
             <a:pPr algn="l">
               <a:lnSpc>
-                <a:spcPct val="120000"/>
+                <a:spcPct val="118000"/>
               </a:lnSpc>
             </a:pPr>
             <a:r>
-              <a:rPr sz="1300" b="1">
+              <a:rPr sz="1200" b="1">
                 <a:solidFill>
                   <a:srgbClr val="C9A84C"/>
                 </a:solidFill>
@@ -3543,7 +3543,7 @@
               <a:t>• </a:t>
             </a:r>
             <a:r>
-              <a:rPr sz="1100">
+              <a:rPr sz="1000">
                 <a:solidFill>
                   <a:srgbClr val="1E1508"/>
                 </a:solidFill>
@@ -3562,7 +3562,7 @@
               </a:spcBef>
             </a:pPr>
             <a:r>
-              <a:rPr sz="900" i="1">
+              <a:rPr sz="800" i="1">
                 <a:solidFill>
                   <a:srgbClr val="5C3A1F"/>
                 </a:solidFill>
@@ -3574,14 +3574,14 @@
           <a:p>
             <a:pPr algn="l">
               <a:lnSpc>
-                <a:spcPct val="120000"/>
+                <a:spcPct val="118000"/>
               </a:lnSpc>
               <a:spcBef>
                 <a:spcPts val="400"/>
               </a:spcBef>
             </a:pPr>
             <a:r>
-              <a:rPr sz="1300" b="1">
+              <a:rPr sz="1200" b="1">
                 <a:solidFill>
                   <a:srgbClr val="C9A84C"/>
                 </a:solidFill>
@@ -3590,7 +3590,7 @@
               <a:t>• </a:t>
             </a:r>
             <a:r>
-              <a:rPr sz="1100">
+              <a:rPr sz="1000">
                 <a:solidFill>
                   <a:srgbClr val="1E1508"/>
                 </a:solidFill>
@@ -3609,7 +3609,7 @@
               </a:spcBef>
             </a:pPr>
             <a:r>
-              <a:rPr sz="900" i="1">
+              <a:rPr sz="800" i="1">
                 <a:solidFill>
                   <a:srgbClr val="5C3A1F"/>
                 </a:solidFill>
@@ -3621,14 +3621,14 @@
           <a:p>
             <a:pPr algn="l">
               <a:lnSpc>
-                <a:spcPct val="120000"/>
+                <a:spcPct val="118000"/>
               </a:lnSpc>
               <a:spcBef>
                 <a:spcPts val="400"/>
               </a:spcBef>
             </a:pPr>
             <a:r>
-              <a:rPr sz="1300" b="1">
+              <a:rPr sz="1200" b="1">
                 <a:solidFill>
                   <a:srgbClr val="C9A84C"/>
                 </a:solidFill>
@@ -3637,7 +3637,7 @@
               <a:t>• </a:t>
             </a:r>
             <a:r>
-              <a:rPr sz="1100">
+              <a:rPr sz="1000">
                 <a:solidFill>
                   <a:srgbClr val="1E1508"/>
                 </a:solidFill>
@@ -3656,7 +3656,7 @@
               </a:spcBef>
             </a:pPr>
             <a:r>
-              <a:rPr sz="900" i="1">
+              <a:rPr sz="800" i="1">
                 <a:solidFill>
                   <a:srgbClr val="5C3A1F"/>
                 </a:solidFill>
@@ -3668,14 +3668,14 @@
           <a:p>
             <a:pPr algn="l">
               <a:lnSpc>
-                <a:spcPct val="120000"/>
+                <a:spcPct val="118000"/>
               </a:lnSpc>
               <a:spcBef>
                 <a:spcPts val="400"/>
               </a:spcBef>
             </a:pPr>
             <a:r>
-              <a:rPr sz="1300" b="1">
+              <a:rPr sz="1200" b="1">
                 <a:solidFill>
                   <a:srgbClr val="C9A84C"/>
                 </a:solidFill>
@@ -3684,7 +3684,7 @@
               <a:t>• </a:t>
             </a:r>
             <a:r>
-              <a:rPr sz="1100">
+              <a:rPr sz="1000">
                 <a:solidFill>
                   <a:srgbClr val="1E1508"/>
                 </a:solidFill>
@@ -3703,7 +3703,7 @@
               </a:spcBef>
             </a:pPr>
             <a:r>
-              <a:rPr sz="900" i="1">
+              <a:rPr sz="800" i="1">
                 <a:solidFill>
                   <a:srgbClr val="5C3A1F"/>
                 </a:solidFill>
@@ -3715,14 +3715,14 @@
           <a:p>
             <a:pPr algn="l">
               <a:lnSpc>
-                <a:spcPct val="120000"/>
+                <a:spcPct val="118000"/>
               </a:lnSpc>
               <a:spcBef>
                 <a:spcPts val="400"/>
               </a:spcBef>
             </a:pPr>
             <a:r>
-              <a:rPr sz="1300" b="1">
+              <a:rPr sz="1200" b="1">
                 <a:solidFill>
                   <a:srgbClr val="C9A84C"/>
                 </a:solidFill>
@@ -3731,7 +3731,7 @@
               <a:t>• </a:t>
             </a:r>
             <a:r>
-              <a:rPr sz="1100">
+              <a:rPr sz="1000">
                 <a:solidFill>
                   <a:srgbClr val="1E1508"/>
                 </a:solidFill>
@@ -3750,7 +3750,7 @@
               </a:spcBef>
             </a:pPr>
             <a:r>
-              <a:rPr sz="900" i="1">
+              <a:rPr sz="800" i="1">
                 <a:solidFill>
                   <a:srgbClr val="5C3A1F"/>
                 </a:solidFill>
@@ -3762,14 +3762,14 @@
           <a:p>
             <a:pPr algn="l">
               <a:lnSpc>
-                <a:spcPct val="120000"/>
+                <a:spcPct val="118000"/>
               </a:lnSpc>
               <a:spcBef>
                 <a:spcPts val="400"/>
               </a:spcBef>
             </a:pPr>
             <a:r>
-              <a:rPr sz="1300" b="1">
+              <a:rPr sz="1200" b="1">
                 <a:solidFill>
                   <a:srgbClr val="C9A84C"/>
                 </a:solidFill>
@@ -3778,7 +3778,7 @@
               <a:t>• </a:t>
             </a:r>
             <a:r>
-              <a:rPr sz="1100">
+              <a:rPr sz="1000">
                 <a:solidFill>
                   <a:srgbClr val="1E1508"/>
                 </a:solidFill>
@@ -3797,7 +3797,7 @@
               </a:spcBef>
             </a:pPr>
             <a:r>
-              <a:rPr sz="900" i="1">
+              <a:rPr sz="800" i="1">
                 <a:solidFill>
                   <a:srgbClr val="5C3A1F"/>
                 </a:solidFill>
@@ -3809,14 +3809,14 @@
           <a:p>
             <a:pPr algn="l">
               <a:lnSpc>
-                <a:spcPct val="120000"/>
+                <a:spcPct val="118000"/>
               </a:lnSpc>
               <a:spcBef>
                 <a:spcPts val="400"/>
               </a:spcBef>
             </a:pPr>
             <a:r>
-              <a:rPr sz="1300" b="1">
+              <a:rPr sz="1200" b="1">
                 <a:solidFill>
                   <a:srgbClr val="C9A84C"/>
                 </a:solidFill>
@@ -3825,7 +3825,7 @@
               <a:t>• </a:t>
             </a:r>
             <a:r>
-              <a:rPr sz="1100">
+              <a:rPr sz="1000">
                 <a:solidFill>
                   <a:srgbClr val="1E1508"/>
                 </a:solidFill>
@@ -3844,7 +3844,7 @@
               </a:spcBef>
             </a:pPr>
             <a:r>
-              <a:rPr sz="900" i="1">
+              <a:rPr sz="800" i="1">
                 <a:solidFill>
                   <a:srgbClr val="5C3A1F"/>
                 </a:solidFill>
@@ -3856,14 +3856,14 @@
           <a:p>
             <a:pPr algn="l">
               <a:lnSpc>
-                <a:spcPct val="120000"/>
+                <a:spcPct val="118000"/>
               </a:lnSpc>
               <a:spcBef>
                 <a:spcPts val="400"/>
               </a:spcBef>
             </a:pPr>
             <a:r>
-              <a:rPr sz="1300" b="1">
+              <a:rPr sz="1200" b="1">
                 <a:solidFill>
                   <a:srgbClr val="C9A84C"/>
                 </a:solidFill>
@@ -3872,7 +3872,7 @@
               <a:t>• </a:t>
             </a:r>
             <a:r>
-              <a:rPr sz="1100">
+              <a:rPr sz="1000">
                 <a:solidFill>
                   <a:srgbClr val="1E1508"/>
                 </a:solidFill>
@@ -3891,13 +3891,60 @@
               </a:spcBef>
             </a:pPr>
             <a:r>
-              <a:rPr sz="900" i="1">
+              <a:rPr sz="800" i="1">
                 <a:solidFill>
                   <a:srgbClr val="5C3A1F"/>
                 </a:solidFill>
                 <a:latin typeface="Calibri"/>
               </a:rPr>
               <a:t>       ↳  Local newspaper's "this weekend" widget pulls straight from /feed.rss.</a:t>
+            </a:r>
+          </a:p>
+          <a:p>
+            <a:pPr algn="l">
+              <a:lnSpc>
+                <a:spcPct val="118000"/>
+              </a:lnSpc>
+              <a:spcBef>
+                <a:spcPts val="400"/>
+              </a:spcBef>
+            </a:pPr>
+            <a:r>
+              <a:rPr sz="1200" b="1">
+                <a:solidFill>
+                  <a:srgbClr val="C9A84C"/>
+                </a:solidFill>
+                <a:latin typeface="Calibri"/>
+              </a:rPr>
+              <a:t>• </a:t>
+            </a:r>
+            <a:r>
+              <a:rPr sz="1000">
+                <a:solidFill>
+                  <a:srgbClr val="1E1508"/>
+                </a:solidFill>
+                <a:latin typeface="Calibri"/>
+              </a:rPr>
+              <a:t>💡 Public "Suggest a venue or event" form — submissions queue for chamber review</a:t>
+            </a:r>
+          </a:p>
+          <a:p>
+            <a:pPr algn="l">
+              <a:lnSpc>
+                <a:spcPct val="110000"/>
+              </a:lnSpc>
+              <a:spcBef>
+                <a:spcPts val="0"/>
+              </a:spcBef>
+            </a:pPr>
+            <a:r>
+              <a:rPr sz="800" i="1">
+                <a:solidFill>
+                  <a:srgbClr val="5C3A1F"/>
+                </a:solidFill>
+                <a:latin typeface="Calibri"/>
+              </a:rPr>
+              <a:t>       ↳  Chamber emails members the URL; venue owner fills the form; entry lands in admin Suggestions tab.</a:t>
             </a:r>
           </a:p>
         </p:txBody>
@@ -6604,7 +6651,7 @@
                 </a:solidFill>
                 <a:latin typeface="Calibri"/>
               </a:rPr>
-              <a:t>Solicit "missing venue" submissions — a simple web form for member venues to flag events that didn't get auto-discovered</a:t>
+              <a:t>Promote the public "Suggest a venue or event" form to members — already wired (footer + admin queue); the lift is socialization, not engineering</a:t>
             </a:r>
           </a:p>
           <a:p>

</xml_diff>

<commit_message>
Move Migration slide to appendix (chat-Claude open decision)
Per the chat-Claude strategy session: '9-phase migration plan for a
prototype conversation feels premature.' Demoted the Migration slide
to a separate APPENDIX_ORDER block that builds AFTER the Thank You
slide, with footer 'A1 / A1' instead of a regular page number and a
small APPENDIX · PULL UP IF ASKED eyebrow in the slide's top-right.

Main flow is now 14 slides closing on Thank You; A1 only comes up if
IT is in the room or someone explicitly asks how this would be hosted.
Closes the open decision in audience_map_template.md.
</commit_message>
<xml_diff>
--- a/demo_pitch.pptx
+++ b/demo_pitch.pptx
@@ -4014,7 +4014,7 @@
                 </a:solidFill>
                 <a:latin typeface="Calibri"/>
               </a:rPr>
-              <a:t>10 / 15</a:t>
+              <a:t>10 / 14</a:t>
             </a:r>
           </a:p>
         </p:txBody>
@@ -5236,7 +5236,7 @@
                 </a:solidFill>
                 <a:latin typeface="Calibri"/>
               </a:rPr>
-              <a:t>11 / 15</a:t>
+              <a:t>11 / 14</a:t>
             </a:r>
           </a:p>
         </p:txBody>
@@ -6171,7 +6171,7 @@
                 </a:solidFill>
                 <a:latin typeface="Calibri"/>
               </a:rPr>
-              <a:t>12 / 15</a:t>
+              <a:t>12 / 14</a:t>
             </a:r>
           </a:p>
         </p:txBody>
@@ -7053,7 +7053,7 @@
                 </a:solidFill>
                 <a:latin typeface="Calibri"/>
               </a:rPr>
-              <a:t>13 / 15</a:t>
+              <a:t>13 / 14</a:t>
             </a:r>
           </a:p>
         </p:txBody>
@@ -7121,36 +7121,45 @@
       <p:grpSpPr/>
       <p:sp>
         <p:nvSpPr>
-          <p:cNvPr id="2" name="TextBox 1"/>
-          <p:cNvSpPr txBox="1"/>
-          <p:nvPr/>
-        </p:nvSpPr>
-        <p:spPr>
-          <a:xfrm>
-            <a:off x="548640" y="365760"/>
-            <a:ext cx="11064240" cy="640080"/>
-          </a:xfrm>
-          <a:prstGeom prst="rect">
-            <a:avLst/>
-          </a:prstGeom>
-          <a:noFill/>
-        </p:spPr>
-        <p:txBody>
-          <a:bodyPr wrap="square" anchor="t" lIns="45720" rIns="45720" tIns="18288" bIns="18288">
-            <a:spAutoFit/>
-          </a:bodyPr>
-          <a:lstStyle/>
-          <a:p>
-            <a:pPr algn="l"/>
-            <a:r>
-              <a:rPr sz="3200" b="1" i="0">
-                <a:solidFill>
-                  <a:srgbClr val="5C3A1F"/>
-                </a:solidFill>
-                <a:latin typeface="Calibri"/>
-              </a:rPr>
-              <a:t>Migration to a county server</a:t>
-            </a:r>
+          <p:cNvPr id="2" name="Rectangle 1"/>
+          <p:cNvSpPr/>
+          <p:nvPr/>
+        </p:nvSpPr>
+        <p:spPr>
+          <a:xfrm>
+            <a:off x="0" y="0"/>
+            <a:ext cx="4114800" cy="6858000"/>
+          </a:xfrm>
+          <a:prstGeom prst="rect">
+            <a:avLst/>
+          </a:prstGeom>
+          <a:solidFill>
+            <a:srgbClr val="5C3A1F"/>
+          </a:solidFill>
+          <a:ln>
+            <a:noFill/>
+          </a:ln>
+          <a:effectLst/>
+        </p:spPr>
+        <p:style>
+          <a:lnRef idx="1">
+            <a:schemeClr val="accent1"/>
+          </a:lnRef>
+          <a:fillRef idx="3">
+            <a:schemeClr val="accent1"/>
+          </a:fillRef>
+          <a:effectRef idx="2">
+            <a:schemeClr val="accent1"/>
+          </a:effectRef>
+          <a:fontRef idx="minor">
+            <a:schemeClr val="lt1"/>
+          </a:fontRef>
+        </p:style>
+        <p:txBody>
+          <a:bodyPr rtlCol="0" anchor="ctr"/>
+          <a:lstStyle/>
+          <a:p>
+            <a:pPr algn="ctr"/>
           </a:p>
         </p:txBody>
       </p:sp>
@@ -7162,8 +7171,8 @@
         </p:nvSpPr>
         <p:spPr>
           <a:xfrm>
-            <a:off x="548640" y="1078992"/>
-            <a:ext cx="11064240" cy="25400"/>
+            <a:off x="4114800" y="0"/>
+            <a:ext cx="73152" cy="6858000"/>
           </a:xfrm>
           <a:prstGeom prst="rect">
             <a:avLst/>
@@ -7174,6 +7183,7 @@
           <a:ln>
             <a:noFill/>
           </a:ln>
+          <a:effectLst/>
         </p:spPr>
         <p:style>
           <a:lnRef idx="1">
@@ -7205,8 +7215,8 @@
         </p:nvSpPr>
         <p:spPr>
           <a:xfrm>
-            <a:off x="548640" y="1207008"/>
-            <a:ext cx="11064240" cy="457200"/>
+            <a:off x="548640" y="2194560"/>
+            <a:ext cx="3383280" cy="914400"/>
           </a:xfrm>
           <a:prstGeom prst="rect">
             <a:avLst/>
@@ -7221,141 +7231,97 @@
           <a:p>
             <a:pPr algn="l"/>
             <a:r>
-              <a:rPr sz="1400" b="0" i="1">
-                <a:solidFill>
-                  <a:srgbClr val="4A5568"/>
-                </a:solidFill>
-                <a:latin typeface="Calibri"/>
-              </a:rPr>
-              <a:t>One focused half-day for someone comfortable with Linux; two days for a learner.</a:t>
-            </a:r>
-          </a:p>
-        </p:txBody>
-      </p:sp>
-      <p:sp>
-        <p:nvSpPr>
-          <p:cNvPr id="5" name="Rectangle 4"/>
+              <a:rPr sz="4400" b="1" i="0">
+                <a:solidFill>
+                  <a:srgbClr val="E8C96A"/>
+                </a:solidFill>
+                <a:latin typeface="Calibri"/>
+              </a:rPr>
+              <a:t>Thank you</a:t>
+            </a:r>
+          </a:p>
+        </p:txBody>
+      </p:sp>
+      <p:sp>
+        <p:nvSpPr>
+          <p:cNvPr id="5" name="TextBox 4"/>
+          <p:cNvSpPr txBox="1"/>
+          <p:nvPr/>
+        </p:nvSpPr>
+        <p:spPr>
+          <a:xfrm>
+            <a:off x="548640" y="3108960"/>
+            <a:ext cx="3383280" cy="640080"/>
+          </a:xfrm>
+          <a:prstGeom prst="rect">
+            <a:avLst/>
+          </a:prstGeom>
+          <a:noFill/>
+        </p:spPr>
+        <p:txBody>
+          <a:bodyPr wrap="square" anchor="t" lIns="45720" rIns="45720" tIns="18288" bIns="18288">
+            <a:spAutoFit/>
+          </a:bodyPr>
+          <a:lstStyle/>
+          <a:p>
+            <a:pPr algn="l"/>
+            <a:r>
+              <a:rPr sz="2200" b="0" i="1">
+                <a:solidFill>
+                  <a:srgbClr val="FFFFFF"/>
+                </a:solidFill>
+                <a:latin typeface="Calibri"/>
+              </a:rPr>
+              <a:t>Questions?</a:t>
+            </a:r>
+          </a:p>
+        </p:txBody>
+      </p:sp>
+      <p:sp>
+        <p:nvSpPr>
+          <p:cNvPr id="6" name="TextBox 5"/>
+          <p:cNvSpPr txBox="1"/>
+          <p:nvPr/>
+        </p:nvSpPr>
+        <p:spPr>
+          <a:xfrm>
+            <a:off x="4480560" y="2194560"/>
+            <a:ext cx="7132320" cy="457200"/>
+          </a:xfrm>
+          <a:prstGeom prst="rect">
+            <a:avLst/>
+          </a:prstGeom>
+          <a:noFill/>
+        </p:spPr>
+        <p:txBody>
+          <a:bodyPr wrap="square" anchor="t" lIns="45720" rIns="45720" tIns="18288" bIns="18288">
+            <a:spAutoFit/>
+          </a:bodyPr>
+          <a:lstStyle/>
+          <a:p>
+            <a:pPr algn="l"/>
+            <a:r>
+              <a:rPr sz="1400" b="1" i="0">
+                <a:solidFill>
+                  <a:srgbClr val="C9A84C"/>
+                </a:solidFill>
+                <a:latin typeface="Calibri"/>
+              </a:rPr>
+              <a:t>The leave-behind one-liner</a:t>
+            </a:r>
+          </a:p>
+        </p:txBody>
+      </p:sp>
+      <p:sp>
+        <p:nvSpPr>
+          <p:cNvPr id="7" name="Rectangle 6"/>
           <p:cNvSpPr/>
           <p:nvPr/>
         </p:nvSpPr>
         <p:spPr>
           <a:xfrm>
-            <a:off x="548640" y="1691640"/>
-            <a:ext cx="11064240" cy="384048"/>
-          </a:xfrm>
-          <a:prstGeom prst="rect">
-            <a:avLst/>
-          </a:prstGeom>
-          <a:solidFill>
-            <a:srgbClr val="F5EFE2"/>
-          </a:solidFill>
-          <a:ln>
-            <a:noFill/>
-          </a:ln>
-          <a:effectLst/>
-        </p:spPr>
-        <p:style>
-          <a:lnRef idx="1">
-            <a:schemeClr val="accent1"/>
-          </a:lnRef>
-          <a:fillRef idx="3">
-            <a:schemeClr val="accent1"/>
-          </a:fillRef>
-          <a:effectRef idx="2">
-            <a:schemeClr val="accent1"/>
-          </a:effectRef>
-          <a:fontRef idx="minor">
-            <a:schemeClr val="lt1"/>
-          </a:fontRef>
-        </p:style>
-        <p:txBody>
-          <a:bodyPr rtlCol="0" anchor="ctr"/>
-          <a:lstStyle/>
-          <a:p>
-            <a:pPr algn="ctr"/>
-          </a:p>
-        </p:txBody>
-      </p:sp>
-      <p:sp>
-        <p:nvSpPr>
-          <p:cNvPr id="6" name="TextBox 5"/>
-          <p:cNvSpPr txBox="1"/>
-          <p:nvPr/>
-        </p:nvSpPr>
-        <p:spPr>
-          <a:xfrm>
-            <a:off x="640080" y="1737360"/>
-            <a:ext cx="1325880" cy="292608"/>
-          </a:xfrm>
-          <a:prstGeom prst="rect">
-            <a:avLst/>
-          </a:prstGeom>
-          <a:noFill/>
-        </p:spPr>
-        <p:txBody>
-          <a:bodyPr wrap="square" anchor="t" lIns="45720" rIns="45720" tIns="18288" bIns="18288">
-            <a:spAutoFit/>
-          </a:bodyPr>
-          <a:lstStyle/>
-          <a:p>
-            <a:pPr algn="l"/>
-            <a:r>
-              <a:rPr sz="1100" b="1" i="0">
-                <a:solidFill>
-                  <a:srgbClr val="5C3A1F"/>
-                </a:solidFill>
-                <a:latin typeface="Calibri"/>
-              </a:rPr>
-              <a:t>Phase</a:t>
-            </a:r>
-          </a:p>
-        </p:txBody>
-      </p:sp>
-      <p:sp>
-        <p:nvSpPr>
-          <p:cNvPr id="7" name="TextBox 6"/>
-          <p:cNvSpPr txBox="1"/>
-          <p:nvPr/>
-        </p:nvSpPr>
-        <p:spPr>
-          <a:xfrm>
-            <a:off x="2103120" y="1737360"/>
-            <a:ext cx="9464040" cy="292608"/>
-          </a:xfrm>
-          <a:prstGeom prst="rect">
-            <a:avLst/>
-          </a:prstGeom>
-          <a:noFill/>
-        </p:spPr>
-        <p:txBody>
-          <a:bodyPr wrap="square" anchor="t" lIns="45720" rIns="45720" tIns="18288" bIns="18288">
-            <a:spAutoFit/>
-          </a:bodyPr>
-          <a:lstStyle/>
-          <a:p>
-            <a:pPr algn="l"/>
-            <a:r>
-              <a:rPr sz="1100" b="1" i="0">
-                <a:solidFill>
-                  <a:srgbClr val="5C3A1F"/>
-                </a:solidFill>
-                <a:latin typeface="Calibri"/>
-              </a:rPr>
-              <a:t>What happens</a:t>
-            </a:r>
-          </a:p>
-        </p:txBody>
-      </p:sp>
-      <p:sp>
-        <p:nvSpPr>
-          <p:cNvPr id="8" name="Rectangle 7"/>
-          <p:cNvSpPr/>
-          <p:nvPr/>
-        </p:nvSpPr>
-        <p:spPr>
-          <a:xfrm>
-            <a:off x="548640" y="2075688"/>
-            <a:ext cx="11064240" cy="25400"/>
+            <a:off x="4480560" y="2606040"/>
+            <a:ext cx="6858000" cy="25400"/>
           </a:xfrm>
           <a:prstGeom prst="rect">
             <a:avLst/>
@@ -7391,58 +7357,14 @@
       </p:sp>
       <p:sp>
         <p:nvSpPr>
-          <p:cNvPr id="9" name="Rectangle 8"/>
-          <p:cNvSpPr/>
-          <p:nvPr/>
-        </p:nvSpPr>
-        <p:spPr>
-          <a:xfrm>
-            <a:off x="548640" y="2112264"/>
-            <a:ext cx="11064240" cy="365760"/>
-          </a:xfrm>
-          <a:prstGeom prst="rect">
-            <a:avLst/>
-          </a:prstGeom>
-          <a:solidFill>
-            <a:srgbClr val="FBF7EE"/>
-          </a:solidFill>
-          <a:ln>
-            <a:noFill/>
-          </a:ln>
-          <a:effectLst/>
-        </p:spPr>
-        <p:style>
-          <a:lnRef idx="1">
-            <a:schemeClr val="accent1"/>
-          </a:lnRef>
-          <a:fillRef idx="3">
-            <a:schemeClr val="accent1"/>
-          </a:fillRef>
-          <a:effectRef idx="2">
-            <a:schemeClr val="accent1"/>
-          </a:effectRef>
-          <a:fontRef idx="minor">
-            <a:schemeClr val="lt1"/>
-          </a:fontRef>
-        </p:style>
-        <p:txBody>
-          <a:bodyPr rtlCol="0" anchor="ctr"/>
-          <a:lstStyle/>
-          <a:p>
-            <a:pPr algn="ctr"/>
-          </a:p>
-        </p:txBody>
-      </p:sp>
-      <p:sp>
-        <p:nvSpPr>
-          <p:cNvPr id="10" name="TextBox 9"/>
-          <p:cNvSpPr txBox="1"/>
-          <p:nvPr/>
-        </p:nvSpPr>
-        <p:spPr>
-          <a:xfrm>
-            <a:off x="640080" y="2157984"/>
-            <a:ext cx="1325880" cy="320040"/>
+          <p:cNvPr id="8" name="TextBox 7"/>
+          <p:cNvSpPr txBox="1"/>
+          <p:nvPr/>
+        </p:nvSpPr>
+        <p:spPr>
+          <a:xfrm>
+            <a:off x="4480560" y="2788920"/>
+            <a:ext cx="7132320" cy="2286000"/>
           </a:xfrm>
           <a:prstGeom prst="rect">
             <a:avLst/>
@@ -7457,27 +7379,27 @@
           <a:p>
             <a:pPr algn="l"/>
             <a:r>
-              <a:rPr sz="1000" b="0" i="0">
-                <a:solidFill>
-                  <a:srgbClr val="1E1508"/>
-                </a:solidFill>
-                <a:latin typeface="Calibri"/>
-              </a:rPr>
-              <a:t>Phase 0</a:t>
-            </a:r>
-          </a:p>
-        </p:txBody>
-      </p:sp>
-      <p:sp>
-        <p:nvSpPr>
-          <p:cNvPr id="11" name="TextBox 10"/>
-          <p:cNvSpPr txBox="1"/>
-          <p:nvPr/>
-        </p:nvSpPr>
-        <p:spPr>
-          <a:xfrm>
-            <a:off x="2103120" y="2157984"/>
-            <a:ext cx="9464040" cy="320040"/>
+              <a:rPr sz="1400" b="0" i="1">
+                <a:solidFill>
+                  <a:srgbClr val="5C3A1F"/>
+                </a:solidFill>
+                <a:latin typeface="Calibri"/>
+              </a:rPr>
+              <a:t>"This isn't a website — it's a planning workspace for visitors and a living directory for the chamber, with AI-assisted curation built in. Privacy-respecting by default, owned by the county outright, maintained in minutes per week."</a:t>
+            </a:r>
+          </a:p>
+        </p:txBody>
+      </p:sp>
+      <p:sp>
+        <p:nvSpPr>
+          <p:cNvPr id="9" name="TextBox 8"/>
+          <p:cNvSpPr txBox="1"/>
+          <p:nvPr/>
+        </p:nvSpPr>
+        <p:spPr>
+          <a:xfrm>
+            <a:off x="4480560" y="5120640"/>
+            <a:ext cx="7132320" cy="1371600"/>
           </a:xfrm>
           <a:prstGeom prst="rect">
             <a:avLst/>
@@ -7492,933 +7414,16 @@
           <a:p>
             <a:pPr algn="l"/>
             <a:r>
-              <a:rPr sz="1000" b="0" i="0">
-                <a:solidFill>
-                  <a:srgbClr val="1E1508"/>
-                </a:solidFill>
-                <a:latin typeface="Calibri"/>
-              </a:rPr>
-              <a:t>Decisions: hosting (DigitalOcean $6/mo recommended), domain, OS, server account ownership</a:t>
-            </a:r>
-          </a:p>
-        </p:txBody>
-      </p:sp>
-      <p:sp>
-        <p:nvSpPr>
-          <p:cNvPr id="12" name="TextBox 11"/>
-          <p:cNvSpPr txBox="1"/>
-          <p:nvPr/>
-        </p:nvSpPr>
-        <p:spPr>
-          <a:xfrm>
-            <a:off x="640080" y="2523744"/>
-            <a:ext cx="1325880" cy="320040"/>
-          </a:xfrm>
-          <a:prstGeom prst="rect">
-            <a:avLst/>
-          </a:prstGeom>
-          <a:noFill/>
-        </p:spPr>
-        <p:txBody>
-          <a:bodyPr wrap="square" anchor="t" lIns="45720" rIns="45720" tIns="18288" bIns="18288">
-            <a:spAutoFit/>
-          </a:bodyPr>
-          <a:lstStyle/>
-          <a:p>
-            <a:pPr algn="l"/>
-            <a:r>
-              <a:rPr sz="1000" b="0" i="0">
-                <a:solidFill>
-                  <a:srgbClr val="1E1508"/>
-                </a:solidFill>
-                <a:latin typeface="Calibri"/>
-              </a:rPr>
-              <a:t>Phase 1</a:t>
-            </a:r>
-          </a:p>
-        </p:txBody>
-      </p:sp>
-      <p:sp>
-        <p:nvSpPr>
-          <p:cNvPr id="13" name="TextBox 12"/>
-          <p:cNvSpPr txBox="1"/>
-          <p:nvPr/>
-        </p:nvSpPr>
-        <p:spPr>
-          <a:xfrm>
-            <a:off x="2103120" y="2523744"/>
-            <a:ext cx="9464040" cy="320040"/>
-          </a:xfrm>
-          <a:prstGeom prst="rect">
-            <a:avLst/>
-          </a:prstGeom>
-          <a:noFill/>
-        </p:spPr>
-        <p:txBody>
-          <a:bodyPr wrap="square" anchor="t" lIns="45720" rIns="45720" tIns="18288" bIns="18288">
-            <a:spAutoFit/>
-          </a:bodyPr>
-          <a:lstStyle/>
-          <a:p>
-            <a:pPr algn="l"/>
-            <a:r>
-              <a:rPr sz="1000" b="0" i="0">
-                <a:solidFill>
-                  <a:srgbClr val="1E1508"/>
-                </a:solidFill>
-                <a:latin typeface="Calibri"/>
-              </a:rPr>
-              <a:t>Pre-flight: domain registered, DNS access, SSH keys ready, Anthropic API key generated</a:t>
-            </a:r>
-          </a:p>
-        </p:txBody>
-      </p:sp>
-      <p:sp>
-        <p:nvSpPr>
-          <p:cNvPr id="14" name="Rectangle 13"/>
-          <p:cNvSpPr/>
-          <p:nvPr/>
-        </p:nvSpPr>
-        <p:spPr>
-          <a:xfrm>
-            <a:off x="548640" y="2843784"/>
-            <a:ext cx="11064240" cy="365760"/>
-          </a:xfrm>
-          <a:prstGeom prst="rect">
-            <a:avLst/>
-          </a:prstGeom>
-          <a:solidFill>
-            <a:srgbClr val="FBF7EE"/>
-          </a:solidFill>
-          <a:ln>
-            <a:noFill/>
-          </a:ln>
-          <a:effectLst/>
-        </p:spPr>
-        <p:style>
-          <a:lnRef idx="1">
-            <a:schemeClr val="accent1"/>
-          </a:lnRef>
-          <a:fillRef idx="3">
-            <a:schemeClr val="accent1"/>
-          </a:fillRef>
-          <a:effectRef idx="2">
-            <a:schemeClr val="accent1"/>
-          </a:effectRef>
-          <a:fontRef idx="minor">
-            <a:schemeClr val="lt1"/>
-          </a:fontRef>
-        </p:style>
-        <p:txBody>
-          <a:bodyPr rtlCol="0" anchor="ctr"/>
-          <a:lstStyle/>
-          <a:p>
-            <a:pPr algn="ctr"/>
-          </a:p>
-        </p:txBody>
-      </p:sp>
-      <p:sp>
-        <p:nvSpPr>
-          <p:cNvPr id="15" name="TextBox 14"/>
-          <p:cNvSpPr txBox="1"/>
-          <p:nvPr/>
-        </p:nvSpPr>
-        <p:spPr>
-          <a:xfrm>
-            <a:off x="640080" y="2889504"/>
-            <a:ext cx="1325880" cy="320040"/>
-          </a:xfrm>
-          <a:prstGeom prst="rect">
-            <a:avLst/>
-          </a:prstGeom>
-          <a:noFill/>
-        </p:spPr>
-        <p:txBody>
-          <a:bodyPr wrap="square" anchor="t" lIns="45720" rIns="45720" tIns="18288" bIns="18288">
-            <a:spAutoFit/>
-          </a:bodyPr>
-          <a:lstStyle/>
-          <a:p>
-            <a:pPr algn="l"/>
-            <a:r>
-              <a:rPr sz="1000" b="0" i="0">
-                <a:solidFill>
-                  <a:srgbClr val="1E1508"/>
-                </a:solidFill>
-                <a:latin typeface="Calibri"/>
-              </a:rPr>
-              <a:t>Phase 2</a:t>
-            </a:r>
-          </a:p>
-        </p:txBody>
-      </p:sp>
-      <p:sp>
-        <p:nvSpPr>
-          <p:cNvPr id="16" name="TextBox 15"/>
-          <p:cNvSpPr txBox="1"/>
-          <p:nvPr/>
-        </p:nvSpPr>
-        <p:spPr>
-          <a:xfrm>
-            <a:off x="2103120" y="2889504"/>
-            <a:ext cx="9464040" cy="320040"/>
-          </a:xfrm>
-          <a:prstGeom prst="rect">
-            <a:avLst/>
-          </a:prstGeom>
-          <a:noFill/>
-        </p:spPr>
-        <p:txBody>
-          <a:bodyPr wrap="square" anchor="t" lIns="45720" rIns="45720" tIns="18288" bIns="18288">
-            <a:spAutoFit/>
-          </a:bodyPr>
-          <a:lstStyle/>
-          <a:p>
-            <a:pPr algn="l"/>
-            <a:r>
-              <a:rPr sz="1000" b="0" i="0">
-                <a:solidFill>
-                  <a:srgbClr val="1E1508"/>
-                </a:solidFill>
-                <a:latin typeface="Calibri"/>
-              </a:rPr>
-              <a:t>Provision: $6/mo Ubuntu droplet, lockdown SSH, install Python + nginx + chromium</a:t>
-            </a:r>
-          </a:p>
-        </p:txBody>
-      </p:sp>
-      <p:sp>
-        <p:nvSpPr>
-          <p:cNvPr id="17" name="TextBox 16"/>
-          <p:cNvSpPr txBox="1"/>
-          <p:nvPr/>
-        </p:nvSpPr>
-        <p:spPr>
-          <a:xfrm>
-            <a:off x="640080" y="3255264"/>
-            <a:ext cx="1325880" cy="320040"/>
-          </a:xfrm>
-          <a:prstGeom prst="rect">
-            <a:avLst/>
-          </a:prstGeom>
-          <a:noFill/>
-        </p:spPr>
-        <p:txBody>
-          <a:bodyPr wrap="square" anchor="t" lIns="45720" rIns="45720" tIns="18288" bIns="18288">
-            <a:spAutoFit/>
-          </a:bodyPr>
-          <a:lstStyle/>
-          <a:p>
-            <a:pPr algn="l"/>
-            <a:r>
-              <a:rPr sz="1000" b="0" i="0">
-                <a:solidFill>
-                  <a:srgbClr val="1E1508"/>
-                </a:solidFill>
-                <a:latin typeface="Calibri"/>
-              </a:rPr>
-              <a:t>Phase 3</a:t>
-            </a:r>
-          </a:p>
-        </p:txBody>
-      </p:sp>
-      <p:sp>
-        <p:nvSpPr>
-          <p:cNvPr id="18" name="TextBox 17"/>
-          <p:cNvSpPr txBox="1"/>
-          <p:nvPr/>
-        </p:nvSpPr>
-        <p:spPr>
-          <a:xfrm>
-            <a:off x="2103120" y="3255264"/>
-            <a:ext cx="9464040" cy="320040"/>
-          </a:xfrm>
-          <a:prstGeom prst="rect">
-            <a:avLst/>
-          </a:prstGeom>
-          <a:noFill/>
-        </p:spPr>
-        <p:txBody>
-          <a:bodyPr wrap="square" anchor="t" lIns="45720" rIns="45720" tIns="18288" bIns="18288">
-            <a:spAutoFit/>
-          </a:bodyPr>
-          <a:lstStyle/>
-          <a:p>
-            <a:pPr algn="l"/>
-            <a:r>
-              <a:rPr sz="1000" b="0" i="0">
-                <a:solidFill>
-                  <a:srgbClr val="1E1508"/>
-                </a:solidFill>
-                <a:latin typeface="Calibri"/>
-              </a:rPr>
-              <a:t>Deploy: git clone, Python venv, install deps, drop API keys in the config file</a:t>
-            </a:r>
-          </a:p>
-        </p:txBody>
-      </p:sp>
-      <p:sp>
-        <p:nvSpPr>
-          <p:cNvPr id="19" name="Rectangle 18"/>
-          <p:cNvSpPr/>
-          <p:nvPr/>
-        </p:nvSpPr>
-        <p:spPr>
-          <a:xfrm>
-            <a:off x="548640" y="3575304"/>
-            <a:ext cx="11064240" cy="365760"/>
-          </a:xfrm>
-          <a:prstGeom prst="rect">
-            <a:avLst/>
-          </a:prstGeom>
-          <a:solidFill>
-            <a:srgbClr val="FBF7EE"/>
-          </a:solidFill>
-          <a:ln>
-            <a:noFill/>
-          </a:ln>
-          <a:effectLst/>
-        </p:spPr>
-        <p:style>
-          <a:lnRef idx="1">
-            <a:schemeClr val="accent1"/>
-          </a:lnRef>
-          <a:fillRef idx="3">
-            <a:schemeClr val="accent1"/>
-          </a:fillRef>
-          <a:effectRef idx="2">
-            <a:schemeClr val="accent1"/>
-          </a:effectRef>
-          <a:fontRef idx="minor">
-            <a:schemeClr val="lt1"/>
-          </a:fontRef>
-        </p:style>
-        <p:txBody>
-          <a:bodyPr rtlCol="0" anchor="ctr"/>
-          <a:lstStyle/>
-          <a:p>
-            <a:pPr algn="ctr"/>
-          </a:p>
-        </p:txBody>
-      </p:sp>
-      <p:sp>
-        <p:nvSpPr>
-          <p:cNvPr id="20" name="TextBox 19"/>
-          <p:cNvSpPr txBox="1"/>
-          <p:nvPr/>
-        </p:nvSpPr>
-        <p:spPr>
-          <a:xfrm>
-            <a:off x="640080" y="3621024"/>
-            <a:ext cx="1325880" cy="320040"/>
-          </a:xfrm>
-          <a:prstGeom prst="rect">
-            <a:avLst/>
-          </a:prstGeom>
-          <a:noFill/>
-        </p:spPr>
-        <p:txBody>
-          <a:bodyPr wrap="square" anchor="t" lIns="45720" rIns="45720" tIns="18288" bIns="18288">
-            <a:spAutoFit/>
-          </a:bodyPr>
-          <a:lstStyle/>
-          <a:p>
-            <a:pPr algn="l"/>
-            <a:r>
-              <a:rPr sz="1000" b="0" i="0">
-                <a:solidFill>
-                  <a:srgbClr val="1E1508"/>
-                </a:solidFill>
-                <a:latin typeface="Calibri"/>
-              </a:rPr>
-              <a:t>Phase 4</a:t>
-            </a:r>
-          </a:p>
-        </p:txBody>
-      </p:sp>
-      <p:sp>
-        <p:nvSpPr>
-          <p:cNvPr id="21" name="TextBox 20"/>
-          <p:cNvSpPr txBox="1"/>
-          <p:nvPr/>
-        </p:nvSpPr>
-        <p:spPr>
-          <a:xfrm>
-            <a:off x="2103120" y="3621024"/>
-            <a:ext cx="9464040" cy="320040"/>
-          </a:xfrm>
-          <a:prstGeom prst="rect">
-            <a:avLst/>
-          </a:prstGeom>
-          <a:noFill/>
-        </p:spPr>
-        <p:txBody>
-          <a:bodyPr wrap="square" anchor="t" lIns="45720" rIns="45720" tIns="18288" bIns="18288">
-            <a:spAutoFit/>
-          </a:bodyPr>
-          <a:lstStyle/>
-          <a:p>
-            <a:pPr algn="l"/>
-            <a:r>
-              <a:rPr sz="1000" b="0" i="0">
-                <a:solidFill>
-                  <a:srgbClr val="1E1508"/>
-                </a:solidFill>
-                <a:latin typeface="Calibri"/>
-              </a:rPr>
-              <a:t>systemd service for auto-restart on crash, auto-start on reboot</a:t>
-            </a:r>
-          </a:p>
-        </p:txBody>
-      </p:sp>
-      <p:sp>
-        <p:nvSpPr>
-          <p:cNvPr id="22" name="TextBox 21"/>
-          <p:cNvSpPr txBox="1"/>
-          <p:nvPr/>
-        </p:nvSpPr>
-        <p:spPr>
-          <a:xfrm>
-            <a:off x="640080" y="3986784"/>
-            <a:ext cx="1325880" cy="320040"/>
-          </a:xfrm>
-          <a:prstGeom prst="rect">
-            <a:avLst/>
-          </a:prstGeom>
-          <a:noFill/>
-        </p:spPr>
-        <p:txBody>
-          <a:bodyPr wrap="square" anchor="t" lIns="45720" rIns="45720" tIns="18288" bIns="18288">
-            <a:spAutoFit/>
-          </a:bodyPr>
-          <a:lstStyle/>
-          <a:p>
-            <a:pPr algn="l"/>
-            <a:r>
-              <a:rPr sz="1000" b="0" i="0">
-                <a:solidFill>
-                  <a:srgbClr val="1E1508"/>
-                </a:solidFill>
-                <a:latin typeface="Calibri"/>
-              </a:rPr>
-              <a:t>Phase 5</a:t>
-            </a:r>
-          </a:p>
-        </p:txBody>
-      </p:sp>
-      <p:sp>
-        <p:nvSpPr>
-          <p:cNvPr id="23" name="TextBox 22"/>
-          <p:cNvSpPr txBox="1"/>
-          <p:nvPr/>
-        </p:nvSpPr>
-        <p:spPr>
-          <a:xfrm>
-            <a:off x="2103120" y="3986784"/>
-            <a:ext cx="9464040" cy="320040"/>
-          </a:xfrm>
-          <a:prstGeom prst="rect">
-            <a:avLst/>
-          </a:prstGeom>
-          <a:noFill/>
-        </p:spPr>
-        <p:txBody>
-          <a:bodyPr wrap="square" anchor="t" lIns="45720" rIns="45720" tIns="18288" bIns="18288">
-            <a:spAutoFit/>
-          </a:bodyPr>
-          <a:lstStyle/>
-          <a:p>
-            <a:pPr algn="l"/>
-            <a:r>
-              <a:rPr sz="1000" b="0" i="0">
-                <a:solidFill>
-                  <a:srgbClr val="1E1508"/>
-                </a:solidFill>
-                <a:latin typeface="Calibri"/>
-              </a:rPr>
-              <a:t>nginx reverse proxy + Let's Encrypt HTTPS (auto-renew via certbot)</a:t>
-            </a:r>
-          </a:p>
-        </p:txBody>
-      </p:sp>
-      <p:sp>
-        <p:nvSpPr>
-          <p:cNvPr id="24" name="Rectangle 23"/>
-          <p:cNvSpPr/>
-          <p:nvPr/>
-        </p:nvSpPr>
-        <p:spPr>
-          <a:xfrm>
-            <a:off x="548640" y="4306824"/>
-            <a:ext cx="11064240" cy="365760"/>
-          </a:xfrm>
-          <a:prstGeom prst="rect">
-            <a:avLst/>
-          </a:prstGeom>
-          <a:solidFill>
-            <a:srgbClr val="FBF7EE"/>
-          </a:solidFill>
-          <a:ln>
-            <a:noFill/>
-          </a:ln>
-          <a:effectLst/>
-        </p:spPr>
-        <p:style>
-          <a:lnRef idx="1">
-            <a:schemeClr val="accent1"/>
-          </a:lnRef>
-          <a:fillRef idx="3">
-            <a:schemeClr val="accent1"/>
-          </a:fillRef>
-          <a:effectRef idx="2">
-            <a:schemeClr val="accent1"/>
-          </a:effectRef>
-          <a:fontRef idx="minor">
-            <a:schemeClr val="lt1"/>
-          </a:fontRef>
-        </p:style>
-        <p:txBody>
-          <a:bodyPr rtlCol="0" anchor="ctr"/>
-          <a:lstStyle/>
-          <a:p>
-            <a:pPr algn="ctr"/>
-          </a:p>
-        </p:txBody>
-      </p:sp>
-      <p:sp>
-        <p:nvSpPr>
-          <p:cNvPr id="25" name="TextBox 24"/>
-          <p:cNvSpPr txBox="1"/>
-          <p:nvPr/>
-        </p:nvSpPr>
-        <p:spPr>
-          <a:xfrm>
-            <a:off x="640080" y="4352544"/>
-            <a:ext cx="1325880" cy="320040"/>
-          </a:xfrm>
-          <a:prstGeom prst="rect">
-            <a:avLst/>
-          </a:prstGeom>
-          <a:noFill/>
-        </p:spPr>
-        <p:txBody>
-          <a:bodyPr wrap="square" anchor="t" lIns="45720" rIns="45720" tIns="18288" bIns="18288">
-            <a:spAutoFit/>
-          </a:bodyPr>
-          <a:lstStyle/>
-          <a:p>
-            <a:pPr algn="l"/>
-            <a:r>
-              <a:rPr sz="1000" b="0" i="0">
-                <a:solidFill>
-                  <a:srgbClr val="1E1508"/>
-                </a:solidFill>
-                <a:latin typeface="Calibri"/>
-              </a:rPr>
-              <a:t>Phase 6</a:t>
-            </a:r>
-          </a:p>
-        </p:txBody>
-      </p:sp>
-      <p:sp>
-        <p:nvSpPr>
-          <p:cNvPr id="26" name="TextBox 25"/>
-          <p:cNvSpPr txBox="1"/>
-          <p:nvPr/>
-        </p:nvSpPr>
-        <p:spPr>
-          <a:xfrm>
-            <a:off x="2103120" y="4352544"/>
-            <a:ext cx="9464040" cy="320040"/>
-          </a:xfrm>
-          <a:prstGeom prst="rect">
-            <a:avLst/>
-          </a:prstGeom>
-          <a:noFill/>
-        </p:spPr>
-        <p:txBody>
-          <a:bodyPr wrap="square" anchor="t" lIns="45720" rIns="45720" tIns="18288" bIns="18288">
-            <a:spAutoFit/>
-          </a:bodyPr>
-          <a:lstStyle/>
-          <a:p>
-            <a:pPr algn="l"/>
-            <a:r>
-              <a:rPr sz="1000" b="0" i="0">
-                <a:solidFill>
-                  <a:srgbClr val="1E1508"/>
-                </a:solidFill>
-                <a:latin typeface="Calibri"/>
-              </a:rPr>
-              <a:t>Schedule nightly: source refresh at 3 AM + AI categorize at 3:30 AM (refresh triggers auto-prune; skip this step and expired events pile up in the queue)</a:t>
-            </a:r>
-          </a:p>
-        </p:txBody>
-      </p:sp>
-      <p:sp>
-        <p:nvSpPr>
-          <p:cNvPr id="27" name="TextBox 26"/>
-          <p:cNvSpPr txBox="1"/>
-          <p:nvPr/>
-        </p:nvSpPr>
-        <p:spPr>
-          <a:xfrm>
-            <a:off x="640080" y="4718304"/>
-            <a:ext cx="1325880" cy="320040"/>
-          </a:xfrm>
-          <a:prstGeom prst="rect">
-            <a:avLst/>
-          </a:prstGeom>
-          <a:noFill/>
-        </p:spPr>
-        <p:txBody>
-          <a:bodyPr wrap="square" anchor="t" lIns="45720" rIns="45720" tIns="18288" bIns="18288">
-            <a:spAutoFit/>
-          </a:bodyPr>
-          <a:lstStyle/>
-          <a:p>
-            <a:pPr algn="l"/>
-            <a:r>
-              <a:rPr sz="1000" b="0" i="0">
-                <a:solidFill>
-                  <a:srgbClr val="1E1508"/>
-                </a:solidFill>
-                <a:latin typeface="Calibri"/>
-              </a:rPr>
-              <a:t>Phase 7</a:t>
-            </a:r>
-          </a:p>
-        </p:txBody>
-      </p:sp>
-      <p:sp>
-        <p:nvSpPr>
-          <p:cNvPr id="28" name="TextBox 27"/>
-          <p:cNvSpPr txBox="1"/>
-          <p:nvPr/>
-        </p:nvSpPr>
-        <p:spPr>
-          <a:xfrm>
-            <a:off x="2103120" y="4718304"/>
-            <a:ext cx="9464040" cy="320040"/>
-          </a:xfrm>
-          <a:prstGeom prst="rect">
-            <a:avLst/>
-          </a:prstGeom>
-          <a:noFill/>
-        </p:spPr>
-        <p:txBody>
-          <a:bodyPr wrap="square" anchor="t" lIns="45720" rIns="45720" tIns="18288" bIns="18288">
-            <a:spAutoFit/>
-          </a:bodyPr>
-          <a:lstStyle/>
-          <a:p>
-            <a:pPr algn="l"/>
-            <a:r>
-              <a:rPr sz="1000" b="0" i="0">
-                <a:solidFill>
-                  <a:srgbClr val="1E1508"/>
-                </a:solidFill>
-                <a:latin typeface="Calibri"/>
-              </a:rPr>
-              <a:t>Backups: provider snapshots ($1/mo) + daily JSON tar to off-site</a:t>
-            </a:r>
-          </a:p>
-        </p:txBody>
-      </p:sp>
-      <p:sp>
-        <p:nvSpPr>
-          <p:cNvPr id="29" name="Rectangle 28"/>
-          <p:cNvSpPr/>
-          <p:nvPr/>
-        </p:nvSpPr>
-        <p:spPr>
-          <a:xfrm>
-            <a:off x="548640" y="5038344"/>
-            <a:ext cx="11064240" cy="365760"/>
-          </a:xfrm>
-          <a:prstGeom prst="rect">
-            <a:avLst/>
-          </a:prstGeom>
-          <a:solidFill>
-            <a:srgbClr val="FBF7EE"/>
-          </a:solidFill>
-          <a:ln>
-            <a:noFill/>
-          </a:ln>
-          <a:effectLst/>
-        </p:spPr>
-        <p:style>
-          <a:lnRef idx="1">
-            <a:schemeClr val="accent1"/>
-          </a:lnRef>
-          <a:fillRef idx="3">
-            <a:schemeClr val="accent1"/>
-          </a:fillRef>
-          <a:effectRef idx="2">
-            <a:schemeClr val="accent1"/>
-          </a:effectRef>
-          <a:fontRef idx="minor">
-            <a:schemeClr val="lt1"/>
-          </a:fontRef>
-        </p:style>
-        <p:txBody>
-          <a:bodyPr rtlCol="0" anchor="ctr"/>
-          <a:lstStyle/>
-          <a:p>
-            <a:pPr algn="ctr"/>
-          </a:p>
-        </p:txBody>
-      </p:sp>
-      <p:sp>
-        <p:nvSpPr>
-          <p:cNvPr id="30" name="TextBox 29"/>
-          <p:cNvSpPr txBox="1"/>
-          <p:nvPr/>
-        </p:nvSpPr>
-        <p:spPr>
-          <a:xfrm>
-            <a:off x="640080" y="5084064"/>
-            <a:ext cx="1325880" cy="320040"/>
-          </a:xfrm>
-          <a:prstGeom prst="rect">
-            <a:avLst/>
-          </a:prstGeom>
-          <a:noFill/>
-        </p:spPr>
-        <p:txBody>
-          <a:bodyPr wrap="square" anchor="t" lIns="45720" rIns="45720" tIns="18288" bIns="18288">
-            <a:spAutoFit/>
-          </a:bodyPr>
-          <a:lstStyle/>
-          <a:p>
-            <a:pPr algn="l"/>
-            <a:r>
-              <a:rPr sz="1000" b="0" i="0">
-                <a:solidFill>
-                  <a:srgbClr val="1E1508"/>
-                </a:solidFill>
-                <a:latin typeface="Calibri"/>
-              </a:rPr>
-              <a:t>Phase 8</a:t>
-            </a:r>
-          </a:p>
-        </p:txBody>
-      </p:sp>
-      <p:sp>
-        <p:nvSpPr>
-          <p:cNvPr id="31" name="TextBox 30"/>
-          <p:cNvSpPr txBox="1"/>
-          <p:nvPr/>
-        </p:nvSpPr>
-        <p:spPr>
-          <a:xfrm>
-            <a:off x="2103120" y="5084064"/>
-            <a:ext cx="9464040" cy="320040"/>
-          </a:xfrm>
-          <a:prstGeom prst="rect">
-            <a:avLst/>
-          </a:prstGeom>
-          <a:noFill/>
-        </p:spPr>
-        <p:txBody>
-          <a:bodyPr wrap="square" anchor="t" lIns="45720" rIns="45720" tIns="18288" bIns="18288">
-            <a:spAutoFit/>
-          </a:bodyPr>
-          <a:lstStyle/>
-          <a:p>
-            <a:pPr algn="l"/>
-            <a:r>
-              <a:rPr sz="1000" b="0" i="0">
-                <a:solidFill>
-                  <a:srgbClr val="1E1508"/>
-                </a:solidFill>
-                <a:latin typeface="Calibri"/>
-              </a:rPr>
-              <a:t>Test checklist: site loads, vibes work, events populate, AI button works, source updates run</a:t>
-            </a:r>
-          </a:p>
-        </p:txBody>
-      </p:sp>
-      <p:sp>
-        <p:nvSpPr>
-          <p:cNvPr id="32" name="TextBox 31"/>
-          <p:cNvSpPr txBox="1"/>
-          <p:nvPr/>
-        </p:nvSpPr>
-        <p:spPr>
-          <a:xfrm>
-            <a:off x="640080" y="5449824"/>
-            <a:ext cx="1325880" cy="320040"/>
-          </a:xfrm>
-          <a:prstGeom prst="rect">
-            <a:avLst/>
-          </a:prstGeom>
-          <a:noFill/>
-        </p:spPr>
-        <p:txBody>
-          <a:bodyPr wrap="square" anchor="t" lIns="45720" rIns="45720" tIns="18288" bIns="18288">
-            <a:spAutoFit/>
-          </a:bodyPr>
-          <a:lstStyle/>
-          <a:p>
-            <a:pPr algn="l"/>
-            <a:r>
-              <a:rPr sz="1000" b="0" i="0">
-                <a:solidFill>
-                  <a:srgbClr val="1E1508"/>
-                </a:solidFill>
-                <a:latin typeface="Calibri"/>
-              </a:rPr>
-              <a:t>Phase 9</a:t>
-            </a:r>
-          </a:p>
-        </p:txBody>
-      </p:sp>
-      <p:sp>
-        <p:nvSpPr>
-          <p:cNvPr id="33" name="TextBox 32"/>
-          <p:cNvSpPr txBox="1"/>
-          <p:nvPr/>
-        </p:nvSpPr>
-        <p:spPr>
-          <a:xfrm>
-            <a:off x="2103120" y="5449824"/>
-            <a:ext cx="9464040" cy="320040"/>
-          </a:xfrm>
-          <a:prstGeom prst="rect">
-            <a:avLst/>
-          </a:prstGeom>
-          <a:noFill/>
-        </p:spPr>
-        <p:txBody>
-          <a:bodyPr wrap="square" anchor="t" lIns="45720" rIns="45720" tIns="18288" bIns="18288">
-            <a:spAutoFit/>
-          </a:bodyPr>
-          <a:lstStyle/>
-          <a:p>
-            <a:pPr algn="l"/>
-            <a:r>
-              <a:rPr sz="1000" b="0" i="0">
-                <a:solidFill>
-                  <a:srgbClr val="1E1508"/>
-                </a:solidFill>
-                <a:latin typeface="Calibri"/>
-              </a:rPr>
-              <a:t>Hand-off to chamber: admin URL, billing alerts, cheat sheet, emergency contact</a:t>
-            </a:r>
-          </a:p>
-        </p:txBody>
-      </p:sp>
-      <p:sp>
-        <p:nvSpPr>
-          <p:cNvPr id="34" name="TextBox 33"/>
-          <p:cNvSpPr txBox="1"/>
-          <p:nvPr/>
-        </p:nvSpPr>
-        <p:spPr>
-          <a:xfrm>
-            <a:off x="548640" y="6492240"/>
-            <a:ext cx="7315200" cy="274320"/>
-          </a:xfrm>
-          <a:prstGeom prst="rect">
-            <a:avLst/>
-          </a:prstGeom>
-          <a:noFill/>
-        </p:spPr>
-        <p:txBody>
-          <a:bodyPr wrap="square" anchor="t" lIns="45720" rIns="45720" tIns="18288" bIns="18288">
-            <a:spAutoFit/>
-          </a:bodyPr>
-          <a:lstStyle/>
-          <a:p>
-            <a:pPr algn="l"/>
-            <a:r>
-              <a:rPr sz="900" b="0" i="0">
+              <a:rPr sz="1100" b="0" i="0">
                 <a:solidFill>
                   <a:srgbClr val="4A5568"/>
                 </a:solidFill>
-                <a:latin typeface="Calibri"/>
-              </a:rPr>
-              <a:t>Western Nevada County Experience</a:t>
-            </a:r>
-          </a:p>
-        </p:txBody>
-      </p:sp>
-      <p:sp>
-        <p:nvSpPr>
-          <p:cNvPr id="35" name="TextBox 34"/>
-          <p:cNvSpPr txBox="1"/>
-          <p:nvPr/>
-        </p:nvSpPr>
-        <p:spPr>
-          <a:xfrm>
-            <a:off x="10515600" y="6492240"/>
-            <a:ext cx="1097280" cy="274320"/>
-          </a:xfrm>
-          <a:prstGeom prst="rect">
-            <a:avLst/>
-          </a:prstGeom>
-          <a:noFill/>
-        </p:spPr>
-        <p:txBody>
-          <a:bodyPr wrap="square" anchor="t" lIns="45720" rIns="45720" tIns="18288" bIns="18288">
-            <a:spAutoFit/>
-          </a:bodyPr>
-          <a:lstStyle/>
-          <a:p>
-            <a:pPr algn="r"/>
-            <a:r>
-              <a:rPr sz="900" b="0" i="0">
-                <a:solidFill>
-                  <a:srgbClr val="4A5568"/>
-                </a:solidFill>
-                <a:latin typeface="Calibri"/>
-              </a:rPr>
-              <a:t>14 / 15</a:t>
-            </a:r>
-          </a:p>
-        </p:txBody>
-      </p:sp>
-      <p:sp>
-        <p:nvSpPr>
-          <p:cNvPr id="36" name="Rectangle 35"/>
-          <p:cNvSpPr/>
-          <p:nvPr/>
-        </p:nvSpPr>
-        <p:spPr>
-          <a:xfrm>
-            <a:off x="548640" y="6455664"/>
-            <a:ext cx="11064240" cy="25400"/>
-          </a:xfrm>
-          <a:prstGeom prst="rect">
-            <a:avLst/>
-          </a:prstGeom>
-          <a:solidFill>
-            <a:srgbClr val="C9A84C"/>
-          </a:solidFill>
-          <a:ln>
-            <a:noFill/>
-          </a:ln>
-        </p:spPr>
-        <p:style>
-          <a:lnRef idx="1">
-            <a:schemeClr val="accent1"/>
-          </a:lnRef>
-          <a:fillRef idx="3">
-            <a:schemeClr val="accent1"/>
-          </a:fillRef>
-          <a:effectRef idx="2">
-            <a:schemeClr val="accent1"/>
-          </a:effectRef>
-          <a:fontRef idx="minor">
-            <a:schemeClr val="lt1"/>
-          </a:fontRef>
-        </p:style>
-        <p:txBody>
-          <a:bodyPr rtlCol="0" anchor="ctr"/>
-          <a:lstStyle/>
-          <a:p>
-            <a:pPr algn="ctr"/>
+                <a:latin typeface="Consolas"/>
+              </a:rPr>
+              <a:t>Live demo:  liammlrb-eng.github.io/nevada-county-experiences
+Repo:       github.com/liammlrb-eng/nevada-county-experiences
+Pitch deck: demo_pitch.pdf  ·  Operator guide: operator_guide.pdf</a:t>
+            </a:r>
           </a:p>
         </p:txBody>
       </p:sp>
@@ -8442,58 +7447,84 @@
       <p:grpSpPr/>
       <p:sp>
         <p:nvSpPr>
-          <p:cNvPr id="2" name="Rectangle 1"/>
+          <p:cNvPr id="2" name="TextBox 1"/>
+          <p:cNvSpPr txBox="1"/>
+          <p:nvPr/>
+        </p:nvSpPr>
+        <p:spPr>
+          <a:xfrm>
+            <a:off x="7772400" y="411480"/>
+            <a:ext cx="3840480" cy="274320"/>
+          </a:xfrm>
+          <a:prstGeom prst="rect">
+            <a:avLst/>
+          </a:prstGeom>
+          <a:noFill/>
+        </p:spPr>
+        <p:txBody>
+          <a:bodyPr wrap="square" anchor="t" lIns="45720" rIns="45720" tIns="18288" bIns="18288">
+            <a:spAutoFit/>
+          </a:bodyPr>
+          <a:lstStyle/>
+          <a:p>
+            <a:pPr algn="r"/>
+            <a:r>
+              <a:rPr sz="900" b="1" i="0">
+                <a:solidFill>
+                  <a:srgbClr val="C9A84C"/>
+                </a:solidFill>
+                <a:latin typeface="Calibri"/>
+              </a:rPr>
+              <a:t>APPENDIX  ·  PULL UP IF ASKED</a:t>
+            </a:r>
+          </a:p>
+        </p:txBody>
+      </p:sp>
+      <p:sp>
+        <p:nvSpPr>
+          <p:cNvPr id="3" name="TextBox 2"/>
+          <p:cNvSpPr txBox="1"/>
+          <p:nvPr/>
+        </p:nvSpPr>
+        <p:spPr>
+          <a:xfrm>
+            <a:off x="548640" y="365760"/>
+            <a:ext cx="11064240" cy="640080"/>
+          </a:xfrm>
+          <a:prstGeom prst="rect">
+            <a:avLst/>
+          </a:prstGeom>
+          <a:noFill/>
+        </p:spPr>
+        <p:txBody>
+          <a:bodyPr wrap="square" anchor="t" lIns="45720" rIns="45720" tIns="18288" bIns="18288">
+            <a:spAutoFit/>
+          </a:bodyPr>
+          <a:lstStyle/>
+          <a:p>
+            <a:pPr algn="l"/>
+            <a:r>
+              <a:rPr sz="3200" b="1" i="0">
+                <a:solidFill>
+                  <a:srgbClr val="5C3A1F"/>
+                </a:solidFill>
+                <a:latin typeface="Calibri"/>
+              </a:rPr>
+              <a:t>Migration to a county server</a:t>
+            </a:r>
+          </a:p>
+        </p:txBody>
+      </p:sp>
+      <p:sp>
+        <p:nvSpPr>
+          <p:cNvPr id="4" name="Rectangle 3"/>
           <p:cNvSpPr/>
           <p:nvPr/>
         </p:nvSpPr>
         <p:spPr>
           <a:xfrm>
-            <a:off x="0" y="0"/>
-            <a:ext cx="4114800" cy="6858000"/>
-          </a:xfrm>
-          <a:prstGeom prst="rect">
-            <a:avLst/>
-          </a:prstGeom>
-          <a:solidFill>
-            <a:srgbClr val="5C3A1F"/>
-          </a:solidFill>
-          <a:ln>
-            <a:noFill/>
-          </a:ln>
-          <a:effectLst/>
-        </p:spPr>
-        <p:style>
-          <a:lnRef idx="1">
-            <a:schemeClr val="accent1"/>
-          </a:lnRef>
-          <a:fillRef idx="3">
-            <a:schemeClr val="accent1"/>
-          </a:fillRef>
-          <a:effectRef idx="2">
-            <a:schemeClr val="accent1"/>
-          </a:effectRef>
-          <a:fontRef idx="minor">
-            <a:schemeClr val="lt1"/>
-          </a:fontRef>
-        </p:style>
-        <p:txBody>
-          <a:bodyPr rtlCol="0" anchor="ctr"/>
-          <a:lstStyle/>
-          <a:p>
-            <a:pPr algn="ctr"/>
-          </a:p>
-        </p:txBody>
-      </p:sp>
-      <p:sp>
-        <p:nvSpPr>
-          <p:cNvPr id="3" name="Rectangle 2"/>
-          <p:cNvSpPr/>
-          <p:nvPr/>
-        </p:nvSpPr>
-        <p:spPr>
-          <a:xfrm>
-            <a:off x="4114800" y="0"/>
-            <a:ext cx="73152" cy="6858000"/>
+            <a:off x="548640" y="1078992"/>
+            <a:ext cx="11064240" cy="25400"/>
           </a:xfrm>
           <a:prstGeom prst="rect">
             <a:avLst/>
@@ -8504,7 +7535,6 @@
           <a:ln>
             <a:noFill/>
           </a:ln>
-          <a:effectLst/>
         </p:spPr>
         <p:style>
           <a:lnRef idx="1">
@@ -8530,14 +7560,14 @@
       </p:sp>
       <p:sp>
         <p:nvSpPr>
-          <p:cNvPr id="4" name="TextBox 3"/>
-          <p:cNvSpPr txBox="1"/>
-          <p:nvPr/>
-        </p:nvSpPr>
-        <p:spPr>
-          <a:xfrm>
-            <a:off x="548640" y="2194560"/>
-            <a:ext cx="3383280" cy="914400"/>
+          <p:cNvPr id="5" name="TextBox 4"/>
+          <p:cNvSpPr txBox="1"/>
+          <p:nvPr/>
+        </p:nvSpPr>
+        <p:spPr>
+          <a:xfrm>
+            <a:off x="548640" y="1207008"/>
+            <a:ext cx="11064240" cy="457200"/>
           </a:xfrm>
           <a:prstGeom prst="rect">
             <a:avLst/>
@@ -8552,27 +7582,71 @@
           <a:p>
             <a:pPr algn="l"/>
             <a:r>
-              <a:rPr sz="4400" b="1" i="0">
-                <a:solidFill>
-                  <a:srgbClr val="E8C96A"/>
-                </a:solidFill>
-                <a:latin typeface="Calibri"/>
-              </a:rPr>
-              <a:t>Thank you</a:t>
-            </a:r>
-          </a:p>
-        </p:txBody>
-      </p:sp>
-      <p:sp>
-        <p:nvSpPr>
-          <p:cNvPr id="5" name="TextBox 4"/>
-          <p:cNvSpPr txBox="1"/>
-          <p:nvPr/>
-        </p:nvSpPr>
-        <p:spPr>
-          <a:xfrm>
-            <a:off x="548640" y="3108960"/>
-            <a:ext cx="3383280" cy="640080"/>
+              <a:rPr sz="1400" b="0" i="1">
+                <a:solidFill>
+                  <a:srgbClr val="4A5568"/>
+                </a:solidFill>
+                <a:latin typeface="Calibri"/>
+              </a:rPr>
+              <a:t>One focused half-day for someone comfortable with Linux; two days for a learner.</a:t>
+            </a:r>
+          </a:p>
+        </p:txBody>
+      </p:sp>
+      <p:sp>
+        <p:nvSpPr>
+          <p:cNvPr id="6" name="Rectangle 5"/>
+          <p:cNvSpPr/>
+          <p:nvPr/>
+        </p:nvSpPr>
+        <p:spPr>
+          <a:xfrm>
+            <a:off x="548640" y="1691640"/>
+            <a:ext cx="11064240" cy="384048"/>
+          </a:xfrm>
+          <a:prstGeom prst="rect">
+            <a:avLst/>
+          </a:prstGeom>
+          <a:solidFill>
+            <a:srgbClr val="F5EFE2"/>
+          </a:solidFill>
+          <a:ln>
+            <a:noFill/>
+          </a:ln>
+          <a:effectLst/>
+        </p:spPr>
+        <p:style>
+          <a:lnRef idx="1">
+            <a:schemeClr val="accent1"/>
+          </a:lnRef>
+          <a:fillRef idx="3">
+            <a:schemeClr val="accent1"/>
+          </a:fillRef>
+          <a:effectRef idx="2">
+            <a:schemeClr val="accent1"/>
+          </a:effectRef>
+          <a:fontRef idx="minor">
+            <a:schemeClr val="lt1"/>
+          </a:fontRef>
+        </p:style>
+        <p:txBody>
+          <a:bodyPr rtlCol="0" anchor="ctr"/>
+          <a:lstStyle/>
+          <a:p>
+            <a:pPr algn="ctr"/>
+          </a:p>
+        </p:txBody>
+      </p:sp>
+      <p:sp>
+        <p:nvSpPr>
+          <p:cNvPr id="7" name="TextBox 6"/>
+          <p:cNvSpPr txBox="1"/>
+          <p:nvPr/>
+        </p:nvSpPr>
+        <p:spPr>
+          <a:xfrm>
+            <a:off x="640080" y="1737360"/>
+            <a:ext cx="1325880" cy="292608"/>
           </a:xfrm>
           <a:prstGeom prst="rect">
             <a:avLst/>
@@ -8587,27 +7661,27 @@
           <a:p>
             <a:pPr algn="l"/>
             <a:r>
-              <a:rPr sz="2200" b="0" i="1">
-                <a:solidFill>
-                  <a:srgbClr val="FFFFFF"/>
-                </a:solidFill>
-                <a:latin typeface="Calibri"/>
-              </a:rPr>
-              <a:t>Questions?</a:t>
-            </a:r>
-          </a:p>
-        </p:txBody>
-      </p:sp>
-      <p:sp>
-        <p:nvSpPr>
-          <p:cNvPr id="6" name="TextBox 5"/>
-          <p:cNvSpPr txBox="1"/>
-          <p:nvPr/>
-        </p:nvSpPr>
-        <p:spPr>
-          <a:xfrm>
-            <a:off x="4480560" y="2194560"/>
-            <a:ext cx="7132320" cy="457200"/>
+              <a:rPr sz="1100" b="1" i="0">
+                <a:solidFill>
+                  <a:srgbClr val="5C3A1F"/>
+                </a:solidFill>
+                <a:latin typeface="Calibri"/>
+              </a:rPr>
+              <a:t>Phase</a:t>
+            </a:r>
+          </a:p>
+        </p:txBody>
+      </p:sp>
+      <p:sp>
+        <p:nvSpPr>
+          <p:cNvPr id="8" name="TextBox 7"/>
+          <p:cNvSpPr txBox="1"/>
+          <p:nvPr/>
+        </p:nvSpPr>
+        <p:spPr>
+          <a:xfrm>
+            <a:off x="2103120" y="1737360"/>
+            <a:ext cx="9464040" cy="292608"/>
           </a:xfrm>
           <a:prstGeom prst="rect">
             <a:avLst/>
@@ -8622,27 +7696,27 @@
           <a:p>
             <a:pPr algn="l"/>
             <a:r>
-              <a:rPr sz="1400" b="1" i="0">
-                <a:solidFill>
-                  <a:srgbClr val="C9A84C"/>
-                </a:solidFill>
-                <a:latin typeface="Calibri"/>
-              </a:rPr>
-              <a:t>The leave-behind one-liner</a:t>
-            </a:r>
-          </a:p>
-        </p:txBody>
-      </p:sp>
-      <p:sp>
-        <p:nvSpPr>
-          <p:cNvPr id="7" name="Rectangle 6"/>
+              <a:rPr sz="1100" b="1" i="0">
+                <a:solidFill>
+                  <a:srgbClr val="5C3A1F"/>
+                </a:solidFill>
+                <a:latin typeface="Calibri"/>
+              </a:rPr>
+              <a:t>What happens</a:t>
+            </a:r>
+          </a:p>
+        </p:txBody>
+      </p:sp>
+      <p:sp>
+        <p:nvSpPr>
+          <p:cNvPr id="9" name="Rectangle 8"/>
           <p:cNvSpPr/>
           <p:nvPr/>
         </p:nvSpPr>
         <p:spPr>
           <a:xfrm>
-            <a:off x="4480560" y="2606040"/>
-            <a:ext cx="6858000" cy="25400"/>
+            <a:off x="548640" y="2075688"/>
+            <a:ext cx="11064240" cy="25400"/>
           </a:xfrm>
           <a:prstGeom prst="rect">
             <a:avLst/>
@@ -8678,14 +7752,58 @@
       </p:sp>
       <p:sp>
         <p:nvSpPr>
-          <p:cNvPr id="8" name="TextBox 7"/>
-          <p:cNvSpPr txBox="1"/>
-          <p:nvPr/>
-        </p:nvSpPr>
-        <p:spPr>
-          <a:xfrm>
-            <a:off x="4480560" y="2788920"/>
-            <a:ext cx="7132320" cy="2286000"/>
+          <p:cNvPr id="10" name="Rectangle 9"/>
+          <p:cNvSpPr/>
+          <p:nvPr/>
+        </p:nvSpPr>
+        <p:spPr>
+          <a:xfrm>
+            <a:off x="548640" y="2112264"/>
+            <a:ext cx="11064240" cy="365760"/>
+          </a:xfrm>
+          <a:prstGeom prst="rect">
+            <a:avLst/>
+          </a:prstGeom>
+          <a:solidFill>
+            <a:srgbClr val="FBF7EE"/>
+          </a:solidFill>
+          <a:ln>
+            <a:noFill/>
+          </a:ln>
+          <a:effectLst/>
+        </p:spPr>
+        <p:style>
+          <a:lnRef idx="1">
+            <a:schemeClr val="accent1"/>
+          </a:lnRef>
+          <a:fillRef idx="3">
+            <a:schemeClr val="accent1"/>
+          </a:fillRef>
+          <a:effectRef idx="2">
+            <a:schemeClr val="accent1"/>
+          </a:effectRef>
+          <a:fontRef idx="minor">
+            <a:schemeClr val="lt1"/>
+          </a:fontRef>
+        </p:style>
+        <p:txBody>
+          <a:bodyPr rtlCol="0" anchor="ctr"/>
+          <a:lstStyle/>
+          <a:p>
+            <a:pPr algn="ctr"/>
+          </a:p>
+        </p:txBody>
+      </p:sp>
+      <p:sp>
+        <p:nvSpPr>
+          <p:cNvPr id="11" name="TextBox 10"/>
+          <p:cNvSpPr txBox="1"/>
+          <p:nvPr/>
+        </p:nvSpPr>
+        <p:spPr>
+          <a:xfrm>
+            <a:off x="640080" y="2157984"/>
+            <a:ext cx="1325880" cy="320040"/>
           </a:xfrm>
           <a:prstGeom prst="rect">
             <a:avLst/>
@@ -8700,27 +7818,27 @@
           <a:p>
             <a:pPr algn="l"/>
             <a:r>
-              <a:rPr sz="1400" b="0" i="1">
-                <a:solidFill>
-                  <a:srgbClr val="5C3A1F"/>
-                </a:solidFill>
-                <a:latin typeface="Calibri"/>
-              </a:rPr>
-              <a:t>"This isn't a website — it's a planning workspace for visitors and a living directory for the chamber, with AI-assisted curation built in. Privacy-respecting by default, owned by the county outright, maintained in minutes per week."</a:t>
-            </a:r>
-          </a:p>
-        </p:txBody>
-      </p:sp>
-      <p:sp>
-        <p:nvSpPr>
-          <p:cNvPr id="9" name="TextBox 8"/>
-          <p:cNvSpPr txBox="1"/>
-          <p:nvPr/>
-        </p:nvSpPr>
-        <p:spPr>
-          <a:xfrm>
-            <a:off x="4480560" y="5120640"/>
-            <a:ext cx="7132320" cy="1371600"/>
+              <a:rPr sz="1000" b="0" i="0">
+                <a:solidFill>
+                  <a:srgbClr val="1E1508"/>
+                </a:solidFill>
+                <a:latin typeface="Calibri"/>
+              </a:rPr>
+              <a:t>Phase 0</a:t>
+            </a:r>
+          </a:p>
+        </p:txBody>
+      </p:sp>
+      <p:sp>
+        <p:nvSpPr>
+          <p:cNvPr id="12" name="TextBox 11"/>
+          <p:cNvSpPr txBox="1"/>
+          <p:nvPr/>
+        </p:nvSpPr>
+        <p:spPr>
+          <a:xfrm>
+            <a:off x="2103120" y="2157984"/>
+            <a:ext cx="9464040" cy="320040"/>
           </a:xfrm>
           <a:prstGeom prst="rect">
             <a:avLst/>
@@ -8735,16 +7853,933 @@
           <a:p>
             <a:pPr algn="l"/>
             <a:r>
-              <a:rPr sz="1100" b="0" i="0">
+              <a:rPr sz="1000" b="0" i="0">
+                <a:solidFill>
+                  <a:srgbClr val="1E1508"/>
+                </a:solidFill>
+                <a:latin typeface="Calibri"/>
+              </a:rPr>
+              <a:t>Decisions: hosting (DigitalOcean $6/mo recommended), domain, OS, server account ownership</a:t>
+            </a:r>
+          </a:p>
+        </p:txBody>
+      </p:sp>
+      <p:sp>
+        <p:nvSpPr>
+          <p:cNvPr id="13" name="TextBox 12"/>
+          <p:cNvSpPr txBox="1"/>
+          <p:nvPr/>
+        </p:nvSpPr>
+        <p:spPr>
+          <a:xfrm>
+            <a:off x="640080" y="2523744"/>
+            <a:ext cx="1325880" cy="320040"/>
+          </a:xfrm>
+          <a:prstGeom prst="rect">
+            <a:avLst/>
+          </a:prstGeom>
+          <a:noFill/>
+        </p:spPr>
+        <p:txBody>
+          <a:bodyPr wrap="square" anchor="t" lIns="45720" rIns="45720" tIns="18288" bIns="18288">
+            <a:spAutoFit/>
+          </a:bodyPr>
+          <a:lstStyle/>
+          <a:p>
+            <a:pPr algn="l"/>
+            <a:r>
+              <a:rPr sz="1000" b="0" i="0">
+                <a:solidFill>
+                  <a:srgbClr val="1E1508"/>
+                </a:solidFill>
+                <a:latin typeface="Calibri"/>
+              </a:rPr>
+              <a:t>Phase 1</a:t>
+            </a:r>
+          </a:p>
+        </p:txBody>
+      </p:sp>
+      <p:sp>
+        <p:nvSpPr>
+          <p:cNvPr id="14" name="TextBox 13"/>
+          <p:cNvSpPr txBox="1"/>
+          <p:nvPr/>
+        </p:nvSpPr>
+        <p:spPr>
+          <a:xfrm>
+            <a:off x="2103120" y="2523744"/>
+            <a:ext cx="9464040" cy="320040"/>
+          </a:xfrm>
+          <a:prstGeom prst="rect">
+            <a:avLst/>
+          </a:prstGeom>
+          <a:noFill/>
+        </p:spPr>
+        <p:txBody>
+          <a:bodyPr wrap="square" anchor="t" lIns="45720" rIns="45720" tIns="18288" bIns="18288">
+            <a:spAutoFit/>
+          </a:bodyPr>
+          <a:lstStyle/>
+          <a:p>
+            <a:pPr algn="l"/>
+            <a:r>
+              <a:rPr sz="1000" b="0" i="0">
+                <a:solidFill>
+                  <a:srgbClr val="1E1508"/>
+                </a:solidFill>
+                <a:latin typeface="Calibri"/>
+              </a:rPr>
+              <a:t>Pre-flight: domain registered, DNS access, SSH keys ready, Anthropic API key generated</a:t>
+            </a:r>
+          </a:p>
+        </p:txBody>
+      </p:sp>
+      <p:sp>
+        <p:nvSpPr>
+          <p:cNvPr id="15" name="Rectangle 14"/>
+          <p:cNvSpPr/>
+          <p:nvPr/>
+        </p:nvSpPr>
+        <p:spPr>
+          <a:xfrm>
+            <a:off x="548640" y="2843784"/>
+            <a:ext cx="11064240" cy="365760"/>
+          </a:xfrm>
+          <a:prstGeom prst="rect">
+            <a:avLst/>
+          </a:prstGeom>
+          <a:solidFill>
+            <a:srgbClr val="FBF7EE"/>
+          </a:solidFill>
+          <a:ln>
+            <a:noFill/>
+          </a:ln>
+          <a:effectLst/>
+        </p:spPr>
+        <p:style>
+          <a:lnRef idx="1">
+            <a:schemeClr val="accent1"/>
+          </a:lnRef>
+          <a:fillRef idx="3">
+            <a:schemeClr val="accent1"/>
+          </a:fillRef>
+          <a:effectRef idx="2">
+            <a:schemeClr val="accent1"/>
+          </a:effectRef>
+          <a:fontRef idx="minor">
+            <a:schemeClr val="lt1"/>
+          </a:fontRef>
+        </p:style>
+        <p:txBody>
+          <a:bodyPr rtlCol="0" anchor="ctr"/>
+          <a:lstStyle/>
+          <a:p>
+            <a:pPr algn="ctr"/>
+          </a:p>
+        </p:txBody>
+      </p:sp>
+      <p:sp>
+        <p:nvSpPr>
+          <p:cNvPr id="16" name="TextBox 15"/>
+          <p:cNvSpPr txBox="1"/>
+          <p:nvPr/>
+        </p:nvSpPr>
+        <p:spPr>
+          <a:xfrm>
+            <a:off x="640080" y="2889504"/>
+            <a:ext cx="1325880" cy="320040"/>
+          </a:xfrm>
+          <a:prstGeom prst="rect">
+            <a:avLst/>
+          </a:prstGeom>
+          <a:noFill/>
+        </p:spPr>
+        <p:txBody>
+          <a:bodyPr wrap="square" anchor="t" lIns="45720" rIns="45720" tIns="18288" bIns="18288">
+            <a:spAutoFit/>
+          </a:bodyPr>
+          <a:lstStyle/>
+          <a:p>
+            <a:pPr algn="l"/>
+            <a:r>
+              <a:rPr sz="1000" b="0" i="0">
+                <a:solidFill>
+                  <a:srgbClr val="1E1508"/>
+                </a:solidFill>
+                <a:latin typeface="Calibri"/>
+              </a:rPr>
+              <a:t>Phase 2</a:t>
+            </a:r>
+          </a:p>
+        </p:txBody>
+      </p:sp>
+      <p:sp>
+        <p:nvSpPr>
+          <p:cNvPr id="17" name="TextBox 16"/>
+          <p:cNvSpPr txBox="1"/>
+          <p:nvPr/>
+        </p:nvSpPr>
+        <p:spPr>
+          <a:xfrm>
+            <a:off x="2103120" y="2889504"/>
+            <a:ext cx="9464040" cy="320040"/>
+          </a:xfrm>
+          <a:prstGeom prst="rect">
+            <a:avLst/>
+          </a:prstGeom>
+          <a:noFill/>
+        </p:spPr>
+        <p:txBody>
+          <a:bodyPr wrap="square" anchor="t" lIns="45720" rIns="45720" tIns="18288" bIns="18288">
+            <a:spAutoFit/>
+          </a:bodyPr>
+          <a:lstStyle/>
+          <a:p>
+            <a:pPr algn="l"/>
+            <a:r>
+              <a:rPr sz="1000" b="0" i="0">
+                <a:solidFill>
+                  <a:srgbClr val="1E1508"/>
+                </a:solidFill>
+                <a:latin typeface="Calibri"/>
+              </a:rPr>
+              <a:t>Provision: $6/mo Ubuntu droplet, lockdown SSH, install Python + nginx + chromium</a:t>
+            </a:r>
+          </a:p>
+        </p:txBody>
+      </p:sp>
+      <p:sp>
+        <p:nvSpPr>
+          <p:cNvPr id="18" name="TextBox 17"/>
+          <p:cNvSpPr txBox="1"/>
+          <p:nvPr/>
+        </p:nvSpPr>
+        <p:spPr>
+          <a:xfrm>
+            <a:off x="640080" y="3255264"/>
+            <a:ext cx="1325880" cy="320040"/>
+          </a:xfrm>
+          <a:prstGeom prst="rect">
+            <a:avLst/>
+          </a:prstGeom>
+          <a:noFill/>
+        </p:spPr>
+        <p:txBody>
+          <a:bodyPr wrap="square" anchor="t" lIns="45720" rIns="45720" tIns="18288" bIns="18288">
+            <a:spAutoFit/>
+          </a:bodyPr>
+          <a:lstStyle/>
+          <a:p>
+            <a:pPr algn="l"/>
+            <a:r>
+              <a:rPr sz="1000" b="0" i="0">
+                <a:solidFill>
+                  <a:srgbClr val="1E1508"/>
+                </a:solidFill>
+                <a:latin typeface="Calibri"/>
+              </a:rPr>
+              <a:t>Phase 3</a:t>
+            </a:r>
+          </a:p>
+        </p:txBody>
+      </p:sp>
+      <p:sp>
+        <p:nvSpPr>
+          <p:cNvPr id="19" name="TextBox 18"/>
+          <p:cNvSpPr txBox="1"/>
+          <p:nvPr/>
+        </p:nvSpPr>
+        <p:spPr>
+          <a:xfrm>
+            <a:off x="2103120" y="3255264"/>
+            <a:ext cx="9464040" cy="320040"/>
+          </a:xfrm>
+          <a:prstGeom prst="rect">
+            <a:avLst/>
+          </a:prstGeom>
+          <a:noFill/>
+        </p:spPr>
+        <p:txBody>
+          <a:bodyPr wrap="square" anchor="t" lIns="45720" rIns="45720" tIns="18288" bIns="18288">
+            <a:spAutoFit/>
+          </a:bodyPr>
+          <a:lstStyle/>
+          <a:p>
+            <a:pPr algn="l"/>
+            <a:r>
+              <a:rPr sz="1000" b="0" i="0">
+                <a:solidFill>
+                  <a:srgbClr val="1E1508"/>
+                </a:solidFill>
+                <a:latin typeface="Calibri"/>
+              </a:rPr>
+              <a:t>Deploy: git clone, Python venv, install deps, drop API keys in the config file</a:t>
+            </a:r>
+          </a:p>
+        </p:txBody>
+      </p:sp>
+      <p:sp>
+        <p:nvSpPr>
+          <p:cNvPr id="20" name="Rectangle 19"/>
+          <p:cNvSpPr/>
+          <p:nvPr/>
+        </p:nvSpPr>
+        <p:spPr>
+          <a:xfrm>
+            <a:off x="548640" y="3575304"/>
+            <a:ext cx="11064240" cy="365760"/>
+          </a:xfrm>
+          <a:prstGeom prst="rect">
+            <a:avLst/>
+          </a:prstGeom>
+          <a:solidFill>
+            <a:srgbClr val="FBF7EE"/>
+          </a:solidFill>
+          <a:ln>
+            <a:noFill/>
+          </a:ln>
+          <a:effectLst/>
+        </p:spPr>
+        <p:style>
+          <a:lnRef idx="1">
+            <a:schemeClr val="accent1"/>
+          </a:lnRef>
+          <a:fillRef idx="3">
+            <a:schemeClr val="accent1"/>
+          </a:fillRef>
+          <a:effectRef idx="2">
+            <a:schemeClr val="accent1"/>
+          </a:effectRef>
+          <a:fontRef idx="minor">
+            <a:schemeClr val="lt1"/>
+          </a:fontRef>
+        </p:style>
+        <p:txBody>
+          <a:bodyPr rtlCol="0" anchor="ctr"/>
+          <a:lstStyle/>
+          <a:p>
+            <a:pPr algn="ctr"/>
+          </a:p>
+        </p:txBody>
+      </p:sp>
+      <p:sp>
+        <p:nvSpPr>
+          <p:cNvPr id="21" name="TextBox 20"/>
+          <p:cNvSpPr txBox="1"/>
+          <p:nvPr/>
+        </p:nvSpPr>
+        <p:spPr>
+          <a:xfrm>
+            <a:off x="640080" y="3621024"/>
+            <a:ext cx="1325880" cy="320040"/>
+          </a:xfrm>
+          <a:prstGeom prst="rect">
+            <a:avLst/>
+          </a:prstGeom>
+          <a:noFill/>
+        </p:spPr>
+        <p:txBody>
+          <a:bodyPr wrap="square" anchor="t" lIns="45720" rIns="45720" tIns="18288" bIns="18288">
+            <a:spAutoFit/>
+          </a:bodyPr>
+          <a:lstStyle/>
+          <a:p>
+            <a:pPr algn="l"/>
+            <a:r>
+              <a:rPr sz="1000" b="0" i="0">
+                <a:solidFill>
+                  <a:srgbClr val="1E1508"/>
+                </a:solidFill>
+                <a:latin typeface="Calibri"/>
+              </a:rPr>
+              <a:t>Phase 4</a:t>
+            </a:r>
+          </a:p>
+        </p:txBody>
+      </p:sp>
+      <p:sp>
+        <p:nvSpPr>
+          <p:cNvPr id="22" name="TextBox 21"/>
+          <p:cNvSpPr txBox="1"/>
+          <p:nvPr/>
+        </p:nvSpPr>
+        <p:spPr>
+          <a:xfrm>
+            <a:off x="2103120" y="3621024"/>
+            <a:ext cx="9464040" cy="320040"/>
+          </a:xfrm>
+          <a:prstGeom prst="rect">
+            <a:avLst/>
+          </a:prstGeom>
+          <a:noFill/>
+        </p:spPr>
+        <p:txBody>
+          <a:bodyPr wrap="square" anchor="t" lIns="45720" rIns="45720" tIns="18288" bIns="18288">
+            <a:spAutoFit/>
+          </a:bodyPr>
+          <a:lstStyle/>
+          <a:p>
+            <a:pPr algn="l"/>
+            <a:r>
+              <a:rPr sz="1000" b="0" i="0">
+                <a:solidFill>
+                  <a:srgbClr val="1E1508"/>
+                </a:solidFill>
+                <a:latin typeface="Calibri"/>
+              </a:rPr>
+              <a:t>systemd service for auto-restart on crash, auto-start on reboot</a:t>
+            </a:r>
+          </a:p>
+        </p:txBody>
+      </p:sp>
+      <p:sp>
+        <p:nvSpPr>
+          <p:cNvPr id="23" name="TextBox 22"/>
+          <p:cNvSpPr txBox="1"/>
+          <p:nvPr/>
+        </p:nvSpPr>
+        <p:spPr>
+          <a:xfrm>
+            <a:off x="640080" y="3986784"/>
+            <a:ext cx="1325880" cy="320040"/>
+          </a:xfrm>
+          <a:prstGeom prst="rect">
+            <a:avLst/>
+          </a:prstGeom>
+          <a:noFill/>
+        </p:spPr>
+        <p:txBody>
+          <a:bodyPr wrap="square" anchor="t" lIns="45720" rIns="45720" tIns="18288" bIns="18288">
+            <a:spAutoFit/>
+          </a:bodyPr>
+          <a:lstStyle/>
+          <a:p>
+            <a:pPr algn="l"/>
+            <a:r>
+              <a:rPr sz="1000" b="0" i="0">
+                <a:solidFill>
+                  <a:srgbClr val="1E1508"/>
+                </a:solidFill>
+                <a:latin typeface="Calibri"/>
+              </a:rPr>
+              <a:t>Phase 5</a:t>
+            </a:r>
+          </a:p>
+        </p:txBody>
+      </p:sp>
+      <p:sp>
+        <p:nvSpPr>
+          <p:cNvPr id="24" name="TextBox 23"/>
+          <p:cNvSpPr txBox="1"/>
+          <p:nvPr/>
+        </p:nvSpPr>
+        <p:spPr>
+          <a:xfrm>
+            <a:off x="2103120" y="3986784"/>
+            <a:ext cx="9464040" cy="320040"/>
+          </a:xfrm>
+          <a:prstGeom prst="rect">
+            <a:avLst/>
+          </a:prstGeom>
+          <a:noFill/>
+        </p:spPr>
+        <p:txBody>
+          <a:bodyPr wrap="square" anchor="t" lIns="45720" rIns="45720" tIns="18288" bIns="18288">
+            <a:spAutoFit/>
+          </a:bodyPr>
+          <a:lstStyle/>
+          <a:p>
+            <a:pPr algn="l"/>
+            <a:r>
+              <a:rPr sz="1000" b="0" i="0">
+                <a:solidFill>
+                  <a:srgbClr val="1E1508"/>
+                </a:solidFill>
+                <a:latin typeface="Calibri"/>
+              </a:rPr>
+              <a:t>nginx reverse proxy + Let's Encrypt HTTPS (auto-renew via certbot)</a:t>
+            </a:r>
+          </a:p>
+        </p:txBody>
+      </p:sp>
+      <p:sp>
+        <p:nvSpPr>
+          <p:cNvPr id="25" name="Rectangle 24"/>
+          <p:cNvSpPr/>
+          <p:nvPr/>
+        </p:nvSpPr>
+        <p:spPr>
+          <a:xfrm>
+            <a:off x="548640" y="4306824"/>
+            <a:ext cx="11064240" cy="365760"/>
+          </a:xfrm>
+          <a:prstGeom prst="rect">
+            <a:avLst/>
+          </a:prstGeom>
+          <a:solidFill>
+            <a:srgbClr val="FBF7EE"/>
+          </a:solidFill>
+          <a:ln>
+            <a:noFill/>
+          </a:ln>
+          <a:effectLst/>
+        </p:spPr>
+        <p:style>
+          <a:lnRef idx="1">
+            <a:schemeClr val="accent1"/>
+          </a:lnRef>
+          <a:fillRef idx="3">
+            <a:schemeClr val="accent1"/>
+          </a:fillRef>
+          <a:effectRef idx="2">
+            <a:schemeClr val="accent1"/>
+          </a:effectRef>
+          <a:fontRef idx="minor">
+            <a:schemeClr val="lt1"/>
+          </a:fontRef>
+        </p:style>
+        <p:txBody>
+          <a:bodyPr rtlCol="0" anchor="ctr"/>
+          <a:lstStyle/>
+          <a:p>
+            <a:pPr algn="ctr"/>
+          </a:p>
+        </p:txBody>
+      </p:sp>
+      <p:sp>
+        <p:nvSpPr>
+          <p:cNvPr id="26" name="TextBox 25"/>
+          <p:cNvSpPr txBox="1"/>
+          <p:nvPr/>
+        </p:nvSpPr>
+        <p:spPr>
+          <a:xfrm>
+            <a:off x="640080" y="4352544"/>
+            <a:ext cx="1325880" cy="320040"/>
+          </a:xfrm>
+          <a:prstGeom prst="rect">
+            <a:avLst/>
+          </a:prstGeom>
+          <a:noFill/>
+        </p:spPr>
+        <p:txBody>
+          <a:bodyPr wrap="square" anchor="t" lIns="45720" rIns="45720" tIns="18288" bIns="18288">
+            <a:spAutoFit/>
+          </a:bodyPr>
+          <a:lstStyle/>
+          <a:p>
+            <a:pPr algn="l"/>
+            <a:r>
+              <a:rPr sz="1000" b="0" i="0">
+                <a:solidFill>
+                  <a:srgbClr val="1E1508"/>
+                </a:solidFill>
+                <a:latin typeface="Calibri"/>
+              </a:rPr>
+              <a:t>Phase 6</a:t>
+            </a:r>
+          </a:p>
+        </p:txBody>
+      </p:sp>
+      <p:sp>
+        <p:nvSpPr>
+          <p:cNvPr id="27" name="TextBox 26"/>
+          <p:cNvSpPr txBox="1"/>
+          <p:nvPr/>
+        </p:nvSpPr>
+        <p:spPr>
+          <a:xfrm>
+            <a:off x="2103120" y="4352544"/>
+            <a:ext cx="9464040" cy="320040"/>
+          </a:xfrm>
+          <a:prstGeom prst="rect">
+            <a:avLst/>
+          </a:prstGeom>
+          <a:noFill/>
+        </p:spPr>
+        <p:txBody>
+          <a:bodyPr wrap="square" anchor="t" lIns="45720" rIns="45720" tIns="18288" bIns="18288">
+            <a:spAutoFit/>
+          </a:bodyPr>
+          <a:lstStyle/>
+          <a:p>
+            <a:pPr algn="l"/>
+            <a:r>
+              <a:rPr sz="1000" b="0" i="0">
+                <a:solidFill>
+                  <a:srgbClr val="1E1508"/>
+                </a:solidFill>
+                <a:latin typeface="Calibri"/>
+              </a:rPr>
+              <a:t>Schedule nightly: source refresh at 3 AM + AI categorize at 3:30 AM (refresh triggers auto-prune; skip this step and expired events pile up in the queue)</a:t>
+            </a:r>
+          </a:p>
+        </p:txBody>
+      </p:sp>
+      <p:sp>
+        <p:nvSpPr>
+          <p:cNvPr id="28" name="TextBox 27"/>
+          <p:cNvSpPr txBox="1"/>
+          <p:nvPr/>
+        </p:nvSpPr>
+        <p:spPr>
+          <a:xfrm>
+            <a:off x="640080" y="4718304"/>
+            <a:ext cx="1325880" cy="320040"/>
+          </a:xfrm>
+          <a:prstGeom prst="rect">
+            <a:avLst/>
+          </a:prstGeom>
+          <a:noFill/>
+        </p:spPr>
+        <p:txBody>
+          <a:bodyPr wrap="square" anchor="t" lIns="45720" rIns="45720" tIns="18288" bIns="18288">
+            <a:spAutoFit/>
+          </a:bodyPr>
+          <a:lstStyle/>
+          <a:p>
+            <a:pPr algn="l"/>
+            <a:r>
+              <a:rPr sz="1000" b="0" i="0">
+                <a:solidFill>
+                  <a:srgbClr val="1E1508"/>
+                </a:solidFill>
+                <a:latin typeface="Calibri"/>
+              </a:rPr>
+              <a:t>Phase 7</a:t>
+            </a:r>
+          </a:p>
+        </p:txBody>
+      </p:sp>
+      <p:sp>
+        <p:nvSpPr>
+          <p:cNvPr id="29" name="TextBox 28"/>
+          <p:cNvSpPr txBox="1"/>
+          <p:nvPr/>
+        </p:nvSpPr>
+        <p:spPr>
+          <a:xfrm>
+            <a:off x="2103120" y="4718304"/>
+            <a:ext cx="9464040" cy="320040"/>
+          </a:xfrm>
+          <a:prstGeom prst="rect">
+            <a:avLst/>
+          </a:prstGeom>
+          <a:noFill/>
+        </p:spPr>
+        <p:txBody>
+          <a:bodyPr wrap="square" anchor="t" lIns="45720" rIns="45720" tIns="18288" bIns="18288">
+            <a:spAutoFit/>
+          </a:bodyPr>
+          <a:lstStyle/>
+          <a:p>
+            <a:pPr algn="l"/>
+            <a:r>
+              <a:rPr sz="1000" b="0" i="0">
+                <a:solidFill>
+                  <a:srgbClr val="1E1508"/>
+                </a:solidFill>
+                <a:latin typeface="Calibri"/>
+              </a:rPr>
+              <a:t>Backups: provider snapshots ($1/mo) + daily JSON tar to off-site</a:t>
+            </a:r>
+          </a:p>
+        </p:txBody>
+      </p:sp>
+      <p:sp>
+        <p:nvSpPr>
+          <p:cNvPr id="30" name="Rectangle 29"/>
+          <p:cNvSpPr/>
+          <p:nvPr/>
+        </p:nvSpPr>
+        <p:spPr>
+          <a:xfrm>
+            <a:off x="548640" y="5038344"/>
+            <a:ext cx="11064240" cy="365760"/>
+          </a:xfrm>
+          <a:prstGeom prst="rect">
+            <a:avLst/>
+          </a:prstGeom>
+          <a:solidFill>
+            <a:srgbClr val="FBF7EE"/>
+          </a:solidFill>
+          <a:ln>
+            <a:noFill/>
+          </a:ln>
+          <a:effectLst/>
+        </p:spPr>
+        <p:style>
+          <a:lnRef idx="1">
+            <a:schemeClr val="accent1"/>
+          </a:lnRef>
+          <a:fillRef idx="3">
+            <a:schemeClr val="accent1"/>
+          </a:fillRef>
+          <a:effectRef idx="2">
+            <a:schemeClr val="accent1"/>
+          </a:effectRef>
+          <a:fontRef idx="minor">
+            <a:schemeClr val="lt1"/>
+          </a:fontRef>
+        </p:style>
+        <p:txBody>
+          <a:bodyPr rtlCol="0" anchor="ctr"/>
+          <a:lstStyle/>
+          <a:p>
+            <a:pPr algn="ctr"/>
+          </a:p>
+        </p:txBody>
+      </p:sp>
+      <p:sp>
+        <p:nvSpPr>
+          <p:cNvPr id="31" name="TextBox 30"/>
+          <p:cNvSpPr txBox="1"/>
+          <p:nvPr/>
+        </p:nvSpPr>
+        <p:spPr>
+          <a:xfrm>
+            <a:off x="640080" y="5084064"/>
+            <a:ext cx="1325880" cy="320040"/>
+          </a:xfrm>
+          <a:prstGeom prst="rect">
+            <a:avLst/>
+          </a:prstGeom>
+          <a:noFill/>
+        </p:spPr>
+        <p:txBody>
+          <a:bodyPr wrap="square" anchor="t" lIns="45720" rIns="45720" tIns="18288" bIns="18288">
+            <a:spAutoFit/>
+          </a:bodyPr>
+          <a:lstStyle/>
+          <a:p>
+            <a:pPr algn="l"/>
+            <a:r>
+              <a:rPr sz="1000" b="0" i="0">
+                <a:solidFill>
+                  <a:srgbClr val="1E1508"/>
+                </a:solidFill>
+                <a:latin typeface="Calibri"/>
+              </a:rPr>
+              <a:t>Phase 8</a:t>
+            </a:r>
+          </a:p>
+        </p:txBody>
+      </p:sp>
+      <p:sp>
+        <p:nvSpPr>
+          <p:cNvPr id="32" name="TextBox 31"/>
+          <p:cNvSpPr txBox="1"/>
+          <p:nvPr/>
+        </p:nvSpPr>
+        <p:spPr>
+          <a:xfrm>
+            <a:off x="2103120" y="5084064"/>
+            <a:ext cx="9464040" cy="320040"/>
+          </a:xfrm>
+          <a:prstGeom prst="rect">
+            <a:avLst/>
+          </a:prstGeom>
+          <a:noFill/>
+        </p:spPr>
+        <p:txBody>
+          <a:bodyPr wrap="square" anchor="t" lIns="45720" rIns="45720" tIns="18288" bIns="18288">
+            <a:spAutoFit/>
+          </a:bodyPr>
+          <a:lstStyle/>
+          <a:p>
+            <a:pPr algn="l"/>
+            <a:r>
+              <a:rPr sz="1000" b="0" i="0">
+                <a:solidFill>
+                  <a:srgbClr val="1E1508"/>
+                </a:solidFill>
+                <a:latin typeface="Calibri"/>
+              </a:rPr>
+              <a:t>Test checklist: site loads, vibes work, events populate, AI button works, source updates run</a:t>
+            </a:r>
+          </a:p>
+        </p:txBody>
+      </p:sp>
+      <p:sp>
+        <p:nvSpPr>
+          <p:cNvPr id="33" name="TextBox 32"/>
+          <p:cNvSpPr txBox="1"/>
+          <p:nvPr/>
+        </p:nvSpPr>
+        <p:spPr>
+          <a:xfrm>
+            <a:off x="640080" y="5449824"/>
+            <a:ext cx="1325880" cy="320040"/>
+          </a:xfrm>
+          <a:prstGeom prst="rect">
+            <a:avLst/>
+          </a:prstGeom>
+          <a:noFill/>
+        </p:spPr>
+        <p:txBody>
+          <a:bodyPr wrap="square" anchor="t" lIns="45720" rIns="45720" tIns="18288" bIns="18288">
+            <a:spAutoFit/>
+          </a:bodyPr>
+          <a:lstStyle/>
+          <a:p>
+            <a:pPr algn="l"/>
+            <a:r>
+              <a:rPr sz="1000" b="0" i="0">
+                <a:solidFill>
+                  <a:srgbClr val="1E1508"/>
+                </a:solidFill>
+                <a:latin typeface="Calibri"/>
+              </a:rPr>
+              <a:t>Phase 9</a:t>
+            </a:r>
+          </a:p>
+        </p:txBody>
+      </p:sp>
+      <p:sp>
+        <p:nvSpPr>
+          <p:cNvPr id="34" name="TextBox 33"/>
+          <p:cNvSpPr txBox="1"/>
+          <p:nvPr/>
+        </p:nvSpPr>
+        <p:spPr>
+          <a:xfrm>
+            <a:off x="2103120" y="5449824"/>
+            <a:ext cx="9464040" cy="320040"/>
+          </a:xfrm>
+          <a:prstGeom prst="rect">
+            <a:avLst/>
+          </a:prstGeom>
+          <a:noFill/>
+        </p:spPr>
+        <p:txBody>
+          <a:bodyPr wrap="square" anchor="t" lIns="45720" rIns="45720" tIns="18288" bIns="18288">
+            <a:spAutoFit/>
+          </a:bodyPr>
+          <a:lstStyle/>
+          <a:p>
+            <a:pPr algn="l"/>
+            <a:r>
+              <a:rPr sz="1000" b="0" i="0">
+                <a:solidFill>
+                  <a:srgbClr val="1E1508"/>
+                </a:solidFill>
+                <a:latin typeface="Calibri"/>
+              </a:rPr>
+              <a:t>Hand-off to chamber: admin URL, billing alerts, cheat sheet, emergency contact</a:t>
+            </a:r>
+          </a:p>
+        </p:txBody>
+      </p:sp>
+      <p:sp>
+        <p:nvSpPr>
+          <p:cNvPr id="35" name="TextBox 34"/>
+          <p:cNvSpPr txBox="1"/>
+          <p:nvPr/>
+        </p:nvSpPr>
+        <p:spPr>
+          <a:xfrm>
+            <a:off x="548640" y="6492240"/>
+            <a:ext cx="7315200" cy="274320"/>
+          </a:xfrm>
+          <a:prstGeom prst="rect">
+            <a:avLst/>
+          </a:prstGeom>
+          <a:noFill/>
+        </p:spPr>
+        <p:txBody>
+          <a:bodyPr wrap="square" anchor="t" lIns="45720" rIns="45720" tIns="18288" bIns="18288">
+            <a:spAutoFit/>
+          </a:bodyPr>
+          <a:lstStyle/>
+          <a:p>
+            <a:pPr algn="l"/>
+            <a:r>
+              <a:rPr sz="900" b="0" i="0">
                 <a:solidFill>
                   <a:srgbClr val="4A5568"/>
                 </a:solidFill>
-                <a:latin typeface="Consolas"/>
-              </a:rPr>
-              <a:t>Live demo:  liammlrb-eng.github.io/nevada-county-experiences
-Repo:       github.com/liammlrb-eng/nevada-county-experiences
-Pitch deck: demo_pitch.pdf  ·  Operator guide: operator_guide.pdf</a:t>
-            </a:r>
+                <a:latin typeface="Calibri"/>
+              </a:rPr>
+              <a:t>Western Nevada County Experience</a:t>
+            </a:r>
+          </a:p>
+        </p:txBody>
+      </p:sp>
+      <p:sp>
+        <p:nvSpPr>
+          <p:cNvPr id="36" name="TextBox 35"/>
+          <p:cNvSpPr txBox="1"/>
+          <p:nvPr/>
+        </p:nvSpPr>
+        <p:spPr>
+          <a:xfrm>
+            <a:off x="10515600" y="6492240"/>
+            <a:ext cx="1097280" cy="274320"/>
+          </a:xfrm>
+          <a:prstGeom prst="rect">
+            <a:avLst/>
+          </a:prstGeom>
+          <a:noFill/>
+        </p:spPr>
+        <p:txBody>
+          <a:bodyPr wrap="square" anchor="t" lIns="45720" rIns="45720" tIns="18288" bIns="18288">
+            <a:spAutoFit/>
+          </a:bodyPr>
+          <a:lstStyle/>
+          <a:p>
+            <a:pPr algn="r"/>
+            <a:r>
+              <a:rPr sz="900" b="0" i="0">
+                <a:solidFill>
+                  <a:srgbClr val="4A5568"/>
+                </a:solidFill>
+                <a:latin typeface="Calibri"/>
+              </a:rPr>
+              <a:t>A1 / A1</a:t>
+            </a:r>
+          </a:p>
+        </p:txBody>
+      </p:sp>
+      <p:sp>
+        <p:nvSpPr>
+          <p:cNvPr id="37" name="Rectangle 36"/>
+          <p:cNvSpPr/>
+          <p:nvPr/>
+        </p:nvSpPr>
+        <p:spPr>
+          <a:xfrm>
+            <a:off x="548640" y="6455664"/>
+            <a:ext cx="11064240" cy="25400"/>
+          </a:xfrm>
+          <a:prstGeom prst="rect">
+            <a:avLst/>
+          </a:prstGeom>
+          <a:solidFill>
+            <a:srgbClr val="C9A84C"/>
+          </a:solidFill>
+          <a:ln>
+            <a:noFill/>
+          </a:ln>
+        </p:spPr>
+        <p:style>
+          <a:lnRef idx="1">
+            <a:schemeClr val="accent1"/>
+          </a:lnRef>
+          <a:fillRef idx="3">
+            <a:schemeClr val="accent1"/>
+          </a:fillRef>
+          <a:effectRef idx="2">
+            <a:schemeClr val="accent1"/>
+          </a:effectRef>
+          <a:fontRef idx="minor">
+            <a:schemeClr val="lt1"/>
+          </a:fontRef>
+        </p:style>
+        <p:txBody>
+          <a:bodyPr rtlCol="0" anchor="ctr"/>
+          <a:lstStyle/>
+          <a:p>
+            <a:pPr algn="ctr"/>
           </a:p>
         </p:txBody>
       </p:sp>
@@ -9362,7 +9397,7 @@
                 </a:solidFill>
                 <a:latin typeface="Calibri"/>
               </a:rPr>
-              <a:t>2 / 15</a:t>
+              <a:t>2 / 14</a:t>
             </a:r>
           </a:p>
         </p:txBody>
@@ -10145,7 +10180,7 @@
                 </a:solidFill>
                 <a:latin typeface="Calibri"/>
               </a:rPr>
-              <a:t>3 / 15</a:t>
+              <a:t>3 / 14</a:t>
             </a:r>
           </a:p>
         </p:txBody>
@@ -11457,7 +11492,7 @@
                 </a:solidFill>
                 <a:latin typeface="Calibri"/>
               </a:rPr>
-              <a:t>4 / 15</a:t>
+              <a:t>4 / 14</a:t>
             </a:r>
           </a:p>
         </p:txBody>
@@ -12482,7 +12517,7 @@
                 </a:solidFill>
                 <a:latin typeface="Calibri"/>
               </a:rPr>
-              <a:t>5 / 15</a:t>
+              <a:t>5 / 14</a:t>
             </a:r>
           </a:p>
         </p:txBody>
@@ -13365,7 +13400,7 @@
                 </a:solidFill>
                 <a:latin typeface="Calibri"/>
               </a:rPr>
-              <a:t>6 / 15</a:t>
+              <a:t>6 / 14</a:t>
             </a:r>
           </a:p>
         </p:txBody>
@@ -13962,7 +13997,7 @@
                 </a:solidFill>
                 <a:latin typeface="Calibri"/>
               </a:rPr>
-              <a:t>7 / 15</a:t>
+              <a:t>7 / 14</a:t>
             </a:r>
           </a:p>
         </p:txBody>
@@ -15379,7 +15414,7 @@
                 </a:solidFill>
                 <a:latin typeface="Calibri"/>
               </a:rPr>
-              <a:t>8 / 15</a:t>
+              <a:t>8 / 14</a:t>
             </a:r>
           </a:p>
         </p:txBody>
@@ -16147,7 +16182,7 @@
                 </a:solidFill>
                 <a:latin typeface="Calibri"/>
               </a:rPr>
-              <a:t>9 / 15</a:t>
+              <a:t>9 / 14</a:t>
             </a:r>
           </a:p>
         </p:txBody>

</xml_diff>

<commit_message>
Genericize Maker Traveler / Curious Forge callout on slide 7
Slide 7 named 'The Curious Forge' (the presenter's own venue) in
persona #9 and listed Maker Traveler first in the 'over-serve four'
recommendation, which reads like the deck is being used to promote
the presenter's business. Two adjustments per chat-Claude open
decision:

- Drop the brand mention. Persona #9 description now reads 'a
  destination-class workshop venue can anchor a regional identity'.
  The 🎯 emoji highlight is also gone.
- Reorder over-serve list: 'Festival Pilgrim · Romantic Weekender ·
  Foodie · Maker Traveler' so Maker Traveler isn't the lead.

Long-form PDF updated to match — Maker Traveler highlight paragraph
no longer names specific businesses, coverage table reference
generalized, recommendation table reordered.

Closes the third open decision in audience_map_template.md.
</commit_message>
<xml_diff>
--- a/demo_pitch.pptx
+++ b/demo_pitch.pptx
@@ -13846,7 +13846,7 @@
                 </a:solidFill>
                 <a:latin typeface="Calibri"/>
               </a:rPr>
-              <a:t>9. Maker Traveler  🎯    —    Travels for the workshop — Curious Forge anchors a destination identity</a:t>
+              <a:t>9. Maker Traveler    —    Travels for the workshop — a destination-class workshop venue can anchor a regional identity</a:t>
             </a:r>
           </a:p>
         </p:txBody>
@@ -13927,7 +13927,7 @@
                 </a:solidFill>
                 <a:latin typeface="Calibri"/>
               </a:rPr>
-              <a:t>Recommended marketing focus (over-serve four):  Maker Traveler  ·  Festival Pilgrim  ·  Romantic Weekender  ·  Foodie</a:t>
+              <a:t>Recommended marketing focus (over-serve four):  Festival Pilgrim  ·  Romantic Weekender  ·  Foodie  ·  Maker Traveler</a:t>
             </a:r>
           </a:p>
         </p:txBody>

</xml_diff>

<commit_message>
Pitch deck: saturate palette + 30% font bump
Two coordinated changes to address 'drab + too small' on projector:

PALETTE
- GOLD #C9A84C -> #B8941A — richer, more saturated; less brown-yellow,
  matches the website's recent color refresh.
- BROWN #5C3A1F -> #4A2D18 — deeper for stronger header contrast on
  cream backgrounds.
- SLATE #4A5568 -> #2D3748 — darker body text; same shift we just
  shipped on the site.
- Added RUST #8B4A2A and FOREST #3A5A3A as secondary accents (not yet
  applied anywhere — available for hand-tuning long slides on the
  next pass).

FONTS
- New FONT_SCALE = 1.30 constant. Every font.size = Pt(...) site
  multiplies through it, so a single number controls deck legibility.
  Effective sizes: 8 -> 10.4, 10 -> 13, 12 -> 15.6, 14 -> 18.2,
  32 -> 41.6 (title). Subtitle and dense slides especially benefit.
</commit_message>
<xml_diff>
--- a/demo_pitch.pptx
+++ b/demo_pitch.pptx
@@ -3117,7 +3117,7 @@
             <a:avLst/>
           </a:prstGeom>
           <a:solidFill>
-            <a:srgbClr val="5C3A1F"/>
+            <a:srgbClr val="4A2D18"/>
           </a:solidFill>
           <a:ln>
             <a:noFill/>
@@ -3161,7 +3161,7 @@
             <a:avLst/>
           </a:prstGeom>
           <a:solidFill>
-            <a:srgbClr val="C9A84C"/>
+            <a:srgbClr val="B8941A"/>
           </a:solidFill>
           <a:ln>
             <a:noFill/>
@@ -3214,7 +3214,7 @@
           <a:p>
             <a:pPr algn="l"/>
             <a:r>
-              <a:rPr sz="4400" b="1" i="0">
+              <a:rPr sz="5720" b="1" i="0">
                 <a:solidFill>
                   <a:srgbClr val="E8C96A"/>
                 </a:solidFill>
@@ -3251,7 +3251,7 @@
           <a:p>
             <a:pPr algn="l"/>
             <a:r>
-              <a:rPr sz="2200" b="0" i="1">
+              <a:rPr sz="2860" b="0" i="1">
                 <a:solidFill>
                   <a:srgbClr val="FFFFFF"/>
                 </a:solidFill>
@@ -3286,9 +3286,9 @@
           <a:p>
             <a:pPr algn="l"/>
             <a:r>
-              <a:rPr sz="2000" b="1" i="0">
-                <a:solidFill>
-                  <a:srgbClr val="5C3A1F"/>
+              <a:rPr sz="2600" b="1" i="0">
+                <a:solidFill>
+                  <a:srgbClr val="4A2D18"/>
                 </a:solidFill>
                 <a:latin typeface="Calibri"/>
               </a:rPr>
@@ -3312,7 +3312,7 @@
             <a:avLst/>
           </a:prstGeom>
           <a:solidFill>
-            <a:srgbClr val="C9A84C"/>
+            <a:srgbClr val="B8941A"/>
           </a:solidFill>
           <a:ln>
             <a:noFill/>
@@ -3364,9 +3364,9 @@
           <a:p>
             <a:pPr algn="l"/>
             <a:r>
-              <a:rPr sz="1400" b="0" i="0">
-                <a:solidFill>
-                  <a:srgbClr val="4A5568"/>
+              <a:rPr sz="1820" b="0" i="0">
+                <a:solidFill>
+                  <a:srgbClr val="2D3748"/>
                 </a:solidFill>
                 <a:latin typeface="Calibri"/>
               </a:rPr>
@@ -3417,9 +3417,9 @@
           <a:p>
             <a:pPr algn="l"/>
             <a:r>
-              <a:rPr sz="3200" b="1" i="0">
-                <a:solidFill>
-                  <a:srgbClr val="5C3A1F"/>
+              <a:rPr sz="4160" b="1" i="0">
+                <a:solidFill>
+                  <a:srgbClr val="4A2D18"/>
                 </a:solidFill>
                 <a:latin typeface="Calibri"/>
               </a:rPr>
@@ -3443,7 +3443,7 @@
             <a:avLst/>
           </a:prstGeom>
           <a:solidFill>
-            <a:srgbClr val="C9A84C"/>
+            <a:srgbClr val="B8941A"/>
           </a:solidFill>
           <a:ln>
             <a:noFill/>
@@ -3495,9 +3495,9 @@
           <a:p>
             <a:pPr algn="l"/>
             <a:r>
-              <a:rPr sz="1400" b="0" i="1">
-                <a:solidFill>
-                  <a:srgbClr val="4A5568"/>
+              <a:rPr sz="1820" b="0" i="1">
+                <a:solidFill>
+                  <a:srgbClr val="2D3748"/>
                 </a:solidFill>
                 <a:latin typeface="Calibri"/>
               </a:rPr>
@@ -3534,16 +3534,16 @@
               </a:lnSpc>
             </a:pPr>
             <a:r>
-              <a:rPr sz="1200" b="1">
-                <a:solidFill>
-                  <a:srgbClr val="C9A84C"/>
+              <a:rPr sz="1560" b="1">
+                <a:solidFill>
+                  <a:srgbClr val="B8941A"/>
                 </a:solidFill>
                 <a:latin typeface="Calibri"/>
               </a:rPr>
               <a:t>• </a:t>
             </a:r>
             <a:r>
-              <a:rPr sz="1000">
+              <a:rPr sz="1300">
                 <a:solidFill>
                   <a:srgbClr val="1E1508"/>
                 </a:solidFill>
@@ -3562,9 +3562,9 @@
               </a:spcBef>
             </a:pPr>
             <a:r>
-              <a:rPr sz="800" i="1">
-                <a:solidFill>
-                  <a:srgbClr val="5C3A1F"/>
+              <a:rPr sz="1040" i="1">
+                <a:solidFill>
+                  <a:srgbClr val="4A2D18"/>
                 </a:solidFill>
                 <a:latin typeface="Calibri"/>
               </a:rPr>
@@ -3581,16 +3581,16 @@
               </a:spcBef>
             </a:pPr>
             <a:r>
-              <a:rPr sz="1200" b="1">
-                <a:solidFill>
-                  <a:srgbClr val="C9A84C"/>
+              <a:rPr sz="1560" b="1">
+                <a:solidFill>
+                  <a:srgbClr val="B8941A"/>
                 </a:solidFill>
                 <a:latin typeface="Calibri"/>
               </a:rPr>
               <a:t>• </a:t>
             </a:r>
             <a:r>
-              <a:rPr sz="1000">
+              <a:rPr sz="1300">
                 <a:solidFill>
                   <a:srgbClr val="1E1508"/>
                 </a:solidFill>
@@ -3609,9 +3609,9 @@
               </a:spcBef>
             </a:pPr>
             <a:r>
-              <a:rPr sz="800" i="1">
-                <a:solidFill>
-                  <a:srgbClr val="5C3A1F"/>
+              <a:rPr sz="1040" i="1">
+                <a:solidFill>
+                  <a:srgbClr val="4A2D18"/>
                 </a:solidFill>
                 <a:latin typeface="Calibri"/>
               </a:rPr>
@@ -3628,16 +3628,16 @@
               </a:spcBef>
             </a:pPr>
             <a:r>
-              <a:rPr sz="1200" b="1">
-                <a:solidFill>
-                  <a:srgbClr val="C9A84C"/>
+              <a:rPr sz="1560" b="1">
+                <a:solidFill>
+                  <a:srgbClr val="B8941A"/>
                 </a:solidFill>
                 <a:latin typeface="Calibri"/>
               </a:rPr>
               <a:t>• </a:t>
             </a:r>
             <a:r>
-              <a:rPr sz="1000">
+              <a:rPr sz="1300">
                 <a:solidFill>
                   <a:srgbClr val="1E1508"/>
                 </a:solidFill>
@@ -3656,9 +3656,9 @@
               </a:spcBef>
             </a:pPr>
             <a:r>
-              <a:rPr sz="800" i="1">
-                <a:solidFill>
-                  <a:srgbClr val="5C3A1F"/>
+              <a:rPr sz="1040" i="1">
+                <a:solidFill>
+                  <a:srgbClr val="4A2D18"/>
                 </a:solidFill>
                 <a:latin typeface="Calibri"/>
               </a:rPr>
@@ -3675,16 +3675,16 @@
               </a:spcBef>
             </a:pPr>
             <a:r>
-              <a:rPr sz="1200" b="1">
-                <a:solidFill>
-                  <a:srgbClr val="C9A84C"/>
+              <a:rPr sz="1560" b="1">
+                <a:solidFill>
+                  <a:srgbClr val="B8941A"/>
                 </a:solidFill>
                 <a:latin typeface="Calibri"/>
               </a:rPr>
               <a:t>• </a:t>
             </a:r>
             <a:r>
-              <a:rPr sz="1000">
+              <a:rPr sz="1300">
                 <a:solidFill>
                   <a:srgbClr val="1E1508"/>
                 </a:solidFill>
@@ -3703,9 +3703,9 @@
               </a:spcBef>
             </a:pPr>
             <a:r>
-              <a:rPr sz="800" i="1">
-                <a:solidFill>
-                  <a:srgbClr val="5C3A1F"/>
+              <a:rPr sz="1040" i="1">
+                <a:solidFill>
+                  <a:srgbClr val="4A2D18"/>
                 </a:solidFill>
                 <a:latin typeface="Calibri"/>
               </a:rPr>
@@ -3722,16 +3722,16 @@
               </a:spcBef>
             </a:pPr>
             <a:r>
-              <a:rPr sz="1200" b="1">
-                <a:solidFill>
-                  <a:srgbClr val="C9A84C"/>
+              <a:rPr sz="1560" b="1">
+                <a:solidFill>
+                  <a:srgbClr val="B8941A"/>
                 </a:solidFill>
                 <a:latin typeface="Calibri"/>
               </a:rPr>
               <a:t>• </a:t>
             </a:r>
             <a:r>
-              <a:rPr sz="1000">
+              <a:rPr sz="1300">
                 <a:solidFill>
                   <a:srgbClr val="1E1508"/>
                 </a:solidFill>
@@ -3750,9 +3750,9 @@
               </a:spcBef>
             </a:pPr>
             <a:r>
-              <a:rPr sz="800" i="1">
-                <a:solidFill>
-                  <a:srgbClr val="5C3A1F"/>
+              <a:rPr sz="1040" i="1">
+                <a:solidFill>
+                  <a:srgbClr val="4A2D18"/>
                 </a:solidFill>
                 <a:latin typeface="Calibri"/>
               </a:rPr>
@@ -3769,16 +3769,16 @@
               </a:spcBef>
             </a:pPr>
             <a:r>
-              <a:rPr sz="1200" b="1">
-                <a:solidFill>
-                  <a:srgbClr val="C9A84C"/>
+              <a:rPr sz="1560" b="1">
+                <a:solidFill>
+                  <a:srgbClr val="B8941A"/>
                 </a:solidFill>
                 <a:latin typeface="Calibri"/>
               </a:rPr>
               <a:t>• </a:t>
             </a:r>
             <a:r>
-              <a:rPr sz="1000">
+              <a:rPr sz="1300">
                 <a:solidFill>
                   <a:srgbClr val="1E1508"/>
                 </a:solidFill>
@@ -3797,9 +3797,9 @@
               </a:spcBef>
             </a:pPr>
             <a:r>
-              <a:rPr sz="800" i="1">
-                <a:solidFill>
-                  <a:srgbClr val="5C3A1F"/>
+              <a:rPr sz="1040" i="1">
+                <a:solidFill>
+                  <a:srgbClr val="4A2D18"/>
                 </a:solidFill>
                 <a:latin typeface="Calibri"/>
               </a:rPr>
@@ -3816,16 +3816,16 @@
               </a:spcBef>
             </a:pPr>
             <a:r>
-              <a:rPr sz="1200" b="1">
-                <a:solidFill>
-                  <a:srgbClr val="C9A84C"/>
+              <a:rPr sz="1560" b="1">
+                <a:solidFill>
+                  <a:srgbClr val="B8941A"/>
                 </a:solidFill>
                 <a:latin typeface="Calibri"/>
               </a:rPr>
               <a:t>• </a:t>
             </a:r>
             <a:r>
-              <a:rPr sz="1000">
+              <a:rPr sz="1300">
                 <a:solidFill>
                   <a:srgbClr val="1E1508"/>
                 </a:solidFill>
@@ -3844,9 +3844,9 @@
               </a:spcBef>
             </a:pPr>
             <a:r>
-              <a:rPr sz="800" i="1">
-                <a:solidFill>
-                  <a:srgbClr val="5C3A1F"/>
+              <a:rPr sz="1040" i="1">
+                <a:solidFill>
+                  <a:srgbClr val="4A2D18"/>
                 </a:solidFill>
                 <a:latin typeface="Calibri"/>
               </a:rPr>
@@ -3863,16 +3863,16 @@
               </a:spcBef>
             </a:pPr>
             <a:r>
-              <a:rPr sz="1200" b="1">
-                <a:solidFill>
-                  <a:srgbClr val="C9A84C"/>
+              <a:rPr sz="1560" b="1">
+                <a:solidFill>
+                  <a:srgbClr val="B8941A"/>
                 </a:solidFill>
                 <a:latin typeface="Calibri"/>
               </a:rPr>
               <a:t>• </a:t>
             </a:r>
             <a:r>
-              <a:rPr sz="1000">
+              <a:rPr sz="1300">
                 <a:solidFill>
                   <a:srgbClr val="1E1508"/>
                 </a:solidFill>
@@ -3891,9 +3891,9 @@
               </a:spcBef>
             </a:pPr>
             <a:r>
-              <a:rPr sz="800" i="1">
-                <a:solidFill>
-                  <a:srgbClr val="5C3A1F"/>
+              <a:rPr sz="1040" i="1">
+                <a:solidFill>
+                  <a:srgbClr val="4A2D18"/>
                 </a:solidFill>
                 <a:latin typeface="Calibri"/>
               </a:rPr>
@@ -3910,16 +3910,16 @@
               </a:spcBef>
             </a:pPr>
             <a:r>
-              <a:rPr sz="1200" b="1">
-                <a:solidFill>
-                  <a:srgbClr val="C9A84C"/>
+              <a:rPr sz="1560" b="1">
+                <a:solidFill>
+                  <a:srgbClr val="B8941A"/>
                 </a:solidFill>
                 <a:latin typeface="Calibri"/>
               </a:rPr>
               <a:t>• </a:t>
             </a:r>
             <a:r>
-              <a:rPr sz="1000">
+              <a:rPr sz="1300">
                 <a:solidFill>
                   <a:srgbClr val="1E1508"/>
                 </a:solidFill>
@@ -3938,9 +3938,9 @@
               </a:spcBef>
             </a:pPr>
             <a:r>
-              <a:rPr sz="800" i="1">
-                <a:solidFill>
-                  <a:srgbClr val="5C3A1F"/>
+              <a:rPr sz="1040" i="1">
+                <a:solidFill>
+                  <a:srgbClr val="4A2D18"/>
                 </a:solidFill>
                 <a:latin typeface="Calibri"/>
               </a:rPr>
@@ -3973,9 +3973,9 @@
           <a:p>
             <a:pPr algn="l"/>
             <a:r>
-              <a:rPr sz="900" b="0" i="0">
-                <a:solidFill>
-                  <a:srgbClr val="4A5568"/>
+              <a:rPr sz="1170" b="0" i="0">
+                <a:solidFill>
+                  <a:srgbClr val="2D3748"/>
                 </a:solidFill>
                 <a:latin typeface="Calibri"/>
               </a:rPr>
@@ -4008,9 +4008,9 @@
           <a:p>
             <a:pPr algn="r"/>
             <a:r>
-              <a:rPr sz="900" b="0" i="0">
-                <a:solidFill>
-                  <a:srgbClr val="4A5568"/>
+              <a:rPr sz="1170" b="0" i="0">
+                <a:solidFill>
+                  <a:srgbClr val="2D3748"/>
                 </a:solidFill>
                 <a:latin typeface="Calibri"/>
               </a:rPr>
@@ -4034,7 +4034,7 @@
             <a:avLst/>
           </a:prstGeom>
           <a:solidFill>
-            <a:srgbClr val="C9A84C"/>
+            <a:srgbClr val="B8941A"/>
           </a:solidFill>
           <a:ln>
             <a:noFill/>
@@ -4104,9 +4104,9 @@
           <a:p>
             <a:pPr algn="l"/>
             <a:r>
-              <a:rPr sz="3200" b="1" i="0">
-                <a:solidFill>
-                  <a:srgbClr val="5C3A1F"/>
+              <a:rPr sz="4160" b="1" i="0">
+                <a:solidFill>
+                  <a:srgbClr val="4A2D18"/>
                 </a:solidFill>
                 <a:latin typeface="Calibri"/>
               </a:rPr>
@@ -4130,7 +4130,7 @@
             <a:avLst/>
           </a:prstGeom>
           <a:solidFill>
-            <a:srgbClr val="C9A84C"/>
+            <a:srgbClr val="B8941A"/>
           </a:solidFill>
           <a:ln>
             <a:noFill/>
@@ -4182,9 +4182,9 @@
           <a:p>
             <a:pPr algn="l"/>
             <a:r>
-              <a:rPr sz="1400" b="0" i="1">
-                <a:solidFill>
-                  <a:srgbClr val="4A5568"/>
+              <a:rPr sz="1820" b="0" i="1">
+                <a:solidFill>
+                  <a:srgbClr val="2D3748"/>
                 </a:solidFill>
                 <a:latin typeface="Calibri"/>
               </a:rPr>
@@ -4217,9 +4217,9 @@
           <a:p>
             <a:pPr algn="l"/>
             <a:r>
-              <a:rPr sz="1400" b="1" i="0">
-                <a:solidFill>
-                  <a:srgbClr val="C9A84C"/>
+              <a:rPr sz="1820" b="1" i="0">
+                <a:solidFill>
+                  <a:srgbClr val="B8941A"/>
                 </a:solidFill>
                 <a:latin typeface="Calibri"/>
               </a:rPr>
@@ -4256,16 +4256,16 @@
               </a:lnSpc>
             </a:pPr>
             <a:r>
-              <a:rPr sz="1200" b="1">
-                <a:solidFill>
-                  <a:srgbClr val="C9A84C"/>
+              <a:rPr sz="1560" b="1">
+                <a:solidFill>
+                  <a:srgbClr val="B8941A"/>
                 </a:solidFill>
                 <a:latin typeface="Calibri"/>
               </a:rPr>
               <a:t>• </a:t>
             </a:r>
             <a:r>
-              <a:rPr sz="1000">
+              <a:rPr sz="1300">
                 <a:solidFill>
                   <a:srgbClr val="1E1508"/>
                 </a:solidFill>
@@ -4284,9 +4284,9 @@
               </a:spcBef>
             </a:pPr>
             <a:r>
-              <a:rPr sz="800" i="1">
-                <a:solidFill>
-                  <a:srgbClr val="5C3A1F"/>
+              <a:rPr sz="1040" i="1">
+                <a:solidFill>
+                  <a:srgbClr val="4A2D18"/>
                 </a:solidFill>
                 <a:latin typeface="Calibri"/>
               </a:rPr>
@@ -4303,16 +4303,16 @@
               </a:spcBef>
             </a:pPr>
             <a:r>
-              <a:rPr sz="1200" b="1">
-                <a:solidFill>
-                  <a:srgbClr val="C9A84C"/>
+              <a:rPr sz="1560" b="1">
+                <a:solidFill>
+                  <a:srgbClr val="B8941A"/>
                 </a:solidFill>
                 <a:latin typeface="Calibri"/>
               </a:rPr>
               <a:t>• </a:t>
             </a:r>
             <a:r>
-              <a:rPr sz="1000">
+              <a:rPr sz="1300">
                 <a:solidFill>
                   <a:srgbClr val="1E1508"/>
                 </a:solidFill>
@@ -4331,9 +4331,9 @@
               </a:spcBef>
             </a:pPr>
             <a:r>
-              <a:rPr sz="800" i="1">
-                <a:solidFill>
-                  <a:srgbClr val="5C3A1F"/>
+              <a:rPr sz="1040" i="1">
+                <a:solidFill>
+                  <a:srgbClr val="4A2D18"/>
                 </a:solidFill>
                 <a:latin typeface="Calibri"/>
               </a:rPr>
@@ -4350,16 +4350,16 @@
               </a:spcBef>
             </a:pPr>
             <a:r>
-              <a:rPr sz="1200" b="1">
-                <a:solidFill>
-                  <a:srgbClr val="C9A84C"/>
+              <a:rPr sz="1560" b="1">
+                <a:solidFill>
+                  <a:srgbClr val="B8941A"/>
                 </a:solidFill>
                 <a:latin typeface="Calibri"/>
               </a:rPr>
               <a:t>• </a:t>
             </a:r>
             <a:r>
-              <a:rPr sz="1000">
+              <a:rPr sz="1300">
                 <a:solidFill>
                   <a:srgbClr val="1E1508"/>
                 </a:solidFill>
@@ -4378,9 +4378,9 @@
               </a:spcBef>
             </a:pPr>
             <a:r>
-              <a:rPr sz="800" i="1">
-                <a:solidFill>
-                  <a:srgbClr val="5C3A1F"/>
+              <a:rPr sz="1040" i="1">
+                <a:solidFill>
+                  <a:srgbClr val="4A2D18"/>
                 </a:solidFill>
                 <a:latin typeface="Calibri"/>
               </a:rPr>
@@ -4397,16 +4397,16 @@
               </a:spcBef>
             </a:pPr>
             <a:r>
-              <a:rPr sz="1200" b="1">
-                <a:solidFill>
-                  <a:srgbClr val="C9A84C"/>
+              <a:rPr sz="1560" b="1">
+                <a:solidFill>
+                  <a:srgbClr val="B8941A"/>
                 </a:solidFill>
                 <a:latin typeface="Calibri"/>
               </a:rPr>
               <a:t>• </a:t>
             </a:r>
             <a:r>
-              <a:rPr sz="1000">
+              <a:rPr sz="1300">
                 <a:solidFill>
                   <a:srgbClr val="1E1508"/>
                 </a:solidFill>
@@ -4425,9 +4425,9 @@
               </a:spcBef>
             </a:pPr>
             <a:r>
-              <a:rPr sz="800" i="1">
-                <a:solidFill>
-                  <a:srgbClr val="5C3A1F"/>
+              <a:rPr sz="1040" i="1">
+                <a:solidFill>
+                  <a:srgbClr val="4A2D18"/>
                 </a:solidFill>
                 <a:latin typeface="Calibri"/>
               </a:rPr>
@@ -4444,16 +4444,16 @@
               </a:spcBef>
             </a:pPr>
             <a:r>
-              <a:rPr sz="1200" b="1">
-                <a:solidFill>
-                  <a:srgbClr val="C9A84C"/>
+              <a:rPr sz="1560" b="1">
+                <a:solidFill>
+                  <a:srgbClr val="B8941A"/>
                 </a:solidFill>
                 <a:latin typeface="Calibri"/>
               </a:rPr>
               <a:t>• </a:t>
             </a:r>
             <a:r>
-              <a:rPr sz="1000">
+              <a:rPr sz="1300">
                 <a:solidFill>
                   <a:srgbClr val="1E1508"/>
                 </a:solidFill>
@@ -4472,9 +4472,9 @@
               </a:spcBef>
             </a:pPr>
             <a:r>
-              <a:rPr sz="800" i="1">
-                <a:solidFill>
-                  <a:srgbClr val="5C3A1F"/>
+              <a:rPr sz="1040" i="1">
+                <a:solidFill>
+                  <a:srgbClr val="4A2D18"/>
                 </a:solidFill>
                 <a:latin typeface="Calibri"/>
               </a:rPr>
@@ -4491,16 +4491,16 @@
               </a:spcBef>
             </a:pPr>
             <a:r>
-              <a:rPr sz="1200" b="1">
-                <a:solidFill>
-                  <a:srgbClr val="C9A84C"/>
+              <a:rPr sz="1560" b="1">
+                <a:solidFill>
+                  <a:srgbClr val="B8941A"/>
                 </a:solidFill>
                 <a:latin typeface="Calibri"/>
               </a:rPr>
               <a:t>• </a:t>
             </a:r>
             <a:r>
-              <a:rPr sz="1000">
+              <a:rPr sz="1300">
                 <a:solidFill>
                   <a:srgbClr val="1E1508"/>
                 </a:solidFill>
@@ -4519,9 +4519,9 @@
               </a:spcBef>
             </a:pPr>
             <a:r>
-              <a:rPr sz="800" i="1">
-                <a:solidFill>
-                  <a:srgbClr val="5C3A1F"/>
+              <a:rPr sz="1040" i="1">
+                <a:solidFill>
+                  <a:srgbClr val="4A2D18"/>
                 </a:solidFill>
                 <a:latin typeface="Calibri"/>
               </a:rPr>
@@ -4554,9 +4554,9 @@
           <a:p>
             <a:pPr algn="l"/>
             <a:r>
-              <a:rPr sz="1400" b="1" i="0">
-                <a:solidFill>
-                  <a:srgbClr val="C9A84C"/>
+              <a:rPr sz="1820" b="1" i="0">
+                <a:solidFill>
+                  <a:srgbClr val="B8941A"/>
                 </a:solidFill>
                 <a:latin typeface="Calibri"/>
               </a:rPr>
@@ -4633,9 +4633,9 @@
           <a:p>
             <a:pPr algn="l"/>
             <a:r>
-              <a:rPr sz="1100" b="1" i="0">
-                <a:solidFill>
-                  <a:srgbClr val="5C3A1F"/>
+              <a:rPr sz="1430" b="1" i="0">
+                <a:solidFill>
+                  <a:srgbClr val="4A2D18"/>
                 </a:solidFill>
                 <a:latin typeface="Calibri"/>
               </a:rPr>
@@ -4668,9 +4668,9 @@
           <a:p>
             <a:pPr algn="l"/>
             <a:r>
-              <a:rPr sz="1100" b="1" i="0">
-                <a:solidFill>
-                  <a:srgbClr val="5C3A1F"/>
+              <a:rPr sz="1430" b="1" i="0">
+                <a:solidFill>
+                  <a:srgbClr val="4A2D18"/>
                 </a:solidFill>
                 <a:latin typeface="Calibri"/>
               </a:rPr>
@@ -4694,7 +4694,7 @@
             <a:avLst/>
           </a:prstGeom>
           <a:solidFill>
-            <a:srgbClr val="C9A84C"/>
+            <a:srgbClr val="B8941A"/>
           </a:solidFill>
           <a:ln>
             <a:noFill/>
@@ -4790,7 +4790,7 @@
           <a:p>
             <a:pPr algn="l"/>
             <a:r>
-              <a:rPr sz="1000" b="0" i="0">
+              <a:rPr sz="1300" b="0" i="0">
                 <a:solidFill>
                   <a:srgbClr val="1E1508"/>
                 </a:solidFill>
@@ -4825,7 +4825,7 @@
           <a:p>
             <a:pPr algn="l"/>
             <a:r>
-              <a:rPr sz="1000" b="0" i="0">
+              <a:rPr sz="1300" b="0" i="0">
                 <a:solidFill>
                   <a:srgbClr val="1E1508"/>
                 </a:solidFill>
@@ -4860,7 +4860,7 @@
           <a:p>
             <a:pPr algn="l"/>
             <a:r>
-              <a:rPr sz="1000" b="0" i="0">
+              <a:rPr sz="1300" b="0" i="0">
                 <a:solidFill>
                   <a:srgbClr val="1E1508"/>
                 </a:solidFill>
@@ -4895,7 +4895,7 @@
           <a:p>
             <a:pPr algn="l"/>
             <a:r>
-              <a:rPr sz="1000" b="0" i="0">
+              <a:rPr sz="1300" b="0" i="0">
                 <a:solidFill>
                   <a:srgbClr val="1E1508"/>
                 </a:solidFill>
@@ -4974,7 +4974,7 @@
           <a:p>
             <a:pPr algn="l"/>
             <a:r>
-              <a:rPr sz="1000" b="0" i="0">
+              <a:rPr sz="1300" b="0" i="0">
                 <a:solidFill>
                   <a:srgbClr val="1E1508"/>
                 </a:solidFill>
@@ -5009,7 +5009,7 @@
           <a:p>
             <a:pPr algn="l"/>
             <a:r>
-              <a:rPr sz="1000" b="0" i="0">
+              <a:rPr sz="1300" b="0" i="0">
                 <a:solidFill>
                   <a:srgbClr val="1E1508"/>
                 </a:solidFill>
@@ -5044,7 +5044,7 @@
           <a:p>
             <a:pPr algn="l"/>
             <a:r>
-              <a:rPr sz="1000" b="0" i="0">
+              <a:rPr sz="1300" b="0" i="0">
                 <a:solidFill>
                   <a:srgbClr val="1E1508"/>
                 </a:solidFill>
@@ -5079,7 +5079,7 @@
           <a:p>
             <a:pPr algn="l"/>
             <a:r>
-              <a:rPr sz="1000" b="0" i="0">
+              <a:rPr sz="1300" b="0" i="0">
                 <a:solidFill>
                   <a:srgbClr val="1E1508"/>
                 </a:solidFill>
@@ -5109,7 +5109,7 @@
           </a:solidFill>
           <a:ln w="6350">
             <a:solidFill>
-              <a:srgbClr val="C9A84C"/>
+              <a:srgbClr val="B8941A"/>
             </a:solidFill>
           </a:ln>
           <a:effectLst/>
@@ -5160,9 +5160,9 @@
           <a:p>
             <a:pPr algn="ctr"/>
             <a:r>
-              <a:rPr sz="1100" b="0" i="1">
-                <a:solidFill>
-                  <a:srgbClr val="5C3A1F"/>
+              <a:rPr sz="1430" b="0" i="1">
+                <a:solidFill>
+                  <a:srgbClr val="4A2D18"/>
                 </a:solidFill>
                 <a:latin typeface="Calibri"/>
               </a:rPr>
@@ -5195,9 +5195,9 @@
           <a:p>
             <a:pPr algn="l"/>
             <a:r>
-              <a:rPr sz="900" b="0" i="0">
-                <a:solidFill>
-                  <a:srgbClr val="4A5568"/>
+              <a:rPr sz="1170" b="0" i="0">
+                <a:solidFill>
+                  <a:srgbClr val="2D3748"/>
                 </a:solidFill>
                 <a:latin typeface="Calibri"/>
               </a:rPr>
@@ -5230,9 +5230,9 @@
           <a:p>
             <a:pPr algn="r"/>
             <a:r>
-              <a:rPr sz="900" b="0" i="0">
-                <a:solidFill>
-                  <a:srgbClr val="4A5568"/>
+              <a:rPr sz="1170" b="0" i="0">
+                <a:solidFill>
+                  <a:srgbClr val="2D3748"/>
                 </a:solidFill>
                 <a:latin typeface="Calibri"/>
               </a:rPr>
@@ -5256,7 +5256,7 @@
             <a:avLst/>
           </a:prstGeom>
           <a:solidFill>
-            <a:srgbClr val="C9A84C"/>
+            <a:srgbClr val="B8941A"/>
           </a:solidFill>
           <a:ln>
             <a:noFill/>
@@ -5326,9 +5326,9 @@
           <a:p>
             <a:pPr algn="l"/>
             <a:r>
-              <a:rPr sz="3200" b="1" i="0">
-                <a:solidFill>
-                  <a:srgbClr val="5C3A1F"/>
+              <a:rPr sz="4160" b="1" i="0">
+                <a:solidFill>
+                  <a:srgbClr val="4A2D18"/>
                 </a:solidFill>
                 <a:latin typeface="Calibri"/>
               </a:rPr>
@@ -5352,7 +5352,7 @@
             <a:avLst/>
           </a:prstGeom>
           <a:solidFill>
-            <a:srgbClr val="C9A84C"/>
+            <a:srgbClr val="B8941A"/>
           </a:solidFill>
           <a:ln>
             <a:noFill/>
@@ -5404,9 +5404,9 @@
           <a:p>
             <a:pPr algn="l"/>
             <a:r>
-              <a:rPr sz="1400" b="0" i="1">
-                <a:solidFill>
-                  <a:srgbClr val="4A5568"/>
+              <a:rPr sz="1820" b="0" i="1">
+                <a:solidFill>
+                  <a:srgbClr val="2D3748"/>
                 </a:solidFill>
                 <a:latin typeface="Calibri"/>
               </a:rPr>
@@ -5485,9 +5485,9 @@
           <a:p>
             <a:pPr algn="ctr"/>
             <a:r>
-              <a:rPr sz="4400" b="1" i="0">
-                <a:solidFill>
-                  <a:srgbClr val="C9A84C"/>
+              <a:rPr sz="5720" b="1" i="0">
+                <a:solidFill>
+                  <a:srgbClr val="B8941A"/>
                 </a:solidFill>
                 <a:latin typeface="Calibri"/>
               </a:rPr>
@@ -5520,9 +5520,9 @@
           <a:p>
             <a:pPr algn="ctr"/>
             <a:r>
-              <a:rPr sz="1100" b="0" i="0">
-                <a:solidFill>
-                  <a:srgbClr val="4A5568"/>
+              <a:rPr sz="1430" b="0" i="0">
+                <a:solidFill>
+                  <a:srgbClr val="2D3748"/>
                 </a:solidFill>
                 <a:latin typeface="Calibri"/>
               </a:rPr>
@@ -5602,9 +5602,9 @@
           <a:p>
             <a:pPr algn="ctr"/>
             <a:r>
-              <a:rPr sz="4400" b="1" i="0">
-                <a:solidFill>
-                  <a:srgbClr val="C9A84C"/>
+              <a:rPr sz="5720" b="1" i="0">
+                <a:solidFill>
+                  <a:srgbClr val="B8941A"/>
                 </a:solidFill>
                 <a:latin typeface="Calibri"/>
               </a:rPr>
@@ -5637,9 +5637,9 @@
           <a:p>
             <a:pPr algn="ctr"/>
             <a:r>
-              <a:rPr sz="1100" b="0" i="0">
-                <a:solidFill>
-                  <a:srgbClr val="4A5568"/>
+              <a:rPr sz="1430" b="0" i="0">
+                <a:solidFill>
+                  <a:srgbClr val="2D3748"/>
                 </a:solidFill>
                 <a:latin typeface="Calibri"/>
               </a:rPr>
@@ -5719,9 +5719,9 @@
           <a:p>
             <a:pPr algn="ctr"/>
             <a:r>
-              <a:rPr sz="4400" b="1" i="0">
-                <a:solidFill>
-                  <a:srgbClr val="C9A84C"/>
+              <a:rPr sz="5720" b="1" i="0">
+                <a:solidFill>
+                  <a:srgbClr val="B8941A"/>
                 </a:solidFill>
                 <a:latin typeface="Calibri"/>
               </a:rPr>
@@ -5754,9 +5754,9 @@
           <a:p>
             <a:pPr algn="ctr"/>
             <a:r>
-              <a:rPr sz="1100" b="0" i="0">
-                <a:solidFill>
-                  <a:srgbClr val="4A5568"/>
+              <a:rPr sz="1430" b="0" i="0">
+                <a:solidFill>
+                  <a:srgbClr val="2D3748"/>
                 </a:solidFill>
                 <a:latin typeface="Calibri"/>
               </a:rPr>
@@ -5836,9 +5836,9 @@
           <a:p>
             <a:pPr algn="ctr"/>
             <a:r>
-              <a:rPr sz="4400" b="1" i="0">
-                <a:solidFill>
-                  <a:srgbClr val="C9A84C"/>
+              <a:rPr sz="5720" b="1" i="0">
+                <a:solidFill>
+                  <a:srgbClr val="B8941A"/>
                 </a:solidFill>
                 <a:latin typeface="Calibri"/>
               </a:rPr>
@@ -5871,9 +5871,9 @@
           <a:p>
             <a:pPr algn="ctr"/>
             <a:r>
-              <a:rPr sz="1100" b="0" i="0">
-                <a:solidFill>
-                  <a:srgbClr val="4A5568"/>
+              <a:rPr sz="1430" b="0" i="0">
+                <a:solidFill>
+                  <a:srgbClr val="2D3748"/>
                 </a:solidFill>
                 <a:latin typeface="Calibri"/>
               </a:rPr>
@@ -5907,9 +5907,9 @@
           <a:p>
             <a:pPr algn="l"/>
             <a:r>
-              <a:rPr sz="1400" b="1" i="0">
-                <a:solidFill>
-                  <a:srgbClr val="C9A84C"/>
+              <a:rPr sz="1820" b="1" i="0">
+                <a:solidFill>
+                  <a:srgbClr val="B8941A"/>
                 </a:solidFill>
                 <a:latin typeface="Calibri"/>
               </a:rPr>
@@ -5946,16 +5946,16 @@
               </a:lnSpc>
             </a:pPr>
             <a:r>
-              <a:rPr sz="1400" b="1">
-                <a:solidFill>
-                  <a:srgbClr val="C9A84C"/>
+              <a:rPr sz="1820" b="1">
+                <a:solidFill>
+                  <a:srgbClr val="B8941A"/>
                 </a:solidFill>
                 <a:latin typeface="Calibri"/>
               </a:rPr>
               <a:t>• </a:t>
             </a:r>
             <a:r>
-              <a:rPr sz="1200">
+              <a:rPr sz="1560">
                 <a:solidFill>
                   <a:srgbClr val="1E1508"/>
                 </a:solidFill>
@@ -5974,16 +5974,16 @@
               </a:spcBef>
             </a:pPr>
             <a:r>
-              <a:rPr sz="1400" b="1">
-                <a:solidFill>
-                  <a:srgbClr val="C9A84C"/>
+              <a:rPr sz="1820" b="1">
+                <a:solidFill>
+                  <a:srgbClr val="B8941A"/>
                 </a:solidFill>
                 <a:latin typeface="Calibri"/>
               </a:rPr>
               <a:t>• </a:t>
             </a:r>
             <a:r>
-              <a:rPr sz="1200">
+              <a:rPr sz="1560">
                 <a:solidFill>
                   <a:srgbClr val="1E1508"/>
                 </a:solidFill>
@@ -6002,16 +6002,16 @@
               </a:spcBef>
             </a:pPr>
             <a:r>
-              <a:rPr sz="1400" b="1">
-                <a:solidFill>
-                  <a:srgbClr val="C9A84C"/>
+              <a:rPr sz="1820" b="1">
+                <a:solidFill>
+                  <a:srgbClr val="B8941A"/>
                 </a:solidFill>
                 <a:latin typeface="Calibri"/>
               </a:rPr>
               <a:t>• </a:t>
             </a:r>
             <a:r>
-              <a:rPr sz="1200">
+              <a:rPr sz="1560">
                 <a:solidFill>
                   <a:srgbClr val="1E1508"/>
                 </a:solidFill>
@@ -6030,16 +6030,16 @@
               </a:spcBef>
             </a:pPr>
             <a:r>
-              <a:rPr sz="1400" b="1">
-                <a:solidFill>
-                  <a:srgbClr val="C9A84C"/>
+              <a:rPr sz="1820" b="1">
+                <a:solidFill>
+                  <a:srgbClr val="B8941A"/>
                 </a:solidFill>
                 <a:latin typeface="Calibri"/>
               </a:rPr>
               <a:t>• </a:t>
             </a:r>
             <a:r>
-              <a:rPr sz="1200">
+              <a:rPr sz="1560">
                 <a:solidFill>
                   <a:srgbClr val="1E1508"/>
                 </a:solidFill>
@@ -6058,16 +6058,16 @@
               </a:spcBef>
             </a:pPr>
             <a:r>
-              <a:rPr sz="1400" b="1">
-                <a:solidFill>
-                  <a:srgbClr val="C9A84C"/>
+              <a:rPr sz="1820" b="1">
+                <a:solidFill>
+                  <a:srgbClr val="B8941A"/>
                 </a:solidFill>
                 <a:latin typeface="Calibri"/>
               </a:rPr>
               <a:t>• </a:t>
             </a:r>
             <a:r>
-              <a:rPr sz="1200">
+              <a:rPr sz="1560">
                 <a:solidFill>
                   <a:srgbClr val="1E1508"/>
                 </a:solidFill>
@@ -6086,16 +6086,16 @@
               </a:spcBef>
             </a:pPr>
             <a:r>
-              <a:rPr sz="1400" b="1">
-                <a:solidFill>
-                  <a:srgbClr val="C9A84C"/>
+              <a:rPr sz="1820" b="1">
+                <a:solidFill>
+                  <a:srgbClr val="B8941A"/>
                 </a:solidFill>
                 <a:latin typeface="Calibri"/>
               </a:rPr>
               <a:t>• </a:t>
             </a:r>
             <a:r>
-              <a:rPr sz="1200">
+              <a:rPr sz="1560">
                 <a:solidFill>
                   <a:srgbClr val="1E1508"/>
                 </a:solidFill>
@@ -6130,9 +6130,9 @@
           <a:p>
             <a:pPr algn="l"/>
             <a:r>
-              <a:rPr sz="900" b="0" i="0">
-                <a:solidFill>
-                  <a:srgbClr val="4A5568"/>
+              <a:rPr sz="1170" b="0" i="0">
+                <a:solidFill>
+                  <a:srgbClr val="2D3748"/>
                 </a:solidFill>
                 <a:latin typeface="Calibri"/>
               </a:rPr>
@@ -6165,9 +6165,9 @@
           <a:p>
             <a:pPr algn="r"/>
             <a:r>
-              <a:rPr sz="900" b="0" i="0">
-                <a:solidFill>
-                  <a:srgbClr val="4A5568"/>
+              <a:rPr sz="1170" b="0" i="0">
+                <a:solidFill>
+                  <a:srgbClr val="2D3748"/>
                 </a:solidFill>
                 <a:latin typeface="Calibri"/>
               </a:rPr>
@@ -6191,7 +6191,7 @@
             <a:avLst/>
           </a:prstGeom>
           <a:solidFill>
-            <a:srgbClr val="C9A84C"/>
+            <a:srgbClr val="B8941A"/>
           </a:solidFill>
           <a:ln>
             <a:noFill/>
@@ -6261,9 +6261,9 @@
           <a:p>
             <a:pPr algn="l"/>
             <a:r>
-              <a:rPr sz="3200" b="1" i="0">
-                <a:solidFill>
-                  <a:srgbClr val="5C3A1F"/>
+              <a:rPr sz="4160" b="1" i="0">
+                <a:solidFill>
+                  <a:srgbClr val="4A2D18"/>
                 </a:solidFill>
                 <a:latin typeface="Calibri"/>
               </a:rPr>
@@ -6287,7 +6287,7 @@
             <a:avLst/>
           </a:prstGeom>
           <a:solidFill>
-            <a:srgbClr val="C9A84C"/>
+            <a:srgbClr val="B8941A"/>
           </a:solidFill>
           <a:ln>
             <a:noFill/>
@@ -6339,9 +6339,9 @@
           <a:p>
             <a:pPr algn="l"/>
             <a:r>
-              <a:rPr sz="1400" b="0" i="1">
-                <a:solidFill>
-                  <a:srgbClr val="4A5568"/>
+              <a:rPr sz="1820" b="0" i="1">
+                <a:solidFill>
+                  <a:srgbClr val="2D3748"/>
                 </a:solidFill>
                 <a:latin typeface="Calibri"/>
               </a:rPr>
@@ -6374,9 +6374,9 @@
           <a:p>
             <a:pPr algn="l"/>
             <a:r>
-              <a:rPr sz="1200" b="1" i="0">
-                <a:solidFill>
-                  <a:srgbClr val="C9A84C"/>
+              <a:rPr sz="1560" b="1" i="0">
+                <a:solidFill>
+                  <a:srgbClr val="B8941A"/>
                 </a:solidFill>
                 <a:latin typeface="Calibri"/>
               </a:rPr>
@@ -6413,16 +6413,16 @@
               </a:lnSpc>
             </a:pPr>
             <a:r>
-              <a:rPr sz="1100" b="1">
-                <a:solidFill>
-                  <a:srgbClr val="C9A84C"/>
+              <a:rPr sz="1430" b="1">
+                <a:solidFill>
+                  <a:srgbClr val="B8941A"/>
                 </a:solidFill>
                 <a:latin typeface="Calibri"/>
               </a:rPr>
               <a:t>• </a:t>
             </a:r>
             <a:r>
-              <a:rPr sz="900">
+              <a:rPr sz="1170">
                 <a:solidFill>
                   <a:srgbClr val="1E1508"/>
                 </a:solidFill>
@@ -6441,16 +6441,16 @@
               </a:spcBef>
             </a:pPr>
             <a:r>
-              <a:rPr sz="1100" b="1">
-                <a:solidFill>
-                  <a:srgbClr val="C9A84C"/>
+              <a:rPr sz="1430" b="1">
+                <a:solidFill>
+                  <a:srgbClr val="B8941A"/>
                 </a:solidFill>
                 <a:latin typeface="Calibri"/>
               </a:rPr>
               <a:t>• </a:t>
             </a:r>
             <a:r>
-              <a:rPr sz="900">
+              <a:rPr sz="1170">
                 <a:solidFill>
                   <a:srgbClr val="1E1508"/>
                 </a:solidFill>
@@ -6469,16 +6469,16 @@
               </a:spcBef>
             </a:pPr>
             <a:r>
-              <a:rPr sz="1100" b="1">
-                <a:solidFill>
-                  <a:srgbClr val="C9A84C"/>
+              <a:rPr sz="1430" b="1">
+                <a:solidFill>
+                  <a:srgbClr val="B8941A"/>
                 </a:solidFill>
                 <a:latin typeface="Calibri"/>
               </a:rPr>
               <a:t>• </a:t>
             </a:r>
             <a:r>
-              <a:rPr sz="900">
+              <a:rPr sz="1170">
                 <a:solidFill>
                   <a:srgbClr val="1E1508"/>
                 </a:solidFill>
@@ -6497,16 +6497,16 @@
               </a:spcBef>
             </a:pPr>
             <a:r>
-              <a:rPr sz="1100" b="1">
-                <a:solidFill>
-                  <a:srgbClr val="C9A84C"/>
+              <a:rPr sz="1430" b="1">
+                <a:solidFill>
+                  <a:srgbClr val="B8941A"/>
                 </a:solidFill>
                 <a:latin typeface="Calibri"/>
               </a:rPr>
               <a:t>• </a:t>
             </a:r>
             <a:r>
-              <a:rPr sz="900">
+              <a:rPr sz="1170">
                 <a:solidFill>
                   <a:srgbClr val="1E1508"/>
                 </a:solidFill>
@@ -6541,9 +6541,9 @@
           <a:p>
             <a:pPr algn="l"/>
             <a:r>
-              <a:rPr sz="1200" b="1" i="0">
-                <a:solidFill>
-                  <a:srgbClr val="C9A84C"/>
+              <a:rPr sz="1560" b="1" i="0">
+                <a:solidFill>
+                  <a:srgbClr val="B8941A"/>
                 </a:solidFill>
                 <a:latin typeface="Calibri"/>
               </a:rPr>
@@ -6580,16 +6580,16 @@
               </a:lnSpc>
             </a:pPr>
             <a:r>
-              <a:rPr sz="1100" b="1">
-                <a:solidFill>
-                  <a:srgbClr val="C9A84C"/>
+              <a:rPr sz="1430" b="1">
+                <a:solidFill>
+                  <a:srgbClr val="B8941A"/>
                 </a:solidFill>
                 <a:latin typeface="Calibri"/>
               </a:rPr>
               <a:t>• </a:t>
             </a:r>
             <a:r>
-              <a:rPr sz="900">
+              <a:rPr sz="1170">
                 <a:solidFill>
                   <a:srgbClr val="1E1508"/>
                 </a:solidFill>
@@ -6608,16 +6608,16 @@
               </a:spcBef>
             </a:pPr>
             <a:r>
-              <a:rPr sz="1100" b="1">
-                <a:solidFill>
-                  <a:srgbClr val="C9A84C"/>
+              <a:rPr sz="1430" b="1">
+                <a:solidFill>
+                  <a:srgbClr val="B8941A"/>
                 </a:solidFill>
                 <a:latin typeface="Calibri"/>
               </a:rPr>
               <a:t>• </a:t>
             </a:r>
             <a:r>
-              <a:rPr sz="900">
+              <a:rPr sz="1170">
                 <a:solidFill>
                   <a:srgbClr val="1E1508"/>
                 </a:solidFill>
@@ -6636,16 +6636,16 @@
               </a:spcBef>
             </a:pPr>
             <a:r>
-              <a:rPr sz="1100" b="1">
-                <a:solidFill>
-                  <a:srgbClr val="C9A84C"/>
+              <a:rPr sz="1430" b="1">
+                <a:solidFill>
+                  <a:srgbClr val="B8941A"/>
                 </a:solidFill>
                 <a:latin typeface="Calibri"/>
               </a:rPr>
               <a:t>• </a:t>
             </a:r>
             <a:r>
-              <a:rPr sz="900">
+              <a:rPr sz="1170">
                 <a:solidFill>
                   <a:srgbClr val="1E1508"/>
                 </a:solidFill>
@@ -6664,16 +6664,16 @@
               </a:spcBef>
             </a:pPr>
             <a:r>
-              <a:rPr sz="1100" b="1">
-                <a:solidFill>
-                  <a:srgbClr val="C9A84C"/>
+              <a:rPr sz="1430" b="1">
+                <a:solidFill>
+                  <a:srgbClr val="B8941A"/>
                 </a:solidFill>
                 <a:latin typeface="Calibri"/>
               </a:rPr>
               <a:t>• </a:t>
             </a:r>
             <a:r>
-              <a:rPr sz="900">
+              <a:rPr sz="1170">
                 <a:solidFill>
                   <a:srgbClr val="1E1508"/>
                 </a:solidFill>
@@ -6708,9 +6708,9 @@
           <a:p>
             <a:pPr algn="l"/>
             <a:r>
-              <a:rPr sz="1200" b="1" i="0">
-                <a:solidFill>
-                  <a:srgbClr val="C9A84C"/>
+              <a:rPr sz="1560" b="1" i="0">
+                <a:solidFill>
+                  <a:srgbClr val="B8941A"/>
                 </a:solidFill>
                 <a:latin typeface="Calibri"/>
               </a:rPr>
@@ -6747,16 +6747,16 @@
               </a:lnSpc>
             </a:pPr>
             <a:r>
-              <a:rPr sz="1050" b="1">
-                <a:solidFill>
-                  <a:srgbClr val="C9A84C"/>
+              <a:rPr sz="1365" b="1">
+                <a:solidFill>
+                  <a:srgbClr val="B8941A"/>
                 </a:solidFill>
                 <a:latin typeface="Calibri"/>
               </a:rPr>
               <a:t>• </a:t>
             </a:r>
             <a:r>
-              <a:rPr sz="850">
+              <a:rPr sz="1105">
                 <a:solidFill>
                   <a:srgbClr val="1E1508"/>
                 </a:solidFill>
@@ -6775,16 +6775,16 @@
               </a:spcBef>
             </a:pPr>
             <a:r>
-              <a:rPr sz="1050" b="1">
-                <a:solidFill>
-                  <a:srgbClr val="C9A84C"/>
+              <a:rPr sz="1365" b="1">
+                <a:solidFill>
+                  <a:srgbClr val="B8941A"/>
                 </a:solidFill>
                 <a:latin typeface="Calibri"/>
               </a:rPr>
               <a:t>• </a:t>
             </a:r>
             <a:r>
-              <a:rPr sz="850">
+              <a:rPr sz="1105">
                 <a:solidFill>
                   <a:srgbClr val="1E1508"/>
                 </a:solidFill>
@@ -6803,16 +6803,16 @@
               </a:spcBef>
             </a:pPr>
             <a:r>
-              <a:rPr sz="1050" b="1">
-                <a:solidFill>
-                  <a:srgbClr val="C9A84C"/>
+              <a:rPr sz="1365" b="1">
+                <a:solidFill>
+                  <a:srgbClr val="B8941A"/>
                 </a:solidFill>
                 <a:latin typeface="Calibri"/>
               </a:rPr>
               <a:t>• </a:t>
             </a:r>
             <a:r>
-              <a:rPr sz="850">
+              <a:rPr sz="1105">
                 <a:solidFill>
                   <a:srgbClr val="1E1508"/>
                 </a:solidFill>
@@ -6831,16 +6831,16 @@
               </a:spcBef>
             </a:pPr>
             <a:r>
-              <a:rPr sz="1050" b="1">
-                <a:solidFill>
-                  <a:srgbClr val="C9A84C"/>
+              <a:rPr sz="1365" b="1">
+                <a:solidFill>
+                  <a:srgbClr val="B8941A"/>
                 </a:solidFill>
                 <a:latin typeface="Calibri"/>
               </a:rPr>
               <a:t>• </a:t>
             </a:r>
             <a:r>
-              <a:rPr sz="850">
+              <a:rPr sz="1105">
                 <a:solidFill>
                   <a:srgbClr val="1E1508"/>
                 </a:solidFill>
@@ -6859,16 +6859,16 @@
               </a:spcBef>
             </a:pPr>
             <a:r>
-              <a:rPr sz="1050" b="1">
-                <a:solidFill>
-                  <a:srgbClr val="C9A84C"/>
+              <a:rPr sz="1365" b="1">
+                <a:solidFill>
+                  <a:srgbClr val="B8941A"/>
                 </a:solidFill>
                 <a:latin typeface="Calibri"/>
               </a:rPr>
               <a:t>• </a:t>
             </a:r>
             <a:r>
-              <a:rPr sz="850">
+              <a:rPr sz="1105">
                 <a:solidFill>
                   <a:srgbClr val="1E1508"/>
                 </a:solidFill>
@@ -6887,16 +6887,16 @@
               </a:spcBef>
             </a:pPr>
             <a:r>
-              <a:rPr sz="1050" b="1">
-                <a:solidFill>
-                  <a:srgbClr val="C9A84C"/>
+              <a:rPr sz="1365" b="1">
+                <a:solidFill>
+                  <a:srgbClr val="B8941A"/>
                 </a:solidFill>
                 <a:latin typeface="Calibri"/>
               </a:rPr>
               <a:t>• </a:t>
             </a:r>
             <a:r>
-              <a:rPr sz="850">
+              <a:rPr sz="1105">
                 <a:solidFill>
                   <a:srgbClr val="1E1508"/>
                 </a:solidFill>
@@ -6926,7 +6926,7 @@
           </a:solidFill>
           <a:ln w="6350">
             <a:solidFill>
-              <a:srgbClr val="C9A84C"/>
+              <a:srgbClr val="B8941A"/>
             </a:solidFill>
           </a:ln>
           <a:effectLst/>
@@ -6977,9 +6977,9 @@
           <a:p>
             <a:pPr algn="ctr"/>
             <a:r>
-              <a:rPr sz="1000" b="0" i="1">
-                <a:solidFill>
-                  <a:srgbClr val="5C3A1F"/>
+              <a:rPr sz="1300" b="0" i="1">
+                <a:solidFill>
+                  <a:srgbClr val="4A2D18"/>
                 </a:solidFill>
                 <a:latin typeface="Calibri"/>
               </a:rPr>
@@ -7012,9 +7012,9 @@
           <a:p>
             <a:pPr algn="l"/>
             <a:r>
-              <a:rPr sz="900" b="0" i="0">
-                <a:solidFill>
-                  <a:srgbClr val="4A5568"/>
+              <a:rPr sz="1170" b="0" i="0">
+                <a:solidFill>
+                  <a:srgbClr val="2D3748"/>
                 </a:solidFill>
                 <a:latin typeface="Calibri"/>
               </a:rPr>
@@ -7047,9 +7047,9 @@
           <a:p>
             <a:pPr algn="r"/>
             <a:r>
-              <a:rPr sz="900" b="0" i="0">
-                <a:solidFill>
-                  <a:srgbClr val="4A5568"/>
+              <a:rPr sz="1170" b="0" i="0">
+                <a:solidFill>
+                  <a:srgbClr val="2D3748"/>
                 </a:solidFill>
                 <a:latin typeface="Calibri"/>
               </a:rPr>
@@ -7073,7 +7073,7 @@
             <a:avLst/>
           </a:prstGeom>
           <a:solidFill>
-            <a:srgbClr val="C9A84C"/>
+            <a:srgbClr val="B8941A"/>
           </a:solidFill>
           <a:ln>
             <a:noFill/>
@@ -7134,7 +7134,7 @@
             <a:avLst/>
           </a:prstGeom>
           <a:solidFill>
-            <a:srgbClr val="5C3A1F"/>
+            <a:srgbClr val="4A2D18"/>
           </a:solidFill>
           <a:ln>
             <a:noFill/>
@@ -7178,7 +7178,7 @@
             <a:avLst/>
           </a:prstGeom>
           <a:solidFill>
-            <a:srgbClr val="C9A84C"/>
+            <a:srgbClr val="B8941A"/>
           </a:solidFill>
           <a:ln>
             <a:noFill/>
@@ -7231,7 +7231,7 @@
           <a:p>
             <a:pPr algn="l"/>
             <a:r>
-              <a:rPr sz="4400" b="1" i="0">
+              <a:rPr sz="5720" b="1" i="0">
                 <a:solidFill>
                   <a:srgbClr val="E8C96A"/>
                 </a:solidFill>
@@ -7266,7 +7266,7 @@
           <a:p>
             <a:pPr algn="l"/>
             <a:r>
-              <a:rPr sz="2200" b="0" i="1">
+              <a:rPr sz="2860" b="0" i="1">
                 <a:solidFill>
                   <a:srgbClr val="FFFFFF"/>
                 </a:solidFill>
@@ -7301,9 +7301,9 @@
           <a:p>
             <a:pPr algn="l"/>
             <a:r>
-              <a:rPr sz="1400" b="1" i="0">
-                <a:solidFill>
-                  <a:srgbClr val="C9A84C"/>
+              <a:rPr sz="1820" b="1" i="0">
+                <a:solidFill>
+                  <a:srgbClr val="B8941A"/>
                 </a:solidFill>
                 <a:latin typeface="Calibri"/>
               </a:rPr>
@@ -7327,7 +7327,7 @@
             <a:avLst/>
           </a:prstGeom>
           <a:solidFill>
-            <a:srgbClr val="C9A84C"/>
+            <a:srgbClr val="B8941A"/>
           </a:solidFill>
           <a:ln>
             <a:noFill/>
@@ -7379,9 +7379,9 @@
           <a:p>
             <a:pPr algn="l"/>
             <a:r>
-              <a:rPr sz="1400" b="0" i="1">
-                <a:solidFill>
-                  <a:srgbClr val="5C3A1F"/>
+              <a:rPr sz="1820" b="0" i="1">
+                <a:solidFill>
+                  <a:srgbClr val="4A2D18"/>
                 </a:solidFill>
                 <a:latin typeface="Calibri"/>
               </a:rPr>
@@ -7414,9 +7414,9 @@
           <a:p>
             <a:pPr algn="l"/>
             <a:r>
-              <a:rPr sz="1100" b="0" i="0">
-                <a:solidFill>
-                  <a:srgbClr val="4A5568"/>
+              <a:rPr sz="1430" b="0" i="0">
+                <a:solidFill>
+                  <a:srgbClr val="2D3748"/>
                 </a:solidFill>
                 <a:latin typeface="Consolas"/>
               </a:rPr>
@@ -7469,9 +7469,9 @@
           <a:p>
             <a:pPr algn="r"/>
             <a:r>
-              <a:rPr sz="900" b="1" i="0">
-                <a:solidFill>
-                  <a:srgbClr val="C9A84C"/>
+              <a:rPr sz="1170" b="1" i="0">
+                <a:solidFill>
+                  <a:srgbClr val="B8941A"/>
                 </a:solidFill>
                 <a:latin typeface="Calibri"/>
               </a:rPr>
@@ -7504,9 +7504,9 @@
           <a:p>
             <a:pPr algn="l"/>
             <a:r>
-              <a:rPr sz="3200" b="1" i="0">
-                <a:solidFill>
-                  <a:srgbClr val="5C3A1F"/>
+              <a:rPr sz="4160" b="1" i="0">
+                <a:solidFill>
+                  <a:srgbClr val="4A2D18"/>
                 </a:solidFill>
                 <a:latin typeface="Calibri"/>
               </a:rPr>
@@ -7530,7 +7530,7 @@
             <a:avLst/>
           </a:prstGeom>
           <a:solidFill>
-            <a:srgbClr val="C9A84C"/>
+            <a:srgbClr val="B8941A"/>
           </a:solidFill>
           <a:ln>
             <a:noFill/>
@@ -7582,9 +7582,9 @@
           <a:p>
             <a:pPr algn="l"/>
             <a:r>
-              <a:rPr sz="1400" b="0" i="1">
-                <a:solidFill>
-                  <a:srgbClr val="4A5568"/>
+              <a:rPr sz="1820" b="0" i="1">
+                <a:solidFill>
+                  <a:srgbClr val="2D3748"/>
                 </a:solidFill>
                 <a:latin typeface="Calibri"/>
               </a:rPr>
@@ -7661,9 +7661,9 @@
           <a:p>
             <a:pPr algn="l"/>
             <a:r>
-              <a:rPr sz="1100" b="1" i="0">
-                <a:solidFill>
-                  <a:srgbClr val="5C3A1F"/>
+              <a:rPr sz="1430" b="1" i="0">
+                <a:solidFill>
+                  <a:srgbClr val="4A2D18"/>
                 </a:solidFill>
                 <a:latin typeface="Calibri"/>
               </a:rPr>
@@ -7696,9 +7696,9 @@
           <a:p>
             <a:pPr algn="l"/>
             <a:r>
-              <a:rPr sz="1100" b="1" i="0">
-                <a:solidFill>
-                  <a:srgbClr val="5C3A1F"/>
+              <a:rPr sz="1430" b="1" i="0">
+                <a:solidFill>
+                  <a:srgbClr val="4A2D18"/>
                 </a:solidFill>
                 <a:latin typeface="Calibri"/>
               </a:rPr>
@@ -7722,7 +7722,7 @@
             <a:avLst/>
           </a:prstGeom>
           <a:solidFill>
-            <a:srgbClr val="C9A84C"/>
+            <a:srgbClr val="B8941A"/>
           </a:solidFill>
           <a:ln>
             <a:noFill/>
@@ -7818,7 +7818,7 @@
           <a:p>
             <a:pPr algn="l"/>
             <a:r>
-              <a:rPr sz="1000" b="0" i="0">
+              <a:rPr sz="1300" b="0" i="0">
                 <a:solidFill>
                   <a:srgbClr val="1E1508"/>
                 </a:solidFill>
@@ -7853,7 +7853,7 @@
           <a:p>
             <a:pPr algn="l"/>
             <a:r>
-              <a:rPr sz="1000" b="0" i="0">
+              <a:rPr sz="1300" b="0" i="0">
                 <a:solidFill>
                   <a:srgbClr val="1E1508"/>
                 </a:solidFill>
@@ -7888,7 +7888,7 @@
           <a:p>
             <a:pPr algn="l"/>
             <a:r>
-              <a:rPr sz="1000" b="0" i="0">
+              <a:rPr sz="1300" b="0" i="0">
                 <a:solidFill>
                   <a:srgbClr val="1E1508"/>
                 </a:solidFill>
@@ -7923,7 +7923,7 @@
           <a:p>
             <a:pPr algn="l"/>
             <a:r>
-              <a:rPr sz="1000" b="0" i="0">
+              <a:rPr sz="1300" b="0" i="0">
                 <a:solidFill>
                   <a:srgbClr val="1E1508"/>
                 </a:solidFill>
@@ -8002,7 +8002,7 @@
           <a:p>
             <a:pPr algn="l"/>
             <a:r>
-              <a:rPr sz="1000" b="0" i="0">
+              <a:rPr sz="1300" b="0" i="0">
                 <a:solidFill>
                   <a:srgbClr val="1E1508"/>
                 </a:solidFill>
@@ -8037,7 +8037,7 @@
           <a:p>
             <a:pPr algn="l"/>
             <a:r>
-              <a:rPr sz="1000" b="0" i="0">
+              <a:rPr sz="1300" b="0" i="0">
                 <a:solidFill>
                   <a:srgbClr val="1E1508"/>
                 </a:solidFill>
@@ -8072,7 +8072,7 @@
           <a:p>
             <a:pPr algn="l"/>
             <a:r>
-              <a:rPr sz="1000" b="0" i="0">
+              <a:rPr sz="1300" b="0" i="0">
                 <a:solidFill>
                   <a:srgbClr val="1E1508"/>
                 </a:solidFill>
@@ -8107,7 +8107,7 @@
           <a:p>
             <a:pPr algn="l"/>
             <a:r>
-              <a:rPr sz="1000" b="0" i="0">
+              <a:rPr sz="1300" b="0" i="0">
                 <a:solidFill>
                   <a:srgbClr val="1E1508"/>
                 </a:solidFill>
@@ -8186,7 +8186,7 @@
           <a:p>
             <a:pPr algn="l"/>
             <a:r>
-              <a:rPr sz="1000" b="0" i="0">
+              <a:rPr sz="1300" b="0" i="0">
                 <a:solidFill>
                   <a:srgbClr val="1E1508"/>
                 </a:solidFill>
@@ -8221,7 +8221,7 @@
           <a:p>
             <a:pPr algn="l"/>
             <a:r>
-              <a:rPr sz="1000" b="0" i="0">
+              <a:rPr sz="1300" b="0" i="0">
                 <a:solidFill>
                   <a:srgbClr val="1E1508"/>
                 </a:solidFill>
@@ -8256,7 +8256,7 @@
           <a:p>
             <a:pPr algn="l"/>
             <a:r>
-              <a:rPr sz="1000" b="0" i="0">
+              <a:rPr sz="1300" b="0" i="0">
                 <a:solidFill>
                   <a:srgbClr val="1E1508"/>
                 </a:solidFill>
@@ -8291,7 +8291,7 @@
           <a:p>
             <a:pPr algn="l"/>
             <a:r>
-              <a:rPr sz="1000" b="0" i="0">
+              <a:rPr sz="1300" b="0" i="0">
                 <a:solidFill>
                   <a:srgbClr val="1E1508"/>
                 </a:solidFill>
@@ -8370,7 +8370,7 @@
           <a:p>
             <a:pPr algn="l"/>
             <a:r>
-              <a:rPr sz="1000" b="0" i="0">
+              <a:rPr sz="1300" b="0" i="0">
                 <a:solidFill>
                   <a:srgbClr val="1E1508"/>
                 </a:solidFill>
@@ -8405,7 +8405,7 @@
           <a:p>
             <a:pPr algn="l"/>
             <a:r>
-              <a:rPr sz="1000" b="0" i="0">
+              <a:rPr sz="1300" b="0" i="0">
                 <a:solidFill>
                   <a:srgbClr val="1E1508"/>
                 </a:solidFill>
@@ -8440,7 +8440,7 @@
           <a:p>
             <a:pPr algn="l"/>
             <a:r>
-              <a:rPr sz="1000" b="0" i="0">
+              <a:rPr sz="1300" b="0" i="0">
                 <a:solidFill>
                   <a:srgbClr val="1E1508"/>
                 </a:solidFill>
@@ -8475,7 +8475,7 @@
           <a:p>
             <a:pPr algn="l"/>
             <a:r>
-              <a:rPr sz="1000" b="0" i="0">
+              <a:rPr sz="1300" b="0" i="0">
                 <a:solidFill>
                   <a:srgbClr val="1E1508"/>
                 </a:solidFill>
@@ -8554,7 +8554,7 @@
           <a:p>
             <a:pPr algn="l"/>
             <a:r>
-              <a:rPr sz="1000" b="0" i="0">
+              <a:rPr sz="1300" b="0" i="0">
                 <a:solidFill>
                   <a:srgbClr val="1E1508"/>
                 </a:solidFill>
@@ -8589,7 +8589,7 @@
           <a:p>
             <a:pPr algn="l"/>
             <a:r>
-              <a:rPr sz="1000" b="0" i="0">
+              <a:rPr sz="1300" b="0" i="0">
                 <a:solidFill>
                   <a:srgbClr val="1E1508"/>
                 </a:solidFill>
@@ -8624,7 +8624,7 @@
           <a:p>
             <a:pPr algn="l"/>
             <a:r>
-              <a:rPr sz="1000" b="0" i="0">
+              <a:rPr sz="1300" b="0" i="0">
                 <a:solidFill>
                   <a:srgbClr val="1E1508"/>
                 </a:solidFill>
@@ -8659,7 +8659,7 @@
           <a:p>
             <a:pPr algn="l"/>
             <a:r>
-              <a:rPr sz="1000" b="0" i="0">
+              <a:rPr sz="1300" b="0" i="0">
                 <a:solidFill>
                   <a:srgbClr val="1E1508"/>
                 </a:solidFill>
@@ -8694,9 +8694,9 @@
           <a:p>
             <a:pPr algn="l"/>
             <a:r>
-              <a:rPr sz="900" b="0" i="0">
-                <a:solidFill>
-                  <a:srgbClr val="4A5568"/>
+              <a:rPr sz="1170" b="0" i="0">
+                <a:solidFill>
+                  <a:srgbClr val="2D3748"/>
                 </a:solidFill>
                 <a:latin typeface="Calibri"/>
               </a:rPr>
@@ -8729,9 +8729,9 @@
           <a:p>
             <a:pPr algn="r"/>
             <a:r>
-              <a:rPr sz="900" b="0" i="0">
-                <a:solidFill>
-                  <a:srgbClr val="4A5568"/>
+              <a:rPr sz="1170" b="0" i="0">
+                <a:solidFill>
+                  <a:srgbClr val="2D3748"/>
                 </a:solidFill>
                 <a:latin typeface="Calibri"/>
               </a:rPr>
@@ -8755,7 +8755,7 @@
             <a:avLst/>
           </a:prstGeom>
           <a:solidFill>
-            <a:srgbClr val="C9A84C"/>
+            <a:srgbClr val="B8941A"/>
           </a:solidFill>
           <a:ln>
             <a:noFill/>
@@ -8825,9 +8825,9 @@
           <a:p>
             <a:pPr algn="l"/>
             <a:r>
-              <a:rPr sz="3200" b="1" i="0">
-                <a:solidFill>
-                  <a:srgbClr val="5C3A1F"/>
+              <a:rPr sz="4160" b="1" i="0">
+                <a:solidFill>
+                  <a:srgbClr val="4A2D18"/>
                 </a:solidFill>
                 <a:latin typeface="Calibri"/>
               </a:rPr>
@@ -8851,7 +8851,7 @@
             <a:avLst/>
           </a:prstGeom>
           <a:solidFill>
-            <a:srgbClr val="C9A84C"/>
+            <a:srgbClr val="B8941A"/>
           </a:solidFill>
           <a:ln>
             <a:noFill/>
@@ -8903,9 +8903,9 @@
           <a:p>
             <a:pPr algn="l"/>
             <a:r>
-              <a:rPr sz="1400" b="0" i="1">
-                <a:solidFill>
-                  <a:srgbClr val="4A5568"/>
+              <a:rPr sz="1820" b="0" i="1">
+                <a:solidFill>
+                  <a:srgbClr val="2D3748"/>
                 </a:solidFill>
                 <a:latin typeface="Calibri"/>
               </a:rPr>
@@ -8938,7 +8938,7 @@
           <a:p>
             <a:pPr algn="l"/>
             <a:r>
-              <a:rPr sz="1500" b="0" i="0">
+              <a:rPr sz="1950" b="0" i="0">
                 <a:solidFill>
                   <a:srgbClr val="1E1508"/>
                 </a:solidFill>
@@ -8977,16 +8977,16 @@
               </a:lnSpc>
             </a:pPr>
             <a:r>
-              <a:rPr sz="1300" b="1">
-                <a:solidFill>
-                  <a:srgbClr val="C9A84C"/>
+              <a:rPr sz="1690" b="1">
+                <a:solidFill>
+                  <a:srgbClr val="B8941A"/>
                 </a:solidFill>
                 <a:latin typeface="Calibri"/>
               </a:rPr>
               <a:t>• </a:t>
             </a:r>
             <a:r>
-              <a:rPr sz="1100">
+              <a:rPr sz="1430">
                 <a:solidFill>
                   <a:srgbClr val="1E1508"/>
                 </a:solidFill>
@@ -9005,9 +9005,9 @@
               </a:spcBef>
             </a:pPr>
             <a:r>
-              <a:rPr sz="900" i="1">
-                <a:solidFill>
-                  <a:srgbClr val="5C3A1F"/>
+              <a:rPr sz="1170" i="1">
+                <a:solidFill>
+                  <a:srgbClr val="4A2D18"/>
                 </a:solidFill>
                 <a:latin typeface="Calibri"/>
               </a:rPr>
@@ -9024,16 +9024,16 @@
               </a:spcBef>
             </a:pPr>
             <a:r>
-              <a:rPr sz="1300" b="1">
-                <a:solidFill>
-                  <a:srgbClr val="C9A84C"/>
+              <a:rPr sz="1690" b="1">
+                <a:solidFill>
+                  <a:srgbClr val="B8941A"/>
                 </a:solidFill>
                 <a:latin typeface="Calibri"/>
               </a:rPr>
               <a:t>• </a:t>
             </a:r>
             <a:r>
-              <a:rPr sz="1100">
+              <a:rPr sz="1430">
                 <a:solidFill>
                   <a:srgbClr val="1E1508"/>
                 </a:solidFill>
@@ -9052,9 +9052,9 @@
               </a:spcBef>
             </a:pPr>
             <a:r>
-              <a:rPr sz="900" i="1">
-                <a:solidFill>
-                  <a:srgbClr val="5C3A1F"/>
+              <a:rPr sz="1170" i="1">
+                <a:solidFill>
+                  <a:srgbClr val="4A2D18"/>
                 </a:solidFill>
                 <a:latin typeface="Calibri"/>
               </a:rPr>
@@ -9071,16 +9071,16 @@
               </a:spcBef>
             </a:pPr>
             <a:r>
-              <a:rPr sz="1300" b="1">
-                <a:solidFill>
-                  <a:srgbClr val="C9A84C"/>
+              <a:rPr sz="1690" b="1">
+                <a:solidFill>
+                  <a:srgbClr val="B8941A"/>
                 </a:solidFill>
                 <a:latin typeface="Calibri"/>
               </a:rPr>
               <a:t>• </a:t>
             </a:r>
             <a:r>
-              <a:rPr sz="1100">
+              <a:rPr sz="1430">
                 <a:solidFill>
                   <a:srgbClr val="1E1508"/>
                 </a:solidFill>
@@ -9099,9 +9099,9 @@
               </a:spcBef>
             </a:pPr>
             <a:r>
-              <a:rPr sz="900" i="1">
-                <a:solidFill>
-                  <a:srgbClr val="5C3A1F"/>
+              <a:rPr sz="1170" i="1">
+                <a:solidFill>
+                  <a:srgbClr val="4A2D18"/>
                 </a:solidFill>
                 <a:latin typeface="Calibri"/>
               </a:rPr>
@@ -9118,16 +9118,16 @@
               </a:spcBef>
             </a:pPr>
             <a:r>
-              <a:rPr sz="1300" b="1">
-                <a:solidFill>
-                  <a:srgbClr val="C9A84C"/>
+              <a:rPr sz="1690" b="1">
+                <a:solidFill>
+                  <a:srgbClr val="B8941A"/>
                 </a:solidFill>
                 <a:latin typeface="Calibri"/>
               </a:rPr>
               <a:t>• </a:t>
             </a:r>
             <a:r>
-              <a:rPr sz="1100">
+              <a:rPr sz="1430">
                 <a:solidFill>
                   <a:srgbClr val="1E1508"/>
                 </a:solidFill>
@@ -9146,9 +9146,9 @@
               </a:spcBef>
             </a:pPr>
             <a:r>
-              <a:rPr sz="900" i="1">
-                <a:solidFill>
-                  <a:srgbClr val="5C3A1F"/>
+              <a:rPr sz="1170" i="1">
+                <a:solidFill>
+                  <a:srgbClr val="4A2D18"/>
                 </a:solidFill>
                 <a:latin typeface="Calibri"/>
               </a:rPr>
@@ -9165,16 +9165,16 @@
               </a:spcBef>
             </a:pPr>
             <a:r>
-              <a:rPr sz="1300" b="1">
-                <a:solidFill>
-                  <a:srgbClr val="C9A84C"/>
+              <a:rPr sz="1690" b="1">
+                <a:solidFill>
+                  <a:srgbClr val="B8941A"/>
                 </a:solidFill>
                 <a:latin typeface="Calibri"/>
               </a:rPr>
               <a:t>• </a:t>
             </a:r>
             <a:r>
-              <a:rPr sz="1100">
+              <a:rPr sz="1430">
                 <a:solidFill>
                   <a:srgbClr val="1E1508"/>
                 </a:solidFill>
@@ -9193,9 +9193,9 @@
               </a:spcBef>
             </a:pPr>
             <a:r>
-              <a:rPr sz="900" i="1">
-                <a:solidFill>
-                  <a:srgbClr val="5C3A1F"/>
+              <a:rPr sz="1170" i="1">
+                <a:solidFill>
+                  <a:srgbClr val="4A2D18"/>
                 </a:solidFill>
                 <a:latin typeface="Calibri"/>
               </a:rPr>
@@ -9212,16 +9212,16 @@
               </a:spcBef>
             </a:pPr>
             <a:r>
-              <a:rPr sz="1300" b="1">
-                <a:solidFill>
-                  <a:srgbClr val="C9A84C"/>
+              <a:rPr sz="1690" b="1">
+                <a:solidFill>
+                  <a:srgbClr val="B8941A"/>
                 </a:solidFill>
                 <a:latin typeface="Calibri"/>
               </a:rPr>
               <a:t>• </a:t>
             </a:r>
             <a:r>
-              <a:rPr sz="1100">
+              <a:rPr sz="1430">
                 <a:solidFill>
                   <a:srgbClr val="1E1508"/>
                 </a:solidFill>
@@ -9240,9 +9240,9 @@
               </a:spcBef>
             </a:pPr>
             <a:r>
-              <a:rPr sz="900" i="1">
-                <a:solidFill>
-                  <a:srgbClr val="5C3A1F"/>
+              <a:rPr sz="1170" i="1">
+                <a:solidFill>
+                  <a:srgbClr val="4A2D18"/>
                 </a:solidFill>
                 <a:latin typeface="Calibri"/>
               </a:rPr>
@@ -9270,7 +9270,7 @@
           </a:solidFill>
           <a:ln w="6350">
             <a:solidFill>
-              <a:srgbClr val="C9A84C"/>
+              <a:srgbClr val="B8941A"/>
             </a:solidFill>
           </a:ln>
           <a:effectLst/>
@@ -9321,9 +9321,9 @@
           <a:p>
             <a:pPr algn="ctr"/>
             <a:r>
-              <a:rPr sz="1300" b="0" i="1">
-                <a:solidFill>
-                  <a:srgbClr val="5C3A1F"/>
+              <a:rPr sz="1690" b="0" i="1">
+                <a:solidFill>
+                  <a:srgbClr val="4A2D18"/>
                 </a:solidFill>
                 <a:latin typeface="Calibri"/>
               </a:rPr>
@@ -9356,9 +9356,9 @@
           <a:p>
             <a:pPr algn="l"/>
             <a:r>
-              <a:rPr sz="900" b="0" i="0">
-                <a:solidFill>
-                  <a:srgbClr val="4A5568"/>
+              <a:rPr sz="1170" b="0" i="0">
+                <a:solidFill>
+                  <a:srgbClr val="2D3748"/>
                 </a:solidFill>
                 <a:latin typeface="Calibri"/>
               </a:rPr>
@@ -9391,9 +9391,9 @@
           <a:p>
             <a:pPr algn="r"/>
             <a:r>
-              <a:rPr sz="900" b="0" i="0">
-                <a:solidFill>
-                  <a:srgbClr val="4A5568"/>
+              <a:rPr sz="1170" b="0" i="0">
+                <a:solidFill>
+                  <a:srgbClr val="2D3748"/>
                 </a:solidFill>
                 <a:latin typeface="Calibri"/>
               </a:rPr>
@@ -9417,7 +9417,7 @@
             <a:avLst/>
           </a:prstGeom>
           <a:solidFill>
-            <a:srgbClr val="C9A84C"/>
+            <a:srgbClr val="B8941A"/>
           </a:solidFill>
           <a:ln>
             <a:noFill/>
@@ -9487,9 +9487,9 @@
           <a:p>
             <a:pPr algn="l"/>
             <a:r>
-              <a:rPr sz="3200" b="1" i="0">
-                <a:solidFill>
-                  <a:srgbClr val="5C3A1F"/>
+              <a:rPr sz="4160" b="1" i="0">
+                <a:solidFill>
+                  <a:srgbClr val="4A2D18"/>
                 </a:solidFill>
                 <a:latin typeface="Calibri"/>
               </a:rPr>
@@ -9513,7 +9513,7 @@
             <a:avLst/>
           </a:prstGeom>
           <a:solidFill>
-            <a:srgbClr val="C9A84C"/>
+            <a:srgbClr val="B8941A"/>
           </a:solidFill>
           <a:ln>
             <a:noFill/>
@@ -9565,9 +9565,9 @@
           <a:p>
             <a:pPr algn="l"/>
             <a:r>
-              <a:rPr sz="1400" b="0" i="1">
-                <a:solidFill>
-                  <a:srgbClr val="4A5568"/>
+              <a:rPr sz="1820" b="0" i="1">
+                <a:solidFill>
+                  <a:srgbClr val="2D3748"/>
                 </a:solidFill>
                 <a:latin typeface="Calibri"/>
               </a:rPr>
@@ -9600,7 +9600,7 @@
           <a:p>
             <a:pPr algn="l"/>
             <a:r>
-              <a:rPr sz="1300" b="0" i="0">
+              <a:rPr sz="1690" b="0" i="0">
                 <a:solidFill>
                   <a:srgbClr val="1E1508"/>
                 </a:solidFill>
@@ -9681,9 +9681,9 @@
           <a:p>
             <a:pPr algn="ctr"/>
             <a:r>
-              <a:rPr sz="4400" b="1" i="0">
-                <a:solidFill>
-                  <a:srgbClr val="C9A84C"/>
+              <a:rPr sz="5720" b="1" i="0">
+                <a:solidFill>
+                  <a:srgbClr val="B8941A"/>
                 </a:solidFill>
                 <a:latin typeface="Calibri"/>
               </a:rPr>
@@ -9716,9 +9716,9 @@
           <a:p>
             <a:pPr algn="ctr"/>
             <a:r>
-              <a:rPr sz="1100" b="0" i="0">
-                <a:solidFill>
-                  <a:srgbClr val="4A5568"/>
+              <a:rPr sz="1430" b="0" i="0">
+                <a:solidFill>
+                  <a:srgbClr val="2D3748"/>
                 </a:solidFill>
                 <a:latin typeface="Calibri"/>
               </a:rPr>
@@ -9798,9 +9798,9 @@
           <a:p>
             <a:pPr algn="ctr"/>
             <a:r>
-              <a:rPr sz="4400" b="1" i="0">
-                <a:solidFill>
-                  <a:srgbClr val="C9A84C"/>
+              <a:rPr sz="5720" b="1" i="0">
+                <a:solidFill>
+                  <a:srgbClr val="B8941A"/>
                 </a:solidFill>
                 <a:latin typeface="Calibri"/>
               </a:rPr>
@@ -9833,9 +9833,9 @@
           <a:p>
             <a:pPr algn="ctr"/>
             <a:r>
-              <a:rPr sz="1100" b="0" i="0">
-                <a:solidFill>
-                  <a:srgbClr val="4A5568"/>
+              <a:rPr sz="1430" b="0" i="0">
+                <a:solidFill>
+                  <a:srgbClr val="2D3748"/>
                 </a:solidFill>
                 <a:latin typeface="Calibri"/>
               </a:rPr>
@@ -9915,9 +9915,9 @@
           <a:p>
             <a:pPr algn="ctr"/>
             <a:r>
-              <a:rPr sz="4400" b="1" i="0">
-                <a:solidFill>
-                  <a:srgbClr val="C9A84C"/>
+              <a:rPr sz="5720" b="1" i="0">
+                <a:solidFill>
+                  <a:srgbClr val="B8941A"/>
                 </a:solidFill>
                 <a:latin typeface="Calibri"/>
               </a:rPr>
@@ -9950,9 +9950,9 @@
           <a:p>
             <a:pPr algn="ctr"/>
             <a:r>
-              <a:rPr sz="1100" b="0" i="0">
-                <a:solidFill>
-                  <a:srgbClr val="4A5568"/>
+              <a:rPr sz="1430" b="0" i="0">
+                <a:solidFill>
+                  <a:srgbClr val="2D3748"/>
                 </a:solidFill>
                 <a:latin typeface="Calibri"/>
               </a:rPr>
@@ -10032,9 +10032,9 @@
           <a:p>
             <a:pPr algn="ctr"/>
             <a:r>
-              <a:rPr sz="4400" b="1" i="0">
-                <a:solidFill>
-                  <a:srgbClr val="C9A84C"/>
+              <a:rPr sz="5720" b="1" i="0">
+                <a:solidFill>
+                  <a:srgbClr val="B8941A"/>
                 </a:solidFill>
                 <a:latin typeface="Calibri"/>
               </a:rPr>
@@ -10067,9 +10067,9 @@
           <a:p>
             <a:pPr algn="ctr"/>
             <a:r>
-              <a:rPr sz="1100" b="0" i="0">
-                <a:solidFill>
-                  <a:srgbClr val="4A5568"/>
+              <a:rPr sz="1430" b="0" i="0">
+                <a:solidFill>
+                  <a:srgbClr val="2D3748"/>
                 </a:solidFill>
                 <a:latin typeface="Calibri"/>
               </a:rPr>
@@ -10103,9 +10103,9 @@
           <a:p>
             <a:pPr algn="l"/>
             <a:r>
-              <a:rPr sz="1100" b="0" i="1">
-                <a:solidFill>
-                  <a:srgbClr val="4A5568"/>
+              <a:rPr sz="1430" b="0" i="1">
+                <a:solidFill>
+                  <a:srgbClr val="2D3748"/>
                 </a:solidFill>
                 <a:latin typeface="Calibri"/>
               </a:rPr>
@@ -10139,9 +10139,9 @@
           <a:p>
             <a:pPr algn="l"/>
             <a:r>
-              <a:rPr sz="900" b="0" i="0">
-                <a:solidFill>
-                  <a:srgbClr val="4A5568"/>
+              <a:rPr sz="1170" b="0" i="0">
+                <a:solidFill>
+                  <a:srgbClr val="2D3748"/>
                 </a:solidFill>
                 <a:latin typeface="Calibri"/>
               </a:rPr>
@@ -10174,9 +10174,9 @@
           <a:p>
             <a:pPr algn="r"/>
             <a:r>
-              <a:rPr sz="900" b="0" i="0">
-                <a:solidFill>
-                  <a:srgbClr val="4A5568"/>
+              <a:rPr sz="1170" b="0" i="0">
+                <a:solidFill>
+                  <a:srgbClr val="2D3748"/>
                 </a:solidFill>
                 <a:latin typeface="Calibri"/>
               </a:rPr>
@@ -10200,7 +10200,7 @@
             <a:avLst/>
           </a:prstGeom>
           <a:solidFill>
-            <a:srgbClr val="C9A84C"/>
+            <a:srgbClr val="B8941A"/>
           </a:solidFill>
           <a:ln>
             <a:noFill/>
@@ -10270,9 +10270,9 @@
           <a:p>
             <a:pPr algn="l"/>
             <a:r>
-              <a:rPr sz="3200" b="1" i="0">
-                <a:solidFill>
-                  <a:srgbClr val="5C3A1F"/>
+              <a:rPr sz="4160" b="1" i="0">
+                <a:solidFill>
+                  <a:srgbClr val="4A2D18"/>
                 </a:solidFill>
                 <a:latin typeface="Calibri"/>
               </a:rPr>
@@ -10296,7 +10296,7 @@
             <a:avLst/>
           </a:prstGeom>
           <a:solidFill>
-            <a:srgbClr val="C9A84C"/>
+            <a:srgbClr val="B8941A"/>
           </a:solidFill>
           <a:ln>
             <a:noFill/>
@@ -10348,9 +10348,9 @@
           <a:p>
             <a:pPr algn="l"/>
             <a:r>
-              <a:rPr sz="1400" b="0" i="1">
-                <a:solidFill>
-                  <a:srgbClr val="4A5568"/>
+              <a:rPr sz="1820" b="0" i="1">
+                <a:solidFill>
+                  <a:srgbClr val="2D3748"/>
                 </a:solidFill>
                 <a:latin typeface="Calibri"/>
               </a:rPr>
@@ -10427,9 +10427,9 @@
           <a:p>
             <a:pPr algn="l"/>
             <a:r>
-              <a:rPr sz="1100" b="1" i="0">
-                <a:solidFill>
-                  <a:srgbClr val="5C3A1F"/>
+              <a:rPr sz="1430" b="1" i="0">
+                <a:solidFill>
+                  <a:srgbClr val="4A2D18"/>
                 </a:solidFill>
                 <a:latin typeface="Calibri"/>
               </a:rPr>
@@ -10462,9 +10462,9 @@
           <a:p>
             <a:pPr algn="l"/>
             <a:r>
-              <a:rPr sz="1100" b="1" i="0">
-                <a:solidFill>
-                  <a:srgbClr val="5C3A1F"/>
+              <a:rPr sz="1430" b="1" i="0">
+                <a:solidFill>
+                  <a:srgbClr val="4A2D18"/>
                 </a:solidFill>
                 <a:latin typeface="Calibri"/>
               </a:rPr>
@@ -10488,7 +10488,7 @@
             <a:avLst/>
           </a:prstGeom>
           <a:solidFill>
-            <a:srgbClr val="C9A84C"/>
+            <a:srgbClr val="B8941A"/>
           </a:solidFill>
           <a:ln>
             <a:noFill/>
@@ -10584,7 +10584,7 @@
           <a:p>
             <a:pPr algn="l"/>
             <a:r>
-              <a:rPr sz="1000" b="0" i="0">
+              <a:rPr sz="1300" b="0" i="0">
                 <a:solidFill>
                   <a:srgbClr val="1E1508"/>
                 </a:solidFill>
@@ -10619,7 +10619,7 @@
           <a:p>
             <a:pPr algn="l"/>
             <a:r>
-              <a:rPr sz="1000" b="0" i="0">
+              <a:rPr sz="1300" b="0" i="0">
                 <a:solidFill>
                   <a:srgbClr val="1E1508"/>
                 </a:solidFill>
@@ -10654,9 +10654,9 @@
           <a:p>
             <a:pPr algn="l"/>
             <a:r>
-              <a:rPr sz="800" b="0" i="1">
-                <a:solidFill>
-                  <a:srgbClr val="5C3A1F"/>
+              <a:rPr sz="1040" b="0" i="1">
+                <a:solidFill>
+                  <a:srgbClr val="4A2D18"/>
                 </a:solidFill>
                 <a:latin typeface="Calibri"/>
               </a:rPr>
@@ -10689,7 +10689,7 @@
           <a:p>
             <a:pPr algn="l"/>
             <a:r>
-              <a:rPr sz="1000" b="0" i="0">
+              <a:rPr sz="1300" b="0" i="0">
                 <a:solidFill>
                   <a:srgbClr val="1E1508"/>
                 </a:solidFill>
@@ -10724,7 +10724,7 @@
           <a:p>
             <a:pPr algn="l"/>
             <a:r>
-              <a:rPr sz="1000" b="0" i="0">
+              <a:rPr sz="1300" b="0" i="0">
                 <a:solidFill>
                   <a:srgbClr val="1E1508"/>
                 </a:solidFill>
@@ -10759,9 +10759,9 @@
           <a:p>
             <a:pPr algn="l"/>
             <a:r>
-              <a:rPr sz="800" b="0" i="1">
-                <a:solidFill>
-                  <a:srgbClr val="5C3A1F"/>
+              <a:rPr sz="1040" b="0" i="1">
+                <a:solidFill>
+                  <a:srgbClr val="4A2D18"/>
                 </a:solidFill>
                 <a:latin typeface="Calibri"/>
               </a:rPr>
@@ -10838,7 +10838,7 @@
           <a:p>
             <a:pPr algn="l"/>
             <a:r>
-              <a:rPr sz="1000" b="0" i="0">
+              <a:rPr sz="1300" b="0" i="0">
                 <a:solidFill>
                   <a:srgbClr val="1E1508"/>
                 </a:solidFill>
@@ -10873,7 +10873,7 @@
           <a:p>
             <a:pPr algn="l"/>
             <a:r>
-              <a:rPr sz="1000" b="0" i="0">
+              <a:rPr sz="1300" b="0" i="0">
                 <a:solidFill>
                   <a:srgbClr val="1E1508"/>
                 </a:solidFill>
@@ -10908,9 +10908,9 @@
           <a:p>
             <a:pPr algn="l"/>
             <a:r>
-              <a:rPr sz="800" b="0" i="1">
-                <a:solidFill>
-                  <a:srgbClr val="5C3A1F"/>
+              <a:rPr sz="1040" b="0" i="1">
+                <a:solidFill>
+                  <a:srgbClr val="4A2D18"/>
                 </a:solidFill>
                 <a:latin typeface="Calibri"/>
               </a:rPr>
@@ -10943,7 +10943,7 @@
           <a:p>
             <a:pPr algn="l"/>
             <a:r>
-              <a:rPr sz="1000" b="0" i="0">
+              <a:rPr sz="1300" b="0" i="0">
                 <a:solidFill>
                   <a:srgbClr val="1E1508"/>
                 </a:solidFill>
@@ -10978,7 +10978,7 @@
           <a:p>
             <a:pPr algn="l"/>
             <a:r>
-              <a:rPr sz="1000" b="0" i="0">
+              <a:rPr sz="1300" b="0" i="0">
                 <a:solidFill>
                   <a:srgbClr val="1E1508"/>
                 </a:solidFill>
@@ -11013,9 +11013,9 @@
           <a:p>
             <a:pPr algn="l"/>
             <a:r>
-              <a:rPr sz="800" b="0" i="1">
-                <a:solidFill>
-                  <a:srgbClr val="5C3A1F"/>
+              <a:rPr sz="1040" b="0" i="1">
+                <a:solidFill>
+                  <a:srgbClr val="4A2D18"/>
                 </a:solidFill>
                 <a:latin typeface="Calibri"/>
               </a:rPr>
@@ -11092,7 +11092,7 @@
           <a:p>
             <a:pPr algn="l"/>
             <a:r>
-              <a:rPr sz="1000" b="0" i="0">
+              <a:rPr sz="1300" b="0" i="0">
                 <a:solidFill>
                   <a:srgbClr val="1E1508"/>
                 </a:solidFill>
@@ -11127,7 +11127,7 @@
           <a:p>
             <a:pPr algn="l"/>
             <a:r>
-              <a:rPr sz="1000" b="0" i="0">
+              <a:rPr sz="1300" b="0" i="0">
                 <a:solidFill>
                   <a:srgbClr val="1E1508"/>
                 </a:solidFill>
@@ -11162,9 +11162,9 @@
           <a:p>
             <a:pPr algn="l"/>
             <a:r>
-              <a:rPr sz="800" b="0" i="1">
-                <a:solidFill>
-                  <a:srgbClr val="5C3A1F"/>
+              <a:rPr sz="1040" b="0" i="1">
+                <a:solidFill>
+                  <a:srgbClr val="4A2D18"/>
                 </a:solidFill>
                 <a:latin typeface="Calibri"/>
               </a:rPr>
@@ -11197,7 +11197,7 @@
           <a:p>
             <a:pPr algn="l"/>
             <a:r>
-              <a:rPr sz="1000" b="0" i="0">
+              <a:rPr sz="1300" b="0" i="0">
                 <a:solidFill>
                   <a:srgbClr val="1E1508"/>
                 </a:solidFill>
@@ -11232,7 +11232,7 @@
           <a:p>
             <a:pPr algn="l"/>
             <a:r>
-              <a:rPr sz="1000" b="0" i="0">
+              <a:rPr sz="1300" b="0" i="0">
                 <a:solidFill>
                   <a:srgbClr val="1E1508"/>
                 </a:solidFill>
@@ -11267,9 +11267,9 @@
           <a:p>
             <a:pPr algn="l"/>
             <a:r>
-              <a:rPr sz="800" b="0" i="1">
-                <a:solidFill>
-                  <a:srgbClr val="5C3A1F"/>
+              <a:rPr sz="1040" b="0" i="1">
+                <a:solidFill>
+                  <a:srgbClr val="4A2D18"/>
                 </a:solidFill>
                 <a:latin typeface="Calibri"/>
               </a:rPr>
@@ -11346,7 +11346,7 @@
           <a:p>
             <a:pPr algn="l"/>
             <a:r>
-              <a:rPr sz="1000" b="0" i="0">
+              <a:rPr sz="1300" b="0" i="0">
                 <a:solidFill>
                   <a:srgbClr val="1E1508"/>
                 </a:solidFill>
@@ -11381,7 +11381,7 @@
           <a:p>
             <a:pPr algn="l"/>
             <a:r>
-              <a:rPr sz="1000" b="0" i="0">
+              <a:rPr sz="1300" b="0" i="0">
                 <a:solidFill>
                   <a:srgbClr val="1E1508"/>
                 </a:solidFill>
@@ -11416,9 +11416,9 @@
           <a:p>
             <a:pPr algn="l"/>
             <a:r>
-              <a:rPr sz="800" b="0" i="1">
-                <a:solidFill>
-                  <a:srgbClr val="5C3A1F"/>
+              <a:rPr sz="1040" b="0" i="1">
+                <a:solidFill>
+                  <a:srgbClr val="4A2D18"/>
                 </a:solidFill>
                 <a:latin typeface="Calibri"/>
               </a:rPr>
@@ -11451,9 +11451,9 @@
           <a:p>
             <a:pPr algn="l"/>
             <a:r>
-              <a:rPr sz="900" b="0" i="0">
-                <a:solidFill>
-                  <a:srgbClr val="4A5568"/>
+              <a:rPr sz="1170" b="0" i="0">
+                <a:solidFill>
+                  <a:srgbClr val="2D3748"/>
                 </a:solidFill>
                 <a:latin typeface="Calibri"/>
               </a:rPr>
@@ -11486,9 +11486,9 @@
           <a:p>
             <a:pPr algn="r"/>
             <a:r>
-              <a:rPr sz="900" b="0" i="0">
-                <a:solidFill>
-                  <a:srgbClr val="4A5568"/>
+              <a:rPr sz="1170" b="0" i="0">
+                <a:solidFill>
+                  <a:srgbClr val="2D3748"/>
                 </a:solidFill>
                 <a:latin typeface="Calibri"/>
               </a:rPr>
@@ -11512,7 +11512,7 @@
             <a:avLst/>
           </a:prstGeom>
           <a:solidFill>
-            <a:srgbClr val="C9A84C"/>
+            <a:srgbClr val="B8941A"/>
           </a:solidFill>
           <a:ln>
             <a:noFill/>
@@ -11582,9 +11582,9 @@
           <a:p>
             <a:pPr algn="l"/>
             <a:r>
-              <a:rPr sz="3200" b="1" i="0">
-                <a:solidFill>
-                  <a:srgbClr val="5C3A1F"/>
+              <a:rPr sz="4160" b="1" i="0">
+                <a:solidFill>
+                  <a:srgbClr val="4A2D18"/>
                 </a:solidFill>
                 <a:latin typeface="Calibri"/>
               </a:rPr>
@@ -11608,7 +11608,7 @@
             <a:avLst/>
           </a:prstGeom>
           <a:solidFill>
-            <a:srgbClr val="C9A84C"/>
+            <a:srgbClr val="B8941A"/>
           </a:solidFill>
           <a:ln>
             <a:noFill/>
@@ -11660,9 +11660,9 @@
           <a:p>
             <a:pPr algn="l"/>
             <a:r>
-              <a:rPr sz="1400" b="0" i="1">
-                <a:solidFill>
-                  <a:srgbClr val="4A5568"/>
+              <a:rPr sz="1820" b="0" i="1">
+                <a:solidFill>
+                  <a:srgbClr val="2D3748"/>
                 </a:solidFill>
                 <a:latin typeface="Calibri"/>
               </a:rPr>
@@ -11699,16 +11699,16 @@
               </a:lnSpc>
             </a:pPr>
             <a:r>
-              <a:rPr sz="1300" b="1">
-                <a:solidFill>
-                  <a:srgbClr val="C9A84C"/>
+              <a:rPr sz="1690" b="1">
+                <a:solidFill>
+                  <a:srgbClr val="B8941A"/>
                 </a:solidFill>
                 <a:latin typeface="Calibri"/>
               </a:rPr>
               <a:t>• </a:t>
             </a:r>
             <a:r>
-              <a:rPr sz="1100">
+              <a:rPr sz="1430">
                 <a:solidFill>
                   <a:srgbClr val="1E1508"/>
                 </a:solidFill>
@@ -11727,9 +11727,9 @@
               </a:spcBef>
             </a:pPr>
             <a:r>
-              <a:rPr sz="900" i="1">
-                <a:solidFill>
-                  <a:srgbClr val="5C3A1F"/>
+              <a:rPr sz="1170" i="1">
+                <a:solidFill>
+                  <a:srgbClr val="4A2D18"/>
                 </a:solidFill>
                 <a:latin typeface="Calibri"/>
               </a:rPr>
@@ -11746,16 +11746,16 @@
               </a:spcBef>
             </a:pPr>
             <a:r>
-              <a:rPr sz="1300" b="1">
-                <a:solidFill>
-                  <a:srgbClr val="C9A84C"/>
+              <a:rPr sz="1690" b="1">
+                <a:solidFill>
+                  <a:srgbClr val="B8941A"/>
                 </a:solidFill>
                 <a:latin typeface="Calibri"/>
               </a:rPr>
               <a:t>• </a:t>
             </a:r>
             <a:r>
-              <a:rPr sz="1100">
+              <a:rPr sz="1430">
                 <a:solidFill>
                   <a:srgbClr val="1E1508"/>
                 </a:solidFill>
@@ -11774,9 +11774,9 @@
               </a:spcBef>
             </a:pPr>
             <a:r>
-              <a:rPr sz="900" i="1">
-                <a:solidFill>
-                  <a:srgbClr val="5C3A1F"/>
+              <a:rPr sz="1170" i="1">
+                <a:solidFill>
+                  <a:srgbClr val="4A2D18"/>
                 </a:solidFill>
                 <a:latin typeface="Calibri"/>
               </a:rPr>
@@ -11793,16 +11793,16 @@
               </a:spcBef>
             </a:pPr>
             <a:r>
-              <a:rPr sz="1300" b="1">
-                <a:solidFill>
-                  <a:srgbClr val="C9A84C"/>
+              <a:rPr sz="1690" b="1">
+                <a:solidFill>
+                  <a:srgbClr val="B8941A"/>
                 </a:solidFill>
                 <a:latin typeface="Calibri"/>
               </a:rPr>
               <a:t>• </a:t>
             </a:r>
             <a:r>
-              <a:rPr sz="1100">
+              <a:rPr sz="1430">
                 <a:solidFill>
                   <a:srgbClr val="1E1508"/>
                 </a:solidFill>
@@ -11821,9 +11821,9 @@
               </a:spcBef>
             </a:pPr>
             <a:r>
-              <a:rPr sz="900" i="1">
-                <a:solidFill>
-                  <a:srgbClr val="5C3A1F"/>
+              <a:rPr sz="1170" i="1">
+                <a:solidFill>
+                  <a:srgbClr val="4A2D18"/>
                 </a:solidFill>
                 <a:latin typeface="Calibri"/>
               </a:rPr>
@@ -11840,16 +11840,16 @@
               </a:spcBef>
             </a:pPr>
             <a:r>
-              <a:rPr sz="1300" b="1">
-                <a:solidFill>
-                  <a:srgbClr val="C9A84C"/>
+              <a:rPr sz="1690" b="1">
+                <a:solidFill>
+                  <a:srgbClr val="B8941A"/>
                 </a:solidFill>
                 <a:latin typeface="Calibri"/>
               </a:rPr>
               <a:t>• </a:t>
             </a:r>
             <a:r>
-              <a:rPr sz="1100">
+              <a:rPr sz="1430">
                 <a:solidFill>
                   <a:srgbClr val="1E1508"/>
                 </a:solidFill>
@@ -11868,9 +11868,9 @@
               </a:spcBef>
             </a:pPr>
             <a:r>
-              <a:rPr sz="900" i="1">
-                <a:solidFill>
-                  <a:srgbClr val="5C3A1F"/>
+              <a:rPr sz="1170" i="1">
+                <a:solidFill>
+                  <a:srgbClr val="4A2D18"/>
                 </a:solidFill>
                 <a:latin typeface="Calibri"/>
               </a:rPr>
@@ -11887,16 +11887,16 @@
               </a:spcBef>
             </a:pPr>
             <a:r>
-              <a:rPr sz="1300" b="1">
-                <a:solidFill>
-                  <a:srgbClr val="C9A84C"/>
+              <a:rPr sz="1690" b="1">
+                <a:solidFill>
+                  <a:srgbClr val="B8941A"/>
                 </a:solidFill>
                 <a:latin typeface="Calibri"/>
               </a:rPr>
               <a:t>• </a:t>
             </a:r>
             <a:r>
-              <a:rPr sz="1100">
+              <a:rPr sz="1430">
                 <a:solidFill>
                   <a:srgbClr val="1E1508"/>
                 </a:solidFill>
@@ -11915,9 +11915,9 @@
               </a:spcBef>
             </a:pPr>
             <a:r>
-              <a:rPr sz="900" i="1">
-                <a:solidFill>
-                  <a:srgbClr val="5C3A1F"/>
+              <a:rPr sz="1170" i="1">
+                <a:solidFill>
+                  <a:srgbClr val="4A2D18"/>
                 </a:solidFill>
                 <a:latin typeface="Calibri"/>
               </a:rPr>
@@ -11934,16 +11934,16 @@
               </a:spcBef>
             </a:pPr>
             <a:r>
-              <a:rPr sz="1300" b="1">
-                <a:solidFill>
-                  <a:srgbClr val="C9A84C"/>
+              <a:rPr sz="1690" b="1">
+                <a:solidFill>
+                  <a:srgbClr val="B8941A"/>
                 </a:solidFill>
                 <a:latin typeface="Calibri"/>
               </a:rPr>
               <a:t>• </a:t>
             </a:r>
             <a:r>
-              <a:rPr sz="1100">
+              <a:rPr sz="1430">
                 <a:solidFill>
                   <a:srgbClr val="1E1508"/>
                 </a:solidFill>
@@ -11962,9 +11962,9 @@
               </a:spcBef>
             </a:pPr>
             <a:r>
-              <a:rPr sz="900" i="1">
-                <a:solidFill>
-                  <a:srgbClr val="5C3A1F"/>
+              <a:rPr sz="1170" i="1">
+                <a:solidFill>
+                  <a:srgbClr val="4A2D18"/>
                 </a:solidFill>
                 <a:latin typeface="Calibri"/>
               </a:rPr>
@@ -11981,16 +11981,16 @@
               </a:spcBef>
             </a:pPr>
             <a:r>
-              <a:rPr sz="1300" b="1">
-                <a:solidFill>
-                  <a:srgbClr val="C9A84C"/>
+              <a:rPr sz="1690" b="1">
+                <a:solidFill>
+                  <a:srgbClr val="B8941A"/>
                 </a:solidFill>
                 <a:latin typeface="Calibri"/>
               </a:rPr>
               <a:t>• </a:t>
             </a:r>
             <a:r>
-              <a:rPr sz="1100">
+              <a:rPr sz="1430">
                 <a:solidFill>
                   <a:srgbClr val="1E1508"/>
                 </a:solidFill>
@@ -12009,9 +12009,9 @@
               </a:spcBef>
             </a:pPr>
             <a:r>
-              <a:rPr sz="900" i="1">
-                <a:solidFill>
-                  <a:srgbClr val="5C3A1F"/>
+              <a:rPr sz="1170" i="1">
+                <a:solidFill>
+                  <a:srgbClr val="4A2D18"/>
                 </a:solidFill>
                 <a:latin typeface="Calibri"/>
               </a:rPr>
@@ -12028,16 +12028,16 @@
               </a:spcBef>
             </a:pPr>
             <a:r>
-              <a:rPr sz="1300" b="1">
-                <a:solidFill>
-                  <a:srgbClr val="C9A84C"/>
+              <a:rPr sz="1690" b="1">
+                <a:solidFill>
+                  <a:srgbClr val="B8941A"/>
                 </a:solidFill>
                 <a:latin typeface="Calibri"/>
               </a:rPr>
               <a:t>• </a:t>
             </a:r>
             <a:r>
-              <a:rPr sz="1100">
+              <a:rPr sz="1430">
                 <a:solidFill>
                   <a:srgbClr val="1E1508"/>
                 </a:solidFill>
@@ -12056,9 +12056,9 @@
               </a:spcBef>
             </a:pPr>
             <a:r>
-              <a:rPr sz="900" i="1">
-                <a:solidFill>
-                  <a:srgbClr val="5C3A1F"/>
+              <a:rPr sz="1170" i="1">
+                <a:solidFill>
+                  <a:srgbClr val="4A2D18"/>
                 </a:solidFill>
                 <a:latin typeface="Calibri"/>
               </a:rPr>
@@ -12137,9 +12137,9 @@
           <a:p>
             <a:pPr algn="l"/>
             <a:r>
-              <a:rPr sz="1100" b="0" i="1">
-                <a:solidFill>
-                  <a:srgbClr val="4A5568"/>
+              <a:rPr sz="1430" b="0" i="1">
+                <a:solidFill>
+                  <a:srgbClr val="2D3748"/>
                 </a:solidFill>
                 <a:latin typeface="Calibri"/>
               </a:rPr>
@@ -12167,7 +12167,7 @@
           </a:solidFill>
           <a:ln w="6350">
             <a:solidFill>
-              <a:srgbClr val="C9A84C"/>
+              <a:srgbClr val="B8941A"/>
             </a:solidFill>
           </a:ln>
           <a:effectLst/>
@@ -12218,9 +12218,9 @@
           <a:p>
             <a:pPr algn="l"/>
             <a:r>
-              <a:rPr sz="1100" b="1" i="0">
-                <a:solidFill>
-                  <a:srgbClr val="5C3A1F"/>
+              <a:rPr sz="1430" b="1" i="0">
+                <a:solidFill>
+                  <a:srgbClr val="4A2D18"/>
                 </a:solidFill>
                 <a:latin typeface="Calibri"/>
               </a:rPr>
@@ -12253,7 +12253,7 @@
           <a:p>
             <a:pPr algn="l"/>
             <a:r>
-              <a:rPr sz="1000" b="0" i="0">
+              <a:rPr sz="1300" b="0" i="0">
                 <a:solidFill>
                   <a:srgbClr val="1E1508"/>
                 </a:solidFill>
@@ -12289,7 +12289,7 @@
           <a:p>
             <a:pPr algn="l"/>
             <a:r>
-              <a:rPr sz="1000" b="0" i="0">
+              <a:rPr sz="1300" b="0" i="0">
                 <a:solidFill>
                   <a:srgbClr val="1E1508"/>
                 </a:solidFill>
@@ -12320,7 +12320,7 @@
           </a:solidFill>
           <a:ln w="6350">
             <a:solidFill>
-              <a:srgbClr val="C9A84C"/>
+              <a:srgbClr val="B8941A"/>
             </a:solidFill>
           </a:ln>
           <a:effectLst/>
@@ -12371,9 +12371,9 @@
           <a:p>
             <a:pPr algn="l"/>
             <a:r>
-              <a:rPr sz="1100" b="1" i="0">
-                <a:solidFill>
-                  <a:srgbClr val="5C3A1F"/>
+              <a:rPr sz="1430" b="1" i="0">
+                <a:solidFill>
+                  <a:srgbClr val="4A2D18"/>
                 </a:solidFill>
                 <a:latin typeface="Calibri"/>
               </a:rPr>
@@ -12406,9 +12406,9 @@
           <a:p>
             <a:pPr algn="l"/>
             <a:r>
-              <a:rPr sz="900" b="0" i="1">
-                <a:solidFill>
-                  <a:srgbClr val="4A5568"/>
+              <a:rPr sz="1170" b="0" i="1">
+                <a:solidFill>
+                  <a:srgbClr val="2D3748"/>
                 </a:solidFill>
                 <a:latin typeface="Calibri"/>
               </a:rPr>
@@ -12441,9 +12441,9 @@
           <a:p>
             <a:pPr algn="l"/>
             <a:r>
-              <a:rPr sz="1000" b="0" i="0">
-                <a:solidFill>
-                  <a:srgbClr val="C9A84C"/>
+              <a:rPr sz="1300" b="0" i="0">
+                <a:solidFill>
+                  <a:srgbClr val="B8941A"/>
                 </a:solidFill>
                 <a:latin typeface="Calibri"/>
               </a:rPr>
@@ -12476,9 +12476,9 @@
           <a:p>
             <a:pPr algn="l"/>
             <a:r>
-              <a:rPr sz="900" b="0" i="0">
-                <a:solidFill>
-                  <a:srgbClr val="4A5568"/>
+              <a:rPr sz="1170" b="0" i="0">
+                <a:solidFill>
+                  <a:srgbClr val="2D3748"/>
                 </a:solidFill>
                 <a:latin typeface="Calibri"/>
               </a:rPr>
@@ -12511,9 +12511,9 @@
           <a:p>
             <a:pPr algn="r"/>
             <a:r>
-              <a:rPr sz="900" b="0" i="0">
-                <a:solidFill>
-                  <a:srgbClr val="4A5568"/>
+              <a:rPr sz="1170" b="0" i="0">
+                <a:solidFill>
+                  <a:srgbClr val="2D3748"/>
                 </a:solidFill>
                 <a:latin typeface="Calibri"/>
               </a:rPr>
@@ -12537,7 +12537,7 @@
             <a:avLst/>
           </a:prstGeom>
           <a:solidFill>
-            <a:srgbClr val="C9A84C"/>
+            <a:srgbClr val="B8941A"/>
           </a:solidFill>
           <a:ln>
             <a:noFill/>
@@ -12607,9 +12607,9 @@
           <a:p>
             <a:pPr algn="l"/>
             <a:r>
-              <a:rPr sz="3200" b="1" i="0">
-                <a:solidFill>
-                  <a:srgbClr val="5C3A1F"/>
+              <a:rPr sz="4160" b="1" i="0">
+                <a:solidFill>
+                  <a:srgbClr val="4A2D18"/>
                 </a:solidFill>
                 <a:latin typeface="Calibri"/>
               </a:rPr>
@@ -12633,7 +12633,7 @@
             <a:avLst/>
           </a:prstGeom>
           <a:solidFill>
-            <a:srgbClr val="C9A84C"/>
+            <a:srgbClr val="B8941A"/>
           </a:solidFill>
           <a:ln>
             <a:noFill/>
@@ -12685,9 +12685,9 @@
           <a:p>
             <a:pPr algn="l"/>
             <a:r>
-              <a:rPr sz="1400" b="0" i="1">
-                <a:solidFill>
-                  <a:srgbClr val="4A5568"/>
+              <a:rPr sz="1820" b="0" i="1">
+                <a:solidFill>
+                  <a:srgbClr val="2D3748"/>
                 </a:solidFill>
                 <a:latin typeface="Calibri"/>
               </a:rPr>
@@ -12764,9 +12764,9 @@
           <a:p>
             <a:pPr algn="l"/>
             <a:r>
-              <a:rPr sz="1100" b="1" i="0">
-                <a:solidFill>
-                  <a:srgbClr val="5C3A1F"/>
+              <a:rPr sz="1430" b="1" i="0">
+                <a:solidFill>
+                  <a:srgbClr val="4A2D18"/>
                 </a:solidFill>
                 <a:latin typeface="Calibri"/>
               </a:rPr>
@@ -12799,9 +12799,9 @@
           <a:p>
             <a:pPr algn="l"/>
             <a:r>
-              <a:rPr sz="1100" b="1" i="0">
-                <a:solidFill>
-                  <a:srgbClr val="5C3A1F"/>
+              <a:rPr sz="1430" b="1" i="0">
+                <a:solidFill>
+                  <a:srgbClr val="4A2D18"/>
                 </a:solidFill>
                 <a:latin typeface="Calibri"/>
               </a:rPr>
@@ -12825,7 +12825,7 @@
             <a:avLst/>
           </a:prstGeom>
           <a:solidFill>
-            <a:srgbClr val="C9A84C"/>
+            <a:srgbClr val="B8941A"/>
           </a:solidFill>
           <a:ln>
             <a:noFill/>
@@ -12921,7 +12921,7 @@
           <a:p>
             <a:pPr algn="l"/>
             <a:r>
-              <a:rPr sz="1100" b="0" i="0">
+              <a:rPr sz="1430" b="0" i="0">
                 <a:solidFill>
                   <a:srgbClr val="1E1508"/>
                 </a:solidFill>
@@ -12956,7 +12956,7 @@
           <a:p>
             <a:pPr algn="l"/>
             <a:r>
-              <a:rPr sz="1100" b="0" i="0">
+              <a:rPr sz="1430" b="0" i="0">
                 <a:solidFill>
                   <a:srgbClr val="1E1508"/>
                 </a:solidFill>
@@ -12991,7 +12991,7 @@
           <a:p>
             <a:pPr algn="l"/>
             <a:r>
-              <a:rPr sz="1100" b="0" i="0">
+              <a:rPr sz="1430" b="0" i="0">
                 <a:solidFill>
                   <a:srgbClr val="1E1508"/>
                 </a:solidFill>
@@ -13026,7 +13026,7 @@
           <a:p>
             <a:pPr algn="l"/>
             <a:r>
-              <a:rPr sz="1100" b="0" i="0">
+              <a:rPr sz="1430" b="0" i="0">
                 <a:solidFill>
                   <a:srgbClr val="1E1508"/>
                 </a:solidFill>
@@ -13105,7 +13105,7 @@
           <a:p>
             <a:pPr algn="l"/>
             <a:r>
-              <a:rPr sz="1100" b="0" i="0">
+              <a:rPr sz="1430" b="0" i="0">
                 <a:solidFill>
                   <a:srgbClr val="1E1508"/>
                 </a:solidFill>
@@ -13140,7 +13140,7 @@
           <a:p>
             <a:pPr algn="l"/>
             <a:r>
-              <a:rPr sz="1100" b="0" i="0">
+              <a:rPr sz="1430" b="0" i="0">
                 <a:solidFill>
                   <a:srgbClr val="1E1508"/>
                 </a:solidFill>
@@ -13175,7 +13175,7 @@
           <a:p>
             <a:pPr algn="l"/>
             <a:r>
-              <a:rPr sz="1100" b="0" i="0">
+              <a:rPr sz="1430" b="0" i="0">
                 <a:solidFill>
                   <a:srgbClr val="1E1508"/>
                 </a:solidFill>
@@ -13210,7 +13210,7 @@
           <a:p>
             <a:pPr algn="l"/>
             <a:r>
-              <a:rPr sz="1100" b="0" i="0">
+              <a:rPr sz="1430" b="0" i="0">
                 <a:solidFill>
                   <a:srgbClr val="1E1508"/>
                 </a:solidFill>
@@ -13289,7 +13289,7 @@
           <a:p>
             <a:pPr algn="l"/>
             <a:r>
-              <a:rPr sz="1100" b="0" i="0">
+              <a:rPr sz="1430" b="0" i="0">
                 <a:solidFill>
                   <a:srgbClr val="1E1508"/>
                 </a:solidFill>
@@ -13324,7 +13324,7 @@
           <a:p>
             <a:pPr algn="l"/>
             <a:r>
-              <a:rPr sz="1100" b="0" i="0">
+              <a:rPr sz="1430" b="0" i="0">
                 <a:solidFill>
                   <a:srgbClr val="1E1508"/>
                 </a:solidFill>
@@ -13359,9 +13359,9 @@
           <a:p>
             <a:pPr algn="l"/>
             <a:r>
-              <a:rPr sz="900" b="0" i="0">
-                <a:solidFill>
-                  <a:srgbClr val="4A5568"/>
+              <a:rPr sz="1170" b="0" i="0">
+                <a:solidFill>
+                  <a:srgbClr val="2D3748"/>
                 </a:solidFill>
                 <a:latin typeface="Calibri"/>
               </a:rPr>
@@ -13394,9 +13394,9 @@
           <a:p>
             <a:pPr algn="r"/>
             <a:r>
-              <a:rPr sz="900" b="0" i="0">
-                <a:solidFill>
-                  <a:srgbClr val="4A5568"/>
+              <a:rPr sz="1170" b="0" i="0">
+                <a:solidFill>
+                  <a:srgbClr val="2D3748"/>
                 </a:solidFill>
                 <a:latin typeface="Calibri"/>
               </a:rPr>
@@ -13420,7 +13420,7 @@
             <a:avLst/>
           </a:prstGeom>
           <a:solidFill>
-            <a:srgbClr val="C9A84C"/>
+            <a:srgbClr val="B8941A"/>
           </a:solidFill>
           <a:ln>
             <a:noFill/>
@@ -13490,9 +13490,9 @@
           <a:p>
             <a:pPr algn="l"/>
             <a:r>
-              <a:rPr sz="3200" b="1" i="0">
-                <a:solidFill>
-                  <a:srgbClr val="5C3A1F"/>
+              <a:rPr sz="4160" b="1" i="0">
+                <a:solidFill>
+                  <a:srgbClr val="4A2D18"/>
                 </a:solidFill>
                 <a:latin typeface="Calibri"/>
               </a:rPr>
@@ -13516,7 +13516,7 @@
             <a:avLst/>
           </a:prstGeom>
           <a:solidFill>
-            <a:srgbClr val="C9A84C"/>
+            <a:srgbClr val="B8941A"/>
           </a:solidFill>
           <a:ln>
             <a:noFill/>
@@ -13568,9 +13568,9 @@
           <a:p>
             <a:pPr algn="l"/>
             <a:r>
-              <a:rPr sz="1400" b="0" i="1">
-                <a:solidFill>
-                  <a:srgbClr val="4A5568"/>
+              <a:rPr sz="1820" b="0" i="1">
+                <a:solidFill>
+                  <a:srgbClr val="2D3748"/>
                 </a:solidFill>
                 <a:latin typeface="Calibri"/>
               </a:rPr>
@@ -13607,16 +13607,16 @@
               </a:lnSpc>
             </a:pPr>
             <a:r>
-              <a:rPr sz="1400" b="1">
-                <a:solidFill>
-                  <a:srgbClr val="C9A84C"/>
+              <a:rPr sz="1820" b="1">
+                <a:solidFill>
+                  <a:srgbClr val="B8941A"/>
                 </a:solidFill>
                 <a:latin typeface="Calibri"/>
               </a:rPr>
               <a:t>• </a:t>
             </a:r>
             <a:r>
-              <a:rPr sz="1200">
+              <a:rPr sz="1560">
                 <a:solidFill>
                   <a:srgbClr val="1E1508"/>
                 </a:solidFill>
@@ -13635,16 +13635,16 @@
               </a:spcBef>
             </a:pPr>
             <a:r>
-              <a:rPr sz="1400" b="1">
-                <a:solidFill>
-                  <a:srgbClr val="C9A84C"/>
+              <a:rPr sz="1820" b="1">
+                <a:solidFill>
+                  <a:srgbClr val="B8941A"/>
                 </a:solidFill>
                 <a:latin typeface="Calibri"/>
               </a:rPr>
               <a:t>• </a:t>
             </a:r>
             <a:r>
-              <a:rPr sz="1200">
+              <a:rPr sz="1560">
                 <a:solidFill>
                   <a:srgbClr val="1E1508"/>
                 </a:solidFill>
@@ -13663,16 +13663,16 @@
               </a:spcBef>
             </a:pPr>
             <a:r>
-              <a:rPr sz="1400" b="1">
-                <a:solidFill>
-                  <a:srgbClr val="C9A84C"/>
+              <a:rPr sz="1820" b="1">
+                <a:solidFill>
+                  <a:srgbClr val="B8941A"/>
                 </a:solidFill>
                 <a:latin typeface="Calibri"/>
               </a:rPr>
               <a:t>• </a:t>
             </a:r>
             <a:r>
-              <a:rPr sz="1200">
+              <a:rPr sz="1560">
                 <a:solidFill>
                   <a:srgbClr val="1E1508"/>
                 </a:solidFill>
@@ -13691,16 +13691,16 @@
               </a:spcBef>
             </a:pPr>
             <a:r>
-              <a:rPr sz="1400" b="1">
-                <a:solidFill>
-                  <a:srgbClr val="C9A84C"/>
+              <a:rPr sz="1820" b="1">
+                <a:solidFill>
+                  <a:srgbClr val="B8941A"/>
                 </a:solidFill>
                 <a:latin typeface="Calibri"/>
               </a:rPr>
               <a:t>• </a:t>
             </a:r>
             <a:r>
-              <a:rPr sz="1200">
+              <a:rPr sz="1560">
                 <a:solidFill>
                   <a:srgbClr val="1E1508"/>
                 </a:solidFill>
@@ -13719,16 +13719,16 @@
               </a:spcBef>
             </a:pPr>
             <a:r>
-              <a:rPr sz="1400" b="1">
-                <a:solidFill>
-                  <a:srgbClr val="C9A84C"/>
+              <a:rPr sz="1820" b="1">
+                <a:solidFill>
+                  <a:srgbClr val="B8941A"/>
                 </a:solidFill>
                 <a:latin typeface="Calibri"/>
               </a:rPr>
               <a:t>• </a:t>
             </a:r>
             <a:r>
-              <a:rPr sz="1200">
+              <a:rPr sz="1560">
                 <a:solidFill>
                   <a:srgbClr val="1E1508"/>
                 </a:solidFill>
@@ -13747,16 +13747,16 @@
               </a:spcBef>
             </a:pPr>
             <a:r>
-              <a:rPr sz="1400" b="1">
-                <a:solidFill>
-                  <a:srgbClr val="C9A84C"/>
+              <a:rPr sz="1820" b="1">
+                <a:solidFill>
+                  <a:srgbClr val="B8941A"/>
                 </a:solidFill>
                 <a:latin typeface="Calibri"/>
               </a:rPr>
               <a:t>• </a:t>
             </a:r>
             <a:r>
-              <a:rPr sz="1200">
+              <a:rPr sz="1560">
                 <a:solidFill>
                   <a:srgbClr val="1E1508"/>
                 </a:solidFill>
@@ -13775,16 +13775,16 @@
               </a:spcBef>
             </a:pPr>
             <a:r>
-              <a:rPr sz="1400" b="1">
-                <a:solidFill>
-                  <a:srgbClr val="C9A84C"/>
+              <a:rPr sz="1820" b="1">
+                <a:solidFill>
+                  <a:srgbClr val="B8941A"/>
                 </a:solidFill>
                 <a:latin typeface="Calibri"/>
               </a:rPr>
               <a:t>• </a:t>
             </a:r>
             <a:r>
-              <a:rPr sz="1200">
+              <a:rPr sz="1560">
                 <a:solidFill>
                   <a:srgbClr val="1E1508"/>
                 </a:solidFill>
@@ -13803,16 +13803,16 @@
               </a:spcBef>
             </a:pPr>
             <a:r>
-              <a:rPr sz="1400" b="1">
-                <a:solidFill>
-                  <a:srgbClr val="C9A84C"/>
+              <a:rPr sz="1820" b="1">
+                <a:solidFill>
+                  <a:srgbClr val="B8941A"/>
                 </a:solidFill>
                 <a:latin typeface="Calibri"/>
               </a:rPr>
               <a:t>• </a:t>
             </a:r>
             <a:r>
-              <a:rPr sz="1200">
+              <a:rPr sz="1560">
                 <a:solidFill>
                   <a:srgbClr val="1E1508"/>
                 </a:solidFill>
@@ -13831,16 +13831,16 @@
               </a:spcBef>
             </a:pPr>
             <a:r>
-              <a:rPr sz="1400" b="1">
-                <a:solidFill>
-                  <a:srgbClr val="C9A84C"/>
+              <a:rPr sz="1820" b="1">
+                <a:solidFill>
+                  <a:srgbClr val="B8941A"/>
                 </a:solidFill>
                 <a:latin typeface="Calibri"/>
               </a:rPr>
               <a:t>• </a:t>
             </a:r>
             <a:r>
-              <a:rPr sz="1200">
+              <a:rPr sz="1560">
                 <a:solidFill>
                   <a:srgbClr val="1E1508"/>
                 </a:solidFill>
@@ -13870,7 +13870,7 @@
           </a:solidFill>
           <a:ln w="6350">
             <a:solidFill>
-              <a:srgbClr val="C9A84C"/>
+              <a:srgbClr val="B8941A"/>
             </a:solidFill>
           </a:ln>
           <a:effectLst/>
@@ -13921,9 +13921,9 @@
           <a:p>
             <a:pPr algn="ctr"/>
             <a:r>
-              <a:rPr sz="1200" b="1" i="0">
-                <a:solidFill>
-                  <a:srgbClr val="5C3A1F"/>
+              <a:rPr sz="1560" b="1" i="0">
+                <a:solidFill>
+                  <a:srgbClr val="4A2D18"/>
                 </a:solidFill>
                 <a:latin typeface="Calibri"/>
               </a:rPr>
@@ -13956,9 +13956,9 @@
           <a:p>
             <a:pPr algn="l"/>
             <a:r>
-              <a:rPr sz="900" b="0" i="0">
-                <a:solidFill>
-                  <a:srgbClr val="4A5568"/>
+              <a:rPr sz="1170" b="0" i="0">
+                <a:solidFill>
+                  <a:srgbClr val="2D3748"/>
                 </a:solidFill>
                 <a:latin typeface="Calibri"/>
               </a:rPr>
@@ -13991,9 +13991,9 @@
           <a:p>
             <a:pPr algn="r"/>
             <a:r>
-              <a:rPr sz="900" b="0" i="0">
-                <a:solidFill>
-                  <a:srgbClr val="4A5568"/>
+              <a:rPr sz="1170" b="0" i="0">
+                <a:solidFill>
+                  <a:srgbClr val="2D3748"/>
                 </a:solidFill>
                 <a:latin typeface="Calibri"/>
               </a:rPr>
@@ -14017,7 +14017,7 @@
             <a:avLst/>
           </a:prstGeom>
           <a:solidFill>
-            <a:srgbClr val="C9A84C"/>
+            <a:srgbClr val="B8941A"/>
           </a:solidFill>
           <a:ln>
             <a:noFill/>
@@ -14087,9 +14087,9 @@
           <a:p>
             <a:pPr algn="l"/>
             <a:r>
-              <a:rPr sz="3200" b="1" i="0">
-                <a:solidFill>
-                  <a:srgbClr val="5C3A1F"/>
+              <a:rPr sz="4160" b="1" i="0">
+                <a:solidFill>
+                  <a:srgbClr val="4A2D18"/>
                 </a:solidFill>
                 <a:latin typeface="Calibri"/>
               </a:rPr>
@@ -14113,7 +14113,7 @@
             <a:avLst/>
           </a:prstGeom>
           <a:solidFill>
-            <a:srgbClr val="C9A84C"/>
+            <a:srgbClr val="B8941A"/>
           </a:solidFill>
           <a:ln>
             <a:noFill/>
@@ -14165,9 +14165,9 @@
           <a:p>
             <a:pPr algn="l"/>
             <a:r>
-              <a:rPr sz="1400" b="0" i="1">
-                <a:solidFill>
-                  <a:srgbClr val="4A5568"/>
+              <a:rPr sz="1820" b="0" i="1">
+                <a:solidFill>
+                  <a:srgbClr val="2D3748"/>
                 </a:solidFill>
                 <a:latin typeface="Calibri"/>
               </a:rPr>
@@ -14244,9 +14244,9 @@
           <a:p>
             <a:pPr algn="l"/>
             <a:r>
-              <a:rPr sz="1100" b="1" i="0">
-                <a:solidFill>
-                  <a:srgbClr val="5C3A1F"/>
+              <a:rPr sz="1430" b="1" i="0">
+                <a:solidFill>
+                  <a:srgbClr val="4A2D18"/>
                 </a:solidFill>
                 <a:latin typeface="Calibri"/>
               </a:rPr>
@@ -14279,9 +14279,9 @@
           <a:p>
             <a:pPr algn="l"/>
             <a:r>
-              <a:rPr sz="1100" b="1" i="0">
-                <a:solidFill>
-                  <a:srgbClr val="5C3A1F"/>
+              <a:rPr sz="1430" b="1" i="0">
+                <a:solidFill>
+                  <a:srgbClr val="4A2D18"/>
                 </a:solidFill>
                 <a:latin typeface="Calibri"/>
               </a:rPr>
@@ -14305,7 +14305,7 @@
             <a:avLst/>
           </a:prstGeom>
           <a:solidFill>
-            <a:srgbClr val="C9A84C"/>
+            <a:srgbClr val="B8941A"/>
           </a:solidFill>
           <a:ln>
             <a:noFill/>
@@ -14401,7 +14401,7 @@
           <a:p>
             <a:pPr algn="l"/>
             <a:r>
-              <a:rPr sz="900" b="0" i="0">
+              <a:rPr sz="1170" b="0" i="0">
                 <a:solidFill>
                   <a:srgbClr val="1E1508"/>
                 </a:solidFill>
@@ -14436,7 +14436,7 @@
           <a:p>
             <a:pPr algn="l"/>
             <a:r>
-              <a:rPr sz="900" b="0" i="0">
+              <a:rPr sz="1170" b="0" i="0">
                 <a:solidFill>
                   <a:srgbClr val="1E1508"/>
                 </a:solidFill>
@@ -14471,9 +14471,9 @@
           <a:p>
             <a:pPr algn="l"/>
             <a:r>
-              <a:rPr sz="800" b="0" i="1">
-                <a:solidFill>
-                  <a:srgbClr val="5C3A1F"/>
+              <a:rPr sz="1040" b="0" i="1">
+                <a:solidFill>
+                  <a:srgbClr val="4A2D18"/>
                 </a:solidFill>
                 <a:latin typeface="Calibri"/>
               </a:rPr>
@@ -14506,7 +14506,7 @@
           <a:p>
             <a:pPr algn="l"/>
             <a:r>
-              <a:rPr sz="900" b="0" i="0">
+              <a:rPr sz="1170" b="0" i="0">
                 <a:solidFill>
                   <a:srgbClr val="1E1508"/>
                 </a:solidFill>
@@ -14541,7 +14541,7 @@
           <a:p>
             <a:pPr algn="l"/>
             <a:r>
-              <a:rPr sz="900" b="0" i="0">
+              <a:rPr sz="1170" b="0" i="0">
                 <a:solidFill>
                   <a:srgbClr val="1E1508"/>
                 </a:solidFill>
@@ -14576,9 +14576,9 @@
           <a:p>
             <a:pPr algn="l"/>
             <a:r>
-              <a:rPr sz="800" b="0" i="1">
-                <a:solidFill>
-                  <a:srgbClr val="5C3A1F"/>
+              <a:rPr sz="1040" b="0" i="1">
+                <a:solidFill>
+                  <a:srgbClr val="4A2D18"/>
                 </a:solidFill>
                 <a:latin typeface="Calibri"/>
               </a:rPr>
@@ -14655,7 +14655,7 @@
           <a:p>
             <a:pPr algn="l"/>
             <a:r>
-              <a:rPr sz="900" b="0" i="0">
+              <a:rPr sz="1170" b="0" i="0">
                 <a:solidFill>
                   <a:srgbClr val="1E1508"/>
                 </a:solidFill>
@@ -14690,7 +14690,7 @@
           <a:p>
             <a:pPr algn="l"/>
             <a:r>
-              <a:rPr sz="900" b="0" i="0">
+              <a:rPr sz="1170" b="0" i="0">
                 <a:solidFill>
                   <a:srgbClr val="1E1508"/>
                 </a:solidFill>
@@ -14725,9 +14725,9 @@
           <a:p>
             <a:pPr algn="l"/>
             <a:r>
-              <a:rPr sz="800" b="0" i="1">
-                <a:solidFill>
-                  <a:srgbClr val="5C3A1F"/>
+              <a:rPr sz="1040" b="0" i="1">
+                <a:solidFill>
+                  <a:srgbClr val="4A2D18"/>
                 </a:solidFill>
                 <a:latin typeface="Calibri"/>
               </a:rPr>
@@ -14760,7 +14760,7 @@
           <a:p>
             <a:pPr algn="l"/>
             <a:r>
-              <a:rPr sz="900" b="0" i="0">
+              <a:rPr sz="1170" b="0" i="0">
                 <a:solidFill>
                   <a:srgbClr val="1E1508"/>
                 </a:solidFill>
@@ -14795,7 +14795,7 @@
           <a:p>
             <a:pPr algn="l"/>
             <a:r>
-              <a:rPr sz="900" b="0" i="0">
+              <a:rPr sz="1170" b="0" i="0">
                 <a:solidFill>
                   <a:srgbClr val="1E1508"/>
                 </a:solidFill>
@@ -14830,9 +14830,9 @@
           <a:p>
             <a:pPr algn="l"/>
             <a:r>
-              <a:rPr sz="800" b="0" i="1">
-                <a:solidFill>
-                  <a:srgbClr val="5C3A1F"/>
+              <a:rPr sz="1040" b="0" i="1">
+                <a:solidFill>
+                  <a:srgbClr val="4A2D18"/>
                 </a:solidFill>
                 <a:latin typeface="Calibri"/>
               </a:rPr>
@@ -14909,7 +14909,7 @@
           <a:p>
             <a:pPr algn="l"/>
             <a:r>
-              <a:rPr sz="900" b="0" i="0">
+              <a:rPr sz="1170" b="0" i="0">
                 <a:solidFill>
                   <a:srgbClr val="1E1508"/>
                 </a:solidFill>
@@ -14944,7 +14944,7 @@
           <a:p>
             <a:pPr algn="l"/>
             <a:r>
-              <a:rPr sz="900" b="0" i="0">
+              <a:rPr sz="1170" b="0" i="0">
                 <a:solidFill>
                   <a:srgbClr val="1E1508"/>
                 </a:solidFill>
@@ -14979,9 +14979,9 @@
           <a:p>
             <a:pPr algn="l"/>
             <a:r>
-              <a:rPr sz="800" b="0" i="1">
-                <a:solidFill>
-                  <a:srgbClr val="5C3A1F"/>
+              <a:rPr sz="1040" b="0" i="1">
+                <a:solidFill>
+                  <a:srgbClr val="4A2D18"/>
                 </a:solidFill>
                 <a:latin typeface="Calibri"/>
               </a:rPr>
@@ -15014,7 +15014,7 @@
           <a:p>
             <a:pPr algn="l"/>
             <a:r>
-              <a:rPr sz="900" b="0" i="0">
+              <a:rPr sz="1170" b="0" i="0">
                 <a:solidFill>
                   <a:srgbClr val="1E1508"/>
                 </a:solidFill>
@@ -15049,7 +15049,7 @@
           <a:p>
             <a:pPr algn="l"/>
             <a:r>
-              <a:rPr sz="900" b="0" i="0">
+              <a:rPr sz="1170" b="0" i="0">
                 <a:solidFill>
                   <a:srgbClr val="1E1508"/>
                 </a:solidFill>
@@ -15084,9 +15084,9 @@
           <a:p>
             <a:pPr algn="l"/>
             <a:r>
-              <a:rPr sz="800" b="0" i="1">
-                <a:solidFill>
-                  <a:srgbClr val="5C3A1F"/>
+              <a:rPr sz="1040" b="0" i="1">
+                <a:solidFill>
+                  <a:srgbClr val="4A2D18"/>
                 </a:solidFill>
                 <a:latin typeface="Calibri"/>
               </a:rPr>
@@ -15163,7 +15163,7 @@
           <a:p>
             <a:pPr algn="l"/>
             <a:r>
-              <a:rPr sz="900" b="0" i="0">
+              <a:rPr sz="1170" b="0" i="0">
                 <a:solidFill>
                   <a:srgbClr val="1E1508"/>
                 </a:solidFill>
@@ -15198,7 +15198,7 @@
           <a:p>
             <a:pPr algn="l"/>
             <a:r>
-              <a:rPr sz="900" b="0" i="0">
+              <a:rPr sz="1170" b="0" i="0">
                 <a:solidFill>
                   <a:srgbClr val="1E1508"/>
                 </a:solidFill>
@@ -15233,9 +15233,9 @@
           <a:p>
             <a:pPr algn="l"/>
             <a:r>
-              <a:rPr sz="800" b="0" i="1">
-                <a:solidFill>
-                  <a:srgbClr val="5C3A1F"/>
+              <a:rPr sz="1040" b="0" i="1">
+                <a:solidFill>
+                  <a:srgbClr val="4A2D18"/>
                 </a:solidFill>
                 <a:latin typeface="Calibri"/>
               </a:rPr>
@@ -15268,7 +15268,7 @@
           <a:p>
             <a:pPr algn="l"/>
             <a:r>
-              <a:rPr sz="900" b="0" i="0">
+              <a:rPr sz="1170" b="0" i="0">
                 <a:solidFill>
                   <a:srgbClr val="1E1508"/>
                 </a:solidFill>
@@ -15303,7 +15303,7 @@
           <a:p>
             <a:pPr algn="l"/>
             <a:r>
-              <a:rPr sz="900" b="0" i="0">
+              <a:rPr sz="1170" b="0" i="0">
                 <a:solidFill>
                   <a:srgbClr val="1E1508"/>
                 </a:solidFill>
@@ -15338,9 +15338,9 @@
           <a:p>
             <a:pPr algn="l"/>
             <a:r>
-              <a:rPr sz="800" b="0" i="1">
-                <a:solidFill>
-                  <a:srgbClr val="5C3A1F"/>
+              <a:rPr sz="1040" b="0" i="1">
+                <a:solidFill>
+                  <a:srgbClr val="4A2D18"/>
                 </a:solidFill>
                 <a:latin typeface="Calibri"/>
               </a:rPr>
@@ -15373,9 +15373,9 @@
           <a:p>
             <a:pPr algn="l"/>
             <a:r>
-              <a:rPr sz="900" b="0" i="0">
-                <a:solidFill>
-                  <a:srgbClr val="4A5568"/>
+              <a:rPr sz="1170" b="0" i="0">
+                <a:solidFill>
+                  <a:srgbClr val="2D3748"/>
                 </a:solidFill>
                 <a:latin typeface="Calibri"/>
               </a:rPr>
@@ -15408,9 +15408,9 @@
           <a:p>
             <a:pPr algn="r"/>
             <a:r>
-              <a:rPr sz="900" b="0" i="0">
-                <a:solidFill>
-                  <a:srgbClr val="4A5568"/>
+              <a:rPr sz="1170" b="0" i="0">
+                <a:solidFill>
+                  <a:srgbClr val="2D3748"/>
                 </a:solidFill>
                 <a:latin typeface="Calibri"/>
               </a:rPr>
@@ -15434,7 +15434,7 @@
             <a:avLst/>
           </a:prstGeom>
           <a:solidFill>
-            <a:srgbClr val="C9A84C"/>
+            <a:srgbClr val="B8941A"/>
           </a:solidFill>
           <a:ln>
             <a:noFill/>
@@ -15504,9 +15504,9 @@
           <a:p>
             <a:pPr algn="l"/>
             <a:r>
-              <a:rPr sz="3200" b="1" i="0">
-                <a:solidFill>
-                  <a:srgbClr val="5C3A1F"/>
+              <a:rPr sz="4160" b="1" i="0">
+                <a:solidFill>
+                  <a:srgbClr val="4A2D18"/>
                 </a:solidFill>
                 <a:latin typeface="Calibri"/>
               </a:rPr>
@@ -15530,7 +15530,7 @@
             <a:avLst/>
           </a:prstGeom>
           <a:solidFill>
-            <a:srgbClr val="C9A84C"/>
+            <a:srgbClr val="B8941A"/>
           </a:solidFill>
           <a:ln>
             <a:noFill/>
@@ -15582,9 +15582,9 @@
           <a:p>
             <a:pPr algn="l"/>
             <a:r>
-              <a:rPr sz="1400" b="0" i="1">
-                <a:solidFill>
-                  <a:srgbClr val="4A5568"/>
+              <a:rPr sz="1820" b="0" i="1">
+                <a:solidFill>
+                  <a:srgbClr val="2D3748"/>
                 </a:solidFill>
                 <a:latin typeface="Calibri"/>
               </a:rPr>
@@ -15621,16 +15621,16 @@
               </a:lnSpc>
             </a:pPr>
             <a:r>
-              <a:rPr sz="1300" b="1">
-                <a:solidFill>
-                  <a:srgbClr val="C9A84C"/>
+              <a:rPr sz="1690" b="1">
+                <a:solidFill>
+                  <a:srgbClr val="B8941A"/>
                 </a:solidFill>
                 <a:latin typeface="Calibri"/>
               </a:rPr>
               <a:t>• </a:t>
             </a:r>
             <a:r>
-              <a:rPr sz="1100">
+              <a:rPr sz="1430">
                 <a:solidFill>
                   <a:srgbClr val="1E1508"/>
                 </a:solidFill>
@@ -15649,9 +15649,9 @@
               </a:spcBef>
             </a:pPr>
             <a:r>
-              <a:rPr sz="900" i="1">
-                <a:solidFill>
-                  <a:srgbClr val="5C3A1F"/>
+              <a:rPr sz="1170" i="1">
+                <a:solidFill>
+                  <a:srgbClr val="4A2D18"/>
                 </a:solidFill>
                 <a:latin typeface="Calibri"/>
               </a:rPr>
@@ -15668,16 +15668,16 @@
               </a:spcBef>
             </a:pPr>
             <a:r>
-              <a:rPr sz="1300" b="1">
-                <a:solidFill>
-                  <a:srgbClr val="C9A84C"/>
+              <a:rPr sz="1690" b="1">
+                <a:solidFill>
+                  <a:srgbClr val="B8941A"/>
                 </a:solidFill>
                 <a:latin typeface="Calibri"/>
               </a:rPr>
               <a:t>• </a:t>
             </a:r>
             <a:r>
-              <a:rPr sz="1100">
+              <a:rPr sz="1430">
                 <a:solidFill>
                   <a:srgbClr val="1E1508"/>
                 </a:solidFill>
@@ -15696,9 +15696,9 @@
               </a:spcBef>
             </a:pPr>
             <a:r>
-              <a:rPr sz="900" i="1">
-                <a:solidFill>
-                  <a:srgbClr val="5C3A1F"/>
+              <a:rPr sz="1170" i="1">
+                <a:solidFill>
+                  <a:srgbClr val="4A2D18"/>
                 </a:solidFill>
                 <a:latin typeface="Calibri"/>
               </a:rPr>
@@ -15715,16 +15715,16 @@
               </a:spcBef>
             </a:pPr>
             <a:r>
-              <a:rPr sz="1300" b="1">
-                <a:solidFill>
-                  <a:srgbClr val="C9A84C"/>
+              <a:rPr sz="1690" b="1">
+                <a:solidFill>
+                  <a:srgbClr val="B8941A"/>
                 </a:solidFill>
                 <a:latin typeface="Calibri"/>
               </a:rPr>
               <a:t>• </a:t>
             </a:r>
             <a:r>
-              <a:rPr sz="1100">
+              <a:rPr sz="1430">
                 <a:solidFill>
                   <a:srgbClr val="1E1508"/>
                 </a:solidFill>
@@ -15743,9 +15743,9 @@
               </a:spcBef>
             </a:pPr>
             <a:r>
-              <a:rPr sz="900" i="1">
-                <a:solidFill>
-                  <a:srgbClr val="5C3A1F"/>
+              <a:rPr sz="1170" i="1">
+                <a:solidFill>
+                  <a:srgbClr val="4A2D18"/>
                 </a:solidFill>
                 <a:latin typeface="Calibri"/>
               </a:rPr>
@@ -15762,16 +15762,16 @@
               </a:spcBef>
             </a:pPr>
             <a:r>
-              <a:rPr sz="1300" b="1">
-                <a:solidFill>
-                  <a:srgbClr val="C9A84C"/>
+              <a:rPr sz="1690" b="1">
+                <a:solidFill>
+                  <a:srgbClr val="B8941A"/>
                 </a:solidFill>
                 <a:latin typeface="Calibri"/>
               </a:rPr>
               <a:t>• </a:t>
             </a:r>
             <a:r>
-              <a:rPr sz="1100">
+              <a:rPr sz="1430">
                 <a:solidFill>
                   <a:srgbClr val="1E1508"/>
                 </a:solidFill>
@@ -15790,9 +15790,9 @@
               </a:spcBef>
             </a:pPr>
             <a:r>
-              <a:rPr sz="900" i="1">
-                <a:solidFill>
-                  <a:srgbClr val="5C3A1F"/>
+              <a:rPr sz="1170" i="1">
+                <a:solidFill>
+                  <a:srgbClr val="4A2D18"/>
                 </a:solidFill>
                 <a:latin typeface="Calibri"/>
               </a:rPr>
@@ -15809,16 +15809,16 @@
               </a:spcBef>
             </a:pPr>
             <a:r>
-              <a:rPr sz="1300" b="1">
-                <a:solidFill>
-                  <a:srgbClr val="C9A84C"/>
+              <a:rPr sz="1690" b="1">
+                <a:solidFill>
+                  <a:srgbClr val="B8941A"/>
                 </a:solidFill>
                 <a:latin typeface="Calibri"/>
               </a:rPr>
               <a:t>• </a:t>
             </a:r>
             <a:r>
-              <a:rPr sz="1100">
+              <a:rPr sz="1430">
                 <a:solidFill>
                   <a:srgbClr val="1E1508"/>
                 </a:solidFill>
@@ -15837,9 +15837,9 @@
               </a:spcBef>
             </a:pPr>
             <a:r>
-              <a:rPr sz="900" i="1">
-                <a:solidFill>
-                  <a:srgbClr val="5C3A1F"/>
+              <a:rPr sz="1170" i="1">
+                <a:solidFill>
+                  <a:srgbClr val="4A2D18"/>
                 </a:solidFill>
                 <a:latin typeface="Calibri"/>
               </a:rPr>
@@ -15856,16 +15856,16 @@
               </a:spcBef>
             </a:pPr>
             <a:r>
-              <a:rPr sz="1300" b="1">
-                <a:solidFill>
-                  <a:srgbClr val="C9A84C"/>
+              <a:rPr sz="1690" b="1">
+                <a:solidFill>
+                  <a:srgbClr val="B8941A"/>
                 </a:solidFill>
                 <a:latin typeface="Calibri"/>
               </a:rPr>
               <a:t>• </a:t>
             </a:r>
             <a:r>
-              <a:rPr sz="1100">
+              <a:rPr sz="1430">
                 <a:solidFill>
                   <a:srgbClr val="1E1508"/>
                 </a:solidFill>
@@ -15884,9 +15884,9 @@
               </a:spcBef>
             </a:pPr>
             <a:r>
-              <a:rPr sz="900" i="1">
-                <a:solidFill>
-                  <a:srgbClr val="5C3A1F"/>
+              <a:rPr sz="1170" i="1">
+                <a:solidFill>
+                  <a:srgbClr val="4A2D18"/>
                 </a:solidFill>
                 <a:latin typeface="Calibri"/>
               </a:rPr>
@@ -15903,16 +15903,16 @@
               </a:spcBef>
             </a:pPr>
             <a:r>
-              <a:rPr sz="1300" b="1">
-                <a:solidFill>
-                  <a:srgbClr val="C9A84C"/>
+              <a:rPr sz="1690" b="1">
+                <a:solidFill>
+                  <a:srgbClr val="B8941A"/>
                 </a:solidFill>
                 <a:latin typeface="Calibri"/>
               </a:rPr>
               <a:t>• </a:t>
             </a:r>
             <a:r>
-              <a:rPr sz="1100">
+              <a:rPr sz="1430">
                 <a:solidFill>
                   <a:srgbClr val="1E1508"/>
                 </a:solidFill>
@@ -15931,9 +15931,9 @@
               </a:spcBef>
             </a:pPr>
             <a:r>
-              <a:rPr sz="900" i="1">
-                <a:solidFill>
-                  <a:srgbClr val="5C3A1F"/>
+              <a:rPr sz="1170" i="1">
+                <a:solidFill>
+                  <a:srgbClr val="4A2D18"/>
                 </a:solidFill>
                 <a:latin typeface="Calibri"/>
               </a:rPr>
@@ -15950,16 +15950,16 @@
               </a:spcBef>
             </a:pPr>
             <a:r>
-              <a:rPr sz="1300" b="1">
-                <a:solidFill>
-                  <a:srgbClr val="C9A84C"/>
+              <a:rPr sz="1690" b="1">
+                <a:solidFill>
+                  <a:srgbClr val="B8941A"/>
                 </a:solidFill>
                 <a:latin typeface="Calibri"/>
               </a:rPr>
               <a:t>• </a:t>
             </a:r>
             <a:r>
-              <a:rPr sz="1100">
+              <a:rPr sz="1430">
                 <a:solidFill>
                   <a:srgbClr val="1E1508"/>
                 </a:solidFill>
@@ -15978,9 +15978,9 @@
               </a:spcBef>
             </a:pPr>
             <a:r>
-              <a:rPr sz="900" i="1">
-                <a:solidFill>
-                  <a:srgbClr val="5C3A1F"/>
+              <a:rPr sz="1170" i="1">
+                <a:solidFill>
+                  <a:srgbClr val="4A2D18"/>
                 </a:solidFill>
                 <a:latin typeface="Calibri"/>
               </a:rPr>
@@ -15997,16 +15997,16 @@
               </a:spcBef>
             </a:pPr>
             <a:r>
-              <a:rPr sz="1300" b="1">
-                <a:solidFill>
-                  <a:srgbClr val="C9A84C"/>
+              <a:rPr sz="1690" b="1">
+                <a:solidFill>
+                  <a:srgbClr val="B8941A"/>
                 </a:solidFill>
                 <a:latin typeface="Calibri"/>
               </a:rPr>
               <a:t>• </a:t>
             </a:r>
             <a:r>
-              <a:rPr sz="1100">
+              <a:rPr sz="1430">
                 <a:solidFill>
                   <a:srgbClr val="1E1508"/>
                 </a:solidFill>
@@ -16025,9 +16025,9 @@
               </a:spcBef>
             </a:pPr>
             <a:r>
-              <a:rPr sz="900" i="1">
-                <a:solidFill>
-                  <a:srgbClr val="5C3A1F"/>
+              <a:rPr sz="1170" i="1">
+                <a:solidFill>
+                  <a:srgbClr val="4A2D18"/>
                 </a:solidFill>
                 <a:latin typeface="Calibri"/>
               </a:rPr>
@@ -16055,7 +16055,7 @@
           </a:solidFill>
           <a:ln w="6350">
             <a:solidFill>
-              <a:srgbClr val="C9A84C"/>
+              <a:srgbClr val="B8941A"/>
             </a:solidFill>
           </a:ln>
           <a:effectLst/>
@@ -16106,9 +16106,9 @@
           <a:p>
             <a:pPr algn="ctr"/>
             <a:r>
-              <a:rPr sz="1400" b="0" i="1">
-                <a:solidFill>
-                  <a:srgbClr val="5C3A1F"/>
+              <a:rPr sz="1820" b="0" i="1">
+                <a:solidFill>
+                  <a:srgbClr val="4A2D18"/>
                 </a:solidFill>
                 <a:latin typeface="Calibri"/>
               </a:rPr>
@@ -16141,9 +16141,9 @@
           <a:p>
             <a:pPr algn="l"/>
             <a:r>
-              <a:rPr sz="900" b="0" i="0">
-                <a:solidFill>
-                  <a:srgbClr val="4A5568"/>
+              <a:rPr sz="1170" b="0" i="0">
+                <a:solidFill>
+                  <a:srgbClr val="2D3748"/>
                 </a:solidFill>
                 <a:latin typeface="Calibri"/>
               </a:rPr>
@@ -16176,9 +16176,9 @@
           <a:p>
             <a:pPr algn="r"/>
             <a:r>
-              <a:rPr sz="900" b="0" i="0">
-                <a:solidFill>
-                  <a:srgbClr val="4A5568"/>
+              <a:rPr sz="1170" b="0" i="0">
+                <a:solidFill>
+                  <a:srgbClr val="2D3748"/>
                 </a:solidFill>
                 <a:latin typeface="Calibri"/>
               </a:rPr>
@@ -16202,7 +16202,7 @@
             <a:avLst/>
           </a:prstGeom>
           <a:solidFill>
-            <a:srgbClr val="C9A84C"/>
+            <a:srgbClr val="B8941A"/>
           </a:solidFill>
           <a:ln>
             <a:noFill/>

</xml_diff>

<commit_message>
Pitch deck: highlight more built-in features
Four targeted edits to make sure no real feature gets buried:

1. SLIDE 10 (Behind the scenes): retitled to 'Behind the scenes —
   low-admin operations' with subtitle '~30 minutes per week...' so
   the time-investment becomes the headline benefit. Added a new
   bullet for chamber-publish / edit / delete of Suggested Experiences
   via the public planner.

2. SLIDE 4 (Discovery): added two new rows — '🏠 Lodging tile' (the
   pitched-roof house tile in the vibe grid that bypasses vibes for
   stay-shopping intent) and '🏋️ Day-Pass Gyms' as an example of the
   12+ vibe-level pills now wired up. Date filter row updated to
   include 'auto-season' as a first-class behavior.

3. SLIDE 5 (Itinerary): added Map view (Leaflet), Print, and 'no
   install, no account, no email' bullets. Tightened body size 11→10
   to fit the longer list.

Plausible Analytics was already covered on slide 9 (Privacy, last
bullet) — no change needed there.
</commit_message>
<xml_diff>
--- a/demo_pitch.pptx
+++ b/demo_pitch.pptx
@@ -3423,7 +3423,7 @@
                 </a:solidFill>
                 <a:latin typeface="Calibri"/>
               </a:rPr>
-              <a:t>Behind the scenes</a:t>
+              <a:t>Behind the scenes — low-admin operations</a:t>
             </a:r>
           </a:p>
         </p:txBody>
@@ -3501,7 +3501,7 @@
                 </a:solidFill>
                 <a:latin typeface="Calibri"/>
               </a:rPr>
-              <a:t>Chamber-staff operations: live data with minimal effort.</a:t>
+              <a:t>~30 minutes per week of chamber-staff time keeps the site live and current.</a:t>
             </a:r>
           </a:p>
         </p:txBody>
@@ -3663,6 +3663,53 @@
                 <a:latin typeface="Calibri"/>
               </a:rPr>
               <a:t>       ↳  One click after a refresh; 460 events get area + venue + tags fixed for ~20¢.</a:t>
+            </a:r>
+          </a:p>
+          <a:p>
+            <a:pPr algn="l">
+              <a:lnSpc>
+                <a:spcPct val="118000"/>
+              </a:lnSpc>
+              <a:spcBef>
+                <a:spcPts val="400"/>
+              </a:spcBef>
+            </a:pPr>
+            <a:r>
+              <a:rPr sz="1560" b="1">
+                <a:solidFill>
+                  <a:srgbClr val="B8941A"/>
+                </a:solidFill>
+                <a:latin typeface="Calibri"/>
+              </a:rPr>
+              <a:t>• </a:t>
+            </a:r>
+            <a:r>
+              <a:rPr sz="1300">
+                <a:solidFill>
+                  <a:srgbClr val="1E1508"/>
+                </a:solidFill>
+                <a:latin typeface="Calibri"/>
+              </a:rPr>
+              <a:t>✨ Publish + edit chamber-curated experiences via the public planner — no separate admin tool</a:t>
+            </a:r>
+          </a:p>
+          <a:p>
+            <a:pPr algn="l">
+              <a:lnSpc>
+                <a:spcPct val="110000"/>
+              </a:lnSpc>
+              <a:spcBef>
+                <a:spcPts val="0"/>
+              </a:spcBef>
+            </a:pPr>
+            <a:r>
+              <a:rPr sz="1040" i="1">
+                <a:solidFill>
+                  <a:srgbClr val="4A2D18"/>
+                </a:solidFill>
+                <a:latin typeface="Calibri"/>
+              </a:rPr>
+              <a:t>       ↳  Chamber builds "Romantic Weekend" in My Itinerary, hits Publish — appears site-wide; edit / delete anytime.</a:t>
             </a:r>
           </a:p>
           <a:p>
@@ -10525,7 +10572,7 @@
         <p:spPr>
           <a:xfrm>
             <a:off x="548640" y="2020824"/>
-            <a:ext cx="11064240" cy="594360"/>
+            <a:ext cx="11064240" cy="548640"/>
           </a:xfrm>
           <a:prstGeom prst="rect">
             <a:avLst/>
@@ -10569,7 +10616,7 @@
         <p:spPr>
           <a:xfrm>
             <a:off x="640080" y="2066544"/>
-            <a:ext cx="2971800" cy="548640"/>
+            <a:ext cx="2971800" cy="502919"/>
           </a:xfrm>
           <a:prstGeom prst="rect">
             <a:avLst/>
@@ -10584,7 +10631,7 @@
           <a:p>
             <a:pPr algn="l"/>
             <a:r>
-              <a:rPr sz="1300" b="0" i="0">
+              <a:rPr sz="1170" b="0" i="0">
                 <a:solidFill>
                   <a:srgbClr val="1E1508"/>
                 </a:solidFill>
@@ -10604,7 +10651,7 @@
         <p:spPr>
           <a:xfrm>
             <a:off x="3749040" y="2057400"/>
-            <a:ext cx="7818119" cy="274320"/>
+            <a:ext cx="7818119" cy="251459"/>
           </a:xfrm>
           <a:prstGeom prst="rect">
             <a:avLst/>
@@ -10619,7 +10666,7 @@
           <a:p>
             <a:pPr algn="l"/>
             <a:r>
-              <a:rPr sz="1300" b="0" i="0">
+              <a:rPr sz="1170" b="0" i="0">
                 <a:solidFill>
                   <a:srgbClr val="1E1508"/>
                 </a:solidFill>
@@ -10638,8 +10685,8 @@
         </p:nvSpPr>
         <p:spPr>
           <a:xfrm>
-            <a:off x="3749040" y="2331720"/>
-            <a:ext cx="7818119" cy="274320"/>
+            <a:off x="3749040" y="2308859"/>
+            <a:ext cx="7818119" cy="251459"/>
           </a:xfrm>
           <a:prstGeom prst="rect">
             <a:avLst/>
@@ -10654,7 +10701,7 @@
           <a:p>
             <a:pPr algn="l"/>
             <a:r>
-              <a:rPr sz="1040" b="0" i="1">
+              <a:rPr sz="975" b="0" i="1">
                 <a:solidFill>
                   <a:srgbClr val="4A2D18"/>
                 </a:solidFill>
@@ -10673,8 +10720,8 @@
         </p:nvSpPr>
         <p:spPr>
           <a:xfrm>
-            <a:off x="640080" y="2660904"/>
-            <a:ext cx="2971800" cy="548640"/>
+            <a:off x="640080" y="2615184"/>
+            <a:ext cx="2971800" cy="502919"/>
           </a:xfrm>
           <a:prstGeom prst="rect">
             <a:avLst/>
@@ -10689,13 +10736,13 @@
           <a:p>
             <a:pPr algn="l"/>
             <a:r>
-              <a:rPr sz="1300" b="0" i="0">
+              <a:rPr sz="1170" b="0" i="0">
                 <a:solidFill>
                   <a:srgbClr val="1E1508"/>
                 </a:solidFill>
                 <a:latin typeface="Calibri"/>
               </a:rPr>
-              <a:t>Vibe-level pills</a:t>
+              <a:t>🏠 Lodging tile — direct route to stays</a:t>
             </a:r>
           </a:p>
         </p:txBody>
@@ -10708,8 +10755,8 @@
         </p:nvSpPr>
         <p:spPr>
           <a:xfrm>
-            <a:off x="3749040" y="2651760"/>
-            <a:ext cx="7818119" cy="274320"/>
+            <a:off x="3749040" y="2606040"/>
+            <a:ext cx="7818119" cy="251459"/>
           </a:xfrm>
           <a:prstGeom prst="rect">
             <a:avLst/>
@@ -10724,13 +10771,13 @@
           <a:p>
             <a:pPr algn="l"/>
             <a:r>
-              <a:rPr sz="1300" b="0" i="0">
+              <a:rPr sz="1170" b="0" i="0">
                 <a:solidFill>
                   <a:srgbClr val="1E1508"/>
                 </a:solidFill>
                 <a:latin typeface="Calibri"/>
               </a:rPr>
-              <a:t>Pick Foodie → narrow to Restaurants / Wineries / Markets / Bakeries / Food Events</a:t>
+              <a:t>A 10th tile alongside the vibes; bypasses the vibe-funnel for "where do I sleep" intent</a:t>
             </a:r>
           </a:p>
         </p:txBody>
@@ -10743,8 +10790,8 @@
         </p:nvSpPr>
         <p:spPr>
           <a:xfrm>
-            <a:off x="3749040" y="2926080"/>
-            <a:ext cx="7818119" cy="274320"/>
+            <a:off x="3749040" y="2857499"/>
+            <a:ext cx="7818119" cy="251459"/>
           </a:xfrm>
           <a:prstGeom prst="rect">
             <a:avLst/>
@@ -10759,13 +10806,13 @@
           <a:p>
             <a:pPr algn="l"/>
             <a:r>
-              <a:rPr sz="1040" b="0" i="1">
+              <a:rPr sz="975" b="0" i="1">
                 <a:solidFill>
                   <a:srgbClr val="4A2D18"/>
                 </a:solidFill>
                 <a:latin typeface="Calibri"/>
               </a:rPr>
-              <a:t>↳  Foodie visitor switches to "Wineries only" without leaving the vibe.</a:t>
+              <a:t>↳  First-time visitor sees the house-shaped Lodging tile, jumps straight to 50+ stays.</a:t>
             </a:r>
           </a:p>
         </p:txBody>
@@ -10778,8 +10825,8 @@
         </p:nvSpPr>
         <p:spPr>
           <a:xfrm>
-            <a:off x="548640" y="3209544"/>
-            <a:ext cx="11064240" cy="594360"/>
+            <a:off x="548640" y="3118104"/>
+            <a:ext cx="11064240" cy="548640"/>
           </a:xfrm>
           <a:prstGeom prst="rect">
             <a:avLst/>
@@ -10822,8 +10869,8 @@
         </p:nvSpPr>
         <p:spPr>
           <a:xfrm>
-            <a:off x="640080" y="3255264"/>
-            <a:ext cx="2971800" cy="548640"/>
+            <a:off x="640080" y="3163824"/>
+            <a:ext cx="2971800" cy="502919"/>
           </a:xfrm>
           <a:prstGeom prst="rect">
             <a:avLst/>
@@ -10838,12 +10885,117 @@
           <a:p>
             <a:pPr algn="l"/>
             <a:r>
-              <a:rPr sz="1300" b="0" i="0">
+              <a:rPr sz="1170" b="0" i="0">
                 <a:solidFill>
                   <a:srgbClr val="1E1508"/>
                 </a:solidFill>
                 <a:latin typeface="Calibri"/>
               </a:rPr>
+              <a:t>Vibe-level pills (12+ across all vibes)</a:t>
+            </a:r>
+          </a:p>
+        </p:txBody>
+      </p:sp>
+      <p:sp>
+        <p:nvSpPr>
+          <p:cNvPr id="18" name="TextBox 17"/>
+          <p:cNvSpPr txBox="1"/>
+          <p:nvPr/>
+        </p:nvSpPr>
+        <p:spPr>
+          <a:xfrm>
+            <a:off x="3749040" y="3154680"/>
+            <a:ext cx="7818119" cy="251459"/>
+          </a:xfrm>
+          <a:prstGeom prst="rect">
+            <a:avLst/>
+          </a:prstGeom>
+          <a:noFill/>
+        </p:spPr>
+        <p:txBody>
+          <a:bodyPr wrap="square" anchor="t" lIns="45720" rIns="45720" tIns="18288" bIns="18288">
+            <a:spAutoFit/>
+          </a:bodyPr>
+          <a:lstStyle/>
+          <a:p>
+            <a:pPr algn="l"/>
+            <a:r>
+              <a:rPr sz="1170" b="0" i="0">
+                <a:solidFill>
+                  <a:srgbClr val="1E1508"/>
+                </a:solidFill>
+                <a:latin typeface="Calibri"/>
+              </a:rPr>
+              <a:t>Foodie → Wineries / Restaurants / Markets · Active → Hiking / Pickleball / Day-Pass Gyms</a:t>
+            </a:r>
+          </a:p>
+        </p:txBody>
+      </p:sp>
+      <p:sp>
+        <p:nvSpPr>
+          <p:cNvPr id="19" name="TextBox 18"/>
+          <p:cNvSpPr txBox="1"/>
+          <p:nvPr/>
+        </p:nvSpPr>
+        <p:spPr>
+          <a:xfrm>
+            <a:off x="3749040" y="3406139"/>
+            <a:ext cx="7818119" cy="251459"/>
+          </a:xfrm>
+          <a:prstGeom prst="rect">
+            <a:avLst/>
+          </a:prstGeom>
+          <a:noFill/>
+        </p:spPr>
+        <p:txBody>
+          <a:bodyPr wrap="square" anchor="t" lIns="45720" rIns="45720" tIns="18288" bIns="18288">
+            <a:spAutoFit/>
+          </a:bodyPr>
+          <a:lstStyle/>
+          <a:p>
+            <a:pPr algn="l"/>
+            <a:r>
+              <a:rPr sz="975" b="0" i="1">
+                <a:solidFill>
+                  <a:srgbClr val="4A2D18"/>
+                </a:solidFill>
+                <a:latin typeface="Calibri"/>
+              </a:rPr>
+              <a:t>↳  Active-vibe visitor taps "🏋️ Day-Pass Gyms" — finds 8 places to keep their routine going.</a:t>
+            </a:r>
+          </a:p>
+        </p:txBody>
+      </p:sp>
+      <p:sp>
+        <p:nvSpPr>
+          <p:cNvPr id="20" name="TextBox 19"/>
+          <p:cNvSpPr txBox="1"/>
+          <p:nvPr/>
+        </p:nvSpPr>
+        <p:spPr>
+          <a:xfrm>
+            <a:off x="640080" y="3712464"/>
+            <a:ext cx="2971800" cy="502919"/>
+          </a:xfrm>
+          <a:prstGeom prst="rect">
+            <a:avLst/>
+          </a:prstGeom>
+          <a:noFill/>
+        </p:spPr>
+        <p:txBody>
+          <a:bodyPr wrap="square" anchor="ctr" lIns="45720" rIns="45720" tIns="18288" bIns="18288">
+            <a:spAutoFit/>
+          </a:bodyPr>
+          <a:lstStyle/>
+          <a:p>
+            <a:pPr algn="l"/>
+            <a:r>
+              <a:rPr sz="1170" b="0" i="0">
+                <a:solidFill>
+                  <a:srgbClr val="1E1508"/>
+                </a:solidFill>
+                <a:latin typeface="Calibri"/>
+              </a:rPr>
               <a:t>Category dropdown + sub-pills</a:t>
             </a:r>
           </a:p>
@@ -10851,14 +11003,14 @@
       </p:sp>
       <p:sp>
         <p:nvSpPr>
-          <p:cNvPr id="18" name="TextBox 17"/>
-          <p:cNvSpPr txBox="1"/>
-          <p:nvPr/>
-        </p:nvSpPr>
-        <p:spPr>
-          <a:xfrm>
-            <a:off x="3749040" y="3246120"/>
-            <a:ext cx="7818119" cy="274320"/>
+          <p:cNvPr id="21" name="TextBox 20"/>
+          <p:cNvSpPr txBox="1"/>
+          <p:nvPr/>
+        </p:nvSpPr>
+        <p:spPr>
+          <a:xfrm>
+            <a:off x="3749040" y="3703320"/>
+            <a:ext cx="7818119" cy="251459"/>
           </a:xfrm>
           <a:prstGeom prst="rect">
             <a:avLst/>
@@ -10873,7 +11025,7 @@
           <a:p>
             <a:pPr algn="l"/>
             <a:r>
-              <a:rPr sz="1300" b="0" i="0">
+              <a:rPr sz="1170" b="0" i="0">
                 <a:solidFill>
                   <a:srgbClr val="1E1508"/>
                 </a:solidFill>
@@ -10886,14 +11038,14 @@
       </p:sp>
       <p:sp>
         <p:nvSpPr>
-          <p:cNvPr id="19" name="TextBox 18"/>
-          <p:cNvSpPr txBox="1"/>
-          <p:nvPr/>
-        </p:nvSpPr>
-        <p:spPr>
-          <a:xfrm>
-            <a:off x="3749040" y="3520440"/>
-            <a:ext cx="7818119" cy="274320"/>
+          <p:cNvPr id="22" name="TextBox 21"/>
+          <p:cNvSpPr txBox="1"/>
+          <p:nvPr/>
+        </p:nvSpPr>
+        <p:spPr>
+          <a:xfrm>
+            <a:off x="3749040" y="3954779"/>
+            <a:ext cx="7818119" cy="251459"/>
           </a:xfrm>
           <a:prstGeom prst="rect">
             <a:avLst/>
@@ -10908,118 +11060,13 @@
           <a:p>
             <a:pPr algn="l"/>
             <a:r>
-              <a:rPr sz="1040" b="0" i="1">
+              <a:rPr sz="975" b="0" i="1">
                 <a:solidFill>
                   <a:srgbClr val="4A2D18"/>
                 </a:solidFill>
                 <a:latin typeface="Calibri"/>
               </a:rPr>
               <a:t>↳  Family of four picks Lodging → B&amp;Bs to find character stays over chains.</a:t>
-            </a:r>
-          </a:p>
-        </p:txBody>
-      </p:sp>
-      <p:sp>
-        <p:nvSpPr>
-          <p:cNvPr id="20" name="TextBox 19"/>
-          <p:cNvSpPr txBox="1"/>
-          <p:nvPr/>
-        </p:nvSpPr>
-        <p:spPr>
-          <a:xfrm>
-            <a:off x="640080" y="3849624"/>
-            <a:ext cx="2971800" cy="548640"/>
-          </a:xfrm>
-          <a:prstGeom prst="rect">
-            <a:avLst/>
-          </a:prstGeom>
-          <a:noFill/>
-        </p:spPr>
-        <p:txBody>
-          <a:bodyPr wrap="square" anchor="ctr" lIns="45720" rIns="45720" tIns="18288" bIns="18288">
-            <a:spAutoFit/>
-          </a:bodyPr>
-          <a:lstStyle/>
-          <a:p>
-            <a:pPr algn="l"/>
-            <a:r>
-              <a:rPr sz="1300" b="0" i="0">
-                <a:solidFill>
-                  <a:srgbClr val="1E1508"/>
-                </a:solidFill>
-                <a:latin typeface="Calibri"/>
-              </a:rPr>
-              <a:t>Activity tags</a:t>
-            </a:r>
-          </a:p>
-        </p:txBody>
-      </p:sp>
-      <p:sp>
-        <p:nvSpPr>
-          <p:cNvPr id="21" name="TextBox 20"/>
-          <p:cNvSpPr txBox="1"/>
-          <p:nvPr/>
-        </p:nvSpPr>
-        <p:spPr>
-          <a:xfrm>
-            <a:off x="3749040" y="3840480"/>
-            <a:ext cx="7818119" cy="274320"/>
-          </a:xfrm>
-          <a:prstGeom prst="rect">
-            <a:avLst/>
-          </a:prstGeom>
-          <a:noFill/>
-        </p:spPr>
-        <p:txBody>
-          <a:bodyPr wrap="square" anchor="t" lIns="45720" rIns="45720" tIns="18288" bIns="18288">
-            <a:spAutoFit/>
-          </a:bodyPr>
-          <a:lstStyle/>
-          <a:p>
-            <a:pPr algn="l"/>
-            <a:r>
-              <a:rPr sz="1300" b="0" i="0">
-                <a:solidFill>
-                  <a:srgbClr val="1E1508"/>
-                </a:solidFill>
-                <a:latin typeface="Calibri"/>
-              </a:rPr>
-              <a:t>Hiking · Biking · Swimming · Fishing · Boating · Running on every relevant card</a:t>
-            </a:r>
-          </a:p>
-        </p:txBody>
-      </p:sp>
-      <p:sp>
-        <p:nvSpPr>
-          <p:cNvPr id="22" name="TextBox 21"/>
-          <p:cNvSpPr txBox="1"/>
-          <p:nvPr/>
-        </p:nvSpPr>
-        <p:spPr>
-          <a:xfrm>
-            <a:off x="3749040" y="4114800"/>
-            <a:ext cx="7818119" cy="274320"/>
-          </a:xfrm>
-          <a:prstGeom prst="rect">
-            <a:avLst/>
-          </a:prstGeom>
-          <a:noFill/>
-        </p:spPr>
-        <p:txBody>
-          <a:bodyPr wrap="square" anchor="t" lIns="45720" rIns="45720" tIns="18288" bIns="18288">
-            <a:spAutoFit/>
-          </a:bodyPr>
-          <a:lstStyle/>
-          <a:p>
-            <a:pPr algn="l"/>
-            <a:r>
-              <a:rPr sz="1040" b="0" i="1">
-                <a:solidFill>
-                  <a:srgbClr val="4A2D18"/>
-                </a:solidFill>
-                <a:latin typeface="Calibri"/>
-              </a:rPr>
-              <a:t>↳  Mountain biker scrolls and immediately spots cards tagged "Biking".</a:t>
             </a:r>
           </a:p>
         </p:txBody>
@@ -11032,8 +11079,8 @@
         </p:nvSpPr>
         <p:spPr>
           <a:xfrm>
-            <a:off x="548640" y="4398264"/>
-            <a:ext cx="11064240" cy="594360"/>
+            <a:off x="548640" y="4215384"/>
+            <a:ext cx="11064240" cy="548640"/>
           </a:xfrm>
           <a:prstGeom prst="rect">
             <a:avLst/>
@@ -11076,8 +11123,8 @@
         </p:nvSpPr>
         <p:spPr>
           <a:xfrm>
-            <a:off x="640080" y="4443984"/>
-            <a:ext cx="2971800" cy="548640"/>
+            <a:off x="640080" y="4261104"/>
+            <a:ext cx="2971800" cy="502919"/>
           </a:xfrm>
           <a:prstGeom prst="rect">
             <a:avLst/>
@@ -11092,13 +11139,13 @@
           <a:p>
             <a:pPr algn="l"/>
             <a:r>
-              <a:rPr sz="1300" b="0" i="0">
+              <a:rPr sz="1170" b="0" i="0">
                 <a:solidFill>
                   <a:srgbClr val="1E1508"/>
                 </a:solidFill>
                 <a:latin typeface="Calibri"/>
               </a:rPr>
-              <a:t>Date filter</a:t>
+              <a:t>Activity tags on every card</a:t>
             </a:r>
           </a:p>
         </p:txBody>
@@ -11111,8 +11158,8 @@
         </p:nvSpPr>
         <p:spPr>
           <a:xfrm>
-            <a:off x="3749040" y="4434840"/>
-            <a:ext cx="7818119" cy="274320"/>
+            <a:off x="3749040" y="4251960"/>
+            <a:ext cx="7818119" cy="251459"/>
           </a:xfrm>
           <a:prstGeom prst="rect">
             <a:avLst/>
@@ -11127,13 +11174,13 @@
           <a:p>
             <a:pPr algn="l"/>
             <a:r>
-              <a:rPr sz="1300" b="0" i="0">
+              <a:rPr sz="1170" b="0" i="0">
                 <a:solidFill>
                   <a:srgbClr val="1E1508"/>
                 </a:solidFill>
                 <a:latin typeface="Calibri"/>
               </a:rPr>
-              <a:t>All Future (default) · Today · Weekend · Week — auto-clears summer-only items in winter</a:t>
+              <a:t>Hiking · Biking · Swimming · Fishing · Boating · Running visible at a glance</a:t>
             </a:r>
           </a:p>
         </p:txBody>
@@ -11146,8 +11193,8 @@
         </p:nvSpPr>
         <p:spPr>
           <a:xfrm>
-            <a:off x="3749040" y="4709160"/>
-            <a:ext cx="7818119" cy="274320"/>
+            <a:off x="3749040" y="4503419"/>
+            <a:ext cx="7818119" cy="251459"/>
           </a:xfrm>
           <a:prstGeom prst="rect">
             <a:avLst/>
@@ -11162,13 +11209,13 @@
           <a:p>
             <a:pPr algn="l"/>
             <a:r>
-              <a:rPr sz="1040" b="0" i="1">
+              <a:rPr sz="975" b="0" i="1">
                 <a:solidFill>
                   <a:srgbClr val="4A2D18"/>
                 </a:solidFill>
                 <a:latin typeface="Calibri"/>
               </a:rPr>
-              <a:t>↳  One-tap "Weekend" — only Sat/Sun events remain across every vibe.</a:t>
+              <a:t>↳  Mountain biker scrolls and immediately spots cards tagged "Biking".</a:t>
             </a:r>
           </a:p>
         </p:txBody>
@@ -11181,8 +11228,8 @@
         </p:nvSpPr>
         <p:spPr>
           <a:xfrm>
-            <a:off x="640080" y="5038344"/>
-            <a:ext cx="2971800" cy="548640"/>
+            <a:off x="640080" y="4809744"/>
+            <a:ext cx="2971800" cy="502919"/>
           </a:xfrm>
           <a:prstGeom prst="rect">
             <a:avLst/>
@@ -11197,13 +11244,13 @@
           <a:p>
             <a:pPr algn="l"/>
             <a:r>
-              <a:rPr sz="1300" b="0" i="0">
+              <a:rPr sz="1170" b="0" i="0">
                 <a:solidFill>
                   <a:srgbClr val="1E1508"/>
                 </a:solidFill>
                 <a:latin typeface="Calibri"/>
               </a:rPr>
-              <a:t>Area filter</a:t>
+              <a:t>Date filter + auto-season</a:t>
             </a:r>
           </a:p>
         </p:txBody>
@@ -11216,8 +11263,8 @@
         </p:nvSpPr>
         <p:spPr>
           <a:xfrm>
-            <a:off x="3749040" y="5029200"/>
-            <a:ext cx="7818119" cy="274320"/>
+            <a:off x="3749040" y="4800600"/>
+            <a:ext cx="7818119" cy="251459"/>
           </a:xfrm>
           <a:prstGeom prst="rect">
             <a:avLst/>
@@ -11232,13 +11279,13 @@
           <a:p>
             <a:pPr algn="l"/>
             <a:r>
-              <a:rPr sz="1300" b="0" i="0">
+              <a:rPr sz="1170" b="0" i="0">
                 <a:solidFill>
                   <a:srgbClr val="1E1508"/>
                 </a:solidFill>
                 <a:latin typeface="Calibri"/>
               </a:rPr>
-              <a:t>County-wide events show for any local area; city events filter normally</a:t>
+              <a:t>All Future · Today · Weekend · This Week — auto-hides summer-only items in winter</a:t>
             </a:r>
           </a:p>
         </p:txBody>
@@ -11251,8 +11298,8 @@
         </p:nvSpPr>
         <p:spPr>
           <a:xfrm>
-            <a:off x="3749040" y="5303520"/>
-            <a:ext cx="7818119" cy="274320"/>
+            <a:off x="3749040" y="5052059"/>
+            <a:ext cx="7818119" cy="251459"/>
           </a:xfrm>
           <a:prstGeom prst="rect">
             <a:avLst/>
@@ -11267,13 +11314,13 @@
           <a:p>
             <a:pPr algn="l"/>
             <a:r>
-              <a:rPr sz="1040" b="0" i="1">
+              <a:rPr sz="975" b="0" i="1">
                 <a:solidFill>
                   <a:srgbClr val="4A2D18"/>
                 </a:solidFill>
                 <a:latin typeface="Calibri"/>
               </a:rPr>
-              <a:t>↳  Penn Valley resident filters out Nevada City clutter for a local night out.</a:t>
+              <a:t>↳  December visitor never sees "Summer Concert Series" — it filters itself out.</a:t>
             </a:r>
           </a:p>
         </p:txBody>
@@ -11286,8 +11333,8 @@
         </p:nvSpPr>
         <p:spPr>
           <a:xfrm>
-            <a:off x="548640" y="5586984"/>
-            <a:ext cx="11064240" cy="594360"/>
+            <a:off x="548640" y="5312664"/>
+            <a:ext cx="11064240" cy="548640"/>
           </a:xfrm>
           <a:prstGeom prst="rect">
             <a:avLst/>
@@ -11330,8 +11377,8 @@
         </p:nvSpPr>
         <p:spPr>
           <a:xfrm>
-            <a:off x="640080" y="5632704"/>
-            <a:ext cx="2971800" cy="548640"/>
+            <a:off x="640080" y="5358384"/>
+            <a:ext cx="2971800" cy="502919"/>
           </a:xfrm>
           <a:prstGeom prst="rect">
             <a:avLst/>
@@ -11346,12 +11393,117 @@
           <a:p>
             <a:pPr algn="l"/>
             <a:r>
-              <a:rPr sz="1300" b="0" i="0">
+              <a:rPr sz="1170" b="0" i="0">
                 <a:solidFill>
                   <a:srgbClr val="1E1508"/>
                 </a:solidFill>
                 <a:latin typeface="Calibri"/>
               </a:rPr>
+              <a:t>Area filter</a:t>
+            </a:r>
+          </a:p>
+        </p:txBody>
+      </p:sp>
+      <p:sp>
+        <p:nvSpPr>
+          <p:cNvPr id="32" name="TextBox 31"/>
+          <p:cNvSpPr txBox="1"/>
+          <p:nvPr/>
+        </p:nvSpPr>
+        <p:spPr>
+          <a:xfrm>
+            <a:off x="3749040" y="5349240"/>
+            <a:ext cx="7818119" cy="251459"/>
+          </a:xfrm>
+          <a:prstGeom prst="rect">
+            <a:avLst/>
+          </a:prstGeom>
+          <a:noFill/>
+        </p:spPr>
+        <p:txBody>
+          <a:bodyPr wrap="square" anchor="t" lIns="45720" rIns="45720" tIns="18288" bIns="18288">
+            <a:spAutoFit/>
+          </a:bodyPr>
+          <a:lstStyle/>
+          <a:p>
+            <a:pPr algn="l"/>
+            <a:r>
+              <a:rPr sz="1170" b="0" i="0">
+                <a:solidFill>
+                  <a:srgbClr val="1E1508"/>
+                </a:solidFill>
+                <a:latin typeface="Calibri"/>
+              </a:rPr>
+              <a:t>County-wide events show for any local area; city events filter normally</a:t>
+            </a:r>
+          </a:p>
+        </p:txBody>
+      </p:sp>
+      <p:sp>
+        <p:nvSpPr>
+          <p:cNvPr id="33" name="TextBox 32"/>
+          <p:cNvSpPr txBox="1"/>
+          <p:nvPr/>
+        </p:nvSpPr>
+        <p:spPr>
+          <a:xfrm>
+            <a:off x="3749040" y="5600699"/>
+            <a:ext cx="7818119" cy="251459"/>
+          </a:xfrm>
+          <a:prstGeom prst="rect">
+            <a:avLst/>
+          </a:prstGeom>
+          <a:noFill/>
+        </p:spPr>
+        <p:txBody>
+          <a:bodyPr wrap="square" anchor="t" lIns="45720" rIns="45720" tIns="18288" bIns="18288">
+            <a:spAutoFit/>
+          </a:bodyPr>
+          <a:lstStyle/>
+          <a:p>
+            <a:pPr algn="l"/>
+            <a:r>
+              <a:rPr sz="975" b="0" i="1">
+                <a:solidFill>
+                  <a:srgbClr val="4A2D18"/>
+                </a:solidFill>
+                <a:latin typeface="Calibri"/>
+              </a:rPr>
+              <a:t>↳  Penn Valley resident filters out Nevada City clutter for a local night out.</a:t>
+            </a:r>
+          </a:p>
+        </p:txBody>
+      </p:sp>
+      <p:sp>
+        <p:nvSpPr>
+          <p:cNvPr id="34" name="TextBox 33"/>
+          <p:cNvSpPr txBox="1"/>
+          <p:nvPr/>
+        </p:nvSpPr>
+        <p:spPr>
+          <a:xfrm>
+            <a:off x="640080" y="5907024"/>
+            <a:ext cx="2971800" cy="502919"/>
+          </a:xfrm>
+          <a:prstGeom prst="rect">
+            <a:avLst/>
+          </a:prstGeom>
+          <a:noFill/>
+        </p:spPr>
+        <p:txBody>
+          <a:bodyPr wrap="square" anchor="ctr" lIns="45720" rIns="45720" tIns="18288" bIns="18288">
+            <a:spAutoFit/>
+          </a:bodyPr>
+          <a:lstStyle/>
+          <a:p>
+            <a:pPr algn="l"/>
+            <a:r>
+              <a:rPr sz="1170" b="0" i="0">
+                <a:solidFill>
+                  <a:srgbClr val="1E1508"/>
+                </a:solidFill>
+                <a:latin typeface="Calibri"/>
+              </a:rPr>
               <a:t>Tag-aware Smart Suggestions</a:t>
             </a:r>
           </a:p>
@@ -11359,14 +11511,14 @@
       </p:sp>
       <p:sp>
         <p:nvSpPr>
-          <p:cNvPr id="32" name="TextBox 31"/>
-          <p:cNvSpPr txBox="1"/>
-          <p:nvPr/>
-        </p:nvSpPr>
-        <p:spPr>
-          <a:xfrm>
-            <a:off x="3749040" y="5623560"/>
-            <a:ext cx="7818119" cy="274320"/>
+          <p:cNvPr id="35" name="TextBox 34"/>
+          <p:cNvSpPr txBox="1"/>
+          <p:nvPr/>
+        </p:nvSpPr>
+        <p:spPr>
+          <a:xfrm>
+            <a:off x="3749040" y="5897880"/>
+            <a:ext cx="7818119" cy="251459"/>
           </a:xfrm>
           <a:prstGeom prst="rect">
             <a:avLst/>
@@ -11381,27 +11533,27 @@
           <a:p>
             <a:pPr algn="l"/>
             <a:r>
-              <a:rPr sz="1300" b="0" i="0">
+              <a:rPr sz="1170" b="0" i="0">
                 <a:solidFill>
                   <a:srgbClr val="1E1508"/>
                 </a:solidFill>
                 <a:latin typeface="Calibri"/>
               </a:rPr>
-              <a:t>"More to Explore" panel in the itinerary — geographic + tag scoring</a:t>
-            </a:r>
-          </a:p>
-        </p:txBody>
-      </p:sp>
-      <p:sp>
-        <p:nvSpPr>
-          <p:cNvPr id="33" name="TextBox 32"/>
-          <p:cNvSpPr txBox="1"/>
-          <p:nvPr/>
-        </p:nvSpPr>
-        <p:spPr>
-          <a:xfrm>
-            <a:off x="3749040" y="5897880"/>
-            <a:ext cx="7818119" cy="274320"/>
+              <a:t>"Near Your Stops" panel in the itinerary — geographic + tag scoring</a:t>
+            </a:r>
+          </a:p>
+        </p:txBody>
+      </p:sp>
+      <p:sp>
+        <p:nvSpPr>
+          <p:cNvPr id="36" name="TextBox 35"/>
+          <p:cNvSpPr txBox="1"/>
+          <p:nvPr/>
+        </p:nvSpPr>
+        <p:spPr>
+          <a:xfrm>
+            <a:off x="3749040" y="6149339"/>
+            <a:ext cx="7818119" cy="251459"/>
           </a:xfrm>
           <a:prstGeom prst="rect">
             <a:avLst/>
@@ -11416,7 +11568,7 @@
           <a:p>
             <a:pPr algn="l"/>
             <a:r>
-              <a:rPr sz="1040" b="0" i="1">
+              <a:rPr sz="975" b="0" i="1">
                 <a:solidFill>
                   <a:srgbClr val="4A2D18"/>
                 </a:solidFill>
@@ -11429,7 +11581,7 @@
       </p:sp>
       <p:sp>
         <p:nvSpPr>
-          <p:cNvPr id="34" name="TextBox 33"/>
+          <p:cNvPr id="37" name="TextBox 36"/>
           <p:cNvSpPr txBox="1"/>
           <p:nvPr/>
         </p:nvSpPr>
@@ -11464,7 +11616,7 @@
       </p:sp>
       <p:sp>
         <p:nvSpPr>
-          <p:cNvPr id="35" name="TextBox 34"/>
+          <p:cNvPr id="38" name="TextBox 37"/>
           <p:cNvSpPr txBox="1"/>
           <p:nvPr/>
         </p:nvSpPr>
@@ -11499,7 +11651,7 @@
       </p:sp>
       <p:sp>
         <p:nvSpPr>
-          <p:cNvPr id="36" name="Rectangle 35"/>
+          <p:cNvPr id="39" name="Rectangle 38"/>
           <p:cNvSpPr/>
           <p:nvPr/>
         </p:nvSpPr>
@@ -11695,11 +11847,11 @@
           <a:p>
             <a:pPr algn="l">
               <a:lnSpc>
-                <a:spcPct val="120000"/>
+                <a:spcPct val="115000"/>
               </a:lnSpc>
             </a:pPr>
             <a:r>
-              <a:rPr sz="1690" b="1">
+              <a:rPr sz="1560" b="1">
                 <a:solidFill>
                   <a:srgbClr val="B8941A"/>
                 </a:solidFill>
@@ -11708,7 +11860,7 @@
               <a:t>• </a:t>
             </a:r>
             <a:r>
-              <a:rPr sz="1430">
+              <a:rPr sz="1300">
                 <a:solidFill>
                   <a:srgbClr val="1E1508"/>
                 </a:solidFill>
@@ -11727,7 +11879,7 @@
               </a:spcBef>
             </a:pPr>
             <a:r>
-              <a:rPr sz="1170" i="1">
+              <a:rPr sz="1040" i="1">
                 <a:solidFill>
                   <a:srgbClr val="4A2D18"/>
                 </a:solidFill>
@@ -11739,14 +11891,14 @@
           <a:p>
             <a:pPr algn="l">
               <a:lnSpc>
-                <a:spcPct val="120000"/>
+                <a:spcPct val="115000"/>
               </a:lnSpc>
               <a:spcBef>
                 <a:spcPts val="400"/>
               </a:spcBef>
             </a:pPr>
             <a:r>
-              <a:rPr sz="1690" b="1">
+              <a:rPr sz="1560" b="1">
                 <a:solidFill>
                   <a:srgbClr val="B8941A"/>
                 </a:solidFill>
@@ -11755,7 +11907,7 @@
               <a:t>• </a:t>
             </a:r>
             <a:r>
-              <a:rPr sz="1430">
+              <a:rPr sz="1300">
                 <a:solidFill>
                   <a:srgbClr val="1E1508"/>
                 </a:solidFill>
@@ -11774,7 +11926,7 @@
               </a:spcBef>
             </a:pPr>
             <a:r>
-              <a:rPr sz="1170" i="1">
+              <a:rPr sz="1040" i="1">
                 <a:solidFill>
                   <a:srgbClr val="4A2D18"/>
                 </a:solidFill>
@@ -11786,14 +11938,14 @@
           <a:p>
             <a:pPr algn="l">
               <a:lnSpc>
-                <a:spcPct val="120000"/>
+                <a:spcPct val="115000"/>
               </a:lnSpc>
               <a:spcBef>
                 <a:spcPts val="400"/>
               </a:spcBef>
             </a:pPr>
             <a:r>
-              <a:rPr sz="1690" b="1">
+              <a:rPr sz="1560" b="1">
                 <a:solidFill>
                   <a:srgbClr val="B8941A"/>
                 </a:solidFill>
@@ -11802,7 +11954,7 @@
               <a:t>• </a:t>
             </a:r>
             <a:r>
-              <a:rPr sz="1430">
+              <a:rPr sz="1300">
                 <a:solidFill>
                   <a:srgbClr val="1E1508"/>
                 </a:solidFill>
@@ -11821,7 +11973,7 @@
               </a:spcBef>
             </a:pPr>
             <a:r>
-              <a:rPr sz="1170" i="1">
+              <a:rPr sz="1040" i="1">
                 <a:solidFill>
                   <a:srgbClr val="4A2D18"/>
                 </a:solidFill>
@@ -11833,14 +11985,14 @@
           <a:p>
             <a:pPr algn="l">
               <a:lnSpc>
-                <a:spcPct val="120000"/>
+                <a:spcPct val="115000"/>
               </a:lnSpc>
               <a:spcBef>
                 <a:spcPts val="400"/>
               </a:spcBef>
             </a:pPr>
             <a:r>
-              <a:rPr sz="1690" b="1">
+              <a:rPr sz="1560" b="1">
                 <a:solidFill>
                   <a:srgbClr val="B8941A"/>
                 </a:solidFill>
@@ -11849,7 +12001,7 @@
               <a:t>• </a:t>
             </a:r>
             <a:r>
-              <a:rPr sz="1430">
+              <a:rPr sz="1300">
                 <a:solidFill>
                   <a:srgbClr val="1E1508"/>
                 </a:solidFill>
@@ -11868,7 +12020,7 @@
               </a:spcBef>
             </a:pPr>
             <a:r>
-              <a:rPr sz="1170" i="1">
+              <a:rPr sz="1040" i="1">
                 <a:solidFill>
                   <a:srgbClr val="4A2D18"/>
                 </a:solidFill>
@@ -11880,14 +12032,14 @@
           <a:p>
             <a:pPr algn="l">
               <a:lnSpc>
-                <a:spcPct val="120000"/>
+                <a:spcPct val="115000"/>
               </a:lnSpc>
               <a:spcBef>
                 <a:spcPts val="400"/>
               </a:spcBef>
             </a:pPr>
             <a:r>
-              <a:rPr sz="1690" b="1">
+              <a:rPr sz="1560" b="1">
                 <a:solidFill>
                   <a:srgbClr val="B8941A"/>
                 </a:solidFill>
@@ -11896,7 +12048,7 @@
               <a:t>• </a:t>
             </a:r>
             <a:r>
-              <a:rPr sz="1430">
+              <a:rPr sz="1300">
                 <a:solidFill>
                   <a:srgbClr val="1E1508"/>
                 </a:solidFill>
@@ -11915,7 +12067,7 @@
               </a:spcBef>
             </a:pPr>
             <a:r>
-              <a:rPr sz="1170" i="1">
+              <a:rPr sz="1040" i="1">
                 <a:solidFill>
                   <a:srgbClr val="4A2D18"/>
                 </a:solidFill>
@@ -11927,14 +12079,14 @@
           <a:p>
             <a:pPr algn="l">
               <a:lnSpc>
-                <a:spcPct val="120000"/>
+                <a:spcPct val="115000"/>
               </a:lnSpc>
               <a:spcBef>
                 <a:spcPts val="400"/>
               </a:spcBef>
             </a:pPr>
             <a:r>
-              <a:rPr sz="1690" b="1">
+              <a:rPr sz="1560" b="1">
                 <a:solidFill>
                   <a:srgbClr val="B8941A"/>
                 </a:solidFill>
@@ -11943,7 +12095,7 @@
               <a:t>• </a:t>
             </a:r>
             <a:r>
-              <a:rPr sz="1430">
+              <a:rPr sz="1300">
                 <a:solidFill>
                   <a:srgbClr val="1E1508"/>
                 </a:solidFill>
@@ -11962,7 +12114,7 @@
               </a:spcBef>
             </a:pPr>
             <a:r>
-              <a:rPr sz="1170" i="1">
+              <a:rPr sz="1040" i="1">
                 <a:solidFill>
                   <a:srgbClr val="4A2D18"/>
                 </a:solidFill>
@@ -11974,14 +12126,14 @@
           <a:p>
             <a:pPr algn="l">
               <a:lnSpc>
-                <a:spcPct val="120000"/>
+                <a:spcPct val="115000"/>
               </a:lnSpc>
               <a:spcBef>
                 <a:spcPts val="400"/>
               </a:spcBef>
             </a:pPr>
             <a:r>
-              <a:rPr sz="1690" b="1">
+              <a:rPr sz="1560" b="1">
                 <a:solidFill>
                   <a:srgbClr val="B8941A"/>
                 </a:solidFill>
@@ -11990,13 +12142,13 @@
               <a:t>• </a:t>
             </a:r>
             <a:r>
-              <a:rPr sz="1430">
+              <a:rPr sz="1300">
                 <a:solidFill>
                   <a:srgbClr val="1E1508"/>
                 </a:solidFill>
                 <a:latin typeface="Calibri"/>
               </a:rPr>
-              <a:t>15-min add → opt-in save → survives tab close + browser restart</a:t>
+              <a:t>🗺 Map view — every stop on a Leaflet map; click pins to navigate</a:t>
             </a:r>
           </a:p>
           <a:p>
@@ -12009,26 +12161,26 @@
               </a:spcBef>
             </a:pPr>
             <a:r>
-              <a:rPr sz="1170" i="1">
+              <a:rPr sz="1040" i="1">
                 <a:solidFill>
                   <a:srgbClr val="4A2D18"/>
                 </a:solidFill>
                 <a:latin typeface="Calibri"/>
               </a:rPr>
-              <a:t>       ↳  Browser closes, phone reboots — itinerary still there next morning.</a:t>
+              <a:t>       ↳  Visitor opens the map: sees the full weekend laid out, decides Day 2 needs a lunch stop near the trail.</a:t>
             </a:r>
           </a:p>
           <a:p>
             <a:pPr algn="l">
               <a:lnSpc>
-                <a:spcPct val="120000"/>
+                <a:spcPct val="115000"/>
               </a:lnSpc>
               <a:spcBef>
                 <a:spcPts val="400"/>
               </a:spcBef>
             </a:pPr>
             <a:r>
-              <a:rPr sz="1690" b="1">
+              <a:rPr sz="1560" b="1">
                 <a:solidFill>
                   <a:srgbClr val="B8941A"/>
                 </a:solidFill>
@@ -12037,13 +12189,13 @@
               <a:t>• </a:t>
             </a:r>
             <a:r>
-              <a:rPr sz="1430">
+              <a:rPr sz="1300">
                 <a:solidFill>
                   <a:srgbClr val="1E1508"/>
                 </a:solidFill>
                 <a:latin typeface="Calibri"/>
               </a:rPr>
-              <a:t>Share link via native phone share sheet, email, text, or copy URL</a:t>
+              <a:t>🖨 Print itinerary — clean PDF-ready layout for paper handouts</a:t>
             </a:r>
           </a:p>
           <a:p>
@@ -12056,13 +12208,154 @@
               </a:spcBef>
             </a:pPr>
             <a:r>
-              <a:rPr sz="1170" i="1">
+              <a:rPr sz="1040" i="1">
                 <a:solidFill>
                   <a:srgbClr val="4A2D18"/>
                 </a:solidFill>
                 <a:latin typeface="Calibri"/>
               </a:rPr>
+              <a:t>       ↳  Older visitor prints the day-by-day plan, walks Mill Street with paper in hand.</a:t>
+            </a:r>
+          </a:p>
+          <a:p>
+            <a:pPr algn="l">
+              <a:lnSpc>
+                <a:spcPct val="115000"/>
+              </a:lnSpc>
+              <a:spcBef>
+                <a:spcPts val="400"/>
+              </a:spcBef>
+            </a:pPr>
+            <a:r>
+              <a:rPr sz="1560" b="1">
+                <a:solidFill>
+                  <a:srgbClr val="B8941A"/>
+                </a:solidFill>
+                <a:latin typeface="Calibri"/>
+              </a:rPr>
+              <a:t>• </a:t>
+            </a:r>
+            <a:r>
+              <a:rPr sz="1300">
+                <a:solidFill>
+                  <a:srgbClr val="1E1508"/>
+                </a:solidFill>
+                <a:latin typeface="Calibri"/>
+              </a:rPr>
+              <a:t>15-min add → opt-in save → survives tab close + browser restart</a:t>
+            </a:r>
+          </a:p>
+          <a:p>
+            <a:pPr algn="l">
+              <a:lnSpc>
+                <a:spcPct val="110000"/>
+              </a:lnSpc>
+              <a:spcBef>
+                <a:spcPts val="0"/>
+              </a:spcBef>
+            </a:pPr>
+            <a:r>
+              <a:rPr sz="1040" i="1">
+                <a:solidFill>
+                  <a:srgbClr val="4A2D18"/>
+                </a:solidFill>
+                <a:latin typeface="Calibri"/>
+              </a:rPr>
+              <a:t>       ↳  Browser closes, phone reboots — itinerary still there next morning.</a:t>
+            </a:r>
+          </a:p>
+          <a:p>
+            <a:pPr algn="l">
+              <a:lnSpc>
+                <a:spcPct val="115000"/>
+              </a:lnSpc>
+              <a:spcBef>
+                <a:spcPts val="400"/>
+              </a:spcBef>
+            </a:pPr>
+            <a:r>
+              <a:rPr sz="1560" b="1">
+                <a:solidFill>
+                  <a:srgbClr val="B8941A"/>
+                </a:solidFill>
+                <a:latin typeface="Calibri"/>
+              </a:rPr>
+              <a:t>• </a:t>
+            </a:r>
+            <a:r>
+              <a:rPr sz="1300">
+                <a:solidFill>
+                  <a:srgbClr val="1E1508"/>
+                </a:solidFill>
+                <a:latin typeface="Calibri"/>
+              </a:rPr>
+              <a:t>Share link via native phone share sheet, email, text, or copy URL</a:t>
+            </a:r>
+          </a:p>
+          <a:p>
+            <a:pPr algn="l">
+              <a:lnSpc>
+                <a:spcPct val="110000"/>
+              </a:lnSpc>
+              <a:spcBef>
+                <a:spcPts val="0"/>
+              </a:spcBef>
+            </a:pPr>
+            <a:r>
+              <a:rPr sz="1040" i="1">
+                <a:solidFill>
+                  <a:srgbClr val="4A2D18"/>
+                </a:solidFill>
+                <a:latin typeface="Calibri"/>
+              </a:rPr>
               <a:t>       ↳  Visitor texts the URL to spouse: "this is what I'm thinking."</a:t>
+            </a:r>
+          </a:p>
+          <a:p>
+            <a:pPr algn="l">
+              <a:lnSpc>
+                <a:spcPct val="115000"/>
+              </a:lnSpc>
+              <a:spcBef>
+                <a:spcPts val="400"/>
+              </a:spcBef>
+            </a:pPr>
+            <a:r>
+              <a:rPr sz="1560" b="1">
+                <a:solidFill>
+                  <a:srgbClr val="B8941A"/>
+                </a:solidFill>
+                <a:latin typeface="Calibri"/>
+              </a:rPr>
+              <a:t>• </a:t>
+            </a:r>
+            <a:r>
+              <a:rPr sz="1300">
+                <a:solidFill>
+                  <a:srgbClr val="1E1508"/>
+                </a:solidFill>
+                <a:latin typeface="Calibri"/>
+              </a:rPr>
+              <a:t>No install, no account, no email — works in any browser</a:t>
+            </a:r>
+          </a:p>
+          <a:p>
+            <a:pPr algn="l">
+              <a:lnSpc>
+                <a:spcPct val="110000"/>
+              </a:lnSpc>
+              <a:spcBef>
+                <a:spcPts val="0"/>
+              </a:spcBef>
+            </a:pPr>
+            <a:r>
+              <a:rPr sz="1040" i="1">
+                <a:solidFill>
+                  <a:srgbClr val="4A2D18"/>
+                </a:solidFill>
+                <a:latin typeface="Calibri"/>
+              </a:rPr>
+              <a:t>       ↳  Visitor planning during a hotel-search lunch break — no signup wall.</a:t>
             </a:r>
           </a:p>
         </p:txBody>

</xml_diff>

<commit_message>
Add universal search to the pitch deck's discovery slide
Co-Authored-By: Claude Opus 4.7 (1M context) <noreply@anthropic.com>
</commit_message>
<xml_diff>
--- a/demo_pitch.pptx
+++ b/demo_pitch.pptx
@@ -9983,7 +9983,7 @@
                 </a:solidFill>
                 <a:latin typeface="Calibri"/>
               </a:rPr>
-              <a:t>Multiple paths to "I found it" — works for browse-mode and date-mode visitors.</a:t>
+              <a:t>Search, browse, or filter by date — multiple paths to "I found it".</a:t>
             </a:r>
           </a:p>
         </p:txBody>
@@ -9996,7 +9996,7 @@
         </p:nvSpPr>
         <p:spPr>
           <a:xfrm>
-            <a:off x="548640" y="1600200"/>
+            <a:off x="548640" y="1481328"/>
             <a:ext cx="11064240" cy="384048"/>
           </a:xfrm>
           <a:prstGeom prst="rect">
@@ -10040,7 +10040,7 @@
         </p:nvSpPr>
         <p:spPr>
           <a:xfrm>
-            <a:off x="640080" y="1645920"/>
+            <a:off x="640080" y="1527048"/>
             <a:ext cx="2971800" cy="292608"/>
           </a:xfrm>
           <a:prstGeom prst="rect">
@@ -10075,7 +10075,7 @@
         </p:nvSpPr>
         <p:spPr>
           <a:xfrm>
-            <a:off x="3749040" y="1645920"/>
+            <a:off x="3749040" y="1527048"/>
             <a:ext cx="7818119" cy="292608"/>
           </a:xfrm>
           <a:prstGeom prst="rect">
@@ -10110,7 +10110,7 @@
         </p:nvSpPr>
         <p:spPr>
           <a:xfrm>
-            <a:off x="548640" y="1984248"/>
+            <a:off x="548640" y="1865376"/>
             <a:ext cx="11064240" cy="31750"/>
           </a:xfrm>
           <a:prstGeom prst="rect">
@@ -10153,8 +10153,8 @@
         </p:nvSpPr>
         <p:spPr>
           <a:xfrm>
-            <a:off x="548640" y="2020824"/>
-            <a:ext cx="11064240" cy="548640"/>
+            <a:off x="548640" y="1901952"/>
+            <a:ext cx="11064240" cy="502920"/>
           </a:xfrm>
           <a:prstGeom prst="rect">
             <a:avLst/>
@@ -10197,8 +10197,8 @@
         </p:nvSpPr>
         <p:spPr>
           <a:xfrm>
-            <a:off x="640080" y="2066544"/>
-            <a:ext cx="2971800" cy="502919"/>
+            <a:off x="640080" y="1947672"/>
+            <a:ext cx="2971800" cy="457200"/>
           </a:xfrm>
           <a:prstGeom prst="rect">
             <a:avLst/>
@@ -10219,6 +10219,76 @@
                 </a:solidFill>
                 <a:latin typeface="Calibri"/>
               </a:rPr>
+              <a:t>Universal keyword search</a:t>
+            </a:r>
+          </a:p>
+        </p:txBody>
+      </p:sp>
+      <p:sp>
+        <p:nvSpPr>
+          <p:cNvPr id="11" name="TextBox 10"/>
+          <p:cNvSpPr txBox="1"/>
+          <p:nvPr/>
+        </p:nvSpPr>
+        <p:spPr>
+          <a:xfrm>
+            <a:off x="3749040" y="1947672"/>
+            <a:ext cx="7818119" cy="457200"/>
+          </a:xfrm>
+          <a:prstGeom prst="rect">
+            <a:avLst/>
+          </a:prstGeom>
+          <a:noFill/>
+        </p:spPr>
+        <p:txBody>
+          <a:bodyPr wrap="square" anchor="t" lIns="45720" rIns="45720" tIns="18288" bIns="18288">
+            <a:spAutoFit/>
+          </a:bodyPr>
+          <a:lstStyle/>
+          <a:p>
+            <a:pPr algn="l"/>
+            <a:r>
+              <a:rPr sz="1170" b="0" i="0">
+                <a:solidFill>
+                  <a:srgbClr val="0F172A"/>
+                </a:solidFill>
+                <a:latin typeface="Calibri"/>
+              </a:rPr>
+              <a:t>One box searches every venue and event — names, descriptions and tags — with built-in synonyms, so a search for "metalsmith" also finds a studio listed only as "blacksmithing"</a:t>
+            </a:r>
+          </a:p>
+        </p:txBody>
+      </p:sp>
+      <p:sp>
+        <p:nvSpPr>
+          <p:cNvPr id="12" name="TextBox 11"/>
+          <p:cNvSpPr txBox="1"/>
+          <p:nvPr/>
+        </p:nvSpPr>
+        <p:spPr>
+          <a:xfrm>
+            <a:off x="640080" y="2450592"/>
+            <a:ext cx="2971800" cy="457200"/>
+          </a:xfrm>
+          <a:prstGeom prst="rect">
+            <a:avLst/>
+          </a:prstGeom>
+          <a:noFill/>
+        </p:spPr>
+        <p:txBody>
+          <a:bodyPr wrap="square" anchor="t" lIns="45720" rIns="45720" tIns="18288" bIns="18288">
+            <a:spAutoFit/>
+          </a:bodyPr>
+          <a:lstStyle/>
+          <a:p>
+            <a:pPr algn="l"/>
+            <a:r>
+              <a:rPr sz="1170" b="0" i="0">
+                <a:solidFill>
+                  <a:srgbClr val="0F172A"/>
+                </a:solidFill>
+                <a:latin typeface="Calibri"/>
+              </a:rPr>
               <a:t>Themed vibes (9 cards)</a:t>
             </a:r>
           </a:p>
@@ -10226,14 +10296,14 @@
       </p:sp>
       <p:sp>
         <p:nvSpPr>
-          <p:cNvPr id="11" name="TextBox 10"/>
-          <p:cNvSpPr txBox="1"/>
-          <p:nvPr/>
-        </p:nvSpPr>
-        <p:spPr>
-          <a:xfrm>
-            <a:off x="3749040" y="2066544"/>
-            <a:ext cx="7818119" cy="502919"/>
+          <p:cNvPr id="13" name="TextBox 12"/>
+          <p:cNvSpPr txBox="1"/>
+          <p:nvPr/>
+        </p:nvSpPr>
+        <p:spPr>
+          <a:xfrm>
+            <a:off x="3749040" y="2450592"/>
+            <a:ext cx="7818119" cy="457200"/>
           </a:xfrm>
           <a:prstGeom prst="rect">
             <a:avLst/>
@@ -10255,76 +10325,6 @@
                 <a:latin typeface="Calibri"/>
               </a:rPr>
               <a:t>Historic · Arts · Hands-On · Foodie · Active · Relaxed · Wellness · Family · Festivals</a:t>
-            </a:r>
-          </a:p>
-        </p:txBody>
-      </p:sp>
-      <p:sp>
-        <p:nvSpPr>
-          <p:cNvPr id="12" name="TextBox 11"/>
-          <p:cNvSpPr txBox="1"/>
-          <p:nvPr/>
-        </p:nvSpPr>
-        <p:spPr>
-          <a:xfrm>
-            <a:off x="640080" y="2615184"/>
-            <a:ext cx="2971800" cy="502919"/>
-          </a:xfrm>
-          <a:prstGeom prst="rect">
-            <a:avLst/>
-          </a:prstGeom>
-          <a:noFill/>
-        </p:spPr>
-        <p:txBody>
-          <a:bodyPr wrap="square" anchor="t" lIns="45720" rIns="45720" tIns="18288" bIns="18288">
-            <a:spAutoFit/>
-          </a:bodyPr>
-          <a:lstStyle/>
-          <a:p>
-            <a:pPr algn="l"/>
-            <a:r>
-              <a:rPr sz="1170" b="0" i="0">
-                <a:solidFill>
-                  <a:srgbClr val="0F172A"/>
-                </a:solidFill>
-                <a:latin typeface="Calibri"/>
-              </a:rPr>
-              <a:t>🏠 Lodging tile — direct route to stays</a:t>
-            </a:r>
-          </a:p>
-        </p:txBody>
-      </p:sp>
-      <p:sp>
-        <p:nvSpPr>
-          <p:cNvPr id="13" name="TextBox 12"/>
-          <p:cNvSpPr txBox="1"/>
-          <p:nvPr/>
-        </p:nvSpPr>
-        <p:spPr>
-          <a:xfrm>
-            <a:off x="3749040" y="2615184"/>
-            <a:ext cx="7818119" cy="502919"/>
-          </a:xfrm>
-          <a:prstGeom prst="rect">
-            <a:avLst/>
-          </a:prstGeom>
-          <a:noFill/>
-        </p:spPr>
-        <p:txBody>
-          <a:bodyPr wrap="square" anchor="t" lIns="45720" rIns="45720" tIns="18288" bIns="18288">
-            <a:spAutoFit/>
-          </a:bodyPr>
-          <a:lstStyle/>
-          <a:p>
-            <a:pPr algn="l"/>
-            <a:r>
-              <a:rPr sz="1170" b="0" i="0">
-                <a:solidFill>
-                  <a:srgbClr val="0F172A"/>
-                </a:solidFill>
-                <a:latin typeface="Calibri"/>
-              </a:rPr>
-              <a:t>A 10th tile alongside the vibes; bypasses the vibe-funnel for "where do I sleep" intent</a:t>
             </a:r>
           </a:p>
         </p:txBody>
@@ -10337,8 +10337,8 @@
         </p:nvSpPr>
         <p:spPr>
           <a:xfrm>
-            <a:off x="548640" y="3118104"/>
-            <a:ext cx="11064240" cy="548640"/>
+            <a:off x="548640" y="2907792"/>
+            <a:ext cx="11064240" cy="502920"/>
           </a:xfrm>
           <a:prstGeom prst="rect">
             <a:avLst/>
@@ -10381,8 +10381,8 @@
         </p:nvSpPr>
         <p:spPr>
           <a:xfrm>
-            <a:off x="640080" y="3163824"/>
-            <a:ext cx="2971800" cy="502919"/>
+            <a:off x="640080" y="2953512"/>
+            <a:ext cx="2971800" cy="457200"/>
           </a:xfrm>
           <a:prstGeom prst="rect">
             <a:avLst/>
@@ -10403,6 +10403,76 @@
                 </a:solidFill>
                 <a:latin typeface="Calibri"/>
               </a:rPr>
+              <a:t>🏠 Lodging tile — direct route to stays</a:t>
+            </a:r>
+          </a:p>
+        </p:txBody>
+      </p:sp>
+      <p:sp>
+        <p:nvSpPr>
+          <p:cNvPr id="16" name="TextBox 15"/>
+          <p:cNvSpPr txBox="1"/>
+          <p:nvPr/>
+        </p:nvSpPr>
+        <p:spPr>
+          <a:xfrm>
+            <a:off x="3749040" y="2953512"/>
+            <a:ext cx="7818119" cy="457200"/>
+          </a:xfrm>
+          <a:prstGeom prst="rect">
+            <a:avLst/>
+          </a:prstGeom>
+          <a:noFill/>
+        </p:spPr>
+        <p:txBody>
+          <a:bodyPr wrap="square" anchor="t" lIns="45720" rIns="45720" tIns="18288" bIns="18288">
+            <a:spAutoFit/>
+          </a:bodyPr>
+          <a:lstStyle/>
+          <a:p>
+            <a:pPr algn="l"/>
+            <a:r>
+              <a:rPr sz="1170" b="0" i="0">
+                <a:solidFill>
+                  <a:srgbClr val="0F172A"/>
+                </a:solidFill>
+                <a:latin typeface="Calibri"/>
+              </a:rPr>
+              <a:t>A 10th tile alongside the vibes; bypasses the vibe-funnel for "where do I sleep" intent</a:t>
+            </a:r>
+          </a:p>
+        </p:txBody>
+      </p:sp>
+      <p:sp>
+        <p:nvSpPr>
+          <p:cNvPr id="17" name="TextBox 16"/>
+          <p:cNvSpPr txBox="1"/>
+          <p:nvPr/>
+        </p:nvSpPr>
+        <p:spPr>
+          <a:xfrm>
+            <a:off x="640080" y="3456432"/>
+            <a:ext cx="2971800" cy="457200"/>
+          </a:xfrm>
+          <a:prstGeom prst="rect">
+            <a:avLst/>
+          </a:prstGeom>
+          <a:noFill/>
+        </p:spPr>
+        <p:txBody>
+          <a:bodyPr wrap="square" anchor="t" lIns="45720" rIns="45720" tIns="18288" bIns="18288">
+            <a:spAutoFit/>
+          </a:bodyPr>
+          <a:lstStyle/>
+          <a:p>
+            <a:pPr algn="l"/>
+            <a:r>
+              <a:rPr sz="1170" b="0" i="0">
+                <a:solidFill>
+                  <a:srgbClr val="0F172A"/>
+                </a:solidFill>
+                <a:latin typeface="Calibri"/>
+              </a:rPr>
               <a:t>Vibe-level pills (12+ across all vibes)</a:t>
             </a:r>
           </a:p>
@@ -10410,14 +10480,14 @@
       </p:sp>
       <p:sp>
         <p:nvSpPr>
-          <p:cNvPr id="16" name="TextBox 15"/>
-          <p:cNvSpPr txBox="1"/>
-          <p:nvPr/>
-        </p:nvSpPr>
-        <p:spPr>
-          <a:xfrm>
-            <a:off x="3749040" y="3163824"/>
-            <a:ext cx="7818119" cy="502919"/>
+          <p:cNvPr id="18" name="TextBox 17"/>
+          <p:cNvSpPr txBox="1"/>
+          <p:nvPr/>
+        </p:nvSpPr>
+        <p:spPr>
+          <a:xfrm>
+            <a:off x="3749040" y="3456432"/>
+            <a:ext cx="7818119" cy="457200"/>
           </a:xfrm>
           <a:prstGeom prst="rect">
             <a:avLst/>
@@ -10439,76 +10509,6 @@
                 <a:latin typeface="Calibri"/>
               </a:rPr>
               <a:t>Foodie → Wineries / Restaurants / Markets · Active → Hiking / Pickleball / Day-Pass Gyms</a:t>
-            </a:r>
-          </a:p>
-        </p:txBody>
-      </p:sp>
-      <p:sp>
-        <p:nvSpPr>
-          <p:cNvPr id="17" name="TextBox 16"/>
-          <p:cNvSpPr txBox="1"/>
-          <p:nvPr/>
-        </p:nvSpPr>
-        <p:spPr>
-          <a:xfrm>
-            <a:off x="640080" y="3712464"/>
-            <a:ext cx="2971800" cy="502919"/>
-          </a:xfrm>
-          <a:prstGeom prst="rect">
-            <a:avLst/>
-          </a:prstGeom>
-          <a:noFill/>
-        </p:spPr>
-        <p:txBody>
-          <a:bodyPr wrap="square" anchor="t" lIns="45720" rIns="45720" tIns="18288" bIns="18288">
-            <a:spAutoFit/>
-          </a:bodyPr>
-          <a:lstStyle/>
-          <a:p>
-            <a:pPr algn="l"/>
-            <a:r>
-              <a:rPr sz="1170" b="0" i="0">
-                <a:solidFill>
-                  <a:srgbClr val="0F172A"/>
-                </a:solidFill>
-                <a:latin typeface="Calibri"/>
-              </a:rPr>
-              <a:t>Category dropdown + sub-pills</a:t>
-            </a:r>
-          </a:p>
-        </p:txBody>
-      </p:sp>
-      <p:sp>
-        <p:nvSpPr>
-          <p:cNvPr id="18" name="TextBox 17"/>
-          <p:cNvSpPr txBox="1"/>
-          <p:nvPr/>
-        </p:nvSpPr>
-        <p:spPr>
-          <a:xfrm>
-            <a:off x="3749040" y="3712464"/>
-            <a:ext cx="7818119" cy="502919"/>
-          </a:xfrm>
-          <a:prstGeom prst="rect">
-            <a:avLst/>
-          </a:prstGeom>
-          <a:noFill/>
-        </p:spPr>
-        <p:txBody>
-          <a:bodyPr wrap="square" anchor="t" lIns="45720" rIns="45720" tIns="18288" bIns="18288">
-            <a:spAutoFit/>
-          </a:bodyPr>
-          <a:lstStyle/>
-          <a:p>
-            <a:pPr algn="l"/>
-            <a:r>
-              <a:rPr sz="1170" b="0" i="0">
-                <a:solidFill>
-                  <a:srgbClr val="0F172A"/>
-                </a:solidFill>
-                <a:latin typeface="Calibri"/>
-              </a:rPr>
-              <a:t>Lodging → Hotels / B&amp;Bs / Glamping / Campgrounds / RV  (and more)</a:t>
             </a:r>
           </a:p>
         </p:txBody>
@@ -10521,8 +10521,8 @@
         </p:nvSpPr>
         <p:spPr>
           <a:xfrm>
-            <a:off x="548640" y="4215384"/>
-            <a:ext cx="11064240" cy="548640"/>
+            <a:off x="548640" y="3913632"/>
+            <a:ext cx="11064240" cy="502920"/>
           </a:xfrm>
           <a:prstGeom prst="rect">
             <a:avLst/>
@@ -10565,8 +10565,8 @@
         </p:nvSpPr>
         <p:spPr>
           <a:xfrm>
-            <a:off x="640080" y="4261104"/>
-            <a:ext cx="2971800" cy="502919"/>
+            <a:off x="640080" y="3959352"/>
+            <a:ext cx="2971800" cy="457200"/>
           </a:xfrm>
           <a:prstGeom prst="rect">
             <a:avLst/>
@@ -10587,6 +10587,76 @@
                 </a:solidFill>
                 <a:latin typeface="Calibri"/>
               </a:rPr>
+              <a:t>Category dropdown + sub-pills</a:t>
+            </a:r>
+          </a:p>
+        </p:txBody>
+      </p:sp>
+      <p:sp>
+        <p:nvSpPr>
+          <p:cNvPr id="21" name="TextBox 20"/>
+          <p:cNvSpPr txBox="1"/>
+          <p:nvPr/>
+        </p:nvSpPr>
+        <p:spPr>
+          <a:xfrm>
+            <a:off x="3749040" y="3959352"/>
+            <a:ext cx="7818119" cy="457200"/>
+          </a:xfrm>
+          <a:prstGeom prst="rect">
+            <a:avLst/>
+          </a:prstGeom>
+          <a:noFill/>
+        </p:spPr>
+        <p:txBody>
+          <a:bodyPr wrap="square" anchor="t" lIns="45720" rIns="45720" tIns="18288" bIns="18288">
+            <a:spAutoFit/>
+          </a:bodyPr>
+          <a:lstStyle/>
+          <a:p>
+            <a:pPr algn="l"/>
+            <a:r>
+              <a:rPr sz="1170" b="0" i="0">
+                <a:solidFill>
+                  <a:srgbClr val="0F172A"/>
+                </a:solidFill>
+                <a:latin typeface="Calibri"/>
+              </a:rPr>
+              <a:t>Lodging → Hotels / B&amp;Bs / Glamping / Campgrounds / RV  (and more)</a:t>
+            </a:r>
+          </a:p>
+        </p:txBody>
+      </p:sp>
+      <p:sp>
+        <p:nvSpPr>
+          <p:cNvPr id="22" name="TextBox 21"/>
+          <p:cNvSpPr txBox="1"/>
+          <p:nvPr/>
+        </p:nvSpPr>
+        <p:spPr>
+          <a:xfrm>
+            <a:off x="640080" y="4462272"/>
+            <a:ext cx="2971800" cy="457200"/>
+          </a:xfrm>
+          <a:prstGeom prst="rect">
+            <a:avLst/>
+          </a:prstGeom>
+          <a:noFill/>
+        </p:spPr>
+        <p:txBody>
+          <a:bodyPr wrap="square" anchor="t" lIns="45720" rIns="45720" tIns="18288" bIns="18288">
+            <a:spAutoFit/>
+          </a:bodyPr>
+          <a:lstStyle/>
+          <a:p>
+            <a:pPr algn="l"/>
+            <a:r>
+              <a:rPr sz="1170" b="0" i="0">
+                <a:solidFill>
+                  <a:srgbClr val="0F172A"/>
+                </a:solidFill>
+                <a:latin typeface="Calibri"/>
+              </a:rPr>
               <a:t>Activity tags on every card</a:t>
             </a:r>
           </a:p>
@@ -10594,14 +10664,14 @@
       </p:sp>
       <p:sp>
         <p:nvSpPr>
-          <p:cNvPr id="21" name="TextBox 20"/>
-          <p:cNvSpPr txBox="1"/>
-          <p:nvPr/>
-        </p:nvSpPr>
-        <p:spPr>
-          <a:xfrm>
-            <a:off x="3749040" y="4261104"/>
-            <a:ext cx="7818119" cy="502919"/>
+          <p:cNvPr id="23" name="TextBox 22"/>
+          <p:cNvSpPr txBox="1"/>
+          <p:nvPr/>
+        </p:nvSpPr>
+        <p:spPr>
+          <a:xfrm>
+            <a:off x="3749040" y="4462272"/>
+            <a:ext cx="7818119" cy="457200"/>
           </a:xfrm>
           <a:prstGeom prst="rect">
             <a:avLst/>
@@ -10623,76 +10693,6 @@
                 <a:latin typeface="Calibri"/>
               </a:rPr>
               <a:t>Hiking · Biking · Swimming · Fishing · Boating · Running visible at a glance</a:t>
-            </a:r>
-          </a:p>
-        </p:txBody>
-      </p:sp>
-      <p:sp>
-        <p:nvSpPr>
-          <p:cNvPr id="22" name="TextBox 21"/>
-          <p:cNvSpPr txBox="1"/>
-          <p:nvPr/>
-        </p:nvSpPr>
-        <p:spPr>
-          <a:xfrm>
-            <a:off x="640080" y="4809744"/>
-            <a:ext cx="2971800" cy="502919"/>
-          </a:xfrm>
-          <a:prstGeom prst="rect">
-            <a:avLst/>
-          </a:prstGeom>
-          <a:noFill/>
-        </p:spPr>
-        <p:txBody>
-          <a:bodyPr wrap="square" anchor="t" lIns="45720" rIns="45720" tIns="18288" bIns="18288">
-            <a:spAutoFit/>
-          </a:bodyPr>
-          <a:lstStyle/>
-          <a:p>
-            <a:pPr algn="l"/>
-            <a:r>
-              <a:rPr sz="1170" b="0" i="0">
-                <a:solidFill>
-                  <a:srgbClr val="0F172A"/>
-                </a:solidFill>
-                <a:latin typeface="Calibri"/>
-              </a:rPr>
-              <a:t>Date filter + auto-season</a:t>
-            </a:r>
-          </a:p>
-        </p:txBody>
-      </p:sp>
-      <p:sp>
-        <p:nvSpPr>
-          <p:cNvPr id="23" name="TextBox 22"/>
-          <p:cNvSpPr txBox="1"/>
-          <p:nvPr/>
-        </p:nvSpPr>
-        <p:spPr>
-          <a:xfrm>
-            <a:off x="3749040" y="4809744"/>
-            <a:ext cx="7818119" cy="502919"/>
-          </a:xfrm>
-          <a:prstGeom prst="rect">
-            <a:avLst/>
-          </a:prstGeom>
-          <a:noFill/>
-        </p:spPr>
-        <p:txBody>
-          <a:bodyPr wrap="square" anchor="t" lIns="45720" rIns="45720" tIns="18288" bIns="18288">
-            <a:spAutoFit/>
-          </a:bodyPr>
-          <a:lstStyle/>
-          <a:p>
-            <a:pPr algn="l"/>
-            <a:r>
-              <a:rPr sz="1170" b="0" i="0">
-                <a:solidFill>
-                  <a:srgbClr val="0F172A"/>
-                </a:solidFill>
-                <a:latin typeface="Calibri"/>
-              </a:rPr>
-              <a:t>All Future · Today · Weekend · This Week — auto-hides summer-only items in winter</a:t>
             </a:r>
           </a:p>
         </p:txBody>
@@ -10705,8 +10705,8 @@
         </p:nvSpPr>
         <p:spPr>
           <a:xfrm>
-            <a:off x="548640" y="5312664"/>
-            <a:ext cx="11064240" cy="548640"/>
+            <a:off x="548640" y="4919472"/>
+            <a:ext cx="11064240" cy="502920"/>
           </a:xfrm>
           <a:prstGeom prst="rect">
             <a:avLst/>
@@ -10749,8 +10749,8 @@
         </p:nvSpPr>
         <p:spPr>
           <a:xfrm>
-            <a:off x="640080" y="5358384"/>
-            <a:ext cx="2971800" cy="502919"/>
+            <a:off x="640080" y="4965192"/>
+            <a:ext cx="2971800" cy="457200"/>
           </a:xfrm>
           <a:prstGeom prst="rect">
             <a:avLst/>
@@ -10771,6 +10771,76 @@
                 </a:solidFill>
                 <a:latin typeface="Calibri"/>
               </a:rPr>
+              <a:t>Date filter + auto-season</a:t>
+            </a:r>
+          </a:p>
+        </p:txBody>
+      </p:sp>
+      <p:sp>
+        <p:nvSpPr>
+          <p:cNvPr id="26" name="TextBox 25"/>
+          <p:cNvSpPr txBox="1"/>
+          <p:nvPr/>
+        </p:nvSpPr>
+        <p:spPr>
+          <a:xfrm>
+            <a:off x="3749040" y="4965192"/>
+            <a:ext cx="7818119" cy="457200"/>
+          </a:xfrm>
+          <a:prstGeom prst="rect">
+            <a:avLst/>
+          </a:prstGeom>
+          <a:noFill/>
+        </p:spPr>
+        <p:txBody>
+          <a:bodyPr wrap="square" anchor="t" lIns="45720" rIns="45720" tIns="18288" bIns="18288">
+            <a:spAutoFit/>
+          </a:bodyPr>
+          <a:lstStyle/>
+          <a:p>
+            <a:pPr algn="l"/>
+            <a:r>
+              <a:rPr sz="1170" b="0" i="0">
+                <a:solidFill>
+                  <a:srgbClr val="0F172A"/>
+                </a:solidFill>
+                <a:latin typeface="Calibri"/>
+              </a:rPr>
+              <a:t>All Future · Today · Weekend · This Week — auto-hides summer-only items in winter</a:t>
+            </a:r>
+          </a:p>
+        </p:txBody>
+      </p:sp>
+      <p:sp>
+        <p:nvSpPr>
+          <p:cNvPr id="27" name="TextBox 26"/>
+          <p:cNvSpPr txBox="1"/>
+          <p:nvPr/>
+        </p:nvSpPr>
+        <p:spPr>
+          <a:xfrm>
+            <a:off x="640080" y="5468112"/>
+            <a:ext cx="2971800" cy="457200"/>
+          </a:xfrm>
+          <a:prstGeom prst="rect">
+            <a:avLst/>
+          </a:prstGeom>
+          <a:noFill/>
+        </p:spPr>
+        <p:txBody>
+          <a:bodyPr wrap="square" anchor="t" lIns="45720" rIns="45720" tIns="18288" bIns="18288">
+            <a:spAutoFit/>
+          </a:bodyPr>
+          <a:lstStyle/>
+          <a:p>
+            <a:pPr algn="l"/>
+            <a:r>
+              <a:rPr sz="1170" b="0" i="0">
+                <a:solidFill>
+                  <a:srgbClr val="0F172A"/>
+                </a:solidFill>
+                <a:latin typeface="Calibri"/>
+              </a:rPr>
               <a:t>Area filter</a:t>
             </a:r>
           </a:p>
@@ -10778,14 +10848,14 @@
       </p:sp>
       <p:sp>
         <p:nvSpPr>
-          <p:cNvPr id="26" name="TextBox 25"/>
-          <p:cNvSpPr txBox="1"/>
-          <p:nvPr/>
-        </p:nvSpPr>
-        <p:spPr>
-          <a:xfrm>
-            <a:off x="3749040" y="5358384"/>
-            <a:ext cx="7818119" cy="502919"/>
+          <p:cNvPr id="28" name="TextBox 27"/>
+          <p:cNvSpPr txBox="1"/>
+          <p:nvPr/>
+        </p:nvSpPr>
+        <p:spPr>
+          <a:xfrm>
+            <a:off x="3749040" y="5468112"/>
+            <a:ext cx="7818119" cy="457200"/>
           </a:xfrm>
           <a:prstGeom prst="rect">
             <a:avLst/>
@@ -10813,14 +10883,58 @@
       </p:sp>
       <p:sp>
         <p:nvSpPr>
-          <p:cNvPr id="27" name="TextBox 26"/>
-          <p:cNvSpPr txBox="1"/>
-          <p:nvPr/>
-        </p:nvSpPr>
-        <p:spPr>
-          <a:xfrm>
-            <a:off x="640080" y="5907024"/>
-            <a:ext cx="2971800" cy="502919"/>
+          <p:cNvPr id="29" name="Rectangle 28"/>
+          <p:cNvSpPr/>
+          <p:nvPr/>
+        </p:nvSpPr>
+        <p:spPr>
+          <a:xfrm>
+            <a:off x="548640" y="5925312"/>
+            <a:ext cx="11064240" cy="502920"/>
+          </a:xfrm>
+          <a:prstGeom prst="rect">
+            <a:avLst/>
+          </a:prstGeom>
+          <a:solidFill>
+            <a:srgbClr val="F1F5F9"/>
+          </a:solidFill>
+          <a:ln>
+            <a:noFill/>
+          </a:ln>
+          <a:effectLst/>
+        </p:spPr>
+        <p:style>
+          <a:lnRef idx="1">
+            <a:schemeClr val="accent1"/>
+          </a:lnRef>
+          <a:fillRef idx="3">
+            <a:schemeClr val="accent1"/>
+          </a:fillRef>
+          <a:effectRef idx="2">
+            <a:schemeClr val="accent1"/>
+          </a:effectRef>
+          <a:fontRef idx="minor">
+            <a:schemeClr val="lt1"/>
+          </a:fontRef>
+        </p:style>
+        <p:txBody>
+          <a:bodyPr rtlCol="0" anchor="ctr"/>
+          <a:lstStyle/>
+          <a:p>
+            <a:pPr algn="ctr"/>
+          </a:p>
+        </p:txBody>
+      </p:sp>
+      <p:sp>
+        <p:nvSpPr>
+          <p:cNvPr id="30" name="TextBox 29"/>
+          <p:cNvSpPr txBox="1"/>
+          <p:nvPr/>
+        </p:nvSpPr>
+        <p:spPr>
+          <a:xfrm>
+            <a:off x="640080" y="5971032"/>
+            <a:ext cx="2971800" cy="457200"/>
           </a:xfrm>
           <a:prstGeom prst="rect">
             <a:avLst/>
@@ -10848,14 +10962,14 @@
       </p:sp>
       <p:sp>
         <p:nvSpPr>
-          <p:cNvPr id="28" name="TextBox 27"/>
-          <p:cNvSpPr txBox="1"/>
-          <p:nvPr/>
-        </p:nvSpPr>
-        <p:spPr>
-          <a:xfrm>
-            <a:off x="3749040" y="5907024"/>
-            <a:ext cx="7818119" cy="502919"/>
+          <p:cNvPr id="31" name="TextBox 30"/>
+          <p:cNvSpPr txBox="1"/>
+          <p:nvPr/>
+        </p:nvSpPr>
+        <p:spPr>
+          <a:xfrm>
+            <a:off x="3749040" y="5971032"/>
+            <a:ext cx="7818119" cy="457200"/>
           </a:xfrm>
           <a:prstGeom prst="rect">
             <a:avLst/>
@@ -10883,7 +10997,7 @@
       </p:sp>
       <p:sp>
         <p:nvSpPr>
-          <p:cNvPr id="29" name="TextBox 28"/>
+          <p:cNvPr id="32" name="TextBox 31"/>
           <p:cNvSpPr txBox="1"/>
           <p:nvPr/>
         </p:nvSpPr>
@@ -10918,7 +11032,7 @@
       </p:sp>
       <p:sp>
         <p:nvSpPr>
-          <p:cNvPr id="30" name="TextBox 29"/>
+          <p:cNvPr id="33" name="TextBox 32"/>
           <p:cNvSpPr txBox="1"/>
           <p:nvPr/>
         </p:nvSpPr>
@@ -10953,7 +11067,7 @@
       </p:sp>
       <p:sp>
         <p:nvSpPr>
-          <p:cNvPr id="31" name="Rectangle 30"/>
+          <p:cNvPr id="34" name="Rectangle 33"/>
           <p:cNvSpPr/>
           <p:nvPr/>
         </p:nvSpPr>

</xml_diff>